<commit_message>
Add selection policy robustness wrapper
</commit_message>
<xml_diff>
--- a/presentations/gen5_selection_policy_hypothesis.pptx
+++ b/presentations/gen5_selection_policy_hypothesis.pptx
@@ -2,18 +2,21 @@
 <file path=ppt/presentation.xml><?xml version="1.0" encoding="utf-8"?>
 <p:presentation xmlns:p="http://schemas.openxmlformats.org/presentationml/2006/main">
   <p:sldMasterIdLst>
-    <p:sldMasterId xmlns:r="http://schemas.openxmlformats.org/officeDocument/2006/relationships" id="2147483648" r:id="R413480349fba4582"/>
+    <p:sldMasterId xmlns:r="http://schemas.openxmlformats.org/officeDocument/2006/relationships" id="2147483648" r:id="R988099be868b4085"/>
   </p:sldMasterIdLst>
   <p:notesMasterIdLst>
-    <p:notesMasterId xmlns:r="http://schemas.openxmlformats.org/officeDocument/2006/relationships" r:id="R9d7d831e353541dc"/>
+    <p:notesMasterId xmlns:r="http://schemas.openxmlformats.org/officeDocument/2006/relationships" r:id="R7a33686f1eba4a37"/>
   </p:notesMasterIdLst>
   <p:sldIdLst>
-    <p:sldId xmlns:r="http://schemas.openxmlformats.org/officeDocument/2006/relationships" id="256" r:id="R9b3db5eb55494c3b"/>
-    <p:sldId xmlns:r="http://schemas.openxmlformats.org/officeDocument/2006/relationships" id="257" r:id="R2114b0014cd046a4"/>
-    <p:sldId xmlns:r="http://schemas.openxmlformats.org/officeDocument/2006/relationships" id="258" r:id="R7bcfd2329f9c446e"/>
-    <p:sldId xmlns:r="http://schemas.openxmlformats.org/officeDocument/2006/relationships" id="259" r:id="R176ca27e14364813"/>
-    <p:sldId xmlns:r="http://schemas.openxmlformats.org/officeDocument/2006/relationships" id="260" r:id="R4bdaa83ea70d4813"/>
-    <p:sldId xmlns:r="http://schemas.openxmlformats.org/officeDocument/2006/relationships" id="261" r:id="R95d6a22adceb4095"/>
+    <p:sldId xmlns:r="http://schemas.openxmlformats.org/officeDocument/2006/relationships" id="256" r:id="Rcf9e02c1b19b4cd5"/>
+    <p:sldId xmlns:r="http://schemas.openxmlformats.org/officeDocument/2006/relationships" id="257" r:id="Rffc48206a34c4daf"/>
+    <p:sldId xmlns:r="http://schemas.openxmlformats.org/officeDocument/2006/relationships" id="258" r:id="R6ad9b93d8223412c"/>
+    <p:sldId xmlns:r="http://schemas.openxmlformats.org/officeDocument/2006/relationships" id="259" r:id="Ra8c78cb0f51f4f83"/>
+    <p:sldId xmlns:r="http://schemas.openxmlformats.org/officeDocument/2006/relationships" id="260" r:id="Rb4bab109af3d49cb"/>
+    <p:sldId xmlns:r="http://schemas.openxmlformats.org/officeDocument/2006/relationships" id="261" r:id="R4958d3814327407b"/>
+    <p:sldId xmlns:r="http://schemas.openxmlformats.org/officeDocument/2006/relationships" id="262" r:id="Rd9f43f4cdf924bb4"/>
+    <p:sldId xmlns:r="http://schemas.openxmlformats.org/officeDocument/2006/relationships" id="263" r:id="R2dec1063b60944b8"/>
+    <p:sldId xmlns:r="http://schemas.openxmlformats.org/officeDocument/2006/relationships" id="264" r:id="R27b2c2ee826f4dcf"/>
   </p:sldIdLst>
   <p:sldSz cx="12192000" cy="6858000"/>
   <p:notesSz cx="6858000" cy="9144000"/>
@@ -898,6 +901,204 @@
 </p:notes>
 </file>
 
+<file path=ppt/notesSlides/notesSlide7.xml><?xml version="1.0" encoding="utf-8"?>
+<p:notes xmlns:p="http://schemas.openxmlformats.org/presentationml/2006/main">
+  <p:cSld>
+    <p:spTree>
+      <p:nvGrpSpPr>
+        <p:cNvPr id="1" name=""/>
+        <p:cNvGrpSpPr/>
+        <p:nvPr/>
+      </p:nvGrpSpPr>
+      <p:grpSpPr>
+        <a:xfrm xmlns:a="http://schemas.openxmlformats.org/drawingml/2006/main"/>
+      </p:grpSpPr>
+      <p:sp>
+        <p:nvSpPr>
+          <p:cNvPr id="2" name="Slide Image Placeholder 1"/>
+          <p:cNvSpPr>
+            <a:spLocks xmlns:a="http://schemas.openxmlformats.org/drawingml/2006/main" noGrp="1"/>
+          </p:cNvSpPr>
+          <p:nvPr>
+            <p:ph type="sldImg" idx="0"/>
+          </p:nvPr>
+        </p:nvSpPr>
+        <p:spPr/>
+      </p:sp>
+      <p:sp>
+        <p:nvSpPr>
+          <p:cNvPr id="3" name="Notes Placeholder 2"/>
+          <p:cNvSpPr>
+            <a:spLocks xmlns:a="http://schemas.openxmlformats.org/drawingml/2006/main" noGrp="1"/>
+          </p:cNvSpPr>
+          <p:nvPr>
+            <p:ph type="body" idx="1"/>
+          </p:nvPr>
+        </p:nvSpPr>
+        <p:spPr/>
+        <p:txBody>
+          <a:bodyPr xmlns:a="http://schemas.openxmlformats.org/drawingml/2006/main"/>
+          <a:lstStyle xmlns:a="http://schemas.openxmlformats.org/drawingml/2006/main"/>
+          <a:p xmlns:a="http://schemas.openxmlformats.org/drawingml/2006/main"/>
+        </p:txBody>
+      </p:sp>
+      <p:sp>
+        <p:nvSpPr>
+          <p:cNvPr id="4" name="Slide Number Placeholder 3"/>
+          <p:cNvSpPr>
+            <a:spLocks xmlns:a="http://schemas.openxmlformats.org/drawingml/2006/main" noGrp="1"/>
+          </p:cNvSpPr>
+          <p:nvPr>
+            <p:ph type="sldNum" idx="5"/>
+          </p:nvPr>
+        </p:nvSpPr>
+        <p:spPr/>
+        <p:txBody>
+          <a:bodyPr xmlns:a="http://schemas.openxmlformats.org/drawingml/2006/main"/>
+          <a:lstStyle xmlns:a="http://schemas.openxmlformats.org/drawingml/2006/main"/>
+          <a:p xmlns:a="http://schemas.openxmlformats.org/drawingml/2006/main"/>
+        </p:txBody>
+      </p:sp>
+    </p:spTree>
+  </p:cSld>
+  <p:clrMapOvr>
+    <a:masterClrMapping xmlns:a="http://schemas.openxmlformats.org/drawingml/2006/main"/>
+  </p:clrMapOvr>
+</p:notes>
+</file>
+
+<file path=ppt/notesSlides/notesSlide8.xml><?xml version="1.0" encoding="utf-8"?>
+<p:notes xmlns:p="http://schemas.openxmlformats.org/presentationml/2006/main">
+  <p:cSld>
+    <p:spTree>
+      <p:nvGrpSpPr>
+        <p:cNvPr id="1" name=""/>
+        <p:cNvGrpSpPr/>
+        <p:nvPr/>
+      </p:nvGrpSpPr>
+      <p:grpSpPr>
+        <a:xfrm xmlns:a="http://schemas.openxmlformats.org/drawingml/2006/main"/>
+      </p:grpSpPr>
+      <p:sp>
+        <p:nvSpPr>
+          <p:cNvPr id="2" name="Slide Image Placeholder 1"/>
+          <p:cNvSpPr>
+            <a:spLocks xmlns:a="http://schemas.openxmlformats.org/drawingml/2006/main" noGrp="1"/>
+          </p:cNvSpPr>
+          <p:nvPr>
+            <p:ph type="sldImg" idx="0"/>
+          </p:nvPr>
+        </p:nvSpPr>
+        <p:spPr/>
+      </p:sp>
+      <p:sp>
+        <p:nvSpPr>
+          <p:cNvPr id="3" name="Notes Placeholder 2"/>
+          <p:cNvSpPr>
+            <a:spLocks xmlns:a="http://schemas.openxmlformats.org/drawingml/2006/main" noGrp="1"/>
+          </p:cNvSpPr>
+          <p:nvPr>
+            <p:ph type="body" idx="1"/>
+          </p:nvPr>
+        </p:nvSpPr>
+        <p:spPr/>
+        <p:txBody>
+          <a:bodyPr xmlns:a="http://schemas.openxmlformats.org/drawingml/2006/main"/>
+          <a:lstStyle xmlns:a="http://schemas.openxmlformats.org/drawingml/2006/main"/>
+          <a:p xmlns:a="http://schemas.openxmlformats.org/drawingml/2006/main"/>
+        </p:txBody>
+      </p:sp>
+      <p:sp>
+        <p:nvSpPr>
+          <p:cNvPr id="4" name="Slide Number Placeholder 3"/>
+          <p:cNvSpPr>
+            <a:spLocks xmlns:a="http://schemas.openxmlformats.org/drawingml/2006/main" noGrp="1"/>
+          </p:cNvSpPr>
+          <p:nvPr>
+            <p:ph type="sldNum" idx="5"/>
+          </p:nvPr>
+        </p:nvSpPr>
+        <p:spPr/>
+        <p:txBody>
+          <a:bodyPr xmlns:a="http://schemas.openxmlformats.org/drawingml/2006/main"/>
+          <a:lstStyle xmlns:a="http://schemas.openxmlformats.org/drawingml/2006/main"/>
+          <a:p xmlns:a="http://schemas.openxmlformats.org/drawingml/2006/main"/>
+        </p:txBody>
+      </p:sp>
+    </p:spTree>
+  </p:cSld>
+  <p:clrMapOvr>
+    <a:masterClrMapping xmlns:a="http://schemas.openxmlformats.org/drawingml/2006/main"/>
+  </p:clrMapOvr>
+</p:notes>
+</file>
+
+<file path=ppt/notesSlides/notesSlide9.xml><?xml version="1.0" encoding="utf-8"?>
+<p:notes xmlns:p="http://schemas.openxmlformats.org/presentationml/2006/main">
+  <p:cSld>
+    <p:spTree>
+      <p:nvGrpSpPr>
+        <p:cNvPr id="1" name=""/>
+        <p:cNvGrpSpPr/>
+        <p:nvPr/>
+      </p:nvGrpSpPr>
+      <p:grpSpPr>
+        <a:xfrm xmlns:a="http://schemas.openxmlformats.org/drawingml/2006/main"/>
+      </p:grpSpPr>
+      <p:sp>
+        <p:nvSpPr>
+          <p:cNvPr id="2" name="Slide Image Placeholder 1"/>
+          <p:cNvSpPr>
+            <a:spLocks xmlns:a="http://schemas.openxmlformats.org/drawingml/2006/main" noGrp="1"/>
+          </p:cNvSpPr>
+          <p:nvPr>
+            <p:ph type="sldImg" idx="0"/>
+          </p:nvPr>
+        </p:nvSpPr>
+        <p:spPr/>
+      </p:sp>
+      <p:sp>
+        <p:nvSpPr>
+          <p:cNvPr id="3" name="Notes Placeholder 2"/>
+          <p:cNvSpPr>
+            <a:spLocks xmlns:a="http://schemas.openxmlformats.org/drawingml/2006/main" noGrp="1"/>
+          </p:cNvSpPr>
+          <p:nvPr>
+            <p:ph type="body" idx="1"/>
+          </p:nvPr>
+        </p:nvSpPr>
+        <p:spPr/>
+        <p:txBody>
+          <a:bodyPr xmlns:a="http://schemas.openxmlformats.org/drawingml/2006/main"/>
+          <a:lstStyle xmlns:a="http://schemas.openxmlformats.org/drawingml/2006/main"/>
+          <a:p xmlns:a="http://schemas.openxmlformats.org/drawingml/2006/main"/>
+        </p:txBody>
+      </p:sp>
+      <p:sp>
+        <p:nvSpPr>
+          <p:cNvPr id="4" name="Slide Number Placeholder 3"/>
+          <p:cNvSpPr>
+            <a:spLocks xmlns:a="http://schemas.openxmlformats.org/drawingml/2006/main" noGrp="1"/>
+          </p:cNvSpPr>
+          <p:nvPr>
+            <p:ph type="sldNum" idx="5"/>
+          </p:nvPr>
+        </p:nvSpPr>
+        <p:spPr/>
+        <p:txBody>
+          <a:bodyPr xmlns:a="http://schemas.openxmlformats.org/drawingml/2006/main"/>
+          <a:lstStyle xmlns:a="http://schemas.openxmlformats.org/drawingml/2006/main"/>
+          <a:p xmlns:a="http://schemas.openxmlformats.org/drawingml/2006/main"/>
+        </p:txBody>
+      </p:sp>
+    </p:spTree>
+  </p:cSld>
+  <p:clrMapOvr>
+    <a:masterClrMapping xmlns:a="http://schemas.openxmlformats.org/drawingml/2006/main"/>
+  </p:clrMapOvr>
+</p:notes>
+</file>
+
 <file path=ppt/slideLayouts/slideLayout1.xml><?xml version="1.0" encoding="utf-8"?>
 <p:sldLayout xmlns:p="http://schemas.openxmlformats.org/presentationml/2006/main" type="title">
   <p:cSld name="Title Slide">
@@ -936,7 +1137,7 @@
   </p:cSld>
   <p:clrMap bg1="lt1" tx1="dk1" bg2="lt2" tx2="dk2" accent1="accent1" accent2="accent2" accent3="accent3" accent4="accent4" accent5="accent5" accent6="accent6" hlink="hlink" folHlink="folHlink"/>
   <p:sldLayoutIdLst>
-    <p:sldLayoutId xmlns:r="http://schemas.openxmlformats.org/officeDocument/2006/relationships" id="2147483649" r:id="R6c09ffcdf30746b7"/>
+    <p:sldLayoutId xmlns:r="http://schemas.openxmlformats.org/officeDocument/2006/relationships" id="2147483649" r:id="Rad83d4d8b19c4699"/>
   </p:sldLayoutIdLst>
   <p:txStyles>
     <p:titleStyle>
@@ -1487,7 +1688,7 @@
           <p:cNvPr id="1" name="">
             <a:extLst xmlns:a="http://schemas.openxmlformats.org/drawingml/2006/main">
               <a:ext uri="{FF2B5EF4-FFF2-40B4-BE49-F238E27FC236}">
-                <a16:creationId xmlns:a16="http://schemas.microsoft.com/office/drawing/2014/main" id="{D4A1A5FC-7FA4-4C13-A748-CD34E793D5E7}"/>
+                <a16:creationId xmlns:a16="http://schemas.microsoft.com/office/drawing/2014/main" id="{21D968A0-6AD4-4EF7-A5AB-CAADBA156A3B}"/>
               </a:ext>
             </a:extLst>
           </p:cNvPr>
@@ -1537,7 +1738,7 @@
           <p:cNvPr id="2" name="">
             <a:extLst xmlns:a="http://schemas.openxmlformats.org/drawingml/2006/main">
               <a:ext uri="{FF2B5EF4-FFF2-40B4-BE49-F238E27FC236}">
-                <a16:creationId xmlns:a16="http://schemas.microsoft.com/office/drawing/2014/main" id="{5EBB8BCF-CD5A-4A6B-81DD-7613F163AEC7}"/>
+                <a16:creationId xmlns:a16="http://schemas.microsoft.com/office/drawing/2014/main" id="{2FB07537-C4A6-4912-8A11-C409D02EFCF6}"/>
               </a:ext>
             </a:extLst>
           </p:cNvPr>
@@ -1587,7 +1788,7 @@
           <p:cNvPr id="3" name="">
             <a:extLst xmlns:a="http://schemas.openxmlformats.org/drawingml/2006/main">
               <a:ext uri="{FF2B5EF4-FFF2-40B4-BE49-F238E27FC236}">
-                <a16:creationId xmlns:a16="http://schemas.microsoft.com/office/drawing/2014/main" id="{1AF3A4E8-BACA-4C6C-B9E9-A198B5A40109}"/>
+                <a16:creationId xmlns:a16="http://schemas.microsoft.com/office/drawing/2014/main" id="{EAE67BE2-D2AA-4EEF-A9EC-B089BE0E5445}"/>
               </a:ext>
             </a:extLst>
           </p:cNvPr>
@@ -1637,7 +1838,7 @@
           <p:cNvPr id="4" name="">
             <a:extLst xmlns:a="http://schemas.openxmlformats.org/drawingml/2006/main">
               <a:ext uri="{FF2B5EF4-FFF2-40B4-BE49-F238E27FC236}">
-                <a16:creationId xmlns:a16="http://schemas.microsoft.com/office/drawing/2014/main" id="{79EC2CFE-7A03-4FB8-9967-4130C439A77E}"/>
+                <a16:creationId xmlns:a16="http://schemas.microsoft.com/office/drawing/2014/main" id="{99E75046-3366-4B33-B3C9-6CF9432A776C}"/>
               </a:ext>
             </a:extLst>
           </p:cNvPr>
@@ -1668,7 +1869,7 @@
           <p:cNvPr id="5" name="">
             <a:extLst xmlns:a="http://schemas.openxmlformats.org/drawingml/2006/main">
               <a:ext uri="{FF2B5EF4-FFF2-40B4-BE49-F238E27FC236}">
-                <a16:creationId xmlns:a16="http://schemas.microsoft.com/office/drawing/2014/main" id="{3F6216B1-2EE3-40CA-BD2A-6BE6C5B3D543}"/>
+                <a16:creationId xmlns:a16="http://schemas.microsoft.com/office/drawing/2014/main" id="{C5337A9D-7977-4DE1-ACD5-70CF9C2F7E5E}"/>
               </a:ext>
             </a:extLst>
           </p:cNvPr>
@@ -1769,7 +1970,7 @@
           <p:cNvPr id="6" name="">
             <a:extLst xmlns:a="http://schemas.openxmlformats.org/drawingml/2006/main">
               <a:ext uri="{FF2B5EF4-FFF2-40B4-BE49-F238E27FC236}">
-                <a16:creationId xmlns:a16="http://schemas.microsoft.com/office/drawing/2014/main" id="{EFBFEA0F-8E91-44AA-81E6-E2A320EC22B6}"/>
+                <a16:creationId xmlns:a16="http://schemas.microsoft.com/office/drawing/2014/main" id="{11D4CB3D-9040-45E3-9789-88902C91B26E}"/>
               </a:ext>
             </a:extLst>
           </p:cNvPr>
@@ -1819,7 +2020,7 @@
           <p:cNvPr id="7" name="">
             <a:extLst xmlns:a="http://schemas.openxmlformats.org/drawingml/2006/main">
               <a:ext uri="{FF2B5EF4-FFF2-40B4-BE49-F238E27FC236}">
-                <a16:creationId xmlns:a16="http://schemas.microsoft.com/office/drawing/2014/main" id="{19F0D9C5-740D-492E-8AE9-300EFC24E417}"/>
+                <a16:creationId xmlns:a16="http://schemas.microsoft.com/office/drawing/2014/main" id="{A5021E50-BC66-430F-BB46-CDD82DED2CE2}"/>
               </a:ext>
             </a:extLst>
           </p:cNvPr>
@@ -1852,7 +2053,7 @@
           <p:cNvPr id="8" name="">
             <a:extLst xmlns:a="http://schemas.openxmlformats.org/drawingml/2006/main">
               <a:ext uri="{FF2B5EF4-FFF2-40B4-BE49-F238E27FC236}">
-                <a16:creationId xmlns:a16="http://schemas.microsoft.com/office/drawing/2014/main" id="{5127CFB3-748C-4AED-80FD-7AE139145CD9}"/>
+                <a16:creationId xmlns:a16="http://schemas.microsoft.com/office/drawing/2014/main" id="{4240C856-E047-41C2-82AC-2E5877F92052}"/>
               </a:ext>
             </a:extLst>
           </p:cNvPr>
@@ -1902,7 +2103,7 @@
           <p:cNvPr id="9" name="">
             <a:extLst xmlns:a="http://schemas.openxmlformats.org/drawingml/2006/main">
               <a:ext uri="{FF2B5EF4-FFF2-40B4-BE49-F238E27FC236}">
-                <a16:creationId xmlns:a16="http://schemas.microsoft.com/office/drawing/2014/main" id="{D89BF088-7A6B-41EA-9FB4-ABE0D6BBA2D2}"/>
+                <a16:creationId xmlns:a16="http://schemas.microsoft.com/office/drawing/2014/main" id="{38315038-AA17-4A94-B5C3-2B8E01E3B435}"/>
               </a:ext>
             </a:extLst>
           </p:cNvPr>
@@ -1950,7 +2151,7 @@
     </p:spTree>
     <p:extLst>
       <p:ext uri="{BB962C8B-B14F-4D97-AF65-F5344CB8AC3E}">
-        <p14:creationId xmlns:p14="http://schemas.microsoft.com/office/powerpoint/2010/main" val="657014724"/>
+        <p14:creationId xmlns:p14="http://schemas.microsoft.com/office/powerpoint/2010/main" val="1961626789"/>
       </p:ext>
     </p:extLst>
   </p:cSld>
@@ -1981,7 +2182,7 @@
           <p:cNvPr id="1" name="">
             <a:extLst xmlns:a="http://schemas.openxmlformats.org/drawingml/2006/main">
               <a:ext uri="{FF2B5EF4-FFF2-40B4-BE49-F238E27FC236}">
-                <a16:creationId xmlns:a16="http://schemas.microsoft.com/office/drawing/2014/main" id="{7EAAB38D-0167-4D2E-B4DD-FD8E605695B9}"/>
+                <a16:creationId xmlns:a16="http://schemas.microsoft.com/office/drawing/2014/main" id="{11FD3F25-EDEA-430E-B507-AF9D846DDFBD}"/>
               </a:ext>
             </a:extLst>
           </p:cNvPr>
@@ -2031,7 +2232,7 @@
           <p:cNvPr id="2" name="">
             <a:extLst xmlns:a="http://schemas.openxmlformats.org/drawingml/2006/main">
               <a:ext uri="{FF2B5EF4-FFF2-40B4-BE49-F238E27FC236}">
-                <a16:creationId xmlns:a16="http://schemas.microsoft.com/office/drawing/2014/main" id="{C5F19ECC-49DF-4C48-A938-89F1667BE599}"/>
+                <a16:creationId xmlns:a16="http://schemas.microsoft.com/office/drawing/2014/main" id="{E8201A1B-F7FA-4A3A-B163-9A7EAF8CA315}"/>
               </a:ext>
             </a:extLst>
           </p:cNvPr>
@@ -2081,7 +2282,7 @@
           <p:cNvPr id="3" name="">
             <a:extLst xmlns:a="http://schemas.openxmlformats.org/drawingml/2006/main">
               <a:ext uri="{FF2B5EF4-FFF2-40B4-BE49-F238E27FC236}">
-                <a16:creationId xmlns:a16="http://schemas.microsoft.com/office/drawing/2014/main" id="{B7AE8B1C-0BA0-4C01-89C4-C7F905166F4E}"/>
+                <a16:creationId xmlns:a16="http://schemas.microsoft.com/office/drawing/2014/main" id="{5DFE9D94-B4FF-4460-B0EE-582268771C34}"/>
               </a:ext>
             </a:extLst>
           </p:cNvPr>
@@ -2131,7 +2332,7 @@
           <p:cNvPr id="4" name="">
             <a:extLst xmlns:a="http://schemas.openxmlformats.org/drawingml/2006/main">
               <a:ext uri="{FF2B5EF4-FFF2-40B4-BE49-F238E27FC236}">
-                <a16:creationId xmlns:a16="http://schemas.microsoft.com/office/drawing/2014/main" id="{E7087E18-CE72-470E-A68C-2AA04747C0D2}"/>
+                <a16:creationId xmlns:a16="http://schemas.microsoft.com/office/drawing/2014/main" id="{34189426-8359-4812-91A4-B7F4BC89C3F0}"/>
               </a:ext>
             </a:extLst>
           </p:cNvPr>
@@ -2162,7 +2363,7 @@
           <p:cNvPr id="5" name="">
             <a:extLst xmlns:a="http://schemas.openxmlformats.org/drawingml/2006/main">
               <a:ext uri="{FF2B5EF4-FFF2-40B4-BE49-F238E27FC236}">
-                <a16:creationId xmlns:a16="http://schemas.microsoft.com/office/drawing/2014/main" id="{AD1A7033-94E3-4904-8B6C-E17ECF1AE8AC}"/>
+                <a16:creationId xmlns:a16="http://schemas.microsoft.com/office/drawing/2014/main" id="{96FBC063-3E50-4585-B050-54BB11F57457}"/>
               </a:ext>
             </a:extLst>
           </p:cNvPr>
@@ -2212,7 +2413,7 @@
           <p:cNvPr id="6" name="">
             <a:extLst xmlns:a="http://schemas.openxmlformats.org/drawingml/2006/main">
               <a:ext uri="{FF2B5EF4-FFF2-40B4-BE49-F238E27FC236}">
-                <a16:creationId xmlns:a16="http://schemas.microsoft.com/office/drawing/2014/main" id="{D6C390ED-8245-448F-ABEA-783ACD15FEF2}"/>
+                <a16:creationId xmlns:a16="http://schemas.microsoft.com/office/drawing/2014/main" id="{0418C969-5EF3-405F-AABC-07BE585F94F1}"/>
               </a:ext>
             </a:extLst>
           </p:cNvPr>
@@ -2262,7 +2463,7 @@
           <p:cNvPr id="7" name="">
             <a:extLst xmlns:a="http://schemas.openxmlformats.org/drawingml/2006/main">
               <a:ext uri="{FF2B5EF4-FFF2-40B4-BE49-F238E27FC236}">
-                <a16:creationId xmlns:a16="http://schemas.microsoft.com/office/drawing/2014/main" id="{B7D75BCB-731F-448A-8D8E-DB91C99914CB}"/>
+                <a16:creationId xmlns:a16="http://schemas.microsoft.com/office/drawing/2014/main" id="{EB404F3A-FB48-422E-8F3C-AC32741EBFDB}"/>
               </a:ext>
             </a:extLst>
           </p:cNvPr>
@@ -2293,7 +2494,7 @@
           <p:cNvPr id="8" name="">
             <a:extLst xmlns:a="http://schemas.openxmlformats.org/drawingml/2006/main">
               <a:ext uri="{FF2B5EF4-FFF2-40B4-BE49-F238E27FC236}">
-                <a16:creationId xmlns:a16="http://schemas.microsoft.com/office/drawing/2014/main" id="{8A9D4757-52FB-4D63-B10C-4059CCECCE64}"/>
+                <a16:creationId xmlns:a16="http://schemas.microsoft.com/office/drawing/2014/main" id="{E631DF4D-350D-448E-853A-DAE9B0B2ADE7}"/>
               </a:ext>
             </a:extLst>
           </p:cNvPr>
@@ -2343,7 +2544,7 @@
           <p:cNvPr id="9" name="">
             <a:extLst xmlns:a="http://schemas.openxmlformats.org/drawingml/2006/main">
               <a:ext uri="{FF2B5EF4-FFF2-40B4-BE49-F238E27FC236}">
-                <a16:creationId xmlns:a16="http://schemas.microsoft.com/office/drawing/2014/main" id="{135865E2-B245-45A3-AC27-6C91F3CF9861}"/>
+                <a16:creationId xmlns:a16="http://schemas.microsoft.com/office/drawing/2014/main" id="{CE835B5F-BC46-46FF-AF4A-A5CC581D2208}"/>
               </a:ext>
             </a:extLst>
           </p:cNvPr>
@@ -2393,7 +2594,7 @@
           <p:cNvPr id="10" name="">
             <a:extLst xmlns:a="http://schemas.openxmlformats.org/drawingml/2006/main">
               <a:ext uri="{FF2B5EF4-FFF2-40B4-BE49-F238E27FC236}">
-                <a16:creationId xmlns:a16="http://schemas.microsoft.com/office/drawing/2014/main" id="{DE798E42-1F05-45DB-9029-3D0B6AA31C1A}"/>
+                <a16:creationId xmlns:a16="http://schemas.microsoft.com/office/drawing/2014/main" id="{D5230B61-28E9-42D3-9CFC-CC07118AC35F}"/>
               </a:ext>
             </a:extLst>
           </p:cNvPr>
@@ -2424,7 +2625,7 @@
           <p:cNvPr id="11" name="">
             <a:extLst xmlns:a="http://schemas.openxmlformats.org/drawingml/2006/main">
               <a:ext uri="{FF2B5EF4-FFF2-40B4-BE49-F238E27FC236}">
-                <a16:creationId xmlns:a16="http://schemas.microsoft.com/office/drawing/2014/main" id="{26DA2594-F17E-4D44-9F3A-61EF7A001BFA}"/>
+                <a16:creationId xmlns:a16="http://schemas.microsoft.com/office/drawing/2014/main" id="{451C8AEE-B4A4-4443-8231-53AFDF984774}"/>
               </a:ext>
             </a:extLst>
           </p:cNvPr>
@@ -2474,7 +2675,7 @@
           <p:cNvPr id="12" name="">
             <a:extLst xmlns:a="http://schemas.openxmlformats.org/drawingml/2006/main">
               <a:ext uri="{FF2B5EF4-FFF2-40B4-BE49-F238E27FC236}">
-                <a16:creationId xmlns:a16="http://schemas.microsoft.com/office/drawing/2014/main" id="{1B999A80-DD0B-4EA9-8093-76C48B16B516}"/>
+                <a16:creationId xmlns:a16="http://schemas.microsoft.com/office/drawing/2014/main" id="{2DC31F69-AE52-4566-B369-38BD4A7273AC}"/>
               </a:ext>
             </a:extLst>
           </p:cNvPr>
@@ -2524,7 +2725,7 @@
           <p:cNvPr id="13" name="">
             <a:extLst xmlns:a="http://schemas.openxmlformats.org/drawingml/2006/main">
               <a:ext uri="{FF2B5EF4-FFF2-40B4-BE49-F238E27FC236}">
-                <a16:creationId xmlns:a16="http://schemas.microsoft.com/office/drawing/2014/main" id="{1EF1C6DB-0387-4836-B102-EEED9E460A8D}"/>
+                <a16:creationId xmlns:a16="http://schemas.microsoft.com/office/drawing/2014/main" id="{6A7090F9-8CC5-4467-B362-DA065AADFE53}"/>
               </a:ext>
             </a:extLst>
           </p:cNvPr>
@@ -2574,7 +2775,7 @@
           <p:cNvPr id="14" name="">
             <a:extLst xmlns:a="http://schemas.openxmlformats.org/drawingml/2006/main">
               <a:ext uri="{FF2B5EF4-FFF2-40B4-BE49-F238E27FC236}">
-                <a16:creationId xmlns:a16="http://schemas.microsoft.com/office/drawing/2014/main" id="{AA6ECE3D-F8FE-4F98-8634-9B4D4B3A3DF0}"/>
+                <a16:creationId xmlns:a16="http://schemas.microsoft.com/office/drawing/2014/main" id="{61B55219-573E-4B8D-AA7E-FF90B1CE50CE}"/>
               </a:ext>
             </a:extLst>
           </p:cNvPr>
@@ -2607,7 +2808,7 @@
           <p:cNvPr id="15" name="">
             <a:extLst xmlns:a="http://schemas.openxmlformats.org/drawingml/2006/main">
               <a:ext uri="{FF2B5EF4-FFF2-40B4-BE49-F238E27FC236}">
-                <a16:creationId xmlns:a16="http://schemas.microsoft.com/office/drawing/2014/main" id="{62544FF0-939A-48D7-8F53-60455A604303}"/>
+                <a16:creationId xmlns:a16="http://schemas.microsoft.com/office/drawing/2014/main" id="{BE6232F8-E1A3-49A8-B244-66AD8940DE1D}"/>
               </a:ext>
             </a:extLst>
           </p:cNvPr>
@@ -2657,7 +2858,7 @@
           <p:cNvPr id="16" name="">
             <a:extLst xmlns:a="http://schemas.openxmlformats.org/drawingml/2006/main">
               <a:ext uri="{FF2B5EF4-FFF2-40B4-BE49-F238E27FC236}">
-                <a16:creationId xmlns:a16="http://schemas.microsoft.com/office/drawing/2014/main" id="{9CB3C3A2-1D08-490D-821C-86E55DA4782F}"/>
+                <a16:creationId xmlns:a16="http://schemas.microsoft.com/office/drawing/2014/main" id="{975C437C-B086-4511-8DEB-A6C7AF915D77}"/>
               </a:ext>
             </a:extLst>
           </p:cNvPr>
@@ -2705,7 +2906,7 @@
     </p:spTree>
     <p:extLst>
       <p:ext uri="{BB962C8B-B14F-4D97-AF65-F5344CB8AC3E}">
-        <p14:creationId xmlns:p14="http://schemas.microsoft.com/office/powerpoint/2010/main" val="654126505"/>
+        <p14:creationId xmlns:p14="http://schemas.microsoft.com/office/powerpoint/2010/main" val="1681893720"/>
       </p:ext>
     </p:extLst>
   </p:cSld>
@@ -2736,7 +2937,7 @@
           <p:cNvPr id="1" name="">
             <a:extLst xmlns:a="http://schemas.openxmlformats.org/drawingml/2006/main">
               <a:ext uri="{FF2B5EF4-FFF2-40B4-BE49-F238E27FC236}">
-                <a16:creationId xmlns:a16="http://schemas.microsoft.com/office/drawing/2014/main" id="{31C849F8-9598-4ABE-9612-9B17E7ACD27B}"/>
+                <a16:creationId xmlns:a16="http://schemas.microsoft.com/office/drawing/2014/main" id="{030927C1-B591-467E-A7E3-F7A830A4DFD9}"/>
               </a:ext>
             </a:extLst>
           </p:cNvPr>
@@ -2786,7 +2987,7 @@
           <p:cNvPr id="2" name="">
             <a:extLst xmlns:a="http://schemas.openxmlformats.org/drawingml/2006/main">
               <a:ext uri="{FF2B5EF4-FFF2-40B4-BE49-F238E27FC236}">
-                <a16:creationId xmlns:a16="http://schemas.microsoft.com/office/drawing/2014/main" id="{F23DC1E9-7F53-4691-A898-C00512E78076}"/>
+                <a16:creationId xmlns:a16="http://schemas.microsoft.com/office/drawing/2014/main" id="{ADF29B1B-D043-4517-B7D6-3F8917F0992C}"/>
               </a:ext>
             </a:extLst>
           </p:cNvPr>
@@ -2836,7 +3037,7 @@
           <p:cNvPr id="3" name="">
             <a:extLst xmlns:a="http://schemas.openxmlformats.org/drawingml/2006/main">
               <a:ext uri="{FF2B5EF4-FFF2-40B4-BE49-F238E27FC236}">
-                <a16:creationId xmlns:a16="http://schemas.microsoft.com/office/drawing/2014/main" id="{7DE6D8C3-1966-4716-99E7-26503190B815}"/>
+                <a16:creationId xmlns:a16="http://schemas.microsoft.com/office/drawing/2014/main" id="{2688C95D-0D0E-4BF0-81B0-B77370F9935D}"/>
               </a:ext>
             </a:extLst>
           </p:cNvPr>
@@ -2867,7 +3068,7 @@
           <p:cNvPr id="4" name="">
             <a:extLst xmlns:a="http://schemas.openxmlformats.org/drawingml/2006/main">
               <a:ext uri="{FF2B5EF4-FFF2-40B4-BE49-F238E27FC236}">
-                <a16:creationId xmlns:a16="http://schemas.microsoft.com/office/drawing/2014/main" id="{2C0FF062-6702-40FC-9A86-C232DDC923F3}"/>
+                <a16:creationId xmlns:a16="http://schemas.microsoft.com/office/drawing/2014/main" id="{4F831067-B7E6-4A89-9C35-5541051E55EF}"/>
               </a:ext>
             </a:extLst>
           </p:cNvPr>
@@ -2917,7 +3118,7 @@
           <p:cNvPr id="5" name="">
             <a:extLst xmlns:a="http://schemas.openxmlformats.org/drawingml/2006/main">
               <a:ext uri="{FF2B5EF4-FFF2-40B4-BE49-F238E27FC236}">
-                <a16:creationId xmlns:a16="http://schemas.microsoft.com/office/drawing/2014/main" id="{0EAF4319-18FB-428E-870F-FC8136369311}"/>
+                <a16:creationId xmlns:a16="http://schemas.microsoft.com/office/drawing/2014/main" id="{A8F0ED91-F682-4E95-BC4E-9ABE1D8D7AF1}"/>
               </a:ext>
             </a:extLst>
           </p:cNvPr>
@@ -2967,7 +3168,7 @@
           <p:cNvPr id="6" name="">
             <a:extLst xmlns:a="http://schemas.openxmlformats.org/drawingml/2006/main">
               <a:ext uri="{FF2B5EF4-FFF2-40B4-BE49-F238E27FC236}">
-                <a16:creationId xmlns:a16="http://schemas.microsoft.com/office/drawing/2014/main" id="{29F63634-CBE5-48CF-8A38-0E2B97AD0202}"/>
+                <a16:creationId xmlns:a16="http://schemas.microsoft.com/office/drawing/2014/main" id="{054DE1A3-FAD8-4959-8FBD-9D184AB38E01}"/>
               </a:ext>
             </a:extLst>
           </p:cNvPr>
@@ -3000,7 +3201,7 @@
           <p:cNvPr id="7" name="">
             <a:extLst xmlns:a="http://schemas.openxmlformats.org/drawingml/2006/main">
               <a:ext uri="{FF2B5EF4-FFF2-40B4-BE49-F238E27FC236}">
-                <a16:creationId xmlns:a16="http://schemas.microsoft.com/office/drawing/2014/main" id="{A6ADAB1D-7602-4B8C-BBBE-2E3E341AF0B2}"/>
+                <a16:creationId xmlns:a16="http://schemas.microsoft.com/office/drawing/2014/main" id="{EB0D5BD4-A4DF-4531-B2CC-6AED1DAF3F53}"/>
               </a:ext>
             </a:extLst>
           </p:cNvPr>
@@ -3084,7 +3285,7 @@
           <p:cNvPr id="8" name="">
             <a:extLst xmlns:a="http://schemas.openxmlformats.org/drawingml/2006/main">
               <a:ext uri="{FF2B5EF4-FFF2-40B4-BE49-F238E27FC236}">
-                <a16:creationId xmlns:a16="http://schemas.microsoft.com/office/drawing/2014/main" id="{9EE9A879-F126-42EC-A1F8-71C5431B826B}"/>
+                <a16:creationId xmlns:a16="http://schemas.microsoft.com/office/drawing/2014/main" id="{C437285D-E20E-42C2-A31F-52C41C71CFD8}"/>
               </a:ext>
             </a:extLst>
           </p:cNvPr>
@@ -3115,7 +3316,7 @@
           <p:cNvPr id="9" name="">
             <a:extLst xmlns:a="http://schemas.openxmlformats.org/drawingml/2006/main">
               <a:ext uri="{FF2B5EF4-FFF2-40B4-BE49-F238E27FC236}">
-                <a16:creationId xmlns:a16="http://schemas.microsoft.com/office/drawing/2014/main" id="{650B5E00-41B3-45C0-8144-DE47D99B9B2C}"/>
+                <a16:creationId xmlns:a16="http://schemas.microsoft.com/office/drawing/2014/main" id="{10943E37-1009-42DD-829A-A96706B879A5}"/>
               </a:ext>
             </a:extLst>
           </p:cNvPr>
@@ -3165,7 +3366,7 @@
           <p:cNvPr id="10" name="">
             <a:extLst xmlns:a="http://schemas.openxmlformats.org/drawingml/2006/main">
               <a:ext uri="{FF2B5EF4-FFF2-40B4-BE49-F238E27FC236}">
-                <a16:creationId xmlns:a16="http://schemas.microsoft.com/office/drawing/2014/main" id="{2B833A0A-1E0F-4356-AF0B-EC1F76283F9D}"/>
+                <a16:creationId xmlns:a16="http://schemas.microsoft.com/office/drawing/2014/main" id="{D6A3C34F-E7D2-41EA-A9FE-83E53C8038F5}"/>
               </a:ext>
             </a:extLst>
           </p:cNvPr>
@@ -3215,7 +3416,7 @@
           <p:cNvPr id="11" name="">
             <a:extLst xmlns:a="http://schemas.openxmlformats.org/drawingml/2006/main">
               <a:ext uri="{FF2B5EF4-FFF2-40B4-BE49-F238E27FC236}">
-                <a16:creationId xmlns:a16="http://schemas.microsoft.com/office/drawing/2014/main" id="{BAF43514-D3B0-49A8-B987-7E572D8DDD6F}"/>
+                <a16:creationId xmlns:a16="http://schemas.microsoft.com/office/drawing/2014/main" id="{6088EB04-824C-43A3-B909-31B0775C2165}"/>
               </a:ext>
             </a:extLst>
           </p:cNvPr>
@@ -3248,7 +3449,7 @@
           <p:cNvPr id="12" name="">
             <a:extLst xmlns:a="http://schemas.openxmlformats.org/drawingml/2006/main">
               <a:ext uri="{FF2B5EF4-FFF2-40B4-BE49-F238E27FC236}">
-                <a16:creationId xmlns:a16="http://schemas.microsoft.com/office/drawing/2014/main" id="{7A1EC935-23EC-4311-ACD1-761DD31E822B}"/>
+                <a16:creationId xmlns:a16="http://schemas.microsoft.com/office/drawing/2014/main" id="{39DA7F3B-08C9-432B-9C7C-9C1B1399CF5F}"/>
               </a:ext>
             </a:extLst>
           </p:cNvPr>
@@ -3332,7 +3533,7 @@
           <p:cNvPr id="13" name="">
             <a:extLst xmlns:a="http://schemas.openxmlformats.org/drawingml/2006/main">
               <a:ext uri="{FF2B5EF4-FFF2-40B4-BE49-F238E27FC236}">
-                <a16:creationId xmlns:a16="http://schemas.microsoft.com/office/drawing/2014/main" id="{096DC8E0-20F6-48D6-B1AE-F4E7DAAD9524}"/>
+                <a16:creationId xmlns:a16="http://schemas.microsoft.com/office/drawing/2014/main" id="{D4836F7D-55E5-4039-B252-C6A674366CBB}"/>
               </a:ext>
             </a:extLst>
           </p:cNvPr>
@@ -3365,7 +3566,7 @@
           <p:cNvPr id="14" name="">
             <a:extLst xmlns:a="http://schemas.openxmlformats.org/drawingml/2006/main">
               <a:ext uri="{FF2B5EF4-FFF2-40B4-BE49-F238E27FC236}">
-                <a16:creationId xmlns:a16="http://schemas.microsoft.com/office/drawing/2014/main" id="{C274115D-2897-49CA-8340-152DCD009C76}"/>
+                <a16:creationId xmlns:a16="http://schemas.microsoft.com/office/drawing/2014/main" id="{6FF7D8EA-D363-435D-BF3D-9E0630F31B6C}"/>
               </a:ext>
             </a:extLst>
           </p:cNvPr>
@@ -3415,7 +3616,7 @@
           <p:cNvPr id="15" name="">
             <a:extLst xmlns:a="http://schemas.openxmlformats.org/drawingml/2006/main">
               <a:ext uri="{FF2B5EF4-FFF2-40B4-BE49-F238E27FC236}">
-                <a16:creationId xmlns:a16="http://schemas.microsoft.com/office/drawing/2014/main" id="{5A913F0F-4270-4A18-BF88-D3C4145620D9}"/>
+                <a16:creationId xmlns:a16="http://schemas.microsoft.com/office/drawing/2014/main" id="{2370AE69-4A21-4ED0-B5E8-9EEAFDC68FB6}"/>
               </a:ext>
             </a:extLst>
           </p:cNvPr>
@@ -3463,7 +3664,7 @@
     </p:spTree>
     <p:extLst>
       <p:ext uri="{BB962C8B-B14F-4D97-AF65-F5344CB8AC3E}">
-        <p14:creationId xmlns:p14="http://schemas.microsoft.com/office/powerpoint/2010/main" val="1796219092"/>
+        <p14:creationId xmlns:p14="http://schemas.microsoft.com/office/powerpoint/2010/main" val="1538936470"/>
       </p:ext>
     </p:extLst>
   </p:cSld>
@@ -3494,7 +3695,7 @@
           <p:cNvPr id="1" name="">
             <a:extLst xmlns:a="http://schemas.openxmlformats.org/drawingml/2006/main">
               <a:ext uri="{FF2B5EF4-FFF2-40B4-BE49-F238E27FC236}">
-                <a16:creationId xmlns:a16="http://schemas.microsoft.com/office/drawing/2014/main" id="{C074D0E4-63C2-468B-AAE7-A7765F61C0CC}"/>
+                <a16:creationId xmlns:a16="http://schemas.microsoft.com/office/drawing/2014/main" id="{52F83C82-7F89-4520-B91C-1127705E6ACA}"/>
               </a:ext>
             </a:extLst>
           </p:cNvPr>
@@ -3544,7 +3745,7 @@
           <p:cNvPr id="2" name="">
             <a:extLst xmlns:a="http://schemas.openxmlformats.org/drawingml/2006/main">
               <a:ext uri="{FF2B5EF4-FFF2-40B4-BE49-F238E27FC236}">
-                <a16:creationId xmlns:a16="http://schemas.microsoft.com/office/drawing/2014/main" id="{BB2ECB8B-7FDE-4887-BDBE-7F25D5DF6A34}"/>
+                <a16:creationId xmlns:a16="http://schemas.microsoft.com/office/drawing/2014/main" id="{881B8218-B697-4A9C-87D7-3E99A96DE911}"/>
               </a:ext>
             </a:extLst>
           </p:cNvPr>
@@ -3594,7 +3795,7 @@
           <p:cNvPr id="3" name="">
             <a:extLst xmlns:a="http://schemas.openxmlformats.org/drawingml/2006/main">
               <a:ext uri="{FF2B5EF4-FFF2-40B4-BE49-F238E27FC236}">
-                <a16:creationId xmlns:a16="http://schemas.microsoft.com/office/drawing/2014/main" id="{708FB12C-58BC-4A9C-964C-2E9F429AB7C7}"/>
+                <a16:creationId xmlns:a16="http://schemas.microsoft.com/office/drawing/2014/main" id="{689E8159-CEAF-446E-B9D8-70AC9B0A4829}"/>
               </a:ext>
             </a:extLst>
           </p:cNvPr>
@@ -3644,7 +3845,7 @@
           <p:cNvPr id="4" name="">
             <a:extLst xmlns:a="http://schemas.openxmlformats.org/drawingml/2006/main">
               <a:ext uri="{FF2B5EF4-FFF2-40B4-BE49-F238E27FC236}">
-                <a16:creationId xmlns:a16="http://schemas.microsoft.com/office/drawing/2014/main" id="{9632FB69-228E-45DE-98AE-E2168019D217}"/>
+                <a16:creationId xmlns:a16="http://schemas.microsoft.com/office/drawing/2014/main" id="{5CF8AB9B-8FBB-4B03-8341-915C05AE2266}"/>
               </a:ext>
             </a:extLst>
           </p:cNvPr>
@@ -3675,7 +3876,7 @@
           <p:cNvPr id="5" name="">
             <a:extLst xmlns:a="http://schemas.openxmlformats.org/drawingml/2006/main">
               <a:ext uri="{FF2B5EF4-FFF2-40B4-BE49-F238E27FC236}">
-                <a16:creationId xmlns:a16="http://schemas.microsoft.com/office/drawing/2014/main" id="{28830057-1FCE-4459-836A-52277AB6D4E3}"/>
+                <a16:creationId xmlns:a16="http://schemas.microsoft.com/office/drawing/2014/main" id="{A78F59B0-31A2-4CFC-AA39-9E7170165469}"/>
               </a:ext>
             </a:extLst>
           </p:cNvPr>
@@ -3725,7 +3926,7 @@
           <p:cNvPr id="6" name="">
             <a:extLst xmlns:a="http://schemas.openxmlformats.org/drawingml/2006/main">
               <a:ext uri="{FF2B5EF4-FFF2-40B4-BE49-F238E27FC236}">
-                <a16:creationId xmlns:a16="http://schemas.microsoft.com/office/drawing/2014/main" id="{FB927DDC-8B37-4626-A92B-F601FCED651F}"/>
+                <a16:creationId xmlns:a16="http://schemas.microsoft.com/office/drawing/2014/main" id="{3AC3DC6E-7853-443B-A4F7-A376BD88A2E8}"/>
               </a:ext>
             </a:extLst>
           </p:cNvPr>
@@ -3775,7 +3976,7 @@
           <p:cNvPr id="7" name="">
             <a:extLst xmlns:a="http://schemas.openxmlformats.org/drawingml/2006/main">
               <a:ext uri="{FF2B5EF4-FFF2-40B4-BE49-F238E27FC236}">
-                <a16:creationId xmlns:a16="http://schemas.microsoft.com/office/drawing/2014/main" id="{6ACFD86F-0A61-4593-9DF9-7601A6260E08}"/>
+                <a16:creationId xmlns:a16="http://schemas.microsoft.com/office/drawing/2014/main" id="{3ADABA3D-182E-43E4-9C9D-0C78AC26B666}"/>
               </a:ext>
             </a:extLst>
           </p:cNvPr>
@@ -3806,7 +4007,7 @@
           <p:cNvPr id="8" name="">
             <a:extLst xmlns:a="http://schemas.openxmlformats.org/drawingml/2006/main">
               <a:ext uri="{FF2B5EF4-FFF2-40B4-BE49-F238E27FC236}">
-                <a16:creationId xmlns:a16="http://schemas.microsoft.com/office/drawing/2014/main" id="{2B00BCBB-9AF9-4633-B8DB-0379154AEC59}"/>
+                <a16:creationId xmlns:a16="http://schemas.microsoft.com/office/drawing/2014/main" id="{90873525-D500-45E2-B335-23DD64952AA9}"/>
               </a:ext>
             </a:extLst>
           </p:cNvPr>
@@ -3856,7 +4057,7 @@
           <p:cNvPr id="9" name="">
             <a:extLst xmlns:a="http://schemas.openxmlformats.org/drawingml/2006/main">
               <a:ext uri="{FF2B5EF4-FFF2-40B4-BE49-F238E27FC236}">
-                <a16:creationId xmlns:a16="http://schemas.microsoft.com/office/drawing/2014/main" id="{C978D559-660E-4411-86D1-853AB9E7D8B1}"/>
+                <a16:creationId xmlns:a16="http://schemas.microsoft.com/office/drawing/2014/main" id="{FE893C19-35FF-45E4-86AA-1FE3245E7165}"/>
               </a:ext>
             </a:extLst>
           </p:cNvPr>
@@ -3906,7 +4107,7 @@
           <p:cNvPr id="10" name="">
             <a:extLst xmlns:a="http://schemas.openxmlformats.org/drawingml/2006/main">
               <a:ext uri="{FF2B5EF4-FFF2-40B4-BE49-F238E27FC236}">
-                <a16:creationId xmlns:a16="http://schemas.microsoft.com/office/drawing/2014/main" id="{29C036CC-5B30-45FD-8751-EAC4F2C37E61}"/>
+                <a16:creationId xmlns:a16="http://schemas.microsoft.com/office/drawing/2014/main" id="{26CA221D-22EF-40C0-8528-F26535DF711B}"/>
               </a:ext>
             </a:extLst>
           </p:cNvPr>
@@ -3937,7 +4138,7 @@
           <p:cNvPr id="11" name="">
             <a:extLst xmlns:a="http://schemas.openxmlformats.org/drawingml/2006/main">
               <a:ext uri="{FF2B5EF4-FFF2-40B4-BE49-F238E27FC236}">
-                <a16:creationId xmlns:a16="http://schemas.microsoft.com/office/drawing/2014/main" id="{F131D452-8118-4B29-A77C-09B24827E11D}"/>
+                <a16:creationId xmlns:a16="http://schemas.microsoft.com/office/drawing/2014/main" id="{2AB6D088-FAF2-464F-9B53-4AABBAA8CFBC}"/>
               </a:ext>
             </a:extLst>
           </p:cNvPr>
@@ -3987,7 +4188,7 @@
           <p:cNvPr id="12" name="">
             <a:extLst xmlns:a="http://schemas.openxmlformats.org/drawingml/2006/main">
               <a:ext uri="{FF2B5EF4-FFF2-40B4-BE49-F238E27FC236}">
-                <a16:creationId xmlns:a16="http://schemas.microsoft.com/office/drawing/2014/main" id="{AB05E70E-0185-4024-9D2D-B9B7C3F29C09}"/>
+                <a16:creationId xmlns:a16="http://schemas.microsoft.com/office/drawing/2014/main" id="{57502089-2B53-4049-92FC-2AA28F765B42}"/>
               </a:ext>
             </a:extLst>
           </p:cNvPr>
@@ -4037,7 +4238,7 @@
           <p:cNvPr id="13" name="">
             <a:extLst xmlns:a="http://schemas.openxmlformats.org/drawingml/2006/main">
               <a:ext uri="{FF2B5EF4-FFF2-40B4-BE49-F238E27FC236}">
-                <a16:creationId xmlns:a16="http://schemas.microsoft.com/office/drawing/2014/main" id="{8AC318B9-490D-44FD-B791-5F975B150979}"/>
+                <a16:creationId xmlns:a16="http://schemas.microsoft.com/office/drawing/2014/main" id="{500D4293-975B-4AA2-8B51-E57AF79166A3}"/>
               </a:ext>
             </a:extLst>
           </p:cNvPr>
@@ -4070,7 +4271,7 @@
           <p:cNvPr id="14" name="">
             <a:extLst xmlns:a="http://schemas.openxmlformats.org/drawingml/2006/main">
               <a:ext uri="{FF2B5EF4-FFF2-40B4-BE49-F238E27FC236}">
-                <a16:creationId xmlns:a16="http://schemas.microsoft.com/office/drawing/2014/main" id="{2AFB8DCC-4F08-4D17-A34E-A7027459E120}"/>
+                <a16:creationId xmlns:a16="http://schemas.microsoft.com/office/drawing/2014/main" id="{AAD0C934-4448-45A4-BFD4-3F0D5F292672}"/>
               </a:ext>
             </a:extLst>
           </p:cNvPr>
@@ -4120,7 +4321,7 @@
           <p:cNvPr id="15" name="">
             <a:extLst xmlns:a="http://schemas.openxmlformats.org/drawingml/2006/main">
               <a:ext uri="{FF2B5EF4-FFF2-40B4-BE49-F238E27FC236}">
-                <a16:creationId xmlns:a16="http://schemas.microsoft.com/office/drawing/2014/main" id="{7B403214-66D2-48D8-89D6-5989477D1CFB}"/>
+                <a16:creationId xmlns:a16="http://schemas.microsoft.com/office/drawing/2014/main" id="{2EB1F151-A73A-4506-8E67-3C3F82E6605E}"/>
               </a:ext>
             </a:extLst>
           </p:cNvPr>
@@ -4168,7 +4369,7 @@
     </p:spTree>
     <p:extLst>
       <p:ext uri="{BB962C8B-B14F-4D97-AF65-F5344CB8AC3E}">
-        <p14:creationId xmlns:p14="http://schemas.microsoft.com/office/powerpoint/2010/main" val="1378373182"/>
+        <p14:creationId xmlns:p14="http://schemas.microsoft.com/office/powerpoint/2010/main" val="1321850849"/>
       </p:ext>
     </p:extLst>
   </p:cSld>
@@ -4199,7 +4400,7 @@
           <p:cNvPr id="1" name="">
             <a:extLst xmlns:a="http://schemas.openxmlformats.org/drawingml/2006/main">
               <a:ext uri="{FF2B5EF4-FFF2-40B4-BE49-F238E27FC236}">
-                <a16:creationId xmlns:a16="http://schemas.microsoft.com/office/drawing/2014/main" id="{63CDA70D-9B1E-42E5-9EEA-021A0C589D10}"/>
+                <a16:creationId xmlns:a16="http://schemas.microsoft.com/office/drawing/2014/main" id="{D762D62A-DBEF-493A-94A3-A330DCAD4EEB}"/>
               </a:ext>
             </a:extLst>
           </p:cNvPr>
@@ -4249,7 +4450,7 @@
           <p:cNvPr id="2" name="">
             <a:extLst xmlns:a="http://schemas.openxmlformats.org/drawingml/2006/main">
               <a:ext uri="{FF2B5EF4-FFF2-40B4-BE49-F238E27FC236}">
-                <a16:creationId xmlns:a16="http://schemas.microsoft.com/office/drawing/2014/main" id="{888D2678-6AEE-41FA-B1E8-EE7484226333}"/>
+                <a16:creationId xmlns:a16="http://schemas.microsoft.com/office/drawing/2014/main" id="{CC5EDC3A-2426-4B2B-9200-F39C88776B0D}"/>
               </a:ext>
             </a:extLst>
           </p:cNvPr>
@@ -4299,7 +4500,7 @@
           <p:cNvPr id="3" name="">
             <a:extLst xmlns:a="http://schemas.openxmlformats.org/drawingml/2006/main">
               <a:ext uri="{FF2B5EF4-FFF2-40B4-BE49-F238E27FC236}">
-                <a16:creationId xmlns:a16="http://schemas.microsoft.com/office/drawing/2014/main" id="{CFF157DC-91C2-4C3B-A9B9-B71615DAD9C6}"/>
+                <a16:creationId xmlns:a16="http://schemas.microsoft.com/office/drawing/2014/main" id="{DA8EE7E0-D142-4A54-82DC-C9066748FD9D}"/>
               </a:ext>
             </a:extLst>
           </p:cNvPr>
@@ -4349,7 +4550,7 @@
           <p:cNvPr id="4" name="">
             <a:extLst xmlns:a="http://schemas.openxmlformats.org/drawingml/2006/main">
               <a:ext uri="{FF2B5EF4-FFF2-40B4-BE49-F238E27FC236}">
-                <a16:creationId xmlns:a16="http://schemas.microsoft.com/office/drawing/2014/main" id="{DCD41C10-6FBC-46FB-BA7D-152863C4A558}"/>
+                <a16:creationId xmlns:a16="http://schemas.microsoft.com/office/drawing/2014/main" id="{9C616F95-5C6F-423F-B31F-E50739F006DD}"/>
               </a:ext>
             </a:extLst>
           </p:cNvPr>
@@ -4399,7 +4600,7 @@
           <p:cNvPr id="5" name="">
             <a:extLst xmlns:a="http://schemas.openxmlformats.org/drawingml/2006/main">
               <a:ext uri="{FF2B5EF4-FFF2-40B4-BE49-F238E27FC236}">
-                <a16:creationId xmlns:a16="http://schemas.microsoft.com/office/drawing/2014/main" id="{E59DAAF2-AB70-4BEE-B6D6-466EE6D99641}"/>
+                <a16:creationId xmlns:a16="http://schemas.microsoft.com/office/drawing/2014/main" id="{9442DEC8-E3A0-410C-A374-DF1561BD44AF}"/>
               </a:ext>
             </a:extLst>
           </p:cNvPr>
@@ -4534,7 +4735,7 @@
           <p:cNvPr id="6" name="">
             <a:extLst xmlns:a="http://schemas.openxmlformats.org/drawingml/2006/main">
               <a:ext uri="{FF2B5EF4-FFF2-40B4-BE49-F238E27FC236}">
-                <a16:creationId xmlns:a16="http://schemas.microsoft.com/office/drawing/2014/main" id="{DC51155F-4ECA-4122-8855-27B56E1779AA}"/>
+                <a16:creationId xmlns:a16="http://schemas.microsoft.com/office/drawing/2014/main" id="{057B5D93-F789-4C05-A3E7-36AB9E39322E}"/>
               </a:ext>
             </a:extLst>
           </p:cNvPr>
@@ -4584,7 +4785,7 @@
           <p:cNvPr id="7" name="">
             <a:extLst xmlns:a="http://schemas.openxmlformats.org/drawingml/2006/main">
               <a:ext uri="{FF2B5EF4-FFF2-40B4-BE49-F238E27FC236}">
-                <a16:creationId xmlns:a16="http://schemas.microsoft.com/office/drawing/2014/main" id="{6D00DABD-3D81-44BE-8B47-58BA87816351}"/>
+                <a16:creationId xmlns:a16="http://schemas.microsoft.com/office/drawing/2014/main" id="{FF8E2344-75FD-4366-A46B-A04AF250B14D}"/>
               </a:ext>
             </a:extLst>
           </p:cNvPr>
@@ -4615,7 +4816,7 @@
           <p:cNvPr id="8" name="">
             <a:extLst xmlns:a="http://schemas.openxmlformats.org/drawingml/2006/main">
               <a:ext uri="{FF2B5EF4-FFF2-40B4-BE49-F238E27FC236}">
-                <a16:creationId xmlns:a16="http://schemas.microsoft.com/office/drawing/2014/main" id="{40F0E4BE-8F5F-496C-BBCA-98CF51816288}"/>
+                <a16:creationId xmlns:a16="http://schemas.microsoft.com/office/drawing/2014/main" id="{25333B13-B1BF-4733-8391-B9D2C32B7EFF}"/>
               </a:ext>
             </a:extLst>
           </p:cNvPr>
@@ -4665,7 +4866,7 @@
           <p:cNvPr id="9" name="">
             <a:extLst xmlns:a="http://schemas.openxmlformats.org/drawingml/2006/main">
               <a:ext uri="{FF2B5EF4-FFF2-40B4-BE49-F238E27FC236}">
-                <a16:creationId xmlns:a16="http://schemas.microsoft.com/office/drawing/2014/main" id="{7108CC7D-B255-4627-B465-01335CF1AEB9}"/>
+                <a16:creationId xmlns:a16="http://schemas.microsoft.com/office/drawing/2014/main" id="{B30FD037-CFB4-4293-85BC-C171E37FD64E}"/>
               </a:ext>
             </a:extLst>
           </p:cNvPr>
@@ -4696,7 +4897,7 @@
           <p:cNvPr id="10" name="">
             <a:extLst xmlns:a="http://schemas.openxmlformats.org/drawingml/2006/main">
               <a:ext uri="{FF2B5EF4-FFF2-40B4-BE49-F238E27FC236}">
-                <a16:creationId xmlns:a16="http://schemas.microsoft.com/office/drawing/2014/main" id="{53D7AF8D-F73E-462C-BD1F-1E2EC6174FA1}"/>
+                <a16:creationId xmlns:a16="http://schemas.microsoft.com/office/drawing/2014/main" id="{52D846FC-0DAA-4972-A5E3-F4281DD467A2}"/>
               </a:ext>
             </a:extLst>
           </p:cNvPr>
@@ -4746,7 +4947,7 @@
           <p:cNvPr id="11" name="">
             <a:extLst xmlns:a="http://schemas.openxmlformats.org/drawingml/2006/main">
               <a:ext uri="{FF2B5EF4-FFF2-40B4-BE49-F238E27FC236}">
-                <a16:creationId xmlns:a16="http://schemas.microsoft.com/office/drawing/2014/main" id="{0EB3F104-F8F6-4165-9D9F-521F33A2A08E}"/>
+                <a16:creationId xmlns:a16="http://schemas.microsoft.com/office/drawing/2014/main" id="{035AE3C1-E16E-4EDB-8B6A-48B8B5D063EF}"/>
               </a:ext>
             </a:extLst>
           </p:cNvPr>
@@ -4796,7 +4997,7 @@
           <p:cNvPr id="12" name="">
             <a:extLst xmlns:a="http://schemas.openxmlformats.org/drawingml/2006/main">
               <a:ext uri="{FF2B5EF4-FFF2-40B4-BE49-F238E27FC236}">
-                <a16:creationId xmlns:a16="http://schemas.microsoft.com/office/drawing/2014/main" id="{B5325ABF-3165-448A-82E5-CA37589A307E}"/>
+                <a16:creationId xmlns:a16="http://schemas.microsoft.com/office/drawing/2014/main" id="{79AAA5A5-ECB7-476E-8297-9185C455BE8F}"/>
               </a:ext>
             </a:extLst>
           </p:cNvPr>
@@ -4829,7 +5030,7 @@
           <p:cNvPr id="13" name="">
             <a:extLst xmlns:a="http://schemas.openxmlformats.org/drawingml/2006/main">
               <a:ext uri="{FF2B5EF4-FFF2-40B4-BE49-F238E27FC236}">
-                <a16:creationId xmlns:a16="http://schemas.microsoft.com/office/drawing/2014/main" id="{A85FB89B-8A86-44FF-8E1E-61D87FD45E7E}"/>
+                <a16:creationId xmlns:a16="http://schemas.microsoft.com/office/drawing/2014/main" id="{7D1AA4DA-5151-45D5-A123-DE2A3ACEB813}"/>
               </a:ext>
             </a:extLst>
           </p:cNvPr>
@@ -4879,7 +5080,7 @@
           <p:cNvPr id="14" name="">
             <a:extLst xmlns:a="http://schemas.openxmlformats.org/drawingml/2006/main">
               <a:ext uri="{FF2B5EF4-FFF2-40B4-BE49-F238E27FC236}">
-                <a16:creationId xmlns:a16="http://schemas.microsoft.com/office/drawing/2014/main" id="{CED9DCDC-2F32-40AF-BD8C-A615A07F6C47}"/>
+                <a16:creationId xmlns:a16="http://schemas.microsoft.com/office/drawing/2014/main" id="{6CD1DB93-E37C-400A-9D51-3A3AF896ED21}"/>
               </a:ext>
             </a:extLst>
           </p:cNvPr>
@@ -4927,7 +5128,7 @@
     </p:spTree>
     <p:extLst>
       <p:ext uri="{BB962C8B-B14F-4D97-AF65-F5344CB8AC3E}">
-        <p14:creationId xmlns:p14="http://schemas.microsoft.com/office/powerpoint/2010/main" val="1205531901"/>
+        <p14:creationId xmlns:p14="http://schemas.microsoft.com/office/powerpoint/2010/main" val="845771341"/>
       </p:ext>
     </p:extLst>
   </p:cSld>
@@ -4958,7 +5159,7 @@
           <p:cNvPr id="1" name="">
             <a:extLst xmlns:a="http://schemas.openxmlformats.org/drawingml/2006/main">
               <a:ext uri="{FF2B5EF4-FFF2-40B4-BE49-F238E27FC236}">
-                <a16:creationId xmlns:a16="http://schemas.microsoft.com/office/drawing/2014/main" id="{E4726837-5104-4B1B-AB57-2CFB59283CEC}"/>
+                <a16:creationId xmlns:a16="http://schemas.microsoft.com/office/drawing/2014/main" id="{102BA0AA-17FA-4180-948B-799131C97A2A}"/>
               </a:ext>
             </a:extLst>
           </p:cNvPr>
@@ -5008,7 +5209,7 @@
           <p:cNvPr id="2" name="">
             <a:extLst xmlns:a="http://schemas.openxmlformats.org/drawingml/2006/main">
               <a:ext uri="{FF2B5EF4-FFF2-40B4-BE49-F238E27FC236}">
-                <a16:creationId xmlns:a16="http://schemas.microsoft.com/office/drawing/2014/main" id="{EBF578AC-2DC7-4E89-9DDE-36AA24F9CE5D}"/>
+                <a16:creationId xmlns:a16="http://schemas.microsoft.com/office/drawing/2014/main" id="{12D3ACF8-C055-404B-9617-32A8F5121BDD}"/>
               </a:ext>
             </a:extLst>
           </p:cNvPr>
@@ -5058,7 +5259,7 @@
           <p:cNvPr id="3" name="">
             <a:extLst xmlns:a="http://schemas.openxmlformats.org/drawingml/2006/main">
               <a:ext uri="{FF2B5EF4-FFF2-40B4-BE49-F238E27FC236}">
-                <a16:creationId xmlns:a16="http://schemas.microsoft.com/office/drawing/2014/main" id="{F0755CFB-22E7-4ECA-94C8-0AA74AA84E96}"/>
+                <a16:creationId xmlns:a16="http://schemas.microsoft.com/office/drawing/2014/main" id="{B1F93CEF-F897-4BC5-9429-B3F95A2F488F}"/>
               </a:ext>
             </a:extLst>
           </p:cNvPr>
@@ -5108,7 +5309,7 @@
           <p:cNvPr id="4" name="">
             <a:extLst xmlns:a="http://schemas.openxmlformats.org/drawingml/2006/main">
               <a:ext uri="{FF2B5EF4-FFF2-40B4-BE49-F238E27FC236}">
-                <a16:creationId xmlns:a16="http://schemas.microsoft.com/office/drawing/2014/main" id="{F74F3A9C-1326-4797-B6C2-52DACAC984FE}"/>
+                <a16:creationId xmlns:a16="http://schemas.microsoft.com/office/drawing/2014/main" id="{627914DC-A7ED-4363-A285-494665F604FA}"/>
               </a:ext>
             </a:extLst>
           </p:cNvPr>
@@ -5226,7 +5427,7 @@
           <p:cNvPr id="5" name="">
             <a:extLst xmlns:a="http://schemas.openxmlformats.org/drawingml/2006/main">
               <a:ext uri="{FF2B5EF4-FFF2-40B4-BE49-F238E27FC236}">
-                <a16:creationId xmlns:a16="http://schemas.microsoft.com/office/drawing/2014/main" id="{816B64A0-9C19-42E0-AD28-EB2DE4CC726D}"/>
+                <a16:creationId xmlns:a16="http://schemas.microsoft.com/office/drawing/2014/main" id="{78223C3F-6015-4A8F-9612-054C49CAF8DC}"/>
               </a:ext>
             </a:extLst>
           </p:cNvPr>
@@ -5276,7 +5477,7 @@
           <p:cNvPr id="6" name="">
             <a:extLst xmlns:a="http://schemas.openxmlformats.org/drawingml/2006/main">
               <a:ext uri="{FF2B5EF4-FFF2-40B4-BE49-F238E27FC236}">
-                <a16:creationId xmlns:a16="http://schemas.microsoft.com/office/drawing/2014/main" id="{FD9009D7-663B-4938-AEF3-8581093EC142}"/>
+                <a16:creationId xmlns:a16="http://schemas.microsoft.com/office/drawing/2014/main" id="{CF91AB23-8191-498D-B867-1B3FD2DEC9FD}"/>
               </a:ext>
             </a:extLst>
           </p:cNvPr>
@@ -5377,7 +5578,7 @@
           <p:cNvPr id="7" name="">
             <a:extLst xmlns:a="http://schemas.openxmlformats.org/drawingml/2006/main">
               <a:ext uri="{FF2B5EF4-FFF2-40B4-BE49-F238E27FC236}">
-                <a16:creationId xmlns:a16="http://schemas.microsoft.com/office/drawing/2014/main" id="{1A8F0BAE-D7AF-43ED-9D55-507CB67E35F8}"/>
+                <a16:creationId xmlns:a16="http://schemas.microsoft.com/office/drawing/2014/main" id="{9A1825F4-4E46-4EB0-8433-FE11B1832A55}"/>
               </a:ext>
             </a:extLst>
           </p:cNvPr>
@@ -5408,7 +5609,7 @@
           <p:cNvPr id="8" name="">
             <a:extLst xmlns:a="http://schemas.openxmlformats.org/drawingml/2006/main">
               <a:ext uri="{FF2B5EF4-FFF2-40B4-BE49-F238E27FC236}">
-                <a16:creationId xmlns:a16="http://schemas.microsoft.com/office/drawing/2014/main" id="{7F57A714-0C02-4E5D-87E1-1C75946BA20A}"/>
+                <a16:creationId xmlns:a16="http://schemas.microsoft.com/office/drawing/2014/main" id="{AF91B3D6-F0F6-4F11-B721-B966EAB4E00E}"/>
               </a:ext>
             </a:extLst>
           </p:cNvPr>
@@ -5458,7 +5659,7 @@
           <p:cNvPr id="9" name="">
             <a:extLst xmlns:a="http://schemas.openxmlformats.org/drawingml/2006/main">
               <a:ext uri="{FF2B5EF4-FFF2-40B4-BE49-F238E27FC236}">
-                <a16:creationId xmlns:a16="http://schemas.microsoft.com/office/drawing/2014/main" id="{5004FB16-41B5-48CC-96D6-2F4F0A16879C}"/>
+                <a16:creationId xmlns:a16="http://schemas.microsoft.com/office/drawing/2014/main" id="{EE971B65-C730-4A8A-871D-051C4D9A22DE}"/>
               </a:ext>
             </a:extLst>
           </p:cNvPr>
@@ -5491,7 +5692,7 @@
           <p:cNvPr id="10" name="">
             <a:extLst xmlns:a="http://schemas.openxmlformats.org/drawingml/2006/main">
               <a:ext uri="{FF2B5EF4-FFF2-40B4-BE49-F238E27FC236}">
-                <a16:creationId xmlns:a16="http://schemas.microsoft.com/office/drawing/2014/main" id="{E666EAF9-92D5-48EE-B9ED-479D92839304}"/>
+                <a16:creationId xmlns:a16="http://schemas.microsoft.com/office/drawing/2014/main" id="{228FF417-6871-4C9F-8AFE-06AAAE4D7F9E}"/>
               </a:ext>
             </a:extLst>
           </p:cNvPr>
@@ -5541,7 +5742,7 @@
           <p:cNvPr id="11" name="">
             <a:extLst xmlns:a="http://schemas.openxmlformats.org/drawingml/2006/main">
               <a:ext uri="{FF2B5EF4-FFF2-40B4-BE49-F238E27FC236}">
-                <a16:creationId xmlns:a16="http://schemas.microsoft.com/office/drawing/2014/main" id="{04057D34-E17C-44CB-B5CD-876F080BE2EB}"/>
+                <a16:creationId xmlns:a16="http://schemas.microsoft.com/office/drawing/2014/main" id="{8266AD29-13F9-4890-B8D9-4205D7AE616D}"/>
               </a:ext>
             </a:extLst>
           </p:cNvPr>
@@ -5589,7 +5790,2199 @@
     </p:spTree>
     <p:extLst>
       <p:ext uri="{BB962C8B-B14F-4D97-AF65-F5344CB8AC3E}">
-        <p14:creationId xmlns:p14="http://schemas.microsoft.com/office/powerpoint/2010/main" val="187868989"/>
+        <p14:creationId xmlns:p14="http://schemas.microsoft.com/office/powerpoint/2010/main" val="466536398"/>
+      </p:ext>
+    </p:extLst>
+  </p:cSld>
+</p:sld>
+</file>
+
+<file path=ppt/slides/slide7.xml><?xml version="1.0" encoding="utf-8"?>
+<p:sld xmlns:p="http://schemas.openxmlformats.org/presentationml/2006/main">
+  <p:cSld>
+    <p:bg>
+      <p:bgPr>
+        <a:solidFill xmlns:a="http://schemas.openxmlformats.org/drawingml/2006/main">
+          <a:srgbClr val="FFFFFF"/>
+        </a:solidFill>
+      </p:bgPr>
+    </p:bg>
+    <p:spTree>
+      <p:nvGrpSpPr>
+        <p:cNvPr id="1" name=""/>
+        <p:cNvGrpSpPr/>
+        <p:nvPr/>
+      </p:nvGrpSpPr>
+      <p:grpSpPr>
+        <a:xfrm xmlns:a="http://schemas.openxmlformats.org/drawingml/2006/main"/>
+      </p:grpSpPr>
+      <p:sp>
+        <p:nvSpPr>
+          <p:cNvPr id="1" name="">
+            <a:extLst xmlns:a="http://schemas.openxmlformats.org/drawingml/2006/main">
+              <a:ext uri="{FF2B5EF4-FFF2-40B4-BE49-F238E27FC236}">
+                <a16:creationId xmlns:a16="http://schemas.microsoft.com/office/drawing/2014/main" id="{F0ABF19A-EA04-4346-959D-1026C3329AF7}"/>
+              </a:ext>
+            </a:extLst>
+          </p:cNvPr>
+          <p:cNvSpPr>
+            <a:spLocks xmlns:a="http://schemas.openxmlformats.org/drawingml/2006/main" noGrp="1"/>
+          </p:cNvSpPr>
+          <p:nvPr/>
+        </p:nvSpPr>
+        <p:spPr>
+          <a:xfrm xmlns:a="http://schemas.openxmlformats.org/drawingml/2006/main">
+            <a:off x="400050" y="400050"/>
+            <a:ext cx="2476500" cy="266700"/>
+          </a:xfrm>
+          <a:prstGeom xmlns:a="http://schemas.openxmlformats.org/drawingml/2006/main" prst="rect">
+            <a:avLst/>
+          </a:prstGeom>
+          <a:noFill xmlns:a="http://schemas.openxmlformats.org/drawingml/2006/main"/>
+          <a:ln xmlns:a="http://schemas.openxmlformats.org/drawingml/2006/main" w="0">
+            <a:noFill/>
+            <a:prstDash val="solid"/>
+          </a:ln>
+        </p:spPr>
+        <p:txBody>
+          <a:bodyPr xmlns:a="http://schemas.openxmlformats.org/drawingml/2006/main"/>
+          <a:lstStyle xmlns:a="http://schemas.openxmlformats.org/drawingml/2006/main"/>
+          <a:p xmlns:a="http://schemas.openxmlformats.org/drawingml/2006/main">
+            <a:pPr>
+              <a:defRPr sz="1200" b="1">
+                <a:solidFill>
+                  <a:srgbClr val="555555"/>
+                </a:solidFill>
+              </a:defRPr>
+            </a:pPr>
+            <a:r>
+              <a:rPr sz="1200" b="1">
+                <a:solidFill>
+                  <a:srgbClr val="555555"/>
+                </a:solidFill>
+              </a:rPr>
+              <a:t>FIRST READOUT</a:t>
+            </a:r>
+          </a:p>
+        </p:txBody>
+      </p:sp>
+      <p:sp>
+        <p:nvSpPr>
+          <p:cNvPr id="2" name="">
+            <a:extLst xmlns:a="http://schemas.openxmlformats.org/drawingml/2006/main">
+              <a:ext uri="{FF2B5EF4-FFF2-40B4-BE49-F238E27FC236}">
+                <a16:creationId xmlns:a16="http://schemas.microsoft.com/office/drawing/2014/main" id="{7833A1BD-0DE8-4722-95B7-185BB1D2F38F}"/>
+              </a:ext>
+            </a:extLst>
+          </p:cNvPr>
+          <p:cNvSpPr>
+            <a:spLocks xmlns:a="http://schemas.openxmlformats.org/drawingml/2006/main" noGrp="1"/>
+          </p:cNvSpPr>
+          <p:nvPr/>
+        </p:nvSpPr>
+        <p:spPr>
+          <a:xfrm xmlns:a="http://schemas.openxmlformats.org/drawingml/2006/main">
+            <a:off x="400050" y="838200"/>
+            <a:ext cx="10096500" cy="876300"/>
+          </a:xfrm>
+          <a:prstGeom xmlns:a="http://schemas.openxmlformats.org/drawingml/2006/main" prst="rect">
+            <a:avLst/>
+          </a:prstGeom>
+          <a:noFill xmlns:a="http://schemas.openxmlformats.org/drawingml/2006/main"/>
+          <a:ln xmlns:a="http://schemas.openxmlformats.org/drawingml/2006/main" w="0">
+            <a:noFill/>
+            <a:prstDash val="solid"/>
+          </a:ln>
+        </p:spPr>
+        <p:txBody>
+          <a:bodyPr xmlns:a="http://schemas.openxmlformats.org/drawingml/2006/main"/>
+          <a:lstStyle xmlns:a="http://schemas.openxmlformats.org/drawingml/2006/main"/>
+          <a:p xmlns:a="http://schemas.openxmlformats.org/drawingml/2006/main">
+            <a:pPr>
+              <a:defRPr sz="2775" b="1">
+                <a:solidFill>
+                  <a:srgbClr val="000000"/>
+                </a:solidFill>
+              </a:defRPr>
+            </a:pPr>
+            <a:r>
+              <a:rPr sz="2775" b="1">
+                <a:solidFill>
+                  <a:srgbClr val="000000"/>
+                </a:solidFill>
+              </a:rPr>
+              <a:t>The policies were closer than the Gen4 file comparison implied</a:t>
+            </a:r>
+          </a:p>
+        </p:txBody>
+      </p:sp>
+      <p:sp>
+        <p:nvSpPr>
+          <p:cNvPr id="3" name="">
+            <a:extLst xmlns:a="http://schemas.openxmlformats.org/drawingml/2006/main">
+              <a:ext uri="{FF2B5EF4-FFF2-40B4-BE49-F238E27FC236}">
+                <a16:creationId xmlns:a16="http://schemas.microsoft.com/office/drawing/2014/main" id="{A2F3946F-AEE1-433C-A108-42EB8AF7E6FF}"/>
+              </a:ext>
+            </a:extLst>
+          </p:cNvPr>
+          <p:cNvSpPr>
+            <a:spLocks xmlns:a="http://schemas.openxmlformats.org/drawingml/2006/main" noGrp="1"/>
+          </p:cNvSpPr>
+          <p:nvPr/>
+        </p:nvSpPr>
+        <p:spPr>
+          <a:xfrm xmlns:a="http://schemas.openxmlformats.org/drawingml/2006/main">
+            <a:off x="400050" y="1847850"/>
+            <a:ext cx="10096500" cy="876300"/>
+          </a:xfrm>
+          <a:prstGeom xmlns:a="http://schemas.openxmlformats.org/drawingml/2006/main" prst="rect">
+            <a:avLst/>
+          </a:prstGeom>
+          <a:noFill xmlns:a="http://schemas.openxmlformats.org/drawingml/2006/main"/>
+          <a:ln xmlns:a="http://schemas.openxmlformats.org/drawingml/2006/main" w="0">
+            <a:noFill/>
+            <a:prstDash val="solid"/>
+          </a:ln>
+        </p:spPr>
+        <p:txBody>
+          <a:bodyPr xmlns:a="http://schemas.openxmlformats.org/drawingml/2006/main"/>
+          <a:lstStyle xmlns:a="http://schemas.openxmlformats.org/drawingml/2006/main"/>
+          <a:p xmlns:a="http://schemas.openxmlformats.org/drawingml/2006/main">
+            <a:pPr>
+              <a:defRPr sz="1725">
+                <a:solidFill>
+                  <a:srgbClr val="222222"/>
+                </a:solidFill>
+              </a:defRPr>
+            </a:pPr>
+            <a:r>
+              <a:rPr sz="1725">
+                <a:solidFill>
+                  <a:srgbClr val="222222"/>
+                </a:solidFill>
+              </a:rPr>
+              <a:t>Inside the Gen5.1 bridge surface, direct and pooled-family authority maps matched on 321 of 375 asset-state rows across Q1-Q3 2026. Replay still diverged because a few state/spec changes can alter entries, exits, and quarter handoff.</a:t>
+            </a:r>
+          </a:p>
+        </p:txBody>
+      </p:sp>
+      <p:sp>
+        <p:nvSpPr>
+          <p:cNvPr id="4" name="">
+            <a:extLst xmlns:a="http://schemas.openxmlformats.org/drawingml/2006/main">
+              <a:ext uri="{FF2B5EF4-FFF2-40B4-BE49-F238E27FC236}">
+                <a16:creationId xmlns:a16="http://schemas.microsoft.com/office/drawing/2014/main" id="{39AEF431-ABD4-4ACD-9856-9D30D6CB2217}"/>
+              </a:ext>
+            </a:extLst>
+          </p:cNvPr>
+          <p:cNvSpPr>
+            <a:spLocks xmlns:a="http://schemas.openxmlformats.org/drawingml/2006/main" noGrp="1"/>
+          </p:cNvSpPr>
+          <p:nvPr/>
+        </p:nvSpPr>
+        <p:spPr>
+          <a:xfrm xmlns:a="http://schemas.openxmlformats.org/drawingml/2006/main">
+            <a:off x="838200" y="3143250"/>
+            <a:ext cx="2914650" cy="1428750"/>
+          </a:xfrm>
+          <a:prstGeom xmlns:a="http://schemas.openxmlformats.org/drawingml/2006/main" prst="rect">
+            <a:avLst/>
+          </a:prstGeom>
+          <a:solidFill xmlns:a="http://schemas.openxmlformats.org/drawingml/2006/main">
+            <a:srgbClr val="F4F4F4"/>
+          </a:solidFill>
+          <a:ln xmlns:a="http://schemas.openxmlformats.org/drawingml/2006/main" w="0">
+            <a:noFill/>
+            <a:prstDash val="solid"/>
+          </a:ln>
+        </p:spPr>
+      </p:sp>
+      <p:sp>
+        <p:nvSpPr>
+          <p:cNvPr id="5" name="">
+            <a:extLst xmlns:a="http://schemas.openxmlformats.org/drawingml/2006/main">
+              <a:ext uri="{FF2B5EF4-FFF2-40B4-BE49-F238E27FC236}">
+                <a16:creationId xmlns:a16="http://schemas.microsoft.com/office/drawing/2014/main" id="{3F738A00-FB5F-4E01-9CBE-DF3AB803F4EC}"/>
+              </a:ext>
+            </a:extLst>
+          </p:cNvPr>
+          <p:cNvSpPr>
+            <a:spLocks xmlns:a="http://schemas.openxmlformats.org/drawingml/2006/main" noGrp="1"/>
+          </p:cNvSpPr>
+          <p:nvPr/>
+        </p:nvSpPr>
+        <p:spPr>
+          <a:xfrm xmlns:a="http://schemas.openxmlformats.org/drawingml/2006/main">
+            <a:off x="1085850" y="3314700"/>
+            <a:ext cx="2095500" cy="609600"/>
+          </a:xfrm>
+          <a:prstGeom xmlns:a="http://schemas.openxmlformats.org/drawingml/2006/main" prst="rect">
+            <a:avLst/>
+          </a:prstGeom>
+          <a:noFill xmlns:a="http://schemas.openxmlformats.org/drawingml/2006/main"/>
+          <a:ln xmlns:a="http://schemas.openxmlformats.org/drawingml/2006/main" w="0">
+            <a:noFill/>
+            <a:prstDash val="solid"/>
+          </a:ln>
+        </p:spPr>
+        <p:txBody>
+          <a:bodyPr xmlns:a="http://schemas.openxmlformats.org/drawingml/2006/main"/>
+          <a:lstStyle xmlns:a="http://schemas.openxmlformats.org/drawingml/2006/main"/>
+          <a:p xmlns:a="http://schemas.openxmlformats.org/drawingml/2006/main">
+            <a:pPr>
+              <a:defRPr sz="4050" b="1">
+                <a:solidFill>
+                  <a:srgbClr val="FF6B35"/>
+                </a:solidFill>
+              </a:defRPr>
+            </a:pPr>
+            <a:r>
+              <a:rPr sz="4050" b="1">
+                <a:solidFill>
+                  <a:srgbClr val="FF6B35"/>
+                </a:solidFill>
+              </a:rPr>
+              <a:t>85.6%</a:t>
+            </a:r>
+          </a:p>
+        </p:txBody>
+      </p:sp>
+      <p:sp>
+        <p:nvSpPr>
+          <p:cNvPr id="6" name="">
+            <a:extLst xmlns:a="http://schemas.openxmlformats.org/drawingml/2006/main">
+              <a:ext uri="{FF2B5EF4-FFF2-40B4-BE49-F238E27FC236}">
+                <a16:creationId xmlns:a16="http://schemas.microsoft.com/office/drawing/2014/main" id="{D97DEE04-C0F7-4896-BEC8-6E88C1C16102}"/>
+              </a:ext>
+            </a:extLst>
+          </p:cNvPr>
+          <p:cNvSpPr>
+            <a:spLocks xmlns:a="http://schemas.openxmlformats.org/drawingml/2006/main" noGrp="1"/>
+          </p:cNvSpPr>
+          <p:nvPr/>
+        </p:nvSpPr>
+        <p:spPr>
+          <a:xfrm xmlns:a="http://schemas.openxmlformats.org/drawingml/2006/main">
+            <a:off x="1085850" y="4038600"/>
+            <a:ext cx="2190750" cy="323850"/>
+          </a:xfrm>
+          <a:prstGeom xmlns:a="http://schemas.openxmlformats.org/drawingml/2006/main" prst="rect">
+            <a:avLst/>
+          </a:prstGeom>
+          <a:noFill xmlns:a="http://schemas.openxmlformats.org/drawingml/2006/main"/>
+          <a:ln xmlns:a="http://schemas.openxmlformats.org/drawingml/2006/main" w="0">
+            <a:noFill/>
+            <a:prstDash val="solid"/>
+          </a:ln>
+        </p:spPr>
+        <p:txBody>
+          <a:bodyPr xmlns:a="http://schemas.openxmlformats.org/drawingml/2006/main"/>
+          <a:lstStyle xmlns:a="http://schemas.openxmlformats.org/drawingml/2006/main"/>
+          <a:p xmlns:a="http://schemas.openxmlformats.org/drawingml/2006/main">
+            <a:pPr>
+              <a:defRPr sz="1575">
+                <a:solidFill>
+                  <a:srgbClr val="000000"/>
+                </a:solidFill>
+              </a:defRPr>
+            </a:pPr>
+            <a:r>
+              <a:rPr sz="1575">
+                <a:solidFill>
+                  <a:srgbClr val="000000"/>
+                </a:solidFill>
+              </a:rPr>
+              <a:t>selected map agreement</a:t>
+            </a:r>
+          </a:p>
+        </p:txBody>
+      </p:sp>
+      <p:sp>
+        <p:nvSpPr>
+          <p:cNvPr id="7" name="">
+            <a:extLst xmlns:a="http://schemas.openxmlformats.org/drawingml/2006/main">
+              <a:ext uri="{FF2B5EF4-FFF2-40B4-BE49-F238E27FC236}">
+                <a16:creationId xmlns:a16="http://schemas.microsoft.com/office/drawing/2014/main" id="{2F2E83C6-7AF7-4EB3-A4C9-8643D1E4222F}"/>
+              </a:ext>
+            </a:extLst>
+          </p:cNvPr>
+          <p:cNvSpPr>
+            <a:spLocks xmlns:a="http://schemas.openxmlformats.org/drawingml/2006/main" noGrp="1"/>
+          </p:cNvSpPr>
+          <p:nvPr/>
+        </p:nvSpPr>
+        <p:spPr>
+          <a:xfrm xmlns:a="http://schemas.openxmlformats.org/drawingml/2006/main">
+            <a:off x="4629150" y="3143250"/>
+            <a:ext cx="2914650" cy="1428750"/>
+          </a:xfrm>
+          <a:prstGeom xmlns:a="http://schemas.openxmlformats.org/drawingml/2006/main" prst="rect">
+            <a:avLst/>
+          </a:prstGeom>
+          <a:solidFill xmlns:a="http://schemas.openxmlformats.org/drawingml/2006/main">
+            <a:srgbClr val="F4F4F4"/>
+          </a:solidFill>
+          <a:ln xmlns:a="http://schemas.openxmlformats.org/drawingml/2006/main" w="0">
+            <a:noFill/>
+            <a:prstDash val="solid"/>
+          </a:ln>
+        </p:spPr>
+      </p:sp>
+      <p:sp>
+        <p:nvSpPr>
+          <p:cNvPr id="8" name="">
+            <a:extLst xmlns:a="http://schemas.openxmlformats.org/drawingml/2006/main">
+              <a:ext uri="{FF2B5EF4-FFF2-40B4-BE49-F238E27FC236}">
+                <a16:creationId xmlns:a16="http://schemas.microsoft.com/office/drawing/2014/main" id="{75985248-7146-4E82-B3B8-8A35F89A08C8}"/>
+              </a:ext>
+            </a:extLst>
+          </p:cNvPr>
+          <p:cNvSpPr>
+            <a:spLocks xmlns:a="http://schemas.openxmlformats.org/drawingml/2006/main" noGrp="1"/>
+          </p:cNvSpPr>
+          <p:nvPr/>
+        </p:nvSpPr>
+        <p:spPr>
+          <a:xfrm xmlns:a="http://schemas.openxmlformats.org/drawingml/2006/main">
+            <a:off x="4876800" y="3314700"/>
+            <a:ext cx="2095500" cy="609600"/>
+          </a:xfrm>
+          <a:prstGeom xmlns:a="http://schemas.openxmlformats.org/drawingml/2006/main" prst="rect">
+            <a:avLst/>
+          </a:prstGeom>
+          <a:noFill xmlns:a="http://schemas.openxmlformats.org/drawingml/2006/main"/>
+          <a:ln xmlns:a="http://schemas.openxmlformats.org/drawingml/2006/main" w="0">
+            <a:noFill/>
+            <a:prstDash val="solid"/>
+          </a:ln>
+        </p:spPr>
+        <p:txBody>
+          <a:bodyPr xmlns:a="http://schemas.openxmlformats.org/drawingml/2006/main"/>
+          <a:lstStyle xmlns:a="http://schemas.openxmlformats.org/drawingml/2006/main"/>
+          <a:p xmlns:a="http://schemas.openxmlformats.org/drawingml/2006/main">
+            <a:pPr>
+              <a:defRPr sz="4050" b="1">
+                <a:solidFill>
+                  <a:srgbClr val="1B7F5A"/>
+                </a:solidFill>
+              </a:defRPr>
+            </a:pPr>
+            <a:r>
+              <a:rPr sz="4050" b="1">
+                <a:solidFill>
+                  <a:srgbClr val="1B7F5A"/>
+                </a:solidFill>
+              </a:rPr>
+              <a:t>AMD</a:t>
+            </a:r>
+          </a:p>
+        </p:txBody>
+      </p:sp>
+      <p:sp>
+        <p:nvSpPr>
+          <p:cNvPr id="9" name="">
+            <a:extLst xmlns:a="http://schemas.openxmlformats.org/drawingml/2006/main">
+              <a:ext uri="{FF2B5EF4-FFF2-40B4-BE49-F238E27FC236}">
+                <a16:creationId xmlns:a16="http://schemas.microsoft.com/office/drawing/2014/main" id="{ABC28C80-3AE5-48A0-AF64-B6A57BEDBF16}"/>
+              </a:ext>
+            </a:extLst>
+          </p:cNvPr>
+          <p:cNvSpPr>
+            <a:spLocks xmlns:a="http://schemas.openxmlformats.org/drawingml/2006/main" noGrp="1"/>
+          </p:cNvSpPr>
+          <p:nvPr/>
+        </p:nvSpPr>
+        <p:spPr>
+          <a:xfrm xmlns:a="http://schemas.openxmlformats.org/drawingml/2006/main">
+            <a:off x="4876800" y="4038600"/>
+            <a:ext cx="2190750" cy="457200"/>
+          </a:xfrm>
+          <a:prstGeom xmlns:a="http://schemas.openxmlformats.org/drawingml/2006/main" prst="rect">
+            <a:avLst/>
+          </a:prstGeom>
+          <a:noFill xmlns:a="http://schemas.openxmlformats.org/drawingml/2006/main"/>
+          <a:ln xmlns:a="http://schemas.openxmlformats.org/drawingml/2006/main" w="0">
+            <a:noFill/>
+            <a:prstDash val="solid"/>
+          </a:ln>
+        </p:spPr>
+        <p:txBody>
+          <a:bodyPr xmlns:a="http://schemas.openxmlformats.org/drawingml/2006/main"/>
+          <a:lstStyle xmlns:a="http://schemas.openxmlformats.org/drawingml/2006/main"/>
+          <a:p xmlns:a="http://schemas.openxmlformats.org/drawingml/2006/main">
+            <a:pPr>
+              <a:defRPr sz="1500">
+                <a:solidFill>
+                  <a:srgbClr val="000000"/>
+                </a:solidFill>
+              </a:defRPr>
+            </a:pPr>
+            <a:r>
+              <a:rPr sz="1500">
+                <a:solidFill>
+                  <a:srgbClr val="000000"/>
+                </a:solidFill>
+              </a:rPr>
+              <a:t>drove much of the Q3 pooled advantage</a:t>
+            </a:r>
+          </a:p>
+        </p:txBody>
+      </p:sp>
+      <p:sp>
+        <p:nvSpPr>
+          <p:cNvPr id="10" name="">
+            <a:extLst xmlns:a="http://schemas.openxmlformats.org/drawingml/2006/main">
+              <a:ext uri="{FF2B5EF4-FFF2-40B4-BE49-F238E27FC236}">
+                <a16:creationId xmlns:a16="http://schemas.microsoft.com/office/drawing/2014/main" id="{C4BCBC0A-CAED-427B-8866-3543903FA7AA}"/>
+              </a:ext>
+            </a:extLst>
+          </p:cNvPr>
+          <p:cNvSpPr>
+            <a:spLocks xmlns:a="http://schemas.openxmlformats.org/drawingml/2006/main" noGrp="1"/>
+          </p:cNvSpPr>
+          <p:nvPr/>
+        </p:nvSpPr>
+        <p:spPr>
+          <a:xfrm xmlns:a="http://schemas.openxmlformats.org/drawingml/2006/main">
+            <a:off x="8420100" y="3143250"/>
+            <a:ext cx="2914650" cy="1428750"/>
+          </a:xfrm>
+          <a:prstGeom xmlns:a="http://schemas.openxmlformats.org/drawingml/2006/main" prst="rect">
+            <a:avLst/>
+          </a:prstGeom>
+          <a:solidFill xmlns:a="http://schemas.openxmlformats.org/drawingml/2006/main">
+            <a:srgbClr val="F4F4F4"/>
+          </a:solidFill>
+          <a:ln xmlns:a="http://schemas.openxmlformats.org/drawingml/2006/main" w="0">
+            <a:noFill/>
+            <a:prstDash val="solid"/>
+          </a:ln>
+        </p:spPr>
+      </p:sp>
+      <p:sp>
+        <p:nvSpPr>
+          <p:cNvPr id="11" name="">
+            <a:extLst xmlns:a="http://schemas.openxmlformats.org/drawingml/2006/main">
+              <a:ext uri="{FF2B5EF4-FFF2-40B4-BE49-F238E27FC236}">
+                <a16:creationId xmlns:a16="http://schemas.microsoft.com/office/drawing/2014/main" id="{E52B5F23-D03A-446F-9832-E8091A51E35D}"/>
+              </a:ext>
+            </a:extLst>
+          </p:cNvPr>
+          <p:cNvSpPr>
+            <a:spLocks xmlns:a="http://schemas.openxmlformats.org/drawingml/2006/main" noGrp="1"/>
+          </p:cNvSpPr>
+          <p:nvPr/>
+        </p:nvSpPr>
+        <p:spPr>
+          <a:xfrm xmlns:a="http://schemas.openxmlformats.org/drawingml/2006/main">
+            <a:off x="8667750" y="3429000"/>
+            <a:ext cx="2381250" cy="438150"/>
+          </a:xfrm>
+          <a:prstGeom xmlns:a="http://schemas.openxmlformats.org/drawingml/2006/main" prst="rect">
+            <a:avLst/>
+          </a:prstGeom>
+          <a:noFill xmlns:a="http://schemas.openxmlformats.org/drawingml/2006/main"/>
+          <a:ln xmlns:a="http://schemas.openxmlformats.org/drawingml/2006/main" w="0">
+            <a:noFill/>
+            <a:prstDash val="solid"/>
+          </a:ln>
+        </p:spPr>
+        <p:txBody>
+          <a:bodyPr xmlns:a="http://schemas.openxmlformats.org/drawingml/2006/main"/>
+          <a:lstStyle xmlns:a="http://schemas.openxmlformats.org/drawingml/2006/main"/>
+          <a:p xmlns:a="http://schemas.openxmlformats.org/drawingml/2006/main">
+            <a:pPr>
+              <a:defRPr sz="2625" b="1">
+                <a:solidFill>
+                  <a:srgbClr val="1D4ED8"/>
+                </a:solidFill>
+              </a:defRPr>
+            </a:pPr>
+            <a:r>
+              <a:rPr sz="2625" b="1">
+                <a:solidFill>
+                  <a:srgbClr val="1D4ED8"/>
+                </a:solidFill>
+              </a:rPr>
+              <a:t>NVDA + TSLA</a:t>
+            </a:r>
+          </a:p>
+        </p:txBody>
+      </p:sp>
+      <p:sp>
+        <p:nvSpPr>
+          <p:cNvPr id="12" name="">
+            <a:extLst xmlns:a="http://schemas.openxmlformats.org/drawingml/2006/main">
+              <a:ext uri="{FF2B5EF4-FFF2-40B4-BE49-F238E27FC236}">
+                <a16:creationId xmlns:a16="http://schemas.microsoft.com/office/drawing/2014/main" id="{A5BE7706-A6E5-4D3B-A140-5C3E284DCC72}"/>
+              </a:ext>
+            </a:extLst>
+          </p:cNvPr>
+          <p:cNvSpPr>
+            <a:spLocks xmlns:a="http://schemas.openxmlformats.org/drawingml/2006/main" noGrp="1"/>
+          </p:cNvSpPr>
+          <p:nvPr/>
+        </p:nvSpPr>
+        <p:spPr>
+          <a:xfrm xmlns:a="http://schemas.openxmlformats.org/drawingml/2006/main">
+            <a:off x="8667750" y="4038600"/>
+            <a:ext cx="2190750" cy="457200"/>
+          </a:xfrm>
+          <a:prstGeom xmlns:a="http://schemas.openxmlformats.org/drawingml/2006/main" prst="rect">
+            <a:avLst/>
+          </a:prstGeom>
+          <a:noFill xmlns:a="http://schemas.openxmlformats.org/drawingml/2006/main"/>
+          <a:ln xmlns:a="http://schemas.openxmlformats.org/drawingml/2006/main" w="0">
+            <a:noFill/>
+            <a:prstDash val="solid"/>
+          </a:ln>
+        </p:spPr>
+        <p:txBody>
+          <a:bodyPr xmlns:a="http://schemas.openxmlformats.org/drawingml/2006/main"/>
+          <a:lstStyle xmlns:a="http://schemas.openxmlformats.org/drawingml/2006/main"/>
+          <a:p xmlns:a="http://schemas.openxmlformats.org/drawingml/2006/main">
+            <a:pPr>
+              <a:defRPr sz="1500">
+                <a:solidFill>
+                  <a:srgbClr val="000000"/>
+                </a:solidFill>
+              </a:defRPr>
+            </a:pPr>
+            <a:r>
+              <a:rPr sz="1500">
+                <a:solidFill>
+                  <a:srgbClr val="000000"/>
+                </a:solidFill>
+              </a:rPr>
+              <a:t>favored direct in both tested windows</a:t>
+            </a:r>
+          </a:p>
+        </p:txBody>
+      </p:sp>
+      <p:sp>
+        <p:nvSpPr>
+          <p:cNvPr id="13" name="">
+            <a:extLst xmlns:a="http://schemas.openxmlformats.org/drawingml/2006/main">
+              <a:ext uri="{FF2B5EF4-FFF2-40B4-BE49-F238E27FC236}">
+                <a16:creationId xmlns:a16="http://schemas.microsoft.com/office/drawing/2014/main" id="{E7CF3A14-8635-439C-B506-FB68EFD7506A}"/>
+              </a:ext>
+            </a:extLst>
+          </p:cNvPr>
+          <p:cNvSpPr>
+            <a:spLocks xmlns:a="http://schemas.openxmlformats.org/drawingml/2006/main" noGrp="1"/>
+          </p:cNvSpPr>
+          <p:nvPr/>
+        </p:nvSpPr>
+        <p:spPr>
+          <a:xfrm xmlns:a="http://schemas.openxmlformats.org/drawingml/2006/main">
+            <a:off x="1028700" y="5257800"/>
+            <a:ext cx="9429750" cy="419100"/>
+          </a:xfrm>
+          <a:prstGeom xmlns:a="http://schemas.openxmlformats.org/drawingml/2006/main" prst="rect">
+            <a:avLst/>
+          </a:prstGeom>
+          <a:noFill xmlns:a="http://schemas.openxmlformats.org/drawingml/2006/main"/>
+          <a:ln xmlns:a="http://schemas.openxmlformats.org/drawingml/2006/main" w="0">
+            <a:noFill/>
+            <a:prstDash val="solid"/>
+          </a:ln>
+        </p:spPr>
+        <p:txBody>
+          <a:bodyPr xmlns:a="http://schemas.openxmlformats.org/drawingml/2006/main"/>
+          <a:lstStyle xmlns:a="http://schemas.openxmlformats.org/drawingml/2006/main"/>
+          <a:p xmlns:a="http://schemas.openxmlformats.org/drawingml/2006/main">
+            <a:pPr>
+              <a:defRPr sz="1800" b="1">
+                <a:solidFill>
+                  <a:srgbClr val="000000"/>
+                </a:solidFill>
+              </a:defRPr>
+            </a:pPr>
+            <a:r>
+              <a:rPr sz="1800" b="1">
+                <a:solidFill>
+                  <a:srgbClr val="000000"/>
+                </a:solidFill>
+              </a:rPr>
+              <a:t>Meaning: do not convert the bridge just for fidelity, but do not dismiss the pooled-family hypothesis either.</a:t>
+            </a:r>
+          </a:p>
+        </p:txBody>
+      </p:sp>
+      <p:sp>
+        <p:nvSpPr>
+          <p:cNvPr id="14" name="">
+            <a:extLst xmlns:a="http://schemas.openxmlformats.org/drawingml/2006/main">
+              <a:ext uri="{FF2B5EF4-FFF2-40B4-BE49-F238E27FC236}">
+                <a16:creationId xmlns:a16="http://schemas.microsoft.com/office/drawing/2014/main" id="{61B8EA2C-F4DF-4498-9B3D-41954DB1CCCA}"/>
+              </a:ext>
+            </a:extLst>
+          </p:cNvPr>
+          <p:cNvSpPr>
+            <a:spLocks xmlns:a="http://schemas.openxmlformats.org/drawingml/2006/main" noGrp="1"/>
+          </p:cNvSpPr>
+          <p:nvPr/>
+        </p:nvSpPr>
+        <p:spPr>
+          <a:xfrm xmlns:a="http://schemas.openxmlformats.org/drawingml/2006/main">
+            <a:off x="400050" y="6343650"/>
+            <a:ext cx="11391900" cy="13335"/>
+          </a:xfrm>
+          <a:prstGeom xmlns:a="http://schemas.openxmlformats.org/drawingml/2006/main" prst="rect">
+            <a:avLst/>
+          </a:prstGeom>
+          <a:solidFill xmlns:a="http://schemas.openxmlformats.org/drawingml/2006/main">
+            <a:srgbClr val="B8BCC4"/>
+          </a:solidFill>
+          <a:ln xmlns:a="http://schemas.openxmlformats.org/drawingml/2006/main" w="0">
+            <a:solidFill>
+              <a:srgbClr val="B8BCC4"/>
+            </a:solidFill>
+            <a:prstDash val="solid"/>
+          </a:ln>
+        </p:spPr>
+      </p:sp>
+      <p:sp>
+        <p:nvSpPr>
+          <p:cNvPr id="15" name="">
+            <a:extLst xmlns:a="http://schemas.openxmlformats.org/drawingml/2006/main">
+              <a:ext uri="{FF2B5EF4-FFF2-40B4-BE49-F238E27FC236}">
+                <a16:creationId xmlns:a16="http://schemas.microsoft.com/office/drawing/2014/main" id="{5623D250-351B-47DB-9585-550B5D01525C}"/>
+              </a:ext>
+            </a:extLst>
+          </p:cNvPr>
+          <p:cNvSpPr>
+            <a:spLocks xmlns:a="http://schemas.openxmlformats.org/drawingml/2006/main" noGrp="1"/>
+          </p:cNvSpPr>
+          <p:nvPr/>
+        </p:nvSpPr>
+        <p:spPr>
+          <a:xfrm xmlns:a="http://schemas.openxmlformats.org/drawingml/2006/main">
+            <a:off x="400050" y="6477000"/>
+            <a:ext cx="4381500" cy="228600"/>
+          </a:xfrm>
+          <a:prstGeom xmlns:a="http://schemas.openxmlformats.org/drawingml/2006/main" prst="rect">
+            <a:avLst/>
+          </a:prstGeom>
+          <a:noFill xmlns:a="http://schemas.openxmlformats.org/drawingml/2006/main"/>
+          <a:ln xmlns:a="http://schemas.openxmlformats.org/drawingml/2006/main" w="0">
+            <a:noFill/>
+            <a:prstDash val="solid"/>
+          </a:ln>
+        </p:spPr>
+        <p:txBody>
+          <a:bodyPr xmlns:a="http://schemas.openxmlformats.org/drawingml/2006/main"/>
+          <a:lstStyle xmlns:a="http://schemas.openxmlformats.org/drawingml/2006/main"/>
+          <a:p xmlns:a="http://schemas.openxmlformats.org/drawingml/2006/main">
+            <a:pPr>
+              <a:defRPr sz="1050">
+                <a:solidFill>
+                  <a:srgbClr val="555555"/>
+                </a:solidFill>
+              </a:defRPr>
+            </a:pPr>
+            <a:r>
+              <a:rPr sz="1050">
+                <a:solidFill>
+                  <a:srgbClr val="555555"/>
+                </a:solidFill>
+              </a:rPr>
+              <a:t>Gen5.1 selection-policy hypothesis</a:t>
+            </a:r>
+          </a:p>
+        </p:txBody>
+      </p:sp>
+      <p:sp>
+        <p:nvSpPr>
+          <p:cNvPr id="16" name="">
+            <a:extLst xmlns:a="http://schemas.openxmlformats.org/drawingml/2006/main">
+              <a:ext uri="{FF2B5EF4-FFF2-40B4-BE49-F238E27FC236}">
+                <a16:creationId xmlns:a16="http://schemas.microsoft.com/office/drawing/2014/main" id="{6975204C-74BB-4FBA-9BC9-D00B480CD8E1}"/>
+              </a:ext>
+            </a:extLst>
+          </p:cNvPr>
+          <p:cNvSpPr>
+            <a:spLocks xmlns:a="http://schemas.openxmlformats.org/drawingml/2006/main" noGrp="1"/>
+          </p:cNvSpPr>
+          <p:nvPr/>
+        </p:nvSpPr>
+        <p:spPr>
+          <a:xfrm xmlns:a="http://schemas.openxmlformats.org/drawingml/2006/main">
+            <a:off x="11277600" y="6457950"/>
+            <a:ext cx="514350" cy="266700"/>
+          </a:xfrm>
+          <a:prstGeom xmlns:a="http://schemas.openxmlformats.org/drawingml/2006/main" prst="rect">
+            <a:avLst/>
+          </a:prstGeom>
+          <a:noFill xmlns:a="http://schemas.openxmlformats.org/drawingml/2006/main"/>
+          <a:ln xmlns:a="http://schemas.openxmlformats.org/drawingml/2006/main" w="0">
+            <a:noFill/>
+            <a:prstDash val="solid"/>
+          </a:ln>
+        </p:spPr>
+        <p:txBody>
+          <a:bodyPr xmlns:a="http://schemas.openxmlformats.org/drawingml/2006/main"/>
+          <a:lstStyle xmlns:a="http://schemas.openxmlformats.org/drawingml/2006/main"/>
+          <a:p xmlns:a="http://schemas.openxmlformats.org/drawingml/2006/main">
+            <a:pPr algn="r">
+              <a:defRPr sz="1200" b="1">
+                <a:solidFill>
+                  <a:srgbClr val="555555"/>
+                </a:solidFill>
+              </a:defRPr>
+            </a:pPr>
+            <a:r>
+              <a:rPr sz="1200" b="1">
+                <a:solidFill>
+                  <a:srgbClr val="555555"/>
+                </a:solidFill>
+              </a:rPr>
+              <a:t>07</a:t>
+            </a:r>
+          </a:p>
+        </p:txBody>
+      </p:sp>
+    </p:spTree>
+    <p:extLst>
+      <p:ext uri="{BB962C8B-B14F-4D97-AF65-F5344CB8AC3E}">
+        <p14:creationId xmlns:p14="http://schemas.microsoft.com/office/powerpoint/2010/main" val="296939888"/>
+      </p:ext>
+    </p:extLst>
+  </p:cSld>
+</p:sld>
+</file>
+
+<file path=ppt/slides/slide8.xml><?xml version="1.0" encoding="utf-8"?>
+<p:sld xmlns:p="http://schemas.openxmlformats.org/presentationml/2006/main">
+  <p:cSld>
+    <p:bg>
+      <p:bgPr>
+        <a:solidFill xmlns:a="http://schemas.openxmlformats.org/drawingml/2006/main">
+          <a:srgbClr val="FFFFFF"/>
+        </a:solidFill>
+      </p:bgPr>
+    </p:bg>
+    <p:spTree>
+      <p:nvGrpSpPr>
+        <p:cNvPr id="1" name=""/>
+        <p:cNvGrpSpPr/>
+        <p:nvPr/>
+      </p:nvGrpSpPr>
+      <p:grpSpPr>
+        <a:xfrm xmlns:a="http://schemas.openxmlformats.org/drawingml/2006/main"/>
+      </p:grpSpPr>
+      <p:sp>
+        <p:nvSpPr>
+          <p:cNvPr id="1" name="">
+            <a:extLst xmlns:a="http://schemas.openxmlformats.org/drawingml/2006/main">
+              <a:ext uri="{FF2B5EF4-FFF2-40B4-BE49-F238E27FC236}">
+                <a16:creationId xmlns:a16="http://schemas.microsoft.com/office/drawing/2014/main" id="{EAFE3749-2F47-4D0A-9AA8-A893BE466A56}"/>
+              </a:ext>
+            </a:extLst>
+          </p:cNvPr>
+          <p:cNvSpPr>
+            <a:spLocks xmlns:a="http://schemas.openxmlformats.org/drawingml/2006/main" noGrp="1"/>
+          </p:cNvSpPr>
+          <p:nvPr/>
+        </p:nvSpPr>
+        <p:spPr>
+          <a:xfrm xmlns:a="http://schemas.openxmlformats.org/drawingml/2006/main">
+            <a:off x="400050" y="400050"/>
+            <a:ext cx="2476500" cy="266700"/>
+          </a:xfrm>
+          <a:prstGeom xmlns:a="http://schemas.openxmlformats.org/drawingml/2006/main" prst="rect">
+            <a:avLst/>
+          </a:prstGeom>
+          <a:noFill xmlns:a="http://schemas.openxmlformats.org/drawingml/2006/main"/>
+          <a:ln xmlns:a="http://schemas.openxmlformats.org/drawingml/2006/main" w="0">
+            <a:noFill/>
+            <a:prstDash val="solid"/>
+          </a:ln>
+        </p:spPr>
+        <p:txBody>
+          <a:bodyPr xmlns:a="http://schemas.openxmlformats.org/drawingml/2006/main"/>
+          <a:lstStyle xmlns:a="http://schemas.openxmlformats.org/drawingml/2006/main"/>
+          <a:p xmlns:a="http://schemas.openxmlformats.org/drawingml/2006/main">
+            <a:pPr>
+              <a:defRPr sz="1200" b="1">
+                <a:solidFill>
+                  <a:srgbClr val="555555"/>
+                </a:solidFill>
+              </a:defRPr>
+            </a:pPr>
+            <a:r>
+              <a:rPr sz="1200" b="1">
+                <a:solidFill>
+                  <a:srgbClr val="555555"/>
+                </a:solidFill>
+              </a:rPr>
+              <a:t>BROADER TEST</a:t>
+            </a:r>
+          </a:p>
+        </p:txBody>
+      </p:sp>
+      <p:sp>
+        <p:nvSpPr>
+          <p:cNvPr id="2" name="">
+            <a:extLst xmlns:a="http://schemas.openxmlformats.org/drawingml/2006/main">
+              <a:ext uri="{FF2B5EF4-FFF2-40B4-BE49-F238E27FC236}">
+                <a16:creationId xmlns:a16="http://schemas.microsoft.com/office/drawing/2014/main" id="{A4C862D9-F3A4-4F54-9D48-5EF3741794DD}"/>
+              </a:ext>
+            </a:extLst>
+          </p:cNvPr>
+          <p:cNvSpPr>
+            <a:spLocks xmlns:a="http://schemas.openxmlformats.org/drawingml/2006/main" noGrp="1"/>
+          </p:cNvSpPr>
+          <p:nvPr/>
+        </p:nvSpPr>
+        <p:spPr>
+          <a:xfrm xmlns:a="http://schemas.openxmlformats.org/drawingml/2006/main">
+            <a:off x="400050" y="838200"/>
+            <a:ext cx="10096500" cy="609600"/>
+          </a:xfrm>
+          <a:prstGeom xmlns:a="http://schemas.openxmlformats.org/drawingml/2006/main" prst="rect">
+            <a:avLst/>
+          </a:prstGeom>
+          <a:noFill xmlns:a="http://schemas.openxmlformats.org/drawingml/2006/main"/>
+          <a:ln xmlns:a="http://schemas.openxmlformats.org/drawingml/2006/main" w="0">
+            <a:noFill/>
+            <a:prstDash val="solid"/>
+          </a:ln>
+        </p:spPr>
+        <p:txBody>
+          <a:bodyPr xmlns:a="http://schemas.openxmlformats.org/drawingml/2006/main"/>
+          <a:lstStyle xmlns:a="http://schemas.openxmlformats.org/drawingml/2006/main"/>
+          <a:p xmlns:a="http://schemas.openxmlformats.org/drawingml/2006/main">
+            <a:pPr>
+              <a:defRPr sz="3000" b="1">
+                <a:solidFill>
+                  <a:srgbClr val="000000"/>
+                </a:solidFill>
+              </a:defRPr>
+            </a:pPr>
+            <a:r>
+              <a:rPr sz="3000" b="1">
+                <a:solidFill>
+                  <a:srgbClr val="000000"/>
+                </a:solidFill>
+              </a:rPr>
+              <a:t>The next comparison needs two clearly labeled evidence lanes</a:t>
+            </a:r>
+          </a:p>
+        </p:txBody>
+      </p:sp>
+      <p:sp>
+        <p:nvSpPr>
+          <p:cNvPr id="3" name="">
+            <a:extLst xmlns:a="http://schemas.openxmlformats.org/drawingml/2006/main">
+              <a:ext uri="{FF2B5EF4-FFF2-40B4-BE49-F238E27FC236}">
+                <a16:creationId xmlns:a16="http://schemas.microsoft.com/office/drawing/2014/main" id="{0EDA81E7-9CFD-4BC5-A43A-28CB43F65324}"/>
+              </a:ext>
+            </a:extLst>
+          </p:cNvPr>
+          <p:cNvSpPr>
+            <a:spLocks xmlns:a="http://schemas.openxmlformats.org/drawingml/2006/main" noGrp="1"/>
+          </p:cNvSpPr>
+          <p:nvPr/>
+        </p:nvSpPr>
+        <p:spPr>
+          <a:xfrm xmlns:a="http://schemas.openxmlformats.org/drawingml/2006/main">
+            <a:off x="685800" y="1809750"/>
+            <a:ext cx="4953000" cy="3048000"/>
+          </a:xfrm>
+          <a:prstGeom xmlns:a="http://schemas.openxmlformats.org/drawingml/2006/main" prst="rect">
+            <a:avLst/>
+          </a:prstGeom>
+          <a:solidFill xmlns:a="http://schemas.openxmlformats.org/drawingml/2006/main">
+            <a:srgbClr val="F4F4F4"/>
+          </a:solidFill>
+          <a:ln xmlns:a="http://schemas.openxmlformats.org/drawingml/2006/main" w="0">
+            <a:noFill/>
+            <a:prstDash val="solid"/>
+          </a:ln>
+        </p:spPr>
+      </p:sp>
+      <p:sp>
+        <p:nvSpPr>
+          <p:cNvPr id="4" name="">
+            <a:extLst xmlns:a="http://schemas.openxmlformats.org/drawingml/2006/main">
+              <a:ext uri="{FF2B5EF4-FFF2-40B4-BE49-F238E27FC236}">
+                <a16:creationId xmlns:a16="http://schemas.microsoft.com/office/drawing/2014/main" id="{5B0F40C9-2887-4D11-88CA-AFC87704210B}"/>
+              </a:ext>
+            </a:extLst>
+          </p:cNvPr>
+          <p:cNvSpPr>
+            <a:spLocks xmlns:a="http://schemas.openxmlformats.org/drawingml/2006/main" noGrp="1"/>
+          </p:cNvSpPr>
+          <p:nvPr/>
+        </p:nvSpPr>
+        <p:spPr>
+          <a:xfrm xmlns:a="http://schemas.openxmlformats.org/drawingml/2006/main">
+            <a:off x="990600" y="2057400"/>
+            <a:ext cx="1905000" cy="400050"/>
+          </a:xfrm>
+          <a:prstGeom xmlns:a="http://schemas.openxmlformats.org/drawingml/2006/main" prst="rect">
+            <a:avLst/>
+          </a:prstGeom>
+          <a:noFill xmlns:a="http://schemas.openxmlformats.org/drawingml/2006/main"/>
+          <a:ln xmlns:a="http://schemas.openxmlformats.org/drawingml/2006/main" w="0">
+            <a:noFill/>
+            <a:prstDash val="solid"/>
+          </a:ln>
+        </p:spPr>
+        <p:txBody>
+          <a:bodyPr xmlns:a="http://schemas.openxmlformats.org/drawingml/2006/main"/>
+          <a:lstStyle xmlns:a="http://schemas.openxmlformats.org/drawingml/2006/main"/>
+          <a:p xmlns:a="http://schemas.openxmlformats.org/drawingml/2006/main">
+            <a:pPr>
+              <a:defRPr sz="2250" b="1">
+                <a:solidFill>
+                  <a:srgbClr val="1D4ED8"/>
+                </a:solidFill>
+              </a:defRPr>
+            </a:pPr>
+            <a:r>
+              <a:rPr sz="2250" b="1">
+                <a:solidFill>
+                  <a:srgbClr val="1D4ED8"/>
+                </a:solidFill>
+              </a:rPr>
+              <a:t>Screen A</a:t>
+            </a:r>
+          </a:p>
+        </p:txBody>
+      </p:sp>
+      <p:sp>
+        <p:nvSpPr>
+          <p:cNvPr id="5" name="">
+            <a:extLst xmlns:a="http://schemas.openxmlformats.org/drawingml/2006/main">
+              <a:ext uri="{FF2B5EF4-FFF2-40B4-BE49-F238E27FC236}">
+                <a16:creationId xmlns:a16="http://schemas.microsoft.com/office/drawing/2014/main" id="{74C03A53-46CC-4973-AACF-FECB0CED55C0}"/>
+              </a:ext>
+            </a:extLst>
+          </p:cNvPr>
+          <p:cNvSpPr>
+            <a:spLocks xmlns:a="http://schemas.openxmlformats.org/drawingml/2006/main" noGrp="1"/>
+          </p:cNvSpPr>
+          <p:nvPr/>
+        </p:nvSpPr>
+        <p:spPr>
+          <a:xfrm xmlns:a="http://schemas.openxmlformats.org/drawingml/2006/main">
+            <a:off x="990600" y="2552700"/>
+            <a:ext cx="4000500" cy="342900"/>
+          </a:xfrm>
+          <a:prstGeom xmlns:a="http://schemas.openxmlformats.org/drawingml/2006/main" prst="rect">
+            <a:avLst/>
+          </a:prstGeom>
+          <a:noFill xmlns:a="http://schemas.openxmlformats.org/drawingml/2006/main"/>
+          <a:ln xmlns:a="http://schemas.openxmlformats.org/drawingml/2006/main" w="0">
+            <a:noFill/>
+            <a:prstDash val="solid"/>
+          </a:ln>
+        </p:spPr>
+        <p:txBody>
+          <a:bodyPr xmlns:a="http://schemas.openxmlformats.org/drawingml/2006/main"/>
+          <a:lstStyle xmlns:a="http://schemas.openxmlformats.org/drawingml/2006/main"/>
+          <a:p xmlns:a="http://schemas.openxmlformats.org/drawingml/2006/main">
+            <a:pPr>
+              <a:defRPr sz="1800" b="1">
+                <a:solidFill>
+                  <a:srgbClr val="000000"/>
+                </a:solidFill>
+              </a:defRPr>
+            </a:pPr>
+            <a:r>
+              <a:rPr sz="1800" b="1">
+                <a:solidFill>
+                  <a:srgbClr val="000000"/>
+                </a:solidFill>
+              </a:rPr>
+              <a:t>Current live basket</a:t>
+            </a:r>
+          </a:p>
+        </p:txBody>
+      </p:sp>
+      <p:sp>
+        <p:nvSpPr>
+          <p:cNvPr id="6" name="">
+            <a:extLst xmlns:a="http://schemas.openxmlformats.org/drawingml/2006/main">
+              <a:ext uri="{FF2B5EF4-FFF2-40B4-BE49-F238E27FC236}">
+                <a16:creationId xmlns:a16="http://schemas.microsoft.com/office/drawing/2014/main" id="{136D63E0-1ADB-49A4-A0D7-633309D746A9}"/>
+              </a:ext>
+            </a:extLst>
+          </p:cNvPr>
+          <p:cNvSpPr>
+            <a:spLocks xmlns:a="http://schemas.openxmlformats.org/drawingml/2006/main" noGrp="1"/>
+          </p:cNvSpPr>
+          <p:nvPr/>
+        </p:nvSpPr>
+        <p:spPr>
+          <a:xfrm xmlns:a="http://schemas.openxmlformats.org/drawingml/2006/main">
+            <a:off x="990600" y="3105150"/>
+            <a:ext cx="4095750" cy="1352550"/>
+          </a:xfrm>
+          <a:prstGeom xmlns:a="http://schemas.openxmlformats.org/drawingml/2006/main" prst="rect">
+            <a:avLst/>
+          </a:prstGeom>
+          <a:noFill xmlns:a="http://schemas.openxmlformats.org/drawingml/2006/main"/>
+          <a:ln xmlns:a="http://schemas.openxmlformats.org/drawingml/2006/main" w="0">
+            <a:noFill/>
+            <a:prstDash val="solid"/>
+          </a:ln>
+        </p:spPr>
+        <p:txBody>
+          <a:bodyPr xmlns:a="http://schemas.openxmlformats.org/drawingml/2006/main"/>
+          <a:lstStyle xmlns:a="http://schemas.openxmlformats.org/drawingml/2006/main"/>
+          <a:p xmlns:a="http://schemas.openxmlformats.org/drawingml/2006/main">
+            <a:pPr>
+              <a:defRPr sz="1500">
+                <a:solidFill>
+                  <a:srgbClr val="222222"/>
+                </a:solidFill>
+              </a:defRPr>
+            </a:pPr>
+            <a:r>
+              <a:rPr sz="1500">
+                <a:solidFill>
+                  <a:srgbClr val="222222"/>
+                </a:solidFill>
+              </a:rPr>
+              <a:t>• AMD,NVDA,PLTR,TSLA,SOFI</a:t>
+            </a:r>
+          </a:p>
+          <a:p xmlns:a="http://schemas.openxmlformats.org/drawingml/2006/main">
+            <a:pPr>
+              <a:defRPr sz="1500">
+                <a:solidFill>
+                  <a:srgbClr val="222222"/>
+                </a:solidFill>
+              </a:defRPr>
+            </a:pPr>
+            <a:r>
+              <a:rPr sz="1500">
+                <a:solidFill>
+                  <a:srgbClr val="222222"/>
+                </a:solidFill>
+              </a:rPr>
+              <a:t>• Gen4 RESEARCH_ASSETS context</a:t>
+            </a:r>
+          </a:p>
+          <a:p xmlns:a="http://schemas.openxmlformats.org/drawingml/2006/main">
+            <a:pPr>
+              <a:defRPr sz="1500">
+                <a:solidFill>
+                  <a:srgbClr val="222222"/>
+                </a:solidFill>
+              </a:defRPr>
+            </a:pPr>
+            <a:r>
+              <a:rPr sz="1500">
+                <a:solidFill>
+                  <a:srgbClr val="222222"/>
+                </a:solidFill>
+              </a:rPr>
+              <a:t>• Best evidence for live bridge policy</a:t>
+            </a:r>
+          </a:p>
+          <a:p xmlns:a="http://schemas.openxmlformats.org/drawingml/2006/main">
+            <a:pPr>
+              <a:defRPr sz="1500">
+                <a:solidFill>
+                  <a:srgbClr val="222222"/>
+                </a:solidFill>
+              </a:defRPr>
+            </a:pPr>
+            <a:r>
+              <a:rPr sz="1500">
+                <a:solidFill>
+                  <a:srgbClr val="222222"/>
+                </a:solidFill>
+              </a:rPr>
+              <a:t>• History limited by newer symbols</a:t>
+            </a:r>
+          </a:p>
+        </p:txBody>
+      </p:sp>
+      <p:sp>
+        <p:nvSpPr>
+          <p:cNvPr id="7" name="">
+            <a:extLst xmlns:a="http://schemas.openxmlformats.org/drawingml/2006/main">
+              <a:ext uri="{FF2B5EF4-FFF2-40B4-BE49-F238E27FC236}">
+                <a16:creationId xmlns:a16="http://schemas.microsoft.com/office/drawing/2014/main" id="{28AD40C1-B0DE-4EE3-8161-6E1EFEBB91C5}"/>
+              </a:ext>
+            </a:extLst>
+          </p:cNvPr>
+          <p:cNvSpPr>
+            <a:spLocks xmlns:a="http://schemas.openxmlformats.org/drawingml/2006/main" noGrp="1"/>
+          </p:cNvSpPr>
+          <p:nvPr/>
+        </p:nvSpPr>
+        <p:spPr>
+          <a:xfrm xmlns:a="http://schemas.openxmlformats.org/drawingml/2006/main">
+            <a:off x="6553200" y="1809750"/>
+            <a:ext cx="4953000" cy="3048000"/>
+          </a:xfrm>
+          <a:prstGeom xmlns:a="http://schemas.openxmlformats.org/drawingml/2006/main" prst="rect">
+            <a:avLst/>
+          </a:prstGeom>
+          <a:solidFill xmlns:a="http://schemas.openxmlformats.org/drawingml/2006/main">
+            <a:srgbClr val="F4F4F4"/>
+          </a:solidFill>
+          <a:ln xmlns:a="http://schemas.openxmlformats.org/drawingml/2006/main" w="0">
+            <a:noFill/>
+            <a:prstDash val="solid"/>
+          </a:ln>
+        </p:spPr>
+      </p:sp>
+      <p:sp>
+        <p:nvSpPr>
+          <p:cNvPr id="8" name="">
+            <a:extLst xmlns:a="http://schemas.openxmlformats.org/drawingml/2006/main">
+              <a:ext uri="{FF2B5EF4-FFF2-40B4-BE49-F238E27FC236}">
+                <a16:creationId xmlns:a16="http://schemas.microsoft.com/office/drawing/2014/main" id="{10AB2769-31D8-406C-9873-37A4559A1A51}"/>
+              </a:ext>
+            </a:extLst>
+          </p:cNvPr>
+          <p:cNvSpPr>
+            <a:spLocks xmlns:a="http://schemas.openxmlformats.org/drawingml/2006/main" noGrp="1"/>
+          </p:cNvSpPr>
+          <p:nvPr/>
+        </p:nvSpPr>
+        <p:spPr>
+          <a:xfrm xmlns:a="http://schemas.openxmlformats.org/drawingml/2006/main">
+            <a:off x="6858000" y="2057400"/>
+            <a:ext cx="1905000" cy="400050"/>
+          </a:xfrm>
+          <a:prstGeom xmlns:a="http://schemas.openxmlformats.org/drawingml/2006/main" prst="rect">
+            <a:avLst/>
+          </a:prstGeom>
+          <a:noFill xmlns:a="http://schemas.openxmlformats.org/drawingml/2006/main"/>
+          <a:ln xmlns:a="http://schemas.openxmlformats.org/drawingml/2006/main" w="0">
+            <a:noFill/>
+            <a:prstDash val="solid"/>
+          </a:ln>
+        </p:spPr>
+        <p:txBody>
+          <a:bodyPr xmlns:a="http://schemas.openxmlformats.org/drawingml/2006/main"/>
+          <a:lstStyle xmlns:a="http://schemas.openxmlformats.org/drawingml/2006/main"/>
+          <a:p xmlns:a="http://schemas.openxmlformats.org/drawingml/2006/main">
+            <a:pPr>
+              <a:defRPr sz="2250" b="1">
+                <a:solidFill>
+                  <a:srgbClr val="1B7F5A"/>
+                </a:solidFill>
+              </a:defRPr>
+            </a:pPr>
+            <a:r>
+              <a:rPr sz="2250" b="1">
+                <a:solidFill>
+                  <a:srgbClr val="1B7F5A"/>
+                </a:solidFill>
+              </a:rPr>
+              <a:t>Screen B</a:t>
+            </a:r>
+          </a:p>
+        </p:txBody>
+      </p:sp>
+      <p:sp>
+        <p:nvSpPr>
+          <p:cNvPr id="9" name="">
+            <a:extLst xmlns:a="http://schemas.openxmlformats.org/drawingml/2006/main">
+              <a:ext uri="{FF2B5EF4-FFF2-40B4-BE49-F238E27FC236}">
+                <a16:creationId xmlns:a16="http://schemas.microsoft.com/office/drawing/2014/main" id="{FF81E073-EB4A-47E4-AEE2-76EC9DE641FB}"/>
+              </a:ext>
+            </a:extLst>
+          </p:cNvPr>
+          <p:cNvSpPr>
+            <a:spLocks xmlns:a="http://schemas.openxmlformats.org/drawingml/2006/main" noGrp="1"/>
+          </p:cNvSpPr>
+          <p:nvPr/>
+        </p:nvSpPr>
+        <p:spPr>
+          <a:xfrm xmlns:a="http://schemas.openxmlformats.org/drawingml/2006/main">
+            <a:off x="6858000" y="2552700"/>
+            <a:ext cx="4000500" cy="342900"/>
+          </a:xfrm>
+          <a:prstGeom xmlns:a="http://schemas.openxmlformats.org/drawingml/2006/main" prst="rect">
+            <a:avLst/>
+          </a:prstGeom>
+          <a:noFill xmlns:a="http://schemas.openxmlformats.org/drawingml/2006/main"/>
+          <a:ln xmlns:a="http://schemas.openxmlformats.org/drawingml/2006/main" w="0">
+            <a:noFill/>
+            <a:prstDash val="solid"/>
+          </a:ln>
+        </p:spPr>
+        <p:txBody>
+          <a:bodyPr xmlns:a="http://schemas.openxmlformats.org/drawingml/2006/main"/>
+          <a:lstStyle xmlns:a="http://schemas.openxmlformats.org/drawingml/2006/main"/>
+          <a:p xmlns:a="http://schemas.openxmlformats.org/drawingml/2006/main">
+            <a:pPr>
+              <a:defRPr sz="1800" b="1">
+                <a:solidFill>
+                  <a:srgbClr val="000000"/>
+                </a:solidFill>
+              </a:defRPr>
+            </a:pPr>
+            <a:r>
+              <a:rPr sz="1800" b="1">
+                <a:solidFill>
+                  <a:srgbClr val="000000"/>
+                </a:solidFill>
+              </a:rPr>
+              <a:t>Historical substitute basket</a:t>
+            </a:r>
+          </a:p>
+        </p:txBody>
+      </p:sp>
+      <p:sp>
+        <p:nvSpPr>
+          <p:cNvPr id="10" name="">
+            <a:extLst xmlns:a="http://schemas.openxmlformats.org/drawingml/2006/main">
+              <a:ext uri="{FF2B5EF4-FFF2-40B4-BE49-F238E27FC236}">
+                <a16:creationId xmlns:a16="http://schemas.microsoft.com/office/drawing/2014/main" id="{3625DD9D-91B0-4028-8E78-325A06E38852}"/>
+              </a:ext>
+            </a:extLst>
+          </p:cNvPr>
+          <p:cNvSpPr>
+            <a:spLocks xmlns:a="http://schemas.openxmlformats.org/drawingml/2006/main" noGrp="1"/>
+          </p:cNvSpPr>
+          <p:nvPr/>
+        </p:nvSpPr>
+        <p:spPr>
+          <a:xfrm xmlns:a="http://schemas.openxmlformats.org/drawingml/2006/main">
+            <a:off x="6858000" y="3105150"/>
+            <a:ext cx="4095750" cy="1352550"/>
+          </a:xfrm>
+          <a:prstGeom xmlns:a="http://schemas.openxmlformats.org/drawingml/2006/main" prst="rect">
+            <a:avLst/>
+          </a:prstGeom>
+          <a:noFill xmlns:a="http://schemas.openxmlformats.org/drawingml/2006/main"/>
+          <a:ln xmlns:a="http://schemas.openxmlformats.org/drawingml/2006/main" w="0">
+            <a:noFill/>
+            <a:prstDash val="solid"/>
+          </a:ln>
+        </p:spPr>
+        <p:txBody>
+          <a:bodyPr xmlns:a="http://schemas.openxmlformats.org/drawingml/2006/main"/>
+          <a:lstStyle xmlns:a="http://schemas.openxmlformats.org/drawingml/2006/main"/>
+          <a:p xmlns:a="http://schemas.openxmlformats.org/drawingml/2006/main">
+            <a:pPr>
+              <a:defRPr sz="1500">
+                <a:solidFill>
+                  <a:srgbClr val="222222"/>
+                </a:solidFill>
+              </a:defRPr>
+            </a:pPr>
+            <a:r>
+              <a:rPr sz="1500">
+                <a:solidFill>
+                  <a:srgbClr val="222222"/>
+                </a:solidFill>
+              </a:rPr>
+              <a:t>• AMD,NVDA,TSLA,AAPL,MSTR</a:t>
+            </a:r>
+          </a:p>
+          <a:p xmlns:a="http://schemas.openxmlformats.org/drawingml/2006/main">
+            <a:pPr>
+              <a:defRPr sz="1500">
+                <a:solidFill>
+                  <a:srgbClr val="222222"/>
+                </a:solidFill>
+              </a:defRPr>
+            </a:pPr>
+            <a:r>
+              <a:rPr sz="1500">
+                <a:solidFill>
+                  <a:srgbClr val="222222"/>
+                </a:solidFill>
+              </a:rPr>
+              <a:t>• Long-history active-plus-risk context</a:t>
+            </a:r>
+          </a:p>
+          <a:p xmlns:a="http://schemas.openxmlformats.org/drawingml/2006/main">
+            <a:pPr>
+              <a:defRPr sz="1500">
+                <a:solidFill>
+                  <a:srgbClr val="222222"/>
+                </a:solidFill>
+              </a:defRPr>
+            </a:pPr>
+            <a:r>
+              <a:rPr sz="1500">
+                <a:solidFill>
+                  <a:srgbClr val="222222"/>
+                </a:solidFill>
+              </a:rPr>
+              <a:t>• Older-regime robustness evidence</a:t>
+            </a:r>
+          </a:p>
+          <a:p xmlns:a="http://schemas.openxmlformats.org/drawingml/2006/main">
+            <a:pPr>
+              <a:defRPr sz="1500">
+                <a:solidFill>
+                  <a:srgbClr val="222222"/>
+                </a:solidFill>
+              </a:defRPr>
+            </a:pPr>
+            <a:r>
+              <a:rPr sz="1500">
+                <a:solidFill>
+                  <a:srgbClr val="222222"/>
+                </a:solidFill>
+              </a:rPr>
+              <a:t>• Not a literal live-basket replication</a:t>
+            </a:r>
+          </a:p>
+        </p:txBody>
+      </p:sp>
+      <p:sp>
+        <p:nvSpPr>
+          <p:cNvPr id="11" name="">
+            <a:extLst xmlns:a="http://schemas.openxmlformats.org/drawingml/2006/main">
+              <a:ext uri="{FF2B5EF4-FFF2-40B4-BE49-F238E27FC236}">
+                <a16:creationId xmlns:a16="http://schemas.microsoft.com/office/drawing/2014/main" id="{FEBA71CF-6DA0-42E1-893E-D5E1D1B5CDE1}"/>
+              </a:ext>
+            </a:extLst>
+          </p:cNvPr>
+          <p:cNvSpPr>
+            <a:spLocks xmlns:a="http://schemas.openxmlformats.org/drawingml/2006/main" noGrp="1"/>
+          </p:cNvSpPr>
+          <p:nvPr/>
+        </p:nvSpPr>
+        <p:spPr>
+          <a:xfrm xmlns:a="http://schemas.openxmlformats.org/drawingml/2006/main">
+            <a:off x="1257300" y="5314950"/>
+            <a:ext cx="9620250" cy="381000"/>
+          </a:xfrm>
+          <a:prstGeom xmlns:a="http://schemas.openxmlformats.org/drawingml/2006/main" prst="rect">
+            <a:avLst/>
+          </a:prstGeom>
+          <a:noFill xmlns:a="http://schemas.openxmlformats.org/drawingml/2006/main"/>
+          <a:ln xmlns:a="http://schemas.openxmlformats.org/drawingml/2006/main" w="0">
+            <a:noFill/>
+            <a:prstDash val="solid"/>
+          </a:ln>
+        </p:spPr>
+        <p:txBody>
+          <a:bodyPr xmlns:a="http://schemas.openxmlformats.org/drawingml/2006/main"/>
+          <a:lstStyle xmlns:a="http://schemas.openxmlformats.org/drawingml/2006/main"/>
+          <a:p xmlns:a="http://schemas.openxmlformats.org/drawingml/2006/main">
+            <a:pPr>
+              <a:defRPr sz="1800" b="1">
+                <a:solidFill>
+                  <a:srgbClr val="000000"/>
+                </a:solidFill>
+              </a:defRPr>
+            </a:pPr>
+            <a:r>
+              <a:rPr sz="1800" b="1">
+                <a:solidFill>
+                  <a:srgbClr val="000000"/>
+                </a:solidFill>
+              </a:rPr>
+              <a:t>The results should be read side by side, not collapsed into one leaderboard.</a:t>
+            </a:r>
+          </a:p>
+        </p:txBody>
+      </p:sp>
+      <p:sp>
+        <p:nvSpPr>
+          <p:cNvPr id="12" name="">
+            <a:extLst xmlns:a="http://schemas.openxmlformats.org/drawingml/2006/main">
+              <a:ext uri="{FF2B5EF4-FFF2-40B4-BE49-F238E27FC236}">
+                <a16:creationId xmlns:a16="http://schemas.microsoft.com/office/drawing/2014/main" id="{48B21B79-1C0B-445B-BCB9-9A604CEAA7FA}"/>
+              </a:ext>
+            </a:extLst>
+          </p:cNvPr>
+          <p:cNvSpPr>
+            <a:spLocks xmlns:a="http://schemas.openxmlformats.org/drawingml/2006/main" noGrp="1"/>
+          </p:cNvSpPr>
+          <p:nvPr/>
+        </p:nvSpPr>
+        <p:spPr>
+          <a:xfrm xmlns:a="http://schemas.openxmlformats.org/drawingml/2006/main">
+            <a:off x="400050" y="6343650"/>
+            <a:ext cx="11391900" cy="13335"/>
+          </a:xfrm>
+          <a:prstGeom xmlns:a="http://schemas.openxmlformats.org/drawingml/2006/main" prst="rect">
+            <a:avLst/>
+          </a:prstGeom>
+          <a:solidFill xmlns:a="http://schemas.openxmlformats.org/drawingml/2006/main">
+            <a:srgbClr val="B8BCC4"/>
+          </a:solidFill>
+          <a:ln xmlns:a="http://schemas.openxmlformats.org/drawingml/2006/main" w="0">
+            <a:solidFill>
+              <a:srgbClr val="B8BCC4"/>
+            </a:solidFill>
+            <a:prstDash val="solid"/>
+          </a:ln>
+        </p:spPr>
+      </p:sp>
+      <p:sp>
+        <p:nvSpPr>
+          <p:cNvPr id="13" name="">
+            <a:extLst xmlns:a="http://schemas.openxmlformats.org/drawingml/2006/main">
+              <a:ext uri="{FF2B5EF4-FFF2-40B4-BE49-F238E27FC236}">
+                <a16:creationId xmlns:a16="http://schemas.microsoft.com/office/drawing/2014/main" id="{55D70820-2B3E-4DD8-924A-41F6B1B5F432}"/>
+              </a:ext>
+            </a:extLst>
+          </p:cNvPr>
+          <p:cNvSpPr>
+            <a:spLocks xmlns:a="http://schemas.openxmlformats.org/drawingml/2006/main" noGrp="1"/>
+          </p:cNvSpPr>
+          <p:nvPr/>
+        </p:nvSpPr>
+        <p:spPr>
+          <a:xfrm xmlns:a="http://schemas.openxmlformats.org/drawingml/2006/main">
+            <a:off x="400050" y="6477000"/>
+            <a:ext cx="4381500" cy="228600"/>
+          </a:xfrm>
+          <a:prstGeom xmlns:a="http://schemas.openxmlformats.org/drawingml/2006/main" prst="rect">
+            <a:avLst/>
+          </a:prstGeom>
+          <a:noFill xmlns:a="http://schemas.openxmlformats.org/drawingml/2006/main"/>
+          <a:ln xmlns:a="http://schemas.openxmlformats.org/drawingml/2006/main" w="0">
+            <a:noFill/>
+            <a:prstDash val="solid"/>
+          </a:ln>
+        </p:spPr>
+        <p:txBody>
+          <a:bodyPr xmlns:a="http://schemas.openxmlformats.org/drawingml/2006/main"/>
+          <a:lstStyle xmlns:a="http://schemas.openxmlformats.org/drawingml/2006/main"/>
+          <a:p xmlns:a="http://schemas.openxmlformats.org/drawingml/2006/main">
+            <a:pPr>
+              <a:defRPr sz="1050">
+                <a:solidFill>
+                  <a:srgbClr val="555555"/>
+                </a:solidFill>
+              </a:defRPr>
+            </a:pPr>
+            <a:r>
+              <a:rPr sz="1050">
+                <a:solidFill>
+                  <a:srgbClr val="555555"/>
+                </a:solidFill>
+              </a:rPr>
+              <a:t>Gen5.1 selection-policy hypothesis</a:t>
+            </a:r>
+          </a:p>
+        </p:txBody>
+      </p:sp>
+      <p:sp>
+        <p:nvSpPr>
+          <p:cNvPr id="14" name="">
+            <a:extLst xmlns:a="http://schemas.openxmlformats.org/drawingml/2006/main">
+              <a:ext uri="{FF2B5EF4-FFF2-40B4-BE49-F238E27FC236}">
+                <a16:creationId xmlns:a16="http://schemas.microsoft.com/office/drawing/2014/main" id="{DC83B31A-B5AD-4DF4-A7E0-AC01A0E27488}"/>
+              </a:ext>
+            </a:extLst>
+          </p:cNvPr>
+          <p:cNvSpPr>
+            <a:spLocks xmlns:a="http://schemas.openxmlformats.org/drawingml/2006/main" noGrp="1"/>
+          </p:cNvSpPr>
+          <p:nvPr/>
+        </p:nvSpPr>
+        <p:spPr>
+          <a:xfrm xmlns:a="http://schemas.openxmlformats.org/drawingml/2006/main">
+            <a:off x="11277600" y="6457950"/>
+            <a:ext cx="514350" cy="266700"/>
+          </a:xfrm>
+          <a:prstGeom xmlns:a="http://schemas.openxmlformats.org/drawingml/2006/main" prst="rect">
+            <a:avLst/>
+          </a:prstGeom>
+          <a:noFill xmlns:a="http://schemas.openxmlformats.org/drawingml/2006/main"/>
+          <a:ln xmlns:a="http://schemas.openxmlformats.org/drawingml/2006/main" w="0">
+            <a:noFill/>
+            <a:prstDash val="solid"/>
+          </a:ln>
+        </p:spPr>
+        <p:txBody>
+          <a:bodyPr xmlns:a="http://schemas.openxmlformats.org/drawingml/2006/main"/>
+          <a:lstStyle xmlns:a="http://schemas.openxmlformats.org/drawingml/2006/main"/>
+          <a:p xmlns:a="http://schemas.openxmlformats.org/drawingml/2006/main">
+            <a:pPr algn="r">
+              <a:defRPr sz="1200" b="1">
+                <a:solidFill>
+                  <a:srgbClr val="555555"/>
+                </a:solidFill>
+              </a:defRPr>
+            </a:pPr>
+            <a:r>
+              <a:rPr sz="1200" b="1">
+                <a:solidFill>
+                  <a:srgbClr val="555555"/>
+                </a:solidFill>
+              </a:rPr>
+              <a:t>08</a:t>
+            </a:r>
+          </a:p>
+        </p:txBody>
+      </p:sp>
+    </p:spTree>
+    <p:extLst>
+      <p:ext uri="{BB962C8B-B14F-4D97-AF65-F5344CB8AC3E}">
+        <p14:creationId xmlns:p14="http://schemas.microsoft.com/office/powerpoint/2010/main" val="1123074192"/>
+      </p:ext>
+    </p:extLst>
+  </p:cSld>
+</p:sld>
+</file>
+
+<file path=ppt/slides/slide9.xml><?xml version="1.0" encoding="utf-8"?>
+<p:sld xmlns:p="http://schemas.openxmlformats.org/presentationml/2006/main">
+  <p:cSld>
+    <p:bg>
+      <p:bgPr>
+        <a:solidFill xmlns:a="http://schemas.openxmlformats.org/drawingml/2006/main">
+          <a:srgbClr val="FFFFFF"/>
+        </a:solidFill>
+      </p:bgPr>
+    </p:bg>
+    <p:spTree>
+      <p:nvGrpSpPr>
+        <p:cNvPr id="1" name=""/>
+        <p:cNvGrpSpPr/>
+        <p:nvPr/>
+      </p:nvGrpSpPr>
+      <p:grpSpPr>
+        <a:xfrm xmlns:a="http://schemas.openxmlformats.org/drawingml/2006/main"/>
+      </p:grpSpPr>
+      <p:sp>
+        <p:nvSpPr>
+          <p:cNvPr id="1" name="">
+            <a:extLst xmlns:a="http://schemas.openxmlformats.org/drawingml/2006/main">
+              <a:ext uri="{FF2B5EF4-FFF2-40B4-BE49-F238E27FC236}">
+                <a16:creationId xmlns:a16="http://schemas.microsoft.com/office/drawing/2014/main" id="{7200820A-1614-4766-8CC6-BA3BFE5E8D2D}"/>
+              </a:ext>
+            </a:extLst>
+          </p:cNvPr>
+          <p:cNvSpPr>
+            <a:spLocks xmlns:a="http://schemas.openxmlformats.org/drawingml/2006/main" noGrp="1"/>
+          </p:cNvSpPr>
+          <p:nvPr/>
+        </p:nvSpPr>
+        <p:spPr>
+          <a:xfrm xmlns:a="http://schemas.openxmlformats.org/drawingml/2006/main">
+            <a:off x="400050" y="400050"/>
+            <a:ext cx="2476500" cy="266700"/>
+          </a:xfrm>
+          <a:prstGeom xmlns:a="http://schemas.openxmlformats.org/drawingml/2006/main" prst="rect">
+            <a:avLst/>
+          </a:prstGeom>
+          <a:noFill xmlns:a="http://schemas.openxmlformats.org/drawingml/2006/main"/>
+          <a:ln xmlns:a="http://schemas.openxmlformats.org/drawingml/2006/main" w="0">
+            <a:noFill/>
+            <a:prstDash val="solid"/>
+          </a:ln>
+        </p:spPr>
+        <p:txBody>
+          <a:bodyPr xmlns:a="http://schemas.openxmlformats.org/drawingml/2006/main"/>
+          <a:lstStyle xmlns:a="http://schemas.openxmlformats.org/drawingml/2006/main"/>
+          <a:p xmlns:a="http://schemas.openxmlformats.org/drawingml/2006/main">
+            <a:pPr>
+              <a:defRPr sz="1200" b="1">
+                <a:solidFill>
+                  <a:srgbClr val="555555"/>
+                </a:solidFill>
+              </a:defRPr>
+            </a:pPr>
+            <a:r>
+              <a:rPr sz="1200" b="1">
+                <a:solidFill>
+                  <a:srgbClr val="555555"/>
+                </a:solidFill>
+              </a:rPr>
+              <a:t>PRACTICAL LIMIT</a:t>
+            </a:r>
+          </a:p>
+        </p:txBody>
+      </p:sp>
+      <p:sp>
+        <p:nvSpPr>
+          <p:cNvPr id="2" name="">
+            <a:extLst xmlns:a="http://schemas.openxmlformats.org/drawingml/2006/main">
+              <a:ext uri="{FF2B5EF4-FFF2-40B4-BE49-F238E27FC236}">
+                <a16:creationId xmlns:a16="http://schemas.microsoft.com/office/drawing/2014/main" id="{107CD28D-E846-4335-9DE0-2ACFFC97E8A9}"/>
+              </a:ext>
+            </a:extLst>
+          </p:cNvPr>
+          <p:cNvSpPr>
+            <a:spLocks xmlns:a="http://schemas.openxmlformats.org/drawingml/2006/main" noGrp="1"/>
+          </p:cNvSpPr>
+          <p:nvPr/>
+        </p:nvSpPr>
+        <p:spPr>
+          <a:xfrm xmlns:a="http://schemas.openxmlformats.org/drawingml/2006/main">
+            <a:off x="400050" y="838200"/>
+            <a:ext cx="10096500" cy="609600"/>
+          </a:xfrm>
+          <a:prstGeom xmlns:a="http://schemas.openxmlformats.org/drawingml/2006/main" prst="rect">
+            <a:avLst/>
+          </a:prstGeom>
+          <a:noFill xmlns:a="http://schemas.openxmlformats.org/drawingml/2006/main"/>
+          <a:ln xmlns:a="http://schemas.openxmlformats.org/drawingml/2006/main" w="0">
+            <a:noFill/>
+            <a:prstDash val="solid"/>
+          </a:ln>
+        </p:spPr>
+        <p:txBody>
+          <a:bodyPr xmlns:a="http://schemas.openxmlformats.org/drawingml/2006/main"/>
+          <a:lstStyle xmlns:a="http://schemas.openxmlformats.org/drawingml/2006/main"/>
+          <a:p xmlns:a="http://schemas.openxmlformats.org/drawingml/2006/main">
+            <a:pPr>
+              <a:defRPr sz="3000" b="1">
+                <a:solidFill>
+                  <a:srgbClr val="000000"/>
+                </a:solidFill>
+              </a:defRPr>
+            </a:pPr>
+            <a:r>
+              <a:rPr sz="3000" b="1">
+                <a:solidFill>
+                  <a:srgbClr val="000000"/>
+                </a:solidFill>
+              </a:rPr>
+              <a:t>The broader run needs resumable authority builds</a:t>
+            </a:r>
+          </a:p>
+        </p:txBody>
+      </p:sp>
+      <p:sp>
+        <p:nvSpPr>
+          <p:cNvPr id="3" name="">
+            <a:extLst xmlns:a="http://schemas.openxmlformats.org/drawingml/2006/main">
+              <a:ext uri="{FF2B5EF4-FFF2-40B4-BE49-F238E27FC236}">
+                <a16:creationId xmlns:a16="http://schemas.microsoft.com/office/drawing/2014/main" id="{88C129BC-8708-4A02-A8A0-3E7C74C42E21}"/>
+              </a:ext>
+            </a:extLst>
+          </p:cNvPr>
+          <p:cNvSpPr>
+            <a:spLocks xmlns:a="http://schemas.openxmlformats.org/drawingml/2006/main" noGrp="1"/>
+          </p:cNvSpPr>
+          <p:nvPr/>
+        </p:nvSpPr>
+        <p:spPr>
+          <a:xfrm xmlns:a="http://schemas.openxmlformats.org/drawingml/2006/main">
+            <a:off x="400050" y="1600200"/>
+            <a:ext cx="10096500" cy="990600"/>
+          </a:xfrm>
+          <a:prstGeom xmlns:a="http://schemas.openxmlformats.org/drawingml/2006/main" prst="rect">
+            <a:avLst/>
+          </a:prstGeom>
+          <a:noFill xmlns:a="http://schemas.openxmlformats.org/drawingml/2006/main"/>
+          <a:ln xmlns:a="http://schemas.openxmlformats.org/drawingml/2006/main" w="0">
+            <a:noFill/>
+            <a:prstDash val="solid"/>
+          </a:ln>
+        </p:spPr>
+        <p:txBody>
+          <a:bodyPr xmlns:a="http://schemas.openxmlformats.org/drawingml/2006/main"/>
+          <a:lstStyle xmlns:a="http://schemas.openxmlformats.org/drawingml/2006/main"/>
+          <a:p xmlns:a="http://schemas.openxmlformats.org/drawingml/2006/main">
+            <a:pPr>
+              <a:defRPr sz="1725">
+                <a:solidFill>
+                  <a:srgbClr val="222222"/>
+                </a:solidFill>
+              </a:defRPr>
+            </a:pPr>
+            <a:r>
+              <a:rPr sz="1725">
+                <a:solidFill>
+                  <a:srgbClr val="222222"/>
+                </a:solidFill>
+              </a:rPr>
+              <a:t>A new five-symbol Gen4-like authority evaluates 172 candidate specs per asset before state routing. The first new A-live authority stayed compute-bound in an interactive run, so the wrapper now records the right job shape but the evidence packet is not complete yet.</a:t>
+            </a:r>
+          </a:p>
+        </p:txBody>
+      </p:sp>
+      <p:sp>
+        <p:nvSpPr>
+          <p:cNvPr id="4" name="">
+            <a:extLst xmlns:a="http://schemas.openxmlformats.org/drawingml/2006/main">
+              <a:ext uri="{FF2B5EF4-FFF2-40B4-BE49-F238E27FC236}">
+                <a16:creationId xmlns:a16="http://schemas.microsoft.com/office/drawing/2014/main" id="{F735C104-0448-4CA6-A058-26E35FD767CB}"/>
+              </a:ext>
+            </a:extLst>
+          </p:cNvPr>
+          <p:cNvSpPr>
+            <a:spLocks xmlns:a="http://schemas.openxmlformats.org/drawingml/2006/main" noGrp="1"/>
+          </p:cNvSpPr>
+          <p:nvPr/>
+        </p:nvSpPr>
+        <p:spPr>
+          <a:xfrm xmlns:a="http://schemas.openxmlformats.org/drawingml/2006/main">
+            <a:off x="914400" y="3086100"/>
+            <a:ext cx="2286000" cy="323850"/>
+          </a:xfrm>
+          <a:prstGeom xmlns:a="http://schemas.openxmlformats.org/drawingml/2006/main" prst="rect">
+            <a:avLst/>
+          </a:prstGeom>
+          <a:noFill xmlns:a="http://schemas.openxmlformats.org/drawingml/2006/main"/>
+          <a:ln xmlns:a="http://schemas.openxmlformats.org/drawingml/2006/main" w="0">
+            <a:noFill/>
+            <a:prstDash val="solid"/>
+          </a:ln>
+        </p:spPr>
+        <p:txBody>
+          <a:bodyPr xmlns:a="http://schemas.openxmlformats.org/drawingml/2006/main"/>
+          <a:lstStyle xmlns:a="http://schemas.openxmlformats.org/drawingml/2006/main"/>
+          <a:p xmlns:a="http://schemas.openxmlformats.org/drawingml/2006/main">
+            <a:pPr>
+              <a:defRPr sz="1875" b="1">
+                <a:solidFill>
+                  <a:srgbClr val="000000"/>
+                </a:solidFill>
+              </a:defRPr>
+            </a:pPr>
+            <a:r>
+              <a:rPr sz="1875" b="1">
+                <a:solidFill>
+                  <a:srgbClr val="000000"/>
+                </a:solidFill>
+              </a:rPr>
+              <a:t>Run order</a:t>
+            </a:r>
+          </a:p>
+        </p:txBody>
+      </p:sp>
+      <p:sp>
+        <p:nvSpPr>
+          <p:cNvPr id="5" name="">
+            <a:extLst xmlns:a="http://schemas.openxmlformats.org/drawingml/2006/main">
+              <a:ext uri="{FF2B5EF4-FFF2-40B4-BE49-F238E27FC236}">
+                <a16:creationId xmlns:a16="http://schemas.microsoft.com/office/drawing/2014/main" id="{7F9E15FB-B780-452A-9C2C-57C445E63747}"/>
+              </a:ext>
+            </a:extLst>
+          </p:cNvPr>
+          <p:cNvSpPr>
+            <a:spLocks xmlns:a="http://schemas.openxmlformats.org/drawingml/2006/main" noGrp="1"/>
+          </p:cNvSpPr>
+          <p:nvPr/>
+        </p:nvSpPr>
+        <p:spPr>
+          <a:xfrm xmlns:a="http://schemas.openxmlformats.org/drawingml/2006/main">
+            <a:off x="914400" y="3581400"/>
+            <a:ext cx="4953000" cy="1219200"/>
+          </a:xfrm>
+          <a:prstGeom xmlns:a="http://schemas.openxmlformats.org/drawingml/2006/main" prst="rect">
+            <a:avLst/>
+          </a:prstGeom>
+          <a:noFill xmlns:a="http://schemas.openxmlformats.org/drawingml/2006/main"/>
+          <a:ln xmlns:a="http://schemas.openxmlformats.org/drawingml/2006/main" w="0">
+            <a:noFill/>
+            <a:prstDash val="solid"/>
+          </a:ln>
+        </p:spPr>
+        <p:txBody>
+          <a:bodyPr xmlns:a="http://schemas.openxmlformats.org/drawingml/2006/main"/>
+          <a:lstStyle xmlns:a="http://schemas.openxmlformats.org/drawingml/2006/main"/>
+          <a:p xmlns:a="http://schemas.openxmlformats.org/drawingml/2006/main">
+            <a:pPr>
+              <a:defRPr sz="1650">
+                <a:solidFill>
+                  <a:srgbClr val="000000"/>
+                </a:solidFill>
+              </a:defRPr>
+            </a:pPr>
+            <a:r>
+              <a:rPr sz="1650">
+                <a:solidFill>
+                  <a:srgbClr val="000000"/>
+                </a:solidFill>
+              </a:rPr>
+              <a:t>• Run A_live as a standalone resumable job.</a:t>
+            </a:r>
+          </a:p>
+          <a:p xmlns:a="http://schemas.openxmlformats.org/drawingml/2006/main">
+            <a:pPr>
+              <a:defRPr sz="1650">
+                <a:solidFill>
+                  <a:srgbClr val="000000"/>
+                </a:solidFill>
+              </a:defRPr>
+            </a:pPr>
+            <a:r>
+              <a:rPr sz="1650">
+                <a:solidFill>
+                  <a:srgbClr val="000000"/>
+                </a:solidFill>
+              </a:rPr>
+              <a:t>• Inspect its report and visuals before starting B_hist.</a:t>
+            </a:r>
+          </a:p>
+          <a:p xmlns:a="http://schemas.openxmlformats.org/drawingml/2006/main">
+            <a:pPr>
+              <a:defRPr sz="1650">
+                <a:solidFill>
+                  <a:srgbClr val="000000"/>
+                </a:solidFill>
+              </a:defRPr>
+            </a:pPr>
+            <a:r>
+              <a:rPr sz="1650">
+                <a:solidFill>
+                  <a:srgbClr val="000000"/>
+                </a:solidFill>
+              </a:rPr>
+              <a:t>• Add per-symbol checkpoints if authority fitting remains too slow.</a:t>
+            </a:r>
+          </a:p>
+        </p:txBody>
+      </p:sp>
+      <p:sp>
+        <p:nvSpPr>
+          <p:cNvPr id="6" name="">
+            <a:extLst xmlns:a="http://schemas.openxmlformats.org/drawingml/2006/main">
+              <a:ext uri="{FF2B5EF4-FFF2-40B4-BE49-F238E27FC236}">
+                <a16:creationId xmlns:a16="http://schemas.microsoft.com/office/drawing/2014/main" id="{0FA7B00B-AC76-44F0-B86E-FF965B19A064}"/>
+              </a:ext>
+            </a:extLst>
+          </p:cNvPr>
+          <p:cNvSpPr>
+            <a:spLocks xmlns:a="http://schemas.openxmlformats.org/drawingml/2006/main" noGrp="1"/>
+          </p:cNvSpPr>
+          <p:nvPr/>
+        </p:nvSpPr>
+        <p:spPr>
+          <a:xfrm xmlns:a="http://schemas.openxmlformats.org/drawingml/2006/main">
+            <a:off x="6667500" y="3086100"/>
+            <a:ext cx="2857500" cy="323850"/>
+          </a:xfrm>
+          <a:prstGeom xmlns:a="http://schemas.openxmlformats.org/drawingml/2006/main" prst="rect">
+            <a:avLst/>
+          </a:prstGeom>
+          <a:noFill xmlns:a="http://schemas.openxmlformats.org/drawingml/2006/main"/>
+          <a:ln xmlns:a="http://schemas.openxmlformats.org/drawingml/2006/main" w="0">
+            <a:noFill/>
+            <a:prstDash val="solid"/>
+          </a:ln>
+        </p:spPr>
+        <p:txBody>
+          <a:bodyPr xmlns:a="http://schemas.openxmlformats.org/drawingml/2006/main"/>
+          <a:lstStyle xmlns:a="http://schemas.openxmlformats.org/drawingml/2006/main"/>
+          <a:p xmlns:a="http://schemas.openxmlformats.org/drawingml/2006/main">
+            <a:pPr>
+              <a:defRPr sz="1875" b="1">
+                <a:solidFill>
+                  <a:srgbClr val="000000"/>
+                </a:solidFill>
+              </a:defRPr>
+            </a:pPr>
+            <a:r>
+              <a:rPr sz="1875" b="1">
+                <a:solidFill>
+                  <a:srgbClr val="000000"/>
+                </a:solidFill>
+              </a:rPr>
+              <a:t>Decision boundary</a:t>
+            </a:r>
+          </a:p>
+        </p:txBody>
+      </p:sp>
+      <p:sp>
+        <p:nvSpPr>
+          <p:cNvPr id="7" name="">
+            <a:extLst xmlns:a="http://schemas.openxmlformats.org/drawingml/2006/main">
+              <a:ext uri="{FF2B5EF4-FFF2-40B4-BE49-F238E27FC236}">
+                <a16:creationId xmlns:a16="http://schemas.microsoft.com/office/drawing/2014/main" id="{3B9D9DB6-6AD5-44B4-B82B-62B0825F733A}"/>
+              </a:ext>
+            </a:extLst>
+          </p:cNvPr>
+          <p:cNvSpPr>
+            <a:spLocks xmlns:a="http://schemas.openxmlformats.org/drawingml/2006/main" noGrp="1"/>
+          </p:cNvSpPr>
+          <p:nvPr/>
+        </p:nvSpPr>
+        <p:spPr>
+          <a:xfrm xmlns:a="http://schemas.openxmlformats.org/drawingml/2006/main">
+            <a:off x="6667500" y="3581400"/>
+            <a:ext cx="4381500" cy="1219200"/>
+          </a:xfrm>
+          <a:prstGeom xmlns:a="http://schemas.openxmlformats.org/drawingml/2006/main" prst="rect">
+            <a:avLst/>
+          </a:prstGeom>
+          <a:noFill xmlns:a="http://schemas.openxmlformats.org/drawingml/2006/main"/>
+          <a:ln xmlns:a="http://schemas.openxmlformats.org/drawingml/2006/main" w="0">
+            <a:noFill/>
+            <a:prstDash val="solid"/>
+          </a:ln>
+        </p:spPr>
+        <p:txBody>
+          <a:bodyPr xmlns:a="http://schemas.openxmlformats.org/drawingml/2006/main"/>
+          <a:lstStyle xmlns:a="http://schemas.openxmlformats.org/drawingml/2006/main"/>
+          <a:p xmlns:a="http://schemas.openxmlformats.org/drawingml/2006/main">
+            <a:pPr>
+              <a:defRPr sz="1650">
+                <a:solidFill>
+                  <a:srgbClr val="000000"/>
+                </a:solidFill>
+              </a:defRPr>
+            </a:pPr>
+            <a:r>
+              <a:rPr sz="1650">
+                <a:solidFill>
+                  <a:srgbClr val="000000"/>
+                </a:solidFill>
+              </a:rPr>
+              <a:t>• No live bridge policy change yet.</a:t>
+            </a:r>
+          </a:p>
+          <a:p xmlns:a="http://schemas.openxmlformats.org/drawingml/2006/main">
+            <a:pPr>
+              <a:defRPr sz="1650">
+                <a:solidFill>
+                  <a:srgbClr val="000000"/>
+                </a:solidFill>
+              </a:defRPr>
+            </a:pPr>
+            <a:r>
+              <a:rPr sz="1650">
+                <a:solidFill>
+                  <a:srgbClr val="000000"/>
+                </a:solidFill>
+              </a:rPr>
+              <a:t>• No merged Screen A plus B winner table.</a:t>
+            </a:r>
+          </a:p>
+          <a:p xmlns:a="http://schemas.openxmlformats.org/drawingml/2006/main">
+            <a:pPr>
+              <a:defRPr sz="1650">
+                <a:solidFill>
+                  <a:srgbClr val="000000"/>
+                </a:solidFill>
+              </a:defRPr>
+            </a:pPr>
+            <a:r>
+              <a:rPr sz="1650">
+                <a:solidFill>
+                  <a:srgbClr val="000000"/>
+                </a:solidFill>
+              </a:rPr>
+              <a:t>• No performance acceptance from these inspection packets.</a:t>
+            </a:r>
+          </a:p>
+        </p:txBody>
+      </p:sp>
+      <p:sp>
+        <p:nvSpPr>
+          <p:cNvPr id="8" name="">
+            <a:extLst xmlns:a="http://schemas.openxmlformats.org/drawingml/2006/main">
+              <a:ext uri="{FF2B5EF4-FFF2-40B4-BE49-F238E27FC236}">
+                <a16:creationId xmlns:a16="http://schemas.microsoft.com/office/drawing/2014/main" id="{CC021D46-C856-4037-B840-F5DF8870F653}"/>
+              </a:ext>
+            </a:extLst>
+          </p:cNvPr>
+          <p:cNvSpPr>
+            <a:spLocks xmlns:a="http://schemas.openxmlformats.org/drawingml/2006/main" noGrp="1"/>
+          </p:cNvSpPr>
+          <p:nvPr/>
+        </p:nvSpPr>
+        <p:spPr>
+          <a:xfrm xmlns:a="http://schemas.openxmlformats.org/drawingml/2006/main">
+            <a:off x="876300" y="5257800"/>
+            <a:ext cx="10439400" cy="514350"/>
+          </a:xfrm>
+          <a:prstGeom xmlns:a="http://schemas.openxmlformats.org/drawingml/2006/main" prst="rect">
+            <a:avLst/>
+          </a:prstGeom>
+          <a:solidFill xmlns:a="http://schemas.openxmlformats.org/drawingml/2006/main">
+            <a:srgbClr val="FFE1D6"/>
+          </a:solidFill>
+          <a:ln xmlns:a="http://schemas.openxmlformats.org/drawingml/2006/main" w="0">
+            <a:noFill/>
+            <a:prstDash val="solid"/>
+          </a:ln>
+        </p:spPr>
+      </p:sp>
+      <p:sp>
+        <p:nvSpPr>
+          <p:cNvPr id="9" name="">
+            <a:extLst xmlns:a="http://schemas.openxmlformats.org/drawingml/2006/main">
+              <a:ext uri="{FF2B5EF4-FFF2-40B4-BE49-F238E27FC236}">
+                <a16:creationId xmlns:a16="http://schemas.microsoft.com/office/drawing/2014/main" id="{8467418A-7FF6-46A8-83FD-FE4383080CDC}"/>
+              </a:ext>
+            </a:extLst>
+          </p:cNvPr>
+          <p:cNvSpPr>
+            <a:spLocks xmlns:a="http://schemas.openxmlformats.org/drawingml/2006/main" noGrp="1"/>
+          </p:cNvSpPr>
+          <p:nvPr/>
+        </p:nvSpPr>
+        <p:spPr>
+          <a:xfrm xmlns:a="http://schemas.openxmlformats.org/drawingml/2006/main">
+            <a:off x="1143000" y="5410200"/>
+            <a:ext cx="9810750" cy="247650"/>
+          </a:xfrm>
+          <a:prstGeom xmlns:a="http://schemas.openxmlformats.org/drawingml/2006/main" prst="rect">
+            <a:avLst/>
+          </a:prstGeom>
+          <a:noFill xmlns:a="http://schemas.openxmlformats.org/drawingml/2006/main"/>
+          <a:ln xmlns:a="http://schemas.openxmlformats.org/drawingml/2006/main" w="0">
+            <a:noFill/>
+            <a:prstDash val="solid"/>
+          </a:ln>
+        </p:spPr>
+        <p:txBody>
+          <a:bodyPr xmlns:a="http://schemas.openxmlformats.org/drawingml/2006/main"/>
+          <a:lstStyle xmlns:a="http://schemas.openxmlformats.org/drawingml/2006/main"/>
+          <a:p xmlns:a="http://schemas.openxmlformats.org/drawingml/2006/main">
+            <a:pPr>
+              <a:defRPr sz="1500" b="1">
+                <a:solidFill>
+                  <a:srgbClr val="000000"/>
+                </a:solidFill>
+              </a:defRPr>
+            </a:pPr>
+            <a:r>
+              <a:rPr sz="1500" b="1">
+                <a:solidFill>
+                  <a:srgbClr val="000000"/>
+                </a:solidFill>
+              </a:rPr>
+              <a:t>The right next step is operational, not methodological: finish the authority packets without changing the experiment.</a:t>
+            </a:r>
+          </a:p>
+        </p:txBody>
+      </p:sp>
+      <p:sp>
+        <p:nvSpPr>
+          <p:cNvPr id="10" name="">
+            <a:extLst xmlns:a="http://schemas.openxmlformats.org/drawingml/2006/main">
+              <a:ext uri="{FF2B5EF4-FFF2-40B4-BE49-F238E27FC236}">
+                <a16:creationId xmlns:a16="http://schemas.microsoft.com/office/drawing/2014/main" id="{C723479D-0C05-44AA-A2E8-AE9DDD0777E4}"/>
+              </a:ext>
+            </a:extLst>
+          </p:cNvPr>
+          <p:cNvSpPr>
+            <a:spLocks xmlns:a="http://schemas.openxmlformats.org/drawingml/2006/main" noGrp="1"/>
+          </p:cNvSpPr>
+          <p:nvPr/>
+        </p:nvSpPr>
+        <p:spPr>
+          <a:xfrm xmlns:a="http://schemas.openxmlformats.org/drawingml/2006/main">
+            <a:off x="400050" y="6343650"/>
+            <a:ext cx="11391900" cy="13335"/>
+          </a:xfrm>
+          <a:prstGeom xmlns:a="http://schemas.openxmlformats.org/drawingml/2006/main" prst="rect">
+            <a:avLst/>
+          </a:prstGeom>
+          <a:solidFill xmlns:a="http://schemas.openxmlformats.org/drawingml/2006/main">
+            <a:srgbClr val="B8BCC4"/>
+          </a:solidFill>
+          <a:ln xmlns:a="http://schemas.openxmlformats.org/drawingml/2006/main" w="0">
+            <a:solidFill>
+              <a:srgbClr val="B8BCC4"/>
+            </a:solidFill>
+            <a:prstDash val="solid"/>
+          </a:ln>
+        </p:spPr>
+      </p:sp>
+      <p:sp>
+        <p:nvSpPr>
+          <p:cNvPr id="11" name="">
+            <a:extLst xmlns:a="http://schemas.openxmlformats.org/drawingml/2006/main">
+              <a:ext uri="{FF2B5EF4-FFF2-40B4-BE49-F238E27FC236}">
+                <a16:creationId xmlns:a16="http://schemas.microsoft.com/office/drawing/2014/main" id="{8CDF41CD-97DB-41A6-BBC9-093F91289C23}"/>
+              </a:ext>
+            </a:extLst>
+          </p:cNvPr>
+          <p:cNvSpPr>
+            <a:spLocks xmlns:a="http://schemas.openxmlformats.org/drawingml/2006/main" noGrp="1"/>
+          </p:cNvSpPr>
+          <p:nvPr/>
+        </p:nvSpPr>
+        <p:spPr>
+          <a:xfrm xmlns:a="http://schemas.openxmlformats.org/drawingml/2006/main">
+            <a:off x="400050" y="6477000"/>
+            <a:ext cx="4381500" cy="228600"/>
+          </a:xfrm>
+          <a:prstGeom xmlns:a="http://schemas.openxmlformats.org/drawingml/2006/main" prst="rect">
+            <a:avLst/>
+          </a:prstGeom>
+          <a:noFill xmlns:a="http://schemas.openxmlformats.org/drawingml/2006/main"/>
+          <a:ln xmlns:a="http://schemas.openxmlformats.org/drawingml/2006/main" w="0">
+            <a:noFill/>
+            <a:prstDash val="solid"/>
+          </a:ln>
+        </p:spPr>
+        <p:txBody>
+          <a:bodyPr xmlns:a="http://schemas.openxmlformats.org/drawingml/2006/main"/>
+          <a:lstStyle xmlns:a="http://schemas.openxmlformats.org/drawingml/2006/main"/>
+          <a:p xmlns:a="http://schemas.openxmlformats.org/drawingml/2006/main">
+            <a:pPr>
+              <a:defRPr sz="1050">
+                <a:solidFill>
+                  <a:srgbClr val="555555"/>
+                </a:solidFill>
+              </a:defRPr>
+            </a:pPr>
+            <a:r>
+              <a:rPr sz="1050">
+                <a:solidFill>
+                  <a:srgbClr val="555555"/>
+                </a:solidFill>
+              </a:rPr>
+              <a:t>Gen5.1 selection-policy hypothesis</a:t>
+            </a:r>
+          </a:p>
+        </p:txBody>
+      </p:sp>
+      <p:sp>
+        <p:nvSpPr>
+          <p:cNvPr id="12" name="">
+            <a:extLst xmlns:a="http://schemas.openxmlformats.org/drawingml/2006/main">
+              <a:ext uri="{FF2B5EF4-FFF2-40B4-BE49-F238E27FC236}">
+                <a16:creationId xmlns:a16="http://schemas.microsoft.com/office/drawing/2014/main" id="{E7AD91E0-4D8A-4BE5-8949-A5877954C82E}"/>
+              </a:ext>
+            </a:extLst>
+          </p:cNvPr>
+          <p:cNvSpPr>
+            <a:spLocks xmlns:a="http://schemas.openxmlformats.org/drawingml/2006/main" noGrp="1"/>
+          </p:cNvSpPr>
+          <p:nvPr/>
+        </p:nvSpPr>
+        <p:spPr>
+          <a:xfrm xmlns:a="http://schemas.openxmlformats.org/drawingml/2006/main">
+            <a:off x="11277600" y="6457950"/>
+            <a:ext cx="514350" cy="266700"/>
+          </a:xfrm>
+          <a:prstGeom xmlns:a="http://schemas.openxmlformats.org/drawingml/2006/main" prst="rect">
+            <a:avLst/>
+          </a:prstGeom>
+          <a:noFill xmlns:a="http://schemas.openxmlformats.org/drawingml/2006/main"/>
+          <a:ln xmlns:a="http://schemas.openxmlformats.org/drawingml/2006/main" w="0">
+            <a:noFill/>
+            <a:prstDash val="solid"/>
+          </a:ln>
+        </p:spPr>
+        <p:txBody>
+          <a:bodyPr xmlns:a="http://schemas.openxmlformats.org/drawingml/2006/main"/>
+          <a:lstStyle xmlns:a="http://schemas.openxmlformats.org/drawingml/2006/main"/>
+          <a:p xmlns:a="http://schemas.openxmlformats.org/drawingml/2006/main">
+            <a:pPr algn="r">
+              <a:defRPr sz="1200" b="1">
+                <a:solidFill>
+                  <a:srgbClr val="555555"/>
+                </a:solidFill>
+              </a:defRPr>
+            </a:pPr>
+            <a:r>
+              <a:rPr sz="1200" b="1">
+                <a:solidFill>
+                  <a:srgbClr val="555555"/>
+                </a:solidFill>
+              </a:rPr>
+              <a:t>09</a:t>
+            </a:r>
+          </a:p>
+        </p:txBody>
+      </p:sp>
+    </p:spTree>
+    <p:extLst>
+      <p:ext uri="{BB962C8B-B14F-4D97-AF65-F5344CB8AC3E}">
+        <p14:creationId xmlns:p14="http://schemas.microsoft.com/office/powerpoint/2010/main" val="2051331921"/>
       </p:ext>
     </p:extLst>
   </p:cSld>

</xml_diff>

<commit_message>
Complete A-live selection policy robustness screen
</commit_message>
<xml_diff>
--- a/presentations/gen5_selection_policy_hypothesis.pptx
+++ b/presentations/gen5_selection_policy_hypothesis.pptx
@@ -2,21 +2,23 @@
 <file path=ppt/presentation.xml><?xml version="1.0" encoding="utf-8"?>
 <p:presentation xmlns:p="http://schemas.openxmlformats.org/presentationml/2006/main">
   <p:sldMasterIdLst>
-    <p:sldMasterId xmlns:r="http://schemas.openxmlformats.org/officeDocument/2006/relationships" id="2147483648" r:id="R988099be868b4085"/>
+    <p:sldMasterId xmlns:r="http://schemas.openxmlformats.org/officeDocument/2006/relationships" id="2147483648" r:id="R0e87ac4984ee4dcf"/>
   </p:sldMasterIdLst>
   <p:notesMasterIdLst>
-    <p:notesMasterId xmlns:r="http://schemas.openxmlformats.org/officeDocument/2006/relationships" r:id="R7a33686f1eba4a37"/>
+    <p:notesMasterId xmlns:r="http://schemas.openxmlformats.org/officeDocument/2006/relationships" r:id="R31cd480f549844eb"/>
   </p:notesMasterIdLst>
   <p:sldIdLst>
-    <p:sldId xmlns:r="http://schemas.openxmlformats.org/officeDocument/2006/relationships" id="256" r:id="Rcf9e02c1b19b4cd5"/>
-    <p:sldId xmlns:r="http://schemas.openxmlformats.org/officeDocument/2006/relationships" id="257" r:id="Rffc48206a34c4daf"/>
-    <p:sldId xmlns:r="http://schemas.openxmlformats.org/officeDocument/2006/relationships" id="258" r:id="R6ad9b93d8223412c"/>
-    <p:sldId xmlns:r="http://schemas.openxmlformats.org/officeDocument/2006/relationships" id="259" r:id="Ra8c78cb0f51f4f83"/>
-    <p:sldId xmlns:r="http://schemas.openxmlformats.org/officeDocument/2006/relationships" id="260" r:id="Rb4bab109af3d49cb"/>
-    <p:sldId xmlns:r="http://schemas.openxmlformats.org/officeDocument/2006/relationships" id="261" r:id="R4958d3814327407b"/>
-    <p:sldId xmlns:r="http://schemas.openxmlformats.org/officeDocument/2006/relationships" id="262" r:id="Rd9f43f4cdf924bb4"/>
-    <p:sldId xmlns:r="http://schemas.openxmlformats.org/officeDocument/2006/relationships" id="263" r:id="R2dec1063b60944b8"/>
-    <p:sldId xmlns:r="http://schemas.openxmlformats.org/officeDocument/2006/relationships" id="264" r:id="R27b2c2ee826f4dcf"/>
+    <p:sldId xmlns:r="http://schemas.openxmlformats.org/officeDocument/2006/relationships" id="256" r:id="Rc6d9d3b4eb2348db"/>
+    <p:sldId xmlns:r="http://schemas.openxmlformats.org/officeDocument/2006/relationships" id="257" r:id="Rd550fd56e3ad4525"/>
+    <p:sldId xmlns:r="http://schemas.openxmlformats.org/officeDocument/2006/relationships" id="258" r:id="R9da405f31eef4ee3"/>
+    <p:sldId xmlns:r="http://schemas.openxmlformats.org/officeDocument/2006/relationships" id="259" r:id="R7f7604497b174844"/>
+    <p:sldId xmlns:r="http://schemas.openxmlformats.org/officeDocument/2006/relationships" id="260" r:id="R19bd0c9d9b3c4718"/>
+    <p:sldId xmlns:r="http://schemas.openxmlformats.org/officeDocument/2006/relationships" id="261" r:id="R13a5e1f0b4cb4470"/>
+    <p:sldId xmlns:r="http://schemas.openxmlformats.org/officeDocument/2006/relationships" id="262" r:id="R9695ee73cd0649bf"/>
+    <p:sldId xmlns:r="http://schemas.openxmlformats.org/officeDocument/2006/relationships" id="263" r:id="Raa83f651714944ba"/>
+    <p:sldId xmlns:r="http://schemas.openxmlformats.org/officeDocument/2006/relationships" id="264" r:id="Rf38b17f26aa04ce7"/>
+    <p:sldId xmlns:r="http://schemas.openxmlformats.org/officeDocument/2006/relationships" id="265" r:id="Redf0fc8edfe74c4e"/>
+    <p:sldId xmlns:r="http://schemas.openxmlformats.org/officeDocument/2006/relationships" id="266" r:id="R56fc06d00f0a4ae0"/>
   </p:sldIdLst>
   <p:sldSz cx="12192000" cy="6858000"/>
   <p:notesSz cx="6858000" cy="9144000"/>
@@ -571,6 +573,138 @@
 </p:notes>
 </file>
 
+<file path=ppt/notesSlides/notesSlide10.xml><?xml version="1.0" encoding="utf-8"?>
+<p:notes xmlns:p="http://schemas.openxmlformats.org/presentationml/2006/main">
+  <p:cSld>
+    <p:spTree>
+      <p:nvGrpSpPr>
+        <p:cNvPr id="1" name=""/>
+        <p:cNvGrpSpPr/>
+        <p:nvPr/>
+      </p:nvGrpSpPr>
+      <p:grpSpPr>
+        <a:xfrm xmlns:a="http://schemas.openxmlformats.org/drawingml/2006/main"/>
+      </p:grpSpPr>
+      <p:sp>
+        <p:nvSpPr>
+          <p:cNvPr id="2" name="Slide Image Placeholder 1"/>
+          <p:cNvSpPr>
+            <a:spLocks xmlns:a="http://schemas.openxmlformats.org/drawingml/2006/main" noGrp="1"/>
+          </p:cNvSpPr>
+          <p:nvPr>
+            <p:ph type="sldImg" idx="0"/>
+          </p:nvPr>
+        </p:nvSpPr>
+        <p:spPr/>
+      </p:sp>
+      <p:sp>
+        <p:nvSpPr>
+          <p:cNvPr id="3" name="Notes Placeholder 2"/>
+          <p:cNvSpPr>
+            <a:spLocks xmlns:a="http://schemas.openxmlformats.org/drawingml/2006/main" noGrp="1"/>
+          </p:cNvSpPr>
+          <p:nvPr>
+            <p:ph type="body" idx="1"/>
+          </p:nvPr>
+        </p:nvSpPr>
+        <p:spPr/>
+        <p:txBody>
+          <a:bodyPr xmlns:a="http://schemas.openxmlformats.org/drawingml/2006/main"/>
+          <a:lstStyle xmlns:a="http://schemas.openxmlformats.org/drawingml/2006/main"/>
+          <a:p xmlns:a="http://schemas.openxmlformats.org/drawingml/2006/main"/>
+        </p:txBody>
+      </p:sp>
+      <p:sp>
+        <p:nvSpPr>
+          <p:cNvPr id="4" name="Slide Number Placeholder 3"/>
+          <p:cNvSpPr>
+            <a:spLocks xmlns:a="http://schemas.openxmlformats.org/drawingml/2006/main" noGrp="1"/>
+          </p:cNvSpPr>
+          <p:nvPr>
+            <p:ph type="sldNum" idx="5"/>
+          </p:nvPr>
+        </p:nvSpPr>
+        <p:spPr/>
+        <p:txBody>
+          <a:bodyPr xmlns:a="http://schemas.openxmlformats.org/drawingml/2006/main"/>
+          <a:lstStyle xmlns:a="http://schemas.openxmlformats.org/drawingml/2006/main"/>
+          <a:p xmlns:a="http://schemas.openxmlformats.org/drawingml/2006/main"/>
+        </p:txBody>
+      </p:sp>
+    </p:spTree>
+  </p:cSld>
+  <p:clrMapOvr>
+    <a:masterClrMapping xmlns:a="http://schemas.openxmlformats.org/drawingml/2006/main"/>
+  </p:clrMapOvr>
+</p:notes>
+</file>
+
+<file path=ppt/notesSlides/notesSlide11.xml><?xml version="1.0" encoding="utf-8"?>
+<p:notes xmlns:p="http://schemas.openxmlformats.org/presentationml/2006/main">
+  <p:cSld>
+    <p:spTree>
+      <p:nvGrpSpPr>
+        <p:cNvPr id="1" name=""/>
+        <p:cNvGrpSpPr/>
+        <p:nvPr/>
+      </p:nvGrpSpPr>
+      <p:grpSpPr>
+        <a:xfrm xmlns:a="http://schemas.openxmlformats.org/drawingml/2006/main"/>
+      </p:grpSpPr>
+      <p:sp>
+        <p:nvSpPr>
+          <p:cNvPr id="2" name="Slide Image Placeholder 1"/>
+          <p:cNvSpPr>
+            <a:spLocks xmlns:a="http://schemas.openxmlformats.org/drawingml/2006/main" noGrp="1"/>
+          </p:cNvSpPr>
+          <p:nvPr>
+            <p:ph type="sldImg" idx="0"/>
+          </p:nvPr>
+        </p:nvSpPr>
+        <p:spPr/>
+      </p:sp>
+      <p:sp>
+        <p:nvSpPr>
+          <p:cNvPr id="3" name="Notes Placeholder 2"/>
+          <p:cNvSpPr>
+            <a:spLocks xmlns:a="http://schemas.openxmlformats.org/drawingml/2006/main" noGrp="1"/>
+          </p:cNvSpPr>
+          <p:nvPr>
+            <p:ph type="body" idx="1"/>
+          </p:nvPr>
+        </p:nvSpPr>
+        <p:spPr/>
+        <p:txBody>
+          <a:bodyPr xmlns:a="http://schemas.openxmlformats.org/drawingml/2006/main"/>
+          <a:lstStyle xmlns:a="http://schemas.openxmlformats.org/drawingml/2006/main"/>
+          <a:p xmlns:a="http://schemas.openxmlformats.org/drawingml/2006/main"/>
+        </p:txBody>
+      </p:sp>
+      <p:sp>
+        <p:nvSpPr>
+          <p:cNvPr id="4" name="Slide Number Placeholder 3"/>
+          <p:cNvSpPr>
+            <a:spLocks xmlns:a="http://schemas.openxmlformats.org/drawingml/2006/main" noGrp="1"/>
+          </p:cNvSpPr>
+          <p:nvPr>
+            <p:ph type="sldNum" idx="5"/>
+          </p:nvPr>
+        </p:nvSpPr>
+        <p:spPr/>
+        <p:txBody>
+          <a:bodyPr xmlns:a="http://schemas.openxmlformats.org/drawingml/2006/main"/>
+          <a:lstStyle xmlns:a="http://schemas.openxmlformats.org/drawingml/2006/main"/>
+          <a:p xmlns:a="http://schemas.openxmlformats.org/drawingml/2006/main"/>
+        </p:txBody>
+      </p:sp>
+    </p:spTree>
+  </p:cSld>
+  <p:clrMapOvr>
+    <a:masterClrMapping xmlns:a="http://schemas.openxmlformats.org/drawingml/2006/main"/>
+  </p:clrMapOvr>
+</p:notes>
+</file>
+
 <file path=ppt/notesSlides/notesSlide2.xml><?xml version="1.0" encoding="utf-8"?>
 <p:notes xmlns:p="http://schemas.openxmlformats.org/presentationml/2006/main">
   <p:cSld>
@@ -1137,7 +1271,7 @@
   </p:cSld>
   <p:clrMap bg1="lt1" tx1="dk1" bg2="lt2" tx2="dk2" accent1="accent1" accent2="accent2" accent3="accent3" accent4="accent4" accent5="accent5" accent6="accent6" hlink="hlink" folHlink="folHlink"/>
   <p:sldLayoutIdLst>
-    <p:sldLayoutId xmlns:r="http://schemas.openxmlformats.org/officeDocument/2006/relationships" id="2147483649" r:id="Rad83d4d8b19c4699"/>
+    <p:sldLayoutId xmlns:r="http://schemas.openxmlformats.org/officeDocument/2006/relationships" id="2147483649" r:id="Rf9e07c0ff6814830"/>
   </p:sldLayoutIdLst>
   <p:txStyles>
     <p:titleStyle>
@@ -1688,7 +1822,7 @@
           <p:cNvPr id="1" name="">
             <a:extLst xmlns:a="http://schemas.openxmlformats.org/drawingml/2006/main">
               <a:ext uri="{FF2B5EF4-FFF2-40B4-BE49-F238E27FC236}">
-                <a16:creationId xmlns:a16="http://schemas.microsoft.com/office/drawing/2014/main" id="{21D968A0-6AD4-4EF7-A5AB-CAADBA156A3B}"/>
+                <a16:creationId xmlns:a16="http://schemas.microsoft.com/office/drawing/2014/main" id="{2D9DAE99-6442-449C-8823-F7BD79A5B302}"/>
               </a:ext>
             </a:extLst>
           </p:cNvPr>
@@ -1738,7 +1872,7 @@
           <p:cNvPr id="2" name="">
             <a:extLst xmlns:a="http://schemas.openxmlformats.org/drawingml/2006/main">
               <a:ext uri="{FF2B5EF4-FFF2-40B4-BE49-F238E27FC236}">
-                <a16:creationId xmlns:a16="http://schemas.microsoft.com/office/drawing/2014/main" id="{2FB07537-C4A6-4912-8A11-C409D02EFCF6}"/>
+                <a16:creationId xmlns:a16="http://schemas.microsoft.com/office/drawing/2014/main" id="{B745960D-BD86-414D-B8EE-F74CAACC06CE}"/>
               </a:ext>
             </a:extLst>
           </p:cNvPr>
@@ -1788,7 +1922,7 @@
           <p:cNvPr id="3" name="">
             <a:extLst xmlns:a="http://schemas.openxmlformats.org/drawingml/2006/main">
               <a:ext uri="{FF2B5EF4-FFF2-40B4-BE49-F238E27FC236}">
-                <a16:creationId xmlns:a16="http://schemas.microsoft.com/office/drawing/2014/main" id="{EAE67BE2-D2AA-4EEF-A9EC-B089BE0E5445}"/>
+                <a16:creationId xmlns:a16="http://schemas.microsoft.com/office/drawing/2014/main" id="{8E6EA3B5-407B-4301-B7C9-D89F1DD456B3}"/>
               </a:ext>
             </a:extLst>
           </p:cNvPr>
@@ -1838,7 +1972,7 @@
           <p:cNvPr id="4" name="">
             <a:extLst xmlns:a="http://schemas.openxmlformats.org/drawingml/2006/main">
               <a:ext uri="{FF2B5EF4-FFF2-40B4-BE49-F238E27FC236}">
-                <a16:creationId xmlns:a16="http://schemas.microsoft.com/office/drawing/2014/main" id="{99E75046-3366-4B33-B3C9-6CF9432A776C}"/>
+                <a16:creationId xmlns:a16="http://schemas.microsoft.com/office/drawing/2014/main" id="{5C8D982B-81B8-4412-ABB9-13E969D7E5AA}"/>
               </a:ext>
             </a:extLst>
           </p:cNvPr>
@@ -1869,7 +2003,7 @@
           <p:cNvPr id="5" name="">
             <a:extLst xmlns:a="http://schemas.openxmlformats.org/drawingml/2006/main">
               <a:ext uri="{FF2B5EF4-FFF2-40B4-BE49-F238E27FC236}">
-                <a16:creationId xmlns:a16="http://schemas.microsoft.com/office/drawing/2014/main" id="{C5337A9D-7977-4DE1-ACD5-70CF9C2F7E5E}"/>
+                <a16:creationId xmlns:a16="http://schemas.microsoft.com/office/drawing/2014/main" id="{9C9F85E9-5319-42D5-8615-04EA3D94A685}"/>
               </a:ext>
             </a:extLst>
           </p:cNvPr>
@@ -1970,7 +2104,7 @@
           <p:cNvPr id="6" name="">
             <a:extLst xmlns:a="http://schemas.openxmlformats.org/drawingml/2006/main">
               <a:ext uri="{FF2B5EF4-FFF2-40B4-BE49-F238E27FC236}">
-                <a16:creationId xmlns:a16="http://schemas.microsoft.com/office/drawing/2014/main" id="{11D4CB3D-9040-45E3-9789-88902C91B26E}"/>
+                <a16:creationId xmlns:a16="http://schemas.microsoft.com/office/drawing/2014/main" id="{567EACFE-FB0D-471B-A303-B39E5F240513}"/>
               </a:ext>
             </a:extLst>
           </p:cNvPr>
@@ -2020,7 +2154,7 @@
           <p:cNvPr id="7" name="">
             <a:extLst xmlns:a="http://schemas.openxmlformats.org/drawingml/2006/main">
               <a:ext uri="{FF2B5EF4-FFF2-40B4-BE49-F238E27FC236}">
-                <a16:creationId xmlns:a16="http://schemas.microsoft.com/office/drawing/2014/main" id="{A5021E50-BC66-430F-BB46-CDD82DED2CE2}"/>
+                <a16:creationId xmlns:a16="http://schemas.microsoft.com/office/drawing/2014/main" id="{7DF03D61-EFA6-4AD7-BE48-8502B656598F}"/>
               </a:ext>
             </a:extLst>
           </p:cNvPr>
@@ -2053,7 +2187,7 @@
           <p:cNvPr id="8" name="">
             <a:extLst xmlns:a="http://schemas.openxmlformats.org/drawingml/2006/main">
               <a:ext uri="{FF2B5EF4-FFF2-40B4-BE49-F238E27FC236}">
-                <a16:creationId xmlns:a16="http://schemas.microsoft.com/office/drawing/2014/main" id="{4240C856-E047-41C2-82AC-2E5877F92052}"/>
+                <a16:creationId xmlns:a16="http://schemas.microsoft.com/office/drawing/2014/main" id="{2FC6F915-90A1-4CC1-A9FA-14F67A92D8F7}"/>
               </a:ext>
             </a:extLst>
           </p:cNvPr>
@@ -2103,7 +2237,7 @@
           <p:cNvPr id="9" name="">
             <a:extLst xmlns:a="http://schemas.openxmlformats.org/drawingml/2006/main">
               <a:ext uri="{FF2B5EF4-FFF2-40B4-BE49-F238E27FC236}">
-                <a16:creationId xmlns:a16="http://schemas.microsoft.com/office/drawing/2014/main" id="{38315038-AA17-4A94-B5C3-2B8E01E3B435}"/>
+                <a16:creationId xmlns:a16="http://schemas.microsoft.com/office/drawing/2014/main" id="{87FD8498-8666-4E46-B702-F044FA9DF343}"/>
               </a:ext>
             </a:extLst>
           </p:cNvPr>
@@ -2151,7 +2285,1024 @@
     </p:spTree>
     <p:extLst>
       <p:ext uri="{BB962C8B-B14F-4D97-AF65-F5344CB8AC3E}">
-        <p14:creationId xmlns:p14="http://schemas.microsoft.com/office/powerpoint/2010/main" val="1961626789"/>
+        <p14:creationId xmlns:p14="http://schemas.microsoft.com/office/powerpoint/2010/main" val="1213871233"/>
+      </p:ext>
+    </p:extLst>
+  </p:cSld>
+</p:sld>
+</file>
+
+<file path=ppt/slides/slide10.xml><?xml version="1.0" encoding="utf-8"?>
+<p:sld xmlns:p="http://schemas.openxmlformats.org/presentationml/2006/main">
+  <p:cSld>
+    <p:bg>
+      <p:bgPr>
+        <a:solidFill xmlns:a="http://schemas.openxmlformats.org/drawingml/2006/main">
+          <a:srgbClr val="FFFFFF"/>
+        </a:solidFill>
+      </p:bgPr>
+    </p:bg>
+    <p:spTree>
+      <p:nvGrpSpPr>
+        <p:cNvPr id="1" name=""/>
+        <p:cNvGrpSpPr/>
+        <p:nvPr/>
+      </p:nvGrpSpPr>
+      <p:grpSpPr>
+        <a:xfrm xmlns:a="http://schemas.openxmlformats.org/drawingml/2006/main"/>
+      </p:grpSpPr>
+      <p:sp>
+        <p:nvSpPr>
+          <p:cNvPr id="1" name="">
+            <a:extLst xmlns:a="http://schemas.openxmlformats.org/drawingml/2006/main">
+              <a:ext uri="{FF2B5EF4-FFF2-40B4-BE49-F238E27FC236}">
+                <a16:creationId xmlns:a16="http://schemas.microsoft.com/office/drawing/2014/main" id="{41D68107-F777-4CCC-9B53-037372E3D57D}"/>
+              </a:ext>
+            </a:extLst>
+          </p:cNvPr>
+          <p:cNvSpPr>
+            <a:spLocks xmlns:a="http://schemas.openxmlformats.org/drawingml/2006/main" noGrp="1"/>
+          </p:cNvSpPr>
+          <p:nvPr/>
+        </p:nvSpPr>
+        <p:spPr>
+          <a:xfrm xmlns:a="http://schemas.openxmlformats.org/drawingml/2006/main">
+            <a:off x="400050" y="400050"/>
+            <a:ext cx="2476500" cy="266700"/>
+          </a:xfrm>
+          <a:prstGeom xmlns:a="http://schemas.openxmlformats.org/drawingml/2006/main" prst="rect">
+            <a:avLst/>
+          </a:prstGeom>
+          <a:noFill xmlns:a="http://schemas.openxmlformats.org/drawingml/2006/main"/>
+          <a:ln xmlns:a="http://schemas.openxmlformats.org/drawingml/2006/main" w="0">
+            <a:noFill/>
+            <a:prstDash val="solid"/>
+          </a:ln>
+        </p:spPr>
+        <p:txBody>
+          <a:bodyPr xmlns:a="http://schemas.openxmlformats.org/drawingml/2006/main"/>
+          <a:lstStyle xmlns:a="http://schemas.openxmlformats.org/drawingml/2006/main"/>
+          <a:p xmlns:a="http://schemas.openxmlformats.org/drawingml/2006/main">
+            <a:pPr>
+              <a:defRPr sz="1200" b="1">
+                <a:solidFill>
+                  <a:srgbClr val="555555"/>
+                </a:solidFill>
+              </a:defRPr>
+            </a:pPr>
+            <a:r>
+              <a:rPr sz="1200" b="1">
+                <a:solidFill>
+                  <a:srgbClr val="555555"/>
+                </a:solidFill>
+              </a:rPr>
+              <a:t>NEXT GATE</a:t>
+            </a:r>
+          </a:p>
+        </p:txBody>
+      </p:sp>
+      <p:sp>
+        <p:nvSpPr>
+          <p:cNvPr id="2" name="">
+            <a:extLst xmlns:a="http://schemas.openxmlformats.org/drawingml/2006/main">
+              <a:ext uri="{FF2B5EF4-FFF2-40B4-BE49-F238E27FC236}">
+                <a16:creationId xmlns:a16="http://schemas.microsoft.com/office/drawing/2014/main" id="{C7921947-7E93-4BBA-8AA5-2C82EBA7B99C}"/>
+              </a:ext>
+            </a:extLst>
+          </p:cNvPr>
+          <p:cNvSpPr>
+            <a:spLocks xmlns:a="http://schemas.openxmlformats.org/drawingml/2006/main" noGrp="1"/>
+          </p:cNvSpPr>
+          <p:nvPr/>
+        </p:nvSpPr>
+        <p:spPr>
+          <a:xfrm xmlns:a="http://schemas.openxmlformats.org/drawingml/2006/main">
+            <a:off x="400050" y="838200"/>
+            <a:ext cx="10096500" cy="914400"/>
+          </a:xfrm>
+          <a:prstGeom xmlns:a="http://schemas.openxmlformats.org/drawingml/2006/main" prst="rect">
+            <a:avLst/>
+          </a:prstGeom>
+          <a:noFill xmlns:a="http://schemas.openxmlformats.org/drawingml/2006/main"/>
+          <a:ln xmlns:a="http://schemas.openxmlformats.org/drawingml/2006/main" w="0">
+            <a:noFill/>
+            <a:prstDash val="solid"/>
+          </a:ln>
+        </p:spPr>
+        <p:txBody>
+          <a:bodyPr xmlns:a="http://schemas.openxmlformats.org/drawingml/2006/main"/>
+          <a:lstStyle xmlns:a="http://schemas.openxmlformats.org/drawingml/2006/main"/>
+          <a:p xmlns:a="http://schemas.openxmlformats.org/drawingml/2006/main">
+            <a:pPr>
+              <a:defRPr sz="2700" b="1">
+                <a:solidFill>
+                  <a:srgbClr val="000000"/>
+                </a:solidFill>
+              </a:defRPr>
+            </a:pPr>
+            <a:r>
+              <a:rPr sz="2700" b="1">
+                <a:solidFill>
+                  <a:srgbClr val="000000"/>
+                </a:solidFill>
+              </a:rPr>
+              <a:t>The next decision is whether more history is worth changing the basket</a:t>
+            </a:r>
+          </a:p>
+        </p:txBody>
+      </p:sp>
+      <p:sp>
+        <p:nvSpPr>
+          <p:cNvPr id="3" name="">
+            <a:extLst xmlns:a="http://schemas.openxmlformats.org/drawingml/2006/main">
+              <a:ext uri="{FF2B5EF4-FFF2-40B4-BE49-F238E27FC236}">
+                <a16:creationId xmlns:a16="http://schemas.microsoft.com/office/drawing/2014/main" id="{79CD4F24-EC76-4057-BC67-67F3D6654EDE}"/>
+              </a:ext>
+            </a:extLst>
+          </p:cNvPr>
+          <p:cNvSpPr>
+            <a:spLocks xmlns:a="http://schemas.openxmlformats.org/drawingml/2006/main" noGrp="1"/>
+          </p:cNvSpPr>
+          <p:nvPr/>
+        </p:nvSpPr>
+        <p:spPr>
+          <a:xfrm xmlns:a="http://schemas.openxmlformats.org/drawingml/2006/main">
+            <a:off x="400050" y="1943100"/>
+            <a:ext cx="10096500" cy="685800"/>
+          </a:xfrm>
+          <a:prstGeom xmlns:a="http://schemas.openxmlformats.org/drawingml/2006/main" prst="rect">
+            <a:avLst/>
+          </a:prstGeom>
+          <a:noFill xmlns:a="http://schemas.openxmlformats.org/drawingml/2006/main"/>
+          <a:ln xmlns:a="http://schemas.openxmlformats.org/drawingml/2006/main" w="0">
+            <a:noFill/>
+            <a:prstDash val="solid"/>
+          </a:ln>
+        </p:spPr>
+        <p:txBody>
+          <a:bodyPr xmlns:a="http://schemas.openxmlformats.org/drawingml/2006/main"/>
+          <a:lstStyle xmlns:a="http://schemas.openxmlformats.org/drawingml/2006/main"/>
+          <a:p xmlns:a="http://schemas.openxmlformats.org/drawingml/2006/main">
+            <a:pPr>
+              <a:defRPr sz="1725">
+                <a:solidFill>
+                  <a:srgbClr val="222222"/>
+                </a:solidFill>
+              </a:defRPr>
+            </a:pPr>
+            <a:r>
+              <a:rPr sz="1725">
+                <a:solidFill>
+                  <a:srgbClr val="222222"/>
+                </a:solidFill>
+              </a:rPr>
+              <a:t>B_hist would swap SOFI and PLTR for AAPL and MSTR to reach older regimes. That is useful robustness evidence, but it is no longer a literal live-basket test.</a:t>
+            </a:r>
+          </a:p>
+        </p:txBody>
+      </p:sp>
+      <p:sp>
+        <p:nvSpPr>
+          <p:cNvPr id="4" name="">
+            <a:extLst xmlns:a="http://schemas.openxmlformats.org/drawingml/2006/main">
+              <a:ext uri="{FF2B5EF4-FFF2-40B4-BE49-F238E27FC236}">
+                <a16:creationId xmlns:a16="http://schemas.microsoft.com/office/drawing/2014/main" id="{EA9ED100-C8D2-40ED-8D33-50015FCFA847}"/>
+              </a:ext>
+            </a:extLst>
+          </p:cNvPr>
+          <p:cNvSpPr>
+            <a:spLocks xmlns:a="http://schemas.openxmlformats.org/drawingml/2006/main" noGrp="1"/>
+          </p:cNvSpPr>
+          <p:nvPr/>
+        </p:nvSpPr>
+        <p:spPr>
+          <a:xfrm xmlns:a="http://schemas.openxmlformats.org/drawingml/2006/main">
+            <a:off x="914400" y="3028950"/>
+            <a:ext cx="3143250" cy="323850"/>
+          </a:xfrm>
+          <a:prstGeom xmlns:a="http://schemas.openxmlformats.org/drawingml/2006/main" prst="rect">
+            <a:avLst/>
+          </a:prstGeom>
+          <a:noFill xmlns:a="http://schemas.openxmlformats.org/drawingml/2006/main"/>
+          <a:ln xmlns:a="http://schemas.openxmlformats.org/drawingml/2006/main" w="0">
+            <a:noFill/>
+            <a:prstDash val="solid"/>
+          </a:ln>
+        </p:spPr>
+        <p:txBody>
+          <a:bodyPr xmlns:a="http://schemas.openxmlformats.org/drawingml/2006/main"/>
+          <a:lstStyle xmlns:a="http://schemas.openxmlformats.org/drawingml/2006/main"/>
+          <a:p xmlns:a="http://schemas.openxmlformats.org/drawingml/2006/main">
+            <a:pPr>
+              <a:defRPr sz="1875" b="1">
+                <a:solidFill>
+                  <a:srgbClr val="000000"/>
+                </a:solidFill>
+              </a:defRPr>
+            </a:pPr>
+            <a:r>
+              <a:rPr sz="1875" b="1">
+                <a:solidFill>
+                  <a:srgbClr val="000000"/>
+                </a:solidFill>
+              </a:rPr>
+              <a:t>Reason to run B_hist</a:t>
+            </a:r>
+          </a:p>
+        </p:txBody>
+      </p:sp>
+      <p:sp>
+        <p:nvSpPr>
+          <p:cNvPr id="5" name="">
+            <a:extLst xmlns:a="http://schemas.openxmlformats.org/drawingml/2006/main">
+              <a:ext uri="{FF2B5EF4-FFF2-40B4-BE49-F238E27FC236}">
+                <a16:creationId xmlns:a16="http://schemas.microsoft.com/office/drawing/2014/main" id="{B5B5C60C-F385-446E-BD76-31F2D3D94AA7}"/>
+              </a:ext>
+            </a:extLst>
+          </p:cNvPr>
+          <p:cNvSpPr>
+            <a:spLocks xmlns:a="http://schemas.openxmlformats.org/drawingml/2006/main" noGrp="1"/>
+          </p:cNvSpPr>
+          <p:nvPr/>
+        </p:nvSpPr>
+        <p:spPr>
+          <a:xfrm xmlns:a="http://schemas.openxmlformats.org/drawingml/2006/main">
+            <a:off x="914400" y="3524250"/>
+            <a:ext cx="4762500" cy="1257300"/>
+          </a:xfrm>
+          <a:prstGeom xmlns:a="http://schemas.openxmlformats.org/drawingml/2006/main" prst="rect">
+            <a:avLst/>
+          </a:prstGeom>
+          <a:noFill xmlns:a="http://schemas.openxmlformats.org/drawingml/2006/main"/>
+          <a:ln xmlns:a="http://schemas.openxmlformats.org/drawingml/2006/main" w="0">
+            <a:noFill/>
+            <a:prstDash val="solid"/>
+          </a:ln>
+        </p:spPr>
+        <p:txBody>
+          <a:bodyPr xmlns:a="http://schemas.openxmlformats.org/drawingml/2006/main"/>
+          <a:lstStyle xmlns:a="http://schemas.openxmlformats.org/drawingml/2006/main"/>
+          <a:p xmlns:a="http://schemas.openxmlformats.org/drawingml/2006/main">
+            <a:pPr>
+              <a:defRPr sz="1575">
+                <a:solidFill>
+                  <a:srgbClr val="000000"/>
+                </a:solidFill>
+              </a:defRPr>
+            </a:pPr>
+            <a:r>
+              <a:rPr sz="1575">
+                <a:solidFill>
+                  <a:srgbClr val="000000"/>
+                </a:solidFill>
+              </a:rPr>
+              <a:t>• Test whether pooled-family behaves better in older market regimes.</a:t>
+            </a:r>
+          </a:p>
+          <a:p xmlns:a="http://schemas.openxmlformats.org/drawingml/2006/main">
+            <a:pPr>
+              <a:defRPr sz="1575">
+                <a:solidFill>
+                  <a:srgbClr val="000000"/>
+                </a:solidFill>
+              </a:defRPr>
+            </a:pPr>
+            <a:r>
+              <a:rPr sz="1575">
+                <a:solidFill>
+                  <a:srgbClr val="000000"/>
+                </a:solidFill>
+              </a:rPr>
+              <a:t>• Decide whether selection policy belongs in future factorial screens.</a:t>
+            </a:r>
+          </a:p>
+          <a:p xmlns:a="http://schemas.openxmlformats.org/drawingml/2006/main">
+            <a:pPr>
+              <a:defRPr sz="1575">
+                <a:solidFill>
+                  <a:srgbClr val="000000"/>
+                </a:solidFill>
+              </a:defRPr>
+            </a:pPr>
+            <a:r>
+              <a:rPr sz="1575">
+                <a:solidFill>
+                  <a:srgbClr val="000000"/>
+                </a:solidFill>
+              </a:rPr>
+              <a:t>• Build collaborator-facing evidence beyond the recent live basket.</a:t>
+            </a:r>
+          </a:p>
+        </p:txBody>
+      </p:sp>
+      <p:sp>
+        <p:nvSpPr>
+          <p:cNvPr id="6" name="">
+            <a:extLst xmlns:a="http://schemas.openxmlformats.org/drawingml/2006/main">
+              <a:ext uri="{FF2B5EF4-FFF2-40B4-BE49-F238E27FC236}">
+                <a16:creationId xmlns:a16="http://schemas.microsoft.com/office/drawing/2014/main" id="{689C8111-9BD0-4F2D-8FF4-A7E3EF0309ED}"/>
+              </a:ext>
+            </a:extLst>
+          </p:cNvPr>
+          <p:cNvSpPr>
+            <a:spLocks xmlns:a="http://schemas.openxmlformats.org/drawingml/2006/main" noGrp="1"/>
+          </p:cNvSpPr>
+          <p:nvPr/>
+        </p:nvSpPr>
+        <p:spPr>
+          <a:xfrm xmlns:a="http://schemas.openxmlformats.org/drawingml/2006/main">
+            <a:off x="6667500" y="3028950"/>
+            <a:ext cx="3143250" cy="323850"/>
+          </a:xfrm>
+          <a:prstGeom xmlns:a="http://schemas.openxmlformats.org/drawingml/2006/main" prst="rect">
+            <a:avLst/>
+          </a:prstGeom>
+          <a:noFill xmlns:a="http://schemas.openxmlformats.org/drawingml/2006/main"/>
+          <a:ln xmlns:a="http://schemas.openxmlformats.org/drawingml/2006/main" w="0">
+            <a:noFill/>
+            <a:prstDash val="solid"/>
+          </a:ln>
+        </p:spPr>
+        <p:txBody>
+          <a:bodyPr xmlns:a="http://schemas.openxmlformats.org/drawingml/2006/main"/>
+          <a:lstStyle xmlns:a="http://schemas.openxmlformats.org/drawingml/2006/main"/>
+          <a:p xmlns:a="http://schemas.openxmlformats.org/drawingml/2006/main">
+            <a:pPr>
+              <a:defRPr sz="1875" b="1">
+                <a:solidFill>
+                  <a:srgbClr val="000000"/>
+                </a:solidFill>
+              </a:defRPr>
+            </a:pPr>
+            <a:r>
+              <a:rPr sz="1875" b="1">
+                <a:solidFill>
+                  <a:srgbClr val="000000"/>
+                </a:solidFill>
+              </a:rPr>
+              <a:t>Reason to pause</a:t>
+            </a:r>
+          </a:p>
+        </p:txBody>
+      </p:sp>
+      <p:sp>
+        <p:nvSpPr>
+          <p:cNvPr id="7" name="">
+            <a:extLst xmlns:a="http://schemas.openxmlformats.org/drawingml/2006/main">
+              <a:ext uri="{FF2B5EF4-FFF2-40B4-BE49-F238E27FC236}">
+                <a16:creationId xmlns:a16="http://schemas.microsoft.com/office/drawing/2014/main" id="{7D546A06-ED08-4835-8227-A7567348A0E9}"/>
+              </a:ext>
+            </a:extLst>
+          </p:cNvPr>
+          <p:cNvSpPr>
+            <a:spLocks xmlns:a="http://schemas.openxmlformats.org/drawingml/2006/main" noGrp="1"/>
+          </p:cNvSpPr>
+          <p:nvPr/>
+        </p:nvSpPr>
+        <p:spPr>
+          <a:xfrm xmlns:a="http://schemas.openxmlformats.org/drawingml/2006/main">
+            <a:off x="6667500" y="3524250"/>
+            <a:ext cx="4762500" cy="1257300"/>
+          </a:xfrm>
+          <a:prstGeom xmlns:a="http://schemas.openxmlformats.org/drawingml/2006/main" prst="rect">
+            <a:avLst/>
+          </a:prstGeom>
+          <a:noFill xmlns:a="http://schemas.openxmlformats.org/drawingml/2006/main"/>
+          <a:ln xmlns:a="http://schemas.openxmlformats.org/drawingml/2006/main" w="0">
+            <a:noFill/>
+            <a:prstDash val="solid"/>
+          </a:ln>
+        </p:spPr>
+        <p:txBody>
+          <a:bodyPr xmlns:a="http://schemas.openxmlformats.org/drawingml/2006/main"/>
+          <a:lstStyle xmlns:a="http://schemas.openxmlformats.org/drawingml/2006/main"/>
+          <a:p xmlns:a="http://schemas.openxmlformats.org/drawingml/2006/main">
+            <a:pPr>
+              <a:defRPr sz="1575">
+                <a:solidFill>
+                  <a:srgbClr val="000000"/>
+                </a:solidFill>
+              </a:defRPr>
+            </a:pPr>
+            <a:r>
+              <a:rPr sz="1575">
+                <a:solidFill>
+                  <a:srgbClr val="000000"/>
+                </a:solidFill>
+              </a:rPr>
+              <a:t>• A_live already favors keeping direct as the bridge default.</a:t>
+            </a:r>
+          </a:p>
+          <a:p xmlns:a="http://schemas.openxmlformats.org/drawingml/2006/main">
+            <a:pPr>
+              <a:defRPr sz="1575">
+                <a:solidFill>
+                  <a:srgbClr val="000000"/>
+                </a:solidFill>
+              </a:defRPr>
+            </a:pPr>
+            <a:r>
+              <a:rPr sz="1575">
+                <a:solidFill>
+                  <a:srgbClr val="000000"/>
+                </a:solidFill>
+              </a:rPr>
+              <a:t>• B_hist is compute-heavy and changes the traded basket.</a:t>
+            </a:r>
+          </a:p>
+          <a:p xmlns:a="http://schemas.openxmlformats.org/drawingml/2006/main">
+            <a:pPr>
+              <a:defRPr sz="1575">
+                <a:solidFill>
+                  <a:srgbClr val="000000"/>
+                </a:solidFill>
+              </a:defRPr>
+            </a:pPr>
+            <a:r>
+              <a:rPr sz="1575">
+                <a:solidFill>
+                  <a:srgbClr val="000000"/>
+                </a:solidFill>
+              </a:rPr>
+              <a:t>• It should not be merged into one winner table with A_live.</a:t>
+            </a:r>
+          </a:p>
+        </p:txBody>
+      </p:sp>
+      <p:sp>
+        <p:nvSpPr>
+          <p:cNvPr id="8" name="">
+            <a:extLst xmlns:a="http://schemas.openxmlformats.org/drawingml/2006/main">
+              <a:ext uri="{FF2B5EF4-FFF2-40B4-BE49-F238E27FC236}">
+                <a16:creationId xmlns:a16="http://schemas.microsoft.com/office/drawing/2014/main" id="{2DFE7CED-68D2-4157-939A-7D0870E5C271}"/>
+              </a:ext>
+            </a:extLst>
+          </p:cNvPr>
+          <p:cNvSpPr>
+            <a:spLocks xmlns:a="http://schemas.openxmlformats.org/drawingml/2006/main" noGrp="1"/>
+          </p:cNvSpPr>
+          <p:nvPr/>
+        </p:nvSpPr>
+        <p:spPr>
+          <a:xfrm xmlns:a="http://schemas.openxmlformats.org/drawingml/2006/main">
+            <a:off x="876300" y="5257800"/>
+            <a:ext cx="10439400" cy="514350"/>
+          </a:xfrm>
+          <a:prstGeom xmlns:a="http://schemas.openxmlformats.org/drawingml/2006/main" prst="rect">
+            <a:avLst/>
+          </a:prstGeom>
+          <a:solidFill xmlns:a="http://schemas.openxmlformats.org/drawingml/2006/main">
+            <a:srgbClr val="FFE1D6"/>
+          </a:solidFill>
+          <a:ln xmlns:a="http://schemas.openxmlformats.org/drawingml/2006/main" w="0">
+            <a:noFill/>
+            <a:prstDash val="solid"/>
+          </a:ln>
+        </p:spPr>
+      </p:sp>
+      <p:sp>
+        <p:nvSpPr>
+          <p:cNvPr id="9" name="">
+            <a:extLst xmlns:a="http://schemas.openxmlformats.org/drawingml/2006/main">
+              <a:ext uri="{FF2B5EF4-FFF2-40B4-BE49-F238E27FC236}">
+                <a16:creationId xmlns:a16="http://schemas.microsoft.com/office/drawing/2014/main" id="{C645926B-2632-4405-860C-957C2C787C99}"/>
+              </a:ext>
+            </a:extLst>
+          </p:cNvPr>
+          <p:cNvSpPr>
+            <a:spLocks xmlns:a="http://schemas.openxmlformats.org/drawingml/2006/main" noGrp="1"/>
+          </p:cNvSpPr>
+          <p:nvPr/>
+        </p:nvSpPr>
+        <p:spPr>
+          <a:xfrm xmlns:a="http://schemas.openxmlformats.org/drawingml/2006/main">
+            <a:off x="1143000" y="5410200"/>
+            <a:ext cx="9810750" cy="247650"/>
+          </a:xfrm>
+          <a:prstGeom xmlns:a="http://schemas.openxmlformats.org/drawingml/2006/main" prst="rect">
+            <a:avLst/>
+          </a:prstGeom>
+          <a:noFill xmlns:a="http://schemas.openxmlformats.org/drawingml/2006/main"/>
+          <a:ln xmlns:a="http://schemas.openxmlformats.org/drawingml/2006/main" w="0">
+            <a:noFill/>
+            <a:prstDash val="solid"/>
+          </a:ln>
+        </p:spPr>
+        <p:txBody>
+          <a:bodyPr xmlns:a="http://schemas.openxmlformats.org/drawingml/2006/main"/>
+          <a:lstStyle xmlns:a="http://schemas.openxmlformats.org/drawingml/2006/main"/>
+          <a:p xmlns:a="http://schemas.openxmlformats.org/drawingml/2006/main">
+            <a:pPr>
+              <a:defRPr sz="1500" b="1">
+                <a:solidFill>
+                  <a:srgbClr val="000000"/>
+                </a:solidFill>
+              </a:defRPr>
+            </a:pPr>
+            <a:r>
+              <a:rPr sz="1500" b="1">
+                <a:solidFill>
+                  <a:srgbClr val="000000"/>
+                </a:solidFill>
+              </a:rPr>
+              <a:t>Recommended posture: keep direct as default, preserve pooled-family as an optional research factor, and run B_hist only if older-regime robustness is the next decision.</a:t>
+            </a:r>
+          </a:p>
+        </p:txBody>
+      </p:sp>
+      <p:sp>
+        <p:nvSpPr>
+          <p:cNvPr id="10" name="">
+            <a:extLst xmlns:a="http://schemas.openxmlformats.org/drawingml/2006/main">
+              <a:ext uri="{FF2B5EF4-FFF2-40B4-BE49-F238E27FC236}">
+                <a16:creationId xmlns:a16="http://schemas.microsoft.com/office/drawing/2014/main" id="{74B84DAC-1421-46BD-8900-A779A6EAAC1B}"/>
+              </a:ext>
+            </a:extLst>
+          </p:cNvPr>
+          <p:cNvSpPr>
+            <a:spLocks xmlns:a="http://schemas.openxmlformats.org/drawingml/2006/main" noGrp="1"/>
+          </p:cNvSpPr>
+          <p:nvPr/>
+        </p:nvSpPr>
+        <p:spPr>
+          <a:xfrm xmlns:a="http://schemas.openxmlformats.org/drawingml/2006/main">
+            <a:off x="400050" y="6343650"/>
+            <a:ext cx="11391900" cy="13335"/>
+          </a:xfrm>
+          <a:prstGeom xmlns:a="http://schemas.openxmlformats.org/drawingml/2006/main" prst="rect">
+            <a:avLst/>
+          </a:prstGeom>
+          <a:solidFill xmlns:a="http://schemas.openxmlformats.org/drawingml/2006/main">
+            <a:srgbClr val="B8BCC4"/>
+          </a:solidFill>
+          <a:ln xmlns:a="http://schemas.openxmlformats.org/drawingml/2006/main" w="0">
+            <a:solidFill>
+              <a:srgbClr val="B8BCC4"/>
+            </a:solidFill>
+            <a:prstDash val="solid"/>
+          </a:ln>
+        </p:spPr>
+      </p:sp>
+      <p:sp>
+        <p:nvSpPr>
+          <p:cNvPr id="11" name="">
+            <a:extLst xmlns:a="http://schemas.openxmlformats.org/drawingml/2006/main">
+              <a:ext uri="{FF2B5EF4-FFF2-40B4-BE49-F238E27FC236}">
+                <a16:creationId xmlns:a16="http://schemas.microsoft.com/office/drawing/2014/main" id="{BFD2C67C-831E-4187-9FC8-C966AE74198A}"/>
+              </a:ext>
+            </a:extLst>
+          </p:cNvPr>
+          <p:cNvSpPr>
+            <a:spLocks xmlns:a="http://schemas.openxmlformats.org/drawingml/2006/main" noGrp="1"/>
+          </p:cNvSpPr>
+          <p:nvPr/>
+        </p:nvSpPr>
+        <p:spPr>
+          <a:xfrm xmlns:a="http://schemas.openxmlformats.org/drawingml/2006/main">
+            <a:off x="400050" y="6477000"/>
+            <a:ext cx="4381500" cy="228600"/>
+          </a:xfrm>
+          <a:prstGeom xmlns:a="http://schemas.openxmlformats.org/drawingml/2006/main" prst="rect">
+            <a:avLst/>
+          </a:prstGeom>
+          <a:noFill xmlns:a="http://schemas.openxmlformats.org/drawingml/2006/main"/>
+          <a:ln xmlns:a="http://schemas.openxmlformats.org/drawingml/2006/main" w="0">
+            <a:noFill/>
+            <a:prstDash val="solid"/>
+          </a:ln>
+        </p:spPr>
+        <p:txBody>
+          <a:bodyPr xmlns:a="http://schemas.openxmlformats.org/drawingml/2006/main"/>
+          <a:lstStyle xmlns:a="http://schemas.openxmlformats.org/drawingml/2006/main"/>
+          <a:p xmlns:a="http://schemas.openxmlformats.org/drawingml/2006/main">
+            <a:pPr>
+              <a:defRPr sz="1050">
+                <a:solidFill>
+                  <a:srgbClr val="555555"/>
+                </a:solidFill>
+              </a:defRPr>
+            </a:pPr>
+            <a:r>
+              <a:rPr sz="1050">
+                <a:solidFill>
+                  <a:srgbClr val="555555"/>
+                </a:solidFill>
+              </a:rPr>
+              <a:t>Gen5.1 selection-policy hypothesis</a:t>
+            </a:r>
+          </a:p>
+        </p:txBody>
+      </p:sp>
+      <p:sp>
+        <p:nvSpPr>
+          <p:cNvPr id="12" name="">
+            <a:extLst xmlns:a="http://schemas.openxmlformats.org/drawingml/2006/main">
+              <a:ext uri="{FF2B5EF4-FFF2-40B4-BE49-F238E27FC236}">
+                <a16:creationId xmlns:a16="http://schemas.microsoft.com/office/drawing/2014/main" id="{FEF6EE1A-B27E-4E7E-8E4C-2E529DFE38C4}"/>
+              </a:ext>
+            </a:extLst>
+          </p:cNvPr>
+          <p:cNvSpPr>
+            <a:spLocks xmlns:a="http://schemas.openxmlformats.org/drawingml/2006/main" noGrp="1"/>
+          </p:cNvSpPr>
+          <p:nvPr/>
+        </p:nvSpPr>
+        <p:spPr>
+          <a:xfrm xmlns:a="http://schemas.openxmlformats.org/drawingml/2006/main">
+            <a:off x="11277600" y="6457950"/>
+            <a:ext cx="514350" cy="266700"/>
+          </a:xfrm>
+          <a:prstGeom xmlns:a="http://schemas.openxmlformats.org/drawingml/2006/main" prst="rect">
+            <a:avLst/>
+          </a:prstGeom>
+          <a:noFill xmlns:a="http://schemas.openxmlformats.org/drawingml/2006/main"/>
+          <a:ln xmlns:a="http://schemas.openxmlformats.org/drawingml/2006/main" w="0">
+            <a:noFill/>
+            <a:prstDash val="solid"/>
+          </a:ln>
+        </p:spPr>
+        <p:txBody>
+          <a:bodyPr xmlns:a="http://schemas.openxmlformats.org/drawingml/2006/main"/>
+          <a:lstStyle xmlns:a="http://schemas.openxmlformats.org/drawingml/2006/main"/>
+          <a:p xmlns:a="http://schemas.openxmlformats.org/drawingml/2006/main">
+            <a:pPr algn="r">
+              <a:defRPr sz="1200" b="1">
+                <a:solidFill>
+                  <a:srgbClr val="555555"/>
+                </a:solidFill>
+              </a:defRPr>
+            </a:pPr>
+            <a:r>
+              <a:rPr sz="1200" b="1">
+                <a:solidFill>
+                  <a:srgbClr val="555555"/>
+                </a:solidFill>
+              </a:rPr>
+              <a:t>10</a:t>
+            </a:r>
+          </a:p>
+        </p:txBody>
+      </p:sp>
+    </p:spTree>
+    <p:extLst>
+      <p:ext uri="{BB962C8B-B14F-4D97-AF65-F5344CB8AC3E}">
+        <p14:creationId xmlns:p14="http://schemas.microsoft.com/office/powerpoint/2010/main" val="1808578038"/>
+      </p:ext>
+    </p:extLst>
+  </p:cSld>
+</p:sld>
+</file>
+
+<file path=ppt/slides/slide11.xml><?xml version="1.0" encoding="utf-8"?>
+<p:sld xmlns:p="http://schemas.openxmlformats.org/presentationml/2006/main">
+  <p:cSld>
+    <p:bg>
+      <p:bgPr>
+        <a:solidFill xmlns:a="http://schemas.openxmlformats.org/drawingml/2006/main">
+          <a:srgbClr val="FFFFFF"/>
+        </a:solidFill>
+      </p:bgPr>
+    </p:bg>
+    <p:spTree>
+      <p:nvGrpSpPr>
+        <p:cNvPr id="1" name=""/>
+        <p:cNvGrpSpPr/>
+        <p:nvPr/>
+      </p:nvGrpSpPr>
+      <p:grpSpPr>
+        <a:xfrm xmlns:a="http://schemas.openxmlformats.org/drawingml/2006/main"/>
+      </p:grpSpPr>
+      <p:sp>
+        <p:nvSpPr>
+          <p:cNvPr id="1" name="">
+            <a:extLst xmlns:a="http://schemas.openxmlformats.org/drawingml/2006/main">
+              <a:ext uri="{FF2B5EF4-FFF2-40B4-BE49-F238E27FC236}">
+                <a16:creationId xmlns:a16="http://schemas.microsoft.com/office/drawing/2014/main" id="{8DE661A8-6E2B-454B-B75E-FAAD54397805}"/>
+              </a:ext>
+            </a:extLst>
+          </p:cNvPr>
+          <p:cNvSpPr>
+            <a:spLocks xmlns:a="http://schemas.openxmlformats.org/drawingml/2006/main" noGrp="1"/>
+          </p:cNvSpPr>
+          <p:nvPr/>
+        </p:nvSpPr>
+        <p:spPr>
+          <a:xfrm xmlns:a="http://schemas.openxmlformats.org/drawingml/2006/main">
+            <a:off x="400050" y="400050"/>
+            <a:ext cx="2476500" cy="266700"/>
+          </a:xfrm>
+          <a:prstGeom xmlns:a="http://schemas.openxmlformats.org/drawingml/2006/main" prst="rect">
+            <a:avLst/>
+          </a:prstGeom>
+          <a:noFill xmlns:a="http://schemas.openxmlformats.org/drawingml/2006/main"/>
+          <a:ln xmlns:a="http://schemas.openxmlformats.org/drawingml/2006/main" w="0">
+            <a:noFill/>
+            <a:prstDash val="solid"/>
+          </a:ln>
+        </p:spPr>
+        <p:txBody>
+          <a:bodyPr xmlns:a="http://schemas.openxmlformats.org/drawingml/2006/main"/>
+          <a:lstStyle xmlns:a="http://schemas.openxmlformats.org/drawingml/2006/main"/>
+          <a:p xmlns:a="http://schemas.openxmlformats.org/drawingml/2006/main">
+            <a:pPr>
+              <a:defRPr sz="1200" b="1">
+                <a:solidFill>
+                  <a:srgbClr val="555555"/>
+                </a:solidFill>
+              </a:defRPr>
+            </a:pPr>
+            <a:r>
+              <a:rPr sz="1200" b="1">
+                <a:solidFill>
+                  <a:srgbClr val="555555"/>
+                </a:solidFill>
+              </a:rPr>
+              <a:t>VISUAL EVIDENCE</a:t>
+            </a:r>
+          </a:p>
+        </p:txBody>
+      </p:sp>
+      <p:sp>
+        <p:nvSpPr>
+          <p:cNvPr id="2" name="">
+            <a:extLst xmlns:a="http://schemas.openxmlformats.org/drawingml/2006/main">
+              <a:ext uri="{FF2B5EF4-FFF2-40B4-BE49-F238E27FC236}">
+                <a16:creationId xmlns:a16="http://schemas.microsoft.com/office/drawing/2014/main" id="{4EAAE26B-7FC2-416D-B22A-6AF10C4AC276}"/>
+              </a:ext>
+            </a:extLst>
+          </p:cNvPr>
+          <p:cNvSpPr>
+            <a:spLocks xmlns:a="http://schemas.openxmlformats.org/drawingml/2006/main" noGrp="1"/>
+          </p:cNvSpPr>
+          <p:nvPr/>
+        </p:nvSpPr>
+        <p:spPr>
+          <a:xfrm xmlns:a="http://schemas.openxmlformats.org/drawingml/2006/main">
+            <a:off x="400050" y="838200"/>
+            <a:ext cx="10096500" cy="914400"/>
+          </a:xfrm>
+          <a:prstGeom xmlns:a="http://schemas.openxmlformats.org/drawingml/2006/main" prst="rect">
+            <a:avLst/>
+          </a:prstGeom>
+          <a:noFill xmlns:a="http://schemas.openxmlformats.org/drawingml/2006/main"/>
+          <a:ln xmlns:a="http://schemas.openxmlformats.org/drawingml/2006/main" w="0">
+            <a:noFill/>
+            <a:prstDash val="solid"/>
+          </a:ln>
+        </p:spPr>
+        <p:txBody>
+          <a:bodyPr xmlns:a="http://schemas.openxmlformats.org/drawingml/2006/main"/>
+          <a:lstStyle xmlns:a="http://schemas.openxmlformats.org/drawingml/2006/main"/>
+          <a:p xmlns:a="http://schemas.openxmlformats.org/drawingml/2006/main">
+            <a:pPr>
+              <a:defRPr sz="2550" b="1">
+                <a:solidFill>
+                  <a:srgbClr val="000000"/>
+                </a:solidFill>
+              </a:defRPr>
+            </a:pPr>
+            <a:r>
+              <a:rPr sz="2550" b="1">
+                <a:solidFill>
+                  <a:srgbClr val="000000"/>
+                </a:solidFill>
+              </a:rPr>
+              <a:t>The A-live charts show steady direct advantage plus one pooled AMD outlier</a:t>
+            </a:r>
+          </a:p>
+        </p:txBody>
+      </p:sp>
+      <p:sp>
+        <p:nvSpPr>
+          <p:cNvPr id="3" name="">
+            <a:extLst xmlns:a="http://schemas.openxmlformats.org/drawingml/2006/main">
+              <a:ext uri="{FF2B5EF4-FFF2-40B4-BE49-F238E27FC236}">
+                <a16:creationId xmlns:a16="http://schemas.microsoft.com/office/drawing/2014/main" id="{8E716224-95A6-4426-8518-C326A053A111}"/>
+              </a:ext>
+            </a:extLst>
+          </p:cNvPr>
+          <p:cNvSpPr>
+            <a:spLocks xmlns:a="http://schemas.openxmlformats.org/drawingml/2006/main" noGrp="1"/>
+          </p:cNvSpPr>
+          <p:nvPr/>
+        </p:nvSpPr>
+        <p:spPr>
+          <a:xfrm xmlns:a="http://schemas.openxmlformats.org/drawingml/2006/main">
+            <a:off x="400050" y="1943100"/>
+            <a:ext cx="10096500" cy="438150"/>
+          </a:xfrm>
+          <a:prstGeom xmlns:a="http://schemas.openxmlformats.org/drawingml/2006/main" prst="rect">
+            <a:avLst/>
+          </a:prstGeom>
+          <a:noFill xmlns:a="http://schemas.openxmlformats.org/drawingml/2006/main"/>
+          <a:ln xmlns:a="http://schemas.openxmlformats.org/drawingml/2006/main" w="0">
+            <a:noFill/>
+            <a:prstDash val="solid"/>
+          </a:ln>
+        </p:spPr>
+        <p:txBody>
+          <a:bodyPr xmlns:a="http://schemas.openxmlformats.org/drawingml/2006/main"/>
+          <a:lstStyle xmlns:a="http://schemas.openxmlformats.org/drawingml/2006/main"/>
+          <a:p xmlns:a="http://schemas.openxmlformats.org/drawingml/2006/main">
+            <a:pPr>
+              <a:defRPr sz="1575">
+                <a:solidFill>
+                  <a:srgbClr val="222222"/>
+                </a:solidFill>
+              </a:defRPr>
+            </a:pPr>
+            <a:r>
+              <a:rPr sz="1575">
+                <a:solidFill>
+                  <a:srgbClr val="222222"/>
+                </a:solidFill>
+              </a:rPr>
+              <a:t>Green cells favor pooled-family; red cells favor direct. The metric dashboard shows direct leading win rate and Sharpe proxy across all four windows.</a:t>
+            </a:r>
+          </a:p>
+        </p:txBody>
+      </p:sp>
+      <p:pic>
+        <p:nvPicPr>
+          <p:cNvPr id="12" name=""/>
+          <p:cNvPicPr>
+            <a:picLocks xmlns:a="http://schemas.openxmlformats.org/drawingml/2006/main" noChangeAspect="1"/>
+          </p:cNvPicPr>
+          <p:nvPr/>
+        </p:nvPicPr>
+        <p:blipFill>
+          <a:blip xmlns:r="http://schemas.openxmlformats.org/officeDocument/2006/relationships" xmlns:a="http://schemas.openxmlformats.org/drawingml/2006/main" r:embed="Rcb3d46d7ef0b40ea"/>
+          <a:stretch xmlns:a="http://schemas.openxmlformats.org/drawingml/2006/main"/>
+        </p:blipFill>
+        <p:spPr>
+          <a:xfrm xmlns:a="http://schemas.openxmlformats.org/drawingml/2006/main">
+            <a:off x="783648" y="2571750"/>
+            <a:ext cx="4909705" cy="3000375"/>
+          </a:xfrm>
+          <a:prstGeom xmlns:a="http://schemas.openxmlformats.org/drawingml/2006/main" prst="rect">
+            <a:avLst/>
+          </a:prstGeom>
+        </p:spPr>
+      </p:pic>
+      <p:pic>
+        <p:nvPicPr>
+          <p:cNvPr id="13" name=""/>
+          <p:cNvPicPr>
+            <a:picLocks xmlns:a="http://schemas.openxmlformats.org/drawingml/2006/main" noChangeAspect="1"/>
+          </p:cNvPicPr>
+          <p:nvPr/>
+        </p:nvPicPr>
+        <p:blipFill>
+          <a:blip xmlns:r="http://schemas.openxmlformats.org/officeDocument/2006/relationships" xmlns:a="http://schemas.openxmlformats.org/drawingml/2006/main" r:embed="R9a60dc8ecfa14704"/>
+          <a:stretch xmlns:a="http://schemas.openxmlformats.org/drawingml/2006/main"/>
+        </p:blipFill>
+        <p:spPr>
+          <a:xfrm xmlns:a="http://schemas.openxmlformats.org/drawingml/2006/main">
+            <a:off x="6381750" y="2583656"/>
+            <a:ext cx="4762500" cy="2976563"/>
+          </a:xfrm>
+          <a:prstGeom xmlns:a="http://schemas.openxmlformats.org/drawingml/2006/main" prst="rect">
+            <a:avLst/>
+          </a:prstGeom>
+        </p:spPr>
+      </p:pic>
+      <p:sp>
+        <p:nvSpPr>
+          <p:cNvPr id="6" name="">
+            <a:extLst xmlns:a="http://schemas.openxmlformats.org/drawingml/2006/main">
+              <a:ext uri="{FF2B5EF4-FFF2-40B4-BE49-F238E27FC236}">
+                <a16:creationId xmlns:a16="http://schemas.microsoft.com/office/drawing/2014/main" id="{0D56D31D-A435-465F-B75B-889A6EAA42FC}"/>
+              </a:ext>
+            </a:extLst>
+          </p:cNvPr>
+          <p:cNvSpPr>
+            <a:spLocks xmlns:a="http://schemas.openxmlformats.org/drawingml/2006/main" noGrp="1"/>
+          </p:cNvSpPr>
+          <p:nvPr/>
+        </p:nvSpPr>
+        <p:spPr>
+          <a:xfrm xmlns:a="http://schemas.openxmlformats.org/drawingml/2006/main">
+            <a:off x="400050" y="6343650"/>
+            <a:ext cx="11391900" cy="13335"/>
+          </a:xfrm>
+          <a:prstGeom xmlns:a="http://schemas.openxmlformats.org/drawingml/2006/main" prst="rect">
+            <a:avLst/>
+          </a:prstGeom>
+          <a:solidFill xmlns:a="http://schemas.openxmlformats.org/drawingml/2006/main">
+            <a:srgbClr val="B8BCC4"/>
+          </a:solidFill>
+          <a:ln xmlns:a="http://schemas.openxmlformats.org/drawingml/2006/main" w="0">
+            <a:solidFill>
+              <a:srgbClr val="B8BCC4"/>
+            </a:solidFill>
+            <a:prstDash val="solid"/>
+          </a:ln>
+        </p:spPr>
+      </p:sp>
+      <p:sp>
+        <p:nvSpPr>
+          <p:cNvPr id="7" name="">
+            <a:extLst xmlns:a="http://schemas.openxmlformats.org/drawingml/2006/main">
+              <a:ext uri="{FF2B5EF4-FFF2-40B4-BE49-F238E27FC236}">
+                <a16:creationId xmlns:a16="http://schemas.microsoft.com/office/drawing/2014/main" id="{9112D585-57E3-485D-A779-B59C228DD857}"/>
+              </a:ext>
+            </a:extLst>
+          </p:cNvPr>
+          <p:cNvSpPr>
+            <a:spLocks xmlns:a="http://schemas.openxmlformats.org/drawingml/2006/main" noGrp="1"/>
+          </p:cNvSpPr>
+          <p:nvPr/>
+        </p:nvSpPr>
+        <p:spPr>
+          <a:xfrm xmlns:a="http://schemas.openxmlformats.org/drawingml/2006/main">
+            <a:off x="400050" y="6477000"/>
+            <a:ext cx="4381500" cy="228600"/>
+          </a:xfrm>
+          <a:prstGeom xmlns:a="http://schemas.openxmlformats.org/drawingml/2006/main" prst="rect">
+            <a:avLst/>
+          </a:prstGeom>
+          <a:noFill xmlns:a="http://schemas.openxmlformats.org/drawingml/2006/main"/>
+          <a:ln xmlns:a="http://schemas.openxmlformats.org/drawingml/2006/main" w="0">
+            <a:noFill/>
+            <a:prstDash val="solid"/>
+          </a:ln>
+        </p:spPr>
+        <p:txBody>
+          <a:bodyPr xmlns:a="http://schemas.openxmlformats.org/drawingml/2006/main"/>
+          <a:lstStyle xmlns:a="http://schemas.openxmlformats.org/drawingml/2006/main"/>
+          <a:p xmlns:a="http://schemas.openxmlformats.org/drawingml/2006/main">
+            <a:pPr>
+              <a:defRPr sz="1050">
+                <a:solidFill>
+                  <a:srgbClr val="555555"/>
+                </a:solidFill>
+              </a:defRPr>
+            </a:pPr>
+            <a:r>
+              <a:rPr sz="1050">
+                <a:solidFill>
+                  <a:srgbClr val="555555"/>
+                </a:solidFill>
+              </a:rPr>
+              <a:t>Gen5.1 selection-policy hypothesis</a:t>
+            </a:r>
+          </a:p>
+        </p:txBody>
+      </p:sp>
+      <p:sp>
+        <p:nvSpPr>
+          <p:cNvPr id="8" name="">
+            <a:extLst xmlns:a="http://schemas.openxmlformats.org/drawingml/2006/main">
+              <a:ext uri="{FF2B5EF4-FFF2-40B4-BE49-F238E27FC236}">
+                <a16:creationId xmlns:a16="http://schemas.microsoft.com/office/drawing/2014/main" id="{72EF93EE-B01D-4357-AD64-ACEC785CD22E}"/>
+              </a:ext>
+            </a:extLst>
+          </p:cNvPr>
+          <p:cNvSpPr>
+            <a:spLocks xmlns:a="http://schemas.openxmlformats.org/drawingml/2006/main" noGrp="1"/>
+          </p:cNvSpPr>
+          <p:nvPr/>
+        </p:nvSpPr>
+        <p:spPr>
+          <a:xfrm xmlns:a="http://schemas.openxmlformats.org/drawingml/2006/main">
+            <a:off x="11277600" y="6457950"/>
+            <a:ext cx="514350" cy="266700"/>
+          </a:xfrm>
+          <a:prstGeom xmlns:a="http://schemas.openxmlformats.org/drawingml/2006/main" prst="rect">
+            <a:avLst/>
+          </a:prstGeom>
+          <a:noFill xmlns:a="http://schemas.openxmlformats.org/drawingml/2006/main"/>
+          <a:ln xmlns:a="http://schemas.openxmlformats.org/drawingml/2006/main" w="0">
+            <a:noFill/>
+            <a:prstDash val="solid"/>
+          </a:ln>
+        </p:spPr>
+        <p:txBody>
+          <a:bodyPr xmlns:a="http://schemas.openxmlformats.org/drawingml/2006/main"/>
+          <a:lstStyle xmlns:a="http://schemas.openxmlformats.org/drawingml/2006/main"/>
+          <a:p xmlns:a="http://schemas.openxmlformats.org/drawingml/2006/main">
+            <a:pPr algn="r">
+              <a:defRPr sz="1200" b="1">
+                <a:solidFill>
+                  <a:srgbClr val="555555"/>
+                </a:solidFill>
+              </a:defRPr>
+            </a:pPr>
+            <a:r>
+              <a:rPr sz="1200" b="1">
+                <a:solidFill>
+                  <a:srgbClr val="555555"/>
+                </a:solidFill>
+              </a:rPr>
+              <a:t>11</a:t>
+            </a:r>
+          </a:p>
+        </p:txBody>
+      </p:sp>
+    </p:spTree>
+    <p:extLst>
+      <p:ext uri="{BB962C8B-B14F-4D97-AF65-F5344CB8AC3E}">
+        <p14:creationId xmlns:p14="http://schemas.microsoft.com/office/powerpoint/2010/main" val="1012383203"/>
       </p:ext>
     </p:extLst>
   </p:cSld>
@@ -2182,7 +3333,7 @@
           <p:cNvPr id="1" name="">
             <a:extLst xmlns:a="http://schemas.openxmlformats.org/drawingml/2006/main">
               <a:ext uri="{FF2B5EF4-FFF2-40B4-BE49-F238E27FC236}">
-                <a16:creationId xmlns:a16="http://schemas.microsoft.com/office/drawing/2014/main" id="{11FD3F25-EDEA-430E-B507-AF9D846DDFBD}"/>
+                <a16:creationId xmlns:a16="http://schemas.microsoft.com/office/drawing/2014/main" id="{9FF72302-E148-4FFE-B64E-2740223AB21F}"/>
               </a:ext>
             </a:extLst>
           </p:cNvPr>
@@ -2232,7 +3383,7 @@
           <p:cNvPr id="2" name="">
             <a:extLst xmlns:a="http://schemas.openxmlformats.org/drawingml/2006/main">
               <a:ext uri="{FF2B5EF4-FFF2-40B4-BE49-F238E27FC236}">
-                <a16:creationId xmlns:a16="http://schemas.microsoft.com/office/drawing/2014/main" id="{E8201A1B-F7FA-4A3A-B163-9A7EAF8CA315}"/>
+                <a16:creationId xmlns:a16="http://schemas.microsoft.com/office/drawing/2014/main" id="{8A1991E9-9C96-4DE7-BE6A-1335D12F5EBE}"/>
               </a:ext>
             </a:extLst>
           </p:cNvPr>
@@ -2282,7 +3433,7 @@
           <p:cNvPr id="3" name="">
             <a:extLst xmlns:a="http://schemas.openxmlformats.org/drawingml/2006/main">
               <a:ext uri="{FF2B5EF4-FFF2-40B4-BE49-F238E27FC236}">
-                <a16:creationId xmlns:a16="http://schemas.microsoft.com/office/drawing/2014/main" id="{5DFE9D94-B4FF-4460-B0EE-582268771C34}"/>
+                <a16:creationId xmlns:a16="http://schemas.microsoft.com/office/drawing/2014/main" id="{2A35D6ED-DF47-44F5-8664-B214243C2E17}"/>
               </a:ext>
             </a:extLst>
           </p:cNvPr>
@@ -2332,7 +3483,7 @@
           <p:cNvPr id="4" name="">
             <a:extLst xmlns:a="http://schemas.openxmlformats.org/drawingml/2006/main">
               <a:ext uri="{FF2B5EF4-FFF2-40B4-BE49-F238E27FC236}">
-                <a16:creationId xmlns:a16="http://schemas.microsoft.com/office/drawing/2014/main" id="{34189426-8359-4812-91A4-B7F4BC89C3F0}"/>
+                <a16:creationId xmlns:a16="http://schemas.microsoft.com/office/drawing/2014/main" id="{6AC38604-CC7D-4EAE-929A-1AE9AC5D4D63}"/>
               </a:ext>
             </a:extLst>
           </p:cNvPr>
@@ -2363,7 +3514,7 @@
           <p:cNvPr id="5" name="">
             <a:extLst xmlns:a="http://schemas.openxmlformats.org/drawingml/2006/main">
               <a:ext uri="{FF2B5EF4-FFF2-40B4-BE49-F238E27FC236}">
-                <a16:creationId xmlns:a16="http://schemas.microsoft.com/office/drawing/2014/main" id="{96FBC063-3E50-4585-B050-54BB11F57457}"/>
+                <a16:creationId xmlns:a16="http://schemas.microsoft.com/office/drawing/2014/main" id="{9D053A91-BB31-443F-829C-8EAAC34A86D4}"/>
               </a:ext>
             </a:extLst>
           </p:cNvPr>
@@ -2413,7 +3564,7 @@
           <p:cNvPr id="6" name="">
             <a:extLst xmlns:a="http://schemas.openxmlformats.org/drawingml/2006/main">
               <a:ext uri="{FF2B5EF4-FFF2-40B4-BE49-F238E27FC236}">
-                <a16:creationId xmlns:a16="http://schemas.microsoft.com/office/drawing/2014/main" id="{0418C969-5EF3-405F-AABC-07BE585F94F1}"/>
+                <a16:creationId xmlns:a16="http://schemas.microsoft.com/office/drawing/2014/main" id="{12330348-EDDC-42F6-860F-D991B11FDD18}"/>
               </a:ext>
             </a:extLst>
           </p:cNvPr>
@@ -2463,7 +3614,7 @@
           <p:cNvPr id="7" name="">
             <a:extLst xmlns:a="http://schemas.openxmlformats.org/drawingml/2006/main">
               <a:ext uri="{FF2B5EF4-FFF2-40B4-BE49-F238E27FC236}">
-                <a16:creationId xmlns:a16="http://schemas.microsoft.com/office/drawing/2014/main" id="{EB404F3A-FB48-422E-8F3C-AC32741EBFDB}"/>
+                <a16:creationId xmlns:a16="http://schemas.microsoft.com/office/drawing/2014/main" id="{B58D9695-7D94-439E-8932-4E3888197A71}"/>
               </a:ext>
             </a:extLst>
           </p:cNvPr>
@@ -2494,7 +3645,7 @@
           <p:cNvPr id="8" name="">
             <a:extLst xmlns:a="http://schemas.openxmlformats.org/drawingml/2006/main">
               <a:ext uri="{FF2B5EF4-FFF2-40B4-BE49-F238E27FC236}">
-                <a16:creationId xmlns:a16="http://schemas.microsoft.com/office/drawing/2014/main" id="{E631DF4D-350D-448E-853A-DAE9B0B2ADE7}"/>
+                <a16:creationId xmlns:a16="http://schemas.microsoft.com/office/drawing/2014/main" id="{6C9F00F6-518F-4412-87EE-FFCC40A8772B}"/>
               </a:ext>
             </a:extLst>
           </p:cNvPr>
@@ -2544,7 +3695,7 @@
           <p:cNvPr id="9" name="">
             <a:extLst xmlns:a="http://schemas.openxmlformats.org/drawingml/2006/main">
               <a:ext uri="{FF2B5EF4-FFF2-40B4-BE49-F238E27FC236}">
-                <a16:creationId xmlns:a16="http://schemas.microsoft.com/office/drawing/2014/main" id="{CE835B5F-BC46-46FF-AF4A-A5CC581D2208}"/>
+                <a16:creationId xmlns:a16="http://schemas.microsoft.com/office/drawing/2014/main" id="{0038523F-B5F1-4FF8-B24A-C948C58309D5}"/>
               </a:ext>
             </a:extLst>
           </p:cNvPr>
@@ -2594,7 +3745,7 @@
           <p:cNvPr id="10" name="">
             <a:extLst xmlns:a="http://schemas.openxmlformats.org/drawingml/2006/main">
               <a:ext uri="{FF2B5EF4-FFF2-40B4-BE49-F238E27FC236}">
-                <a16:creationId xmlns:a16="http://schemas.microsoft.com/office/drawing/2014/main" id="{D5230B61-28E9-42D3-9CFC-CC07118AC35F}"/>
+                <a16:creationId xmlns:a16="http://schemas.microsoft.com/office/drawing/2014/main" id="{99A89105-ABC8-4488-A5F4-13EE69DB3DE6}"/>
               </a:ext>
             </a:extLst>
           </p:cNvPr>
@@ -2625,7 +3776,7 @@
           <p:cNvPr id="11" name="">
             <a:extLst xmlns:a="http://schemas.openxmlformats.org/drawingml/2006/main">
               <a:ext uri="{FF2B5EF4-FFF2-40B4-BE49-F238E27FC236}">
-                <a16:creationId xmlns:a16="http://schemas.microsoft.com/office/drawing/2014/main" id="{451C8AEE-B4A4-4443-8231-53AFDF984774}"/>
+                <a16:creationId xmlns:a16="http://schemas.microsoft.com/office/drawing/2014/main" id="{E967EBD0-D5D2-4C25-B9C4-B86C133B7452}"/>
               </a:ext>
             </a:extLst>
           </p:cNvPr>
@@ -2675,7 +3826,7 @@
           <p:cNvPr id="12" name="">
             <a:extLst xmlns:a="http://schemas.openxmlformats.org/drawingml/2006/main">
               <a:ext uri="{FF2B5EF4-FFF2-40B4-BE49-F238E27FC236}">
-                <a16:creationId xmlns:a16="http://schemas.microsoft.com/office/drawing/2014/main" id="{2DC31F69-AE52-4566-B369-38BD4A7273AC}"/>
+                <a16:creationId xmlns:a16="http://schemas.microsoft.com/office/drawing/2014/main" id="{70E57310-CB82-4D6B-955F-E41AA16663AE}"/>
               </a:ext>
             </a:extLst>
           </p:cNvPr>
@@ -2725,7 +3876,7 @@
           <p:cNvPr id="13" name="">
             <a:extLst xmlns:a="http://schemas.openxmlformats.org/drawingml/2006/main">
               <a:ext uri="{FF2B5EF4-FFF2-40B4-BE49-F238E27FC236}">
-                <a16:creationId xmlns:a16="http://schemas.microsoft.com/office/drawing/2014/main" id="{6A7090F9-8CC5-4467-B362-DA065AADFE53}"/>
+                <a16:creationId xmlns:a16="http://schemas.microsoft.com/office/drawing/2014/main" id="{B8C8A495-2435-490D-B4BD-D0C4BA704EAB}"/>
               </a:ext>
             </a:extLst>
           </p:cNvPr>
@@ -2775,7 +3926,7 @@
           <p:cNvPr id="14" name="">
             <a:extLst xmlns:a="http://schemas.openxmlformats.org/drawingml/2006/main">
               <a:ext uri="{FF2B5EF4-FFF2-40B4-BE49-F238E27FC236}">
-                <a16:creationId xmlns:a16="http://schemas.microsoft.com/office/drawing/2014/main" id="{61B55219-573E-4B8D-AA7E-FF90B1CE50CE}"/>
+                <a16:creationId xmlns:a16="http://schemas.microsoft.com/office/drawing/2014/main" id="{BF428658-F2DD-474C-BDCA-AB98E5AAC9FE}"/>
               </a:ext>
             </a:extLst>
           </p:cNvPr>
@@ -2808,7 +3959,7 @@
           <p:cNvPr id="15" name="">
             <a:extLst xmlns:a="http://schemas.openxmlformats.org/drawingml/2006/main">
               <a:ext uri="{FF2B5EF4-FFF2-40B4-BE49-F238E27FC236}">
-                <a16:creationId xmlns:a16="http://schemas.microsoft.com/office/drawing/2014/main" id="{BE6232F8-E1A3-49A8-B244-66AD8940DE1D}"/>
+                <a16:creationId xmlns:a16="http://schemas.microsoft.com/office/drawing/2014/main" id="{1D427AB1-16F3-47EA-8FFC-635184E7765C}"/>
               </a:ext>
             </a:extLst>
           </p:cNvPr>
@@ -2858,7 +4009,7 @@
           <p:cNvPr id="16" name="">
             <a:extLst xmlns:a="http://schemas.openxmlformats.org/drawingml/2006/main">
               <a:ext uri="{FF2B5EF4-FFF2-40B4-BE49-F238E27FC236}">
-                <a16:creationId xmlns:a16="http://schemas.microsoft.com/office/drawing/2014/main" id="{975C437C-B086-4511-8DEB-A6C7AF915D77}"/>
+                <a16:creationId xmlns:a16="http://schemas.microsoft.com/office/drawing/2014/main" id="{FDC2674E-B110-47FB-A455-B254500B73EC}"/>
               </a:ext>
             </a:extLst>
           </p:cNvPr>
@@ -2906,7 +4057,7 @@
     </p:spTree>
     <p:extLst>
       <p:ext uri="{BB962C8B-B14F-4D97-AF65-F5344CB8AC3E}">
-        <p14:creationId xmlns:p14="http://schemas.microsoft.com/office/powerpoint/2010/main" val="1681893720"/>
+        <p14:creationId xmlns:p14="http://schemas.microsoft.com/office/powerpoint/2010/main" val="1915247318"/>
       </p:ext>
     </p:extLst>
   </p:cSld>
@@ -2937,7 +4088,7 @@
           <p:cNvPr id="1" name="">
             <a:extLst xmlns:a="http://schemas.openxmlformats.org/drawingml/2006/main">
               <a:ext uri="{FF2B5EF4-FFF2-40B4-BE49-F238E27FC236}">
-                <a16:creationId xmlns:a16="http://schemas.microsoft.com/office/drawing/2014/main" id="{030927C1-B591-467E-A7E3-F7A830A4DFD9}"/>
+                <a16:creationId xmlns:a16="http://schemas.microsoft.com/office/drawing/2014/main" id="{17BDAB3D-6565-4D23-A17A-DB8E49E5BA66}"/>
               </a:ext>
             </a:extLst>
           </p:cNvPr>
@@ -2987,7 +4138,7 @@
           <p:cNvPr id="2" name="">
             <a:extLst xmlns:a="http://schemas.openxmlformats.org/drawingml/2006/main">
               <a:ext uri="{FF2B5EF4-FFF2-40B4-BE49-F238E27FC236}">
-                <a16:creationId xmlns:a16="http://schemas.microsoft.com/office/drawing/2014/main" id="{ADF29B1B-D043-4517-B7D6-3F8917F0992C}"/>
+                <a16:creationId xmlns:a16="http://schemas.microsoft.com/office/drawing/2014/main" id="{4C7065CF-9445-465F-94A8-DA91F9C0BF48}"/>
               </a:ext>
             </a:extLst>
           </p:cNvPr>
@@ -3037,7 +4188,7 @@
           <p:cNvPr id="3" name="">
             <a:extLst xmlns:a="http://schemas.openxmlformats.org/drawingml/2006/main">
               <a:ext uri="{FF2B5EF4-FFF2-40B4-BE49-F238E27FC236}">
-                <a16:creationId xmlns:a16="http://schemas.microsoft.com/office/drawing/2014/main" id="{2688C95D-0D0E-4BF0-81B0-B77370F9935D}"/>
+                <a16:creationId xmlns:a16="http://schemas.microsoft.com/office/drawing/2014/main" id="{167BFA29-F12F-4948-B7E2-AD884E6F6EFB}"/>
               </a:ext>
             </a:extLst>
           </p:cNvPr>
@@ -3068,7 +4219,7 @@
           <p:cNvPr id="4" name="">
             <a:extLst xmlns:a="http://schemas.openxmlformats.org/drawingml/2006/main">
               <a:ext uri="{FF2B5EF4-FFF2-40B4-BE49-F238E27FC236}">
-                <a16:creationId xmlns:a16="http://schemas.microsoft.com/office/drawing/2014/main" id="{4F831067-B7E6-4A89-9C35-5541051E55EF}"/>
+                <a16:creationId xmlns:a16="http://schemas.microsoft.com/office/drawing/2014/main" id="{5CBDED1C-2019-498B-B0C1-638912061157}"/>
               </a:ext>
             </a:extLst>
           </p:cNvPr>
@@ -3118,7 +4269,7 @@
           <p:cNvPr id="5" name="">
             <a:extLst xmlns:a="http://schemas.openxmlformats.org/drawingml/2006/main">
               <a:ext uri="{FF2B5EF4-FFF2-40B4-BE49-F238E27FC236}">
-                <a16:creationId xmlns:a16="http://schemas.microsoft.com/office/drawing/2014/main" id="{A8F0ED91-F682-4E95-BC4E-9ABE1D8D7AF1}"/>
+                <a16:creationId xmlns:a16="http://schemas.microsoft.com/office/drawing/2014/main" id="{33A914FE-A271-4E9E-8D90-0E506979D77B}"/>
               </a:ext>
             </a:extLst>
           </p:cNvPr>
@@ -3168,7 +4319,7 @@
           <p:cNvPr id="6" name="">
             <a:extLst xmlns:a="http://schemas.openxmlformats.org/drawingml/2006/main">
               <a:ext uri="{FF2B5EF4-FFF2-40B4-BE49-F238E27FC236}">
-                <a16:creationId xmlns:a16="http://schemas.microsoft.com/office/drawing/2014/main" id="{054DE1A3-FAD8-4959-8FBD-9D184AB38E01}"/>
+                <a16:creationId xmlns:a16="http://schemas.microsoft.com/office/drawing/2014/main" id="{98500A35-03C5-428E-9968-B57C9E2C2C87}"/>
               </a:ext>
             </a:extLst>
           </p:cNvPr>
@@ -3201,7 +4352,7 @@
           <p:cNvPr id="7" name="">
             <a:extLst xmlns:a="http://schemas.openxmlformats.org/drawingml/2006/main">
               <a:ext uri="{FF2B5EF4-FFF2-40B4-BE49-F238E27FC236}">
-                <a16:creationId xmlns:a16="http://schemas.microsoft.com/office/drawing/2014/main" id="{EB0D5BD4-A4DF-4531-B2CC-6AED1DAF3F53}"/>
+                <a16:creationId xmlns:a16="http://schemas.microsoft.com/office/drawing/2014/main" id="{908B3CAB-5F6E-46DB-B954-B6F7308D9DCD}"/>
               </a:ext>
             </a:extLst>
           </p:cNvPr>
@@ -3285,7 +4436,7 @@
           <p:cNvPr id="8" name="">
             <a:extLst xmlns:a="http://schemas.openxmlformats.org/drawingml/2006/main">
               <a:ext uri="{FF2B5EF4-FFF2-40B4-BE49-F238E27FC236}">
-                <a16:creationId xmlns:a16="http://schemas.microsoft.com/office/drawing/2014/main" id="{C437285D-E20E-42C2-A31F-52C41C71CFD8}"/>
+                <a16:creationId xmlns:a16="http://schemas.microsoft.com/office/drawing/2014/main" id="{74B7D7B8-B468-4C8D-A7A7-63788F9D9D8D}"/>
               </a:ext>
             </a:extLst>
           </p:cNvPr>
@@ -3316,7 +4467,7 @@
           <p:cNvPr id="9" name="">
             <a:extLst xmlns:a="http://schemas.openxmlformats.org/drawingml/2006/main">
               <a:ext uri="{FF2B5EF4-FFF2-40B4-BE49-F238E27FC236}">
-                <a16:creationId xmlns:a16="http://schemas.microsoft.com/office/drawing/2014/main" id="{10943E37-1009-42DD-829A-A96706B879A5}"/>
+                <a16:creationId xmlns:a16="http://schemas.microsoft.com/office/drawing/2014/main" id="{03F4308E-081C-497E-B9CA-175DE3DD4BE6}"/>
               </a:ext>
             </a:extLst>
           </p:cNvPr>
@@ -3366,7 +4517,7 @@
           <p:cNvPr id="10" name="">
             <a:extLst xmlns:a="http://schemas.openxmlformats.org/drawingml/2006/main">
               <a:ext uri="{FF2B5EF4-FFF2-40B4-BE49-F238E27FC236}">
-                <a16:creationId xmlns:a16="http://schemas.microsoft.com/office/drawing/2014/main" id="{D6A3C34F-E7D2-41EA-A9FE-83E53C8038F5}"/>
+                <a16:creationId xmlns:a16="http://schemas.microsoft.com/office/drawing/2014/main" id="{11C443BE-053F-4B5B-BB27-BC6D1171C14A}"/>
               </a:ext>
             </a:extLst>
           </p:cNvPr>
@@ -3416,7 +4567,7 @@
           <p:cNvPr id="11" name="">
             <a:extLst xmlns:a="http://schemas.openxmlformats.org/drawingml/2006/main">
               <a:ext uri="{FF2B5EF4-FFF2-40B4-BE49-F238E27FC236}">
-                <a16:creationId xmlns:a16="http://schemas.microsoft.com/office/drawing/2014/main" id="{6088EB04-824C-43A3-B909-31B0775C2165}"/>
+                <a16:creationId xmlns:a16="http://schemas.microsoft.com/office/drawing/2014/main" id="{D039E851-B986-49FF-92FA-9D683030262F}"/>
               </a:ext>
             </a:extLst>
           </p:cNvPr>
@@ -3449,7 +4600,7 @@
           <p:cNvPr id="12" name="">
             <a:extLst xmlns:a="http://schemas.openxmlformats.org/drawingml/2006/main">
               <a:ext uri="{FF2B5EF4-FFF2-40B4-BE49-F238E27FC236}">
-                <a16:creationId xmlns:a16="http://schemas.microsoft.com/office/drawing/2014/main" id="{39DA7F3B-08C9-432B-9C7C-9C1B1399CF5F}"/>
+                <a16:creationId xmlns:a16="http://schemas.microsoft.com/office/drawing/2014/main" id="{14E13225-8A18-462B-81BB-CA277B035576}"/>
               </a:ext>
             </a:extLst>
           </p:cNvPr>
@@ -3533,7 +4684,7 @@
           <p:cNvPr id="13" name="">
             <a:extLst xmlns:a="http://schemas.openxmlformats.org/drawingml/2006/main">
               <a:ext uri="{FF2B5EF4-FFF2-40B4-BE49-F238E27FC236}">
-                <a16:creationId xmlns:a16="http://schemas.microsoft.com/office/drawing/2014/main" id="{D4836F7D-55E5-4039-B252-C6A674366CBB}"/>
+                <a16:creationId xmlns:a16="http://schemas.microsoft.com/office/drawing/2014/main" id="{FD1E8350-0E5A-4546-9029-97B6DFAB2934}"/>
               </a:ext>
             </a:extLst>
           </p:cNvPr>
@@ -3566,7 +4717,7 @@
           <p:cNvPr id="14" name="">
             <a:extLst xmlns:a="http://schemas.openxmlformats.org/drawingml/2006/main">
               <a:ext uri="{FF2B5EF4-FFF2-40B4-BE49-F238E27FC236}">
-                <a16:creationId xmlns:a16="http://schemas.microsoft.com/office/drawing/2014/main" id="{6FF7D8EA-D363-435D-BF3D-9E0630F31B6C}"/>
+                <a16:creationId xmlns:a16="http://schemas.microsoft.com/office/drawing/2014/main" id="{FCB443EB-4E42-455E-A652-8EA06E0DD1B7}"/>
               </a:ext>
             </a:extLst>
           </p:cNvPr>
@@ -3616,7 +4767,7 @@
           <p:cNvPr id="15" name="">
             <a:extLst xmlns:a="http://schemas.openxmlformats.org/drawingml/2006/main">
               <a:ext uri="{FF2B5EF4-FFF2-40B4-BE49-F238E27FC236}">
-                <a16:creationId xmlns:a16="http://schemas.microsoft.com/office/drawing/2014/main" id="{2370AE69-4A21-4ED0-B5E8-9EEAFDC68FB6}"/>
+                <a16:creationId xmlns:a16="http://schemas.microsoft.com/office/drawing/2014/main" id="{E4F69070-6AFF-41CF-9FED-DABEC3B3F885}"/>
               </a:ext>
             </a:extLst>
           </p:cNvPr>
@@ -3664,7 +4815,7 @@
     </p:spTree>
     <p:extLst>
       <p:ext uri="{BB962C8B-B14F-4D97-AF65-F5344CB8AC3E}">
-        <p14:creationId xmlns:p14="http://schemas.microsoft.com/office/powerpoint/2010/main" val="1538936470"/>
+        <p14:creationId xmlns:p14="http://schemas.microsoft.com/office/powerpoint/2010/main" val="696732711"/>
       </p:ext>
     </p:extLst>
   </p:cSld>
@@ -3695,7 +4846,7 @@
           <p:cNvPr id="1" name="">
             <a:extLst xmlns:a="http://schemas.openxmlformats.org/drawingml/2006/main">
               <a:ext uri="{FF2B5EF4-FFF2-40B4-BE49-F238E27FC236}">
-                <a16:creationId xmlns:a16="http://schemas.microsoft.com/office/drawing/2014/main" id="{52F83C82-7F89-4520-B91C-1127705E6ACA}"/>
+                <a16:creationId xmlns:a16="http://schemas.microsoft.com/office/drawing/2014/main" id="{65ADB377-17B5-45CE-BCB0-BC38C6CE8BA3}"/>
               </a:ext>
             </a:extLst>
           </p:cNvPr>
@@ -3745,7 +4896,7 @@
           <p:cNvPr id="2" name="">
             <a:extLst xmlns:a="http://schemas.openxmlformats.org/drawingml/2006/main">
               <a:ext uri="{FF2B5EF4-FFF2-40B4-BE49-F238E27FC236}">
-                <a16:creationId xmlns:a16="http://schemas.microsoft.com/office/drawing/2014/main" id="{881B8218-B697-4A9C-87D7-3E99A96DE911}"/>
+                <a16:creationId xmlns:a16="http://schemas.microsoft.com/office/drawing/2014/main" id="{3C15BF38-EC4C-4492-A5FA-4186E28A8025}"/>
               </a:ext>
             </a:extLst>
           </p:cNvPr>
@@ -3795,7 +4946,7 @@
           <p:cNvPr id="3" name="">
             <a:extLst xmlns:a="http://schemas.openxmlformats.org/drawingml/2006/main">
               <a:ext uri="{FF2B5EF4-FFF2-40B4-BE49-F238E27FC236}">
-                <a16:creationId xmlns:a16="http://schemas.microsoft.com/office/drawing/2014/main" id="{689E8159-CEAF-446E-B9D8-70AC9B0A4829}"/>
+                <a16:creationId xmlns:a16="http://schemas.microsoft.com/office/drawing/2014/main" id="{9E282AF2-A2BC-4157-BEA5-F06A7878ADB4}"/>
               </a:ext>
             </a:extLst>
           </p:cNvPr>
@@ -3845,7 +4996,7 @@
           <p:cNvPr id="4" name="">
             <a:extLst xmlns:a="http://schemas.openxmlformats.org/drawingml/2006/main">
               <a:ext uri="{FF2B5EF4-FFF2-40B4-BE49-F238E27FC236}">
-                <a16:creationId xmlns:a16="http://schemas.microsoft.com/office/drawing/2014/main" id="{5CF8AB9B-8FBB-4B03-8341-915C05AE2266}"/>
+                <a16:creationId xmlns:a16="http://schemas.microsoft.com/office/drawing/2014/main" id="{A5BAF0C5-3FCA-4EA8-BA74-6C3CE6E871CB}"/>
               </a:ext>
             </a:extLst>
           </p:cNvPr>
@@ -3876,7 +5027,7 @@
           <p:cNvPr id="5" name="">
             <a:extLst xmlns:a="http://schemas.openxmlformats.org/drawingml/2006/main">
               <a:ext uri="{FF2B5EF4-FFF2-40B4-BE49-F238E27FC236}">
-                <a16:creationId xmlns:a16="http://schemas.microsoft.com/office/drawing/2014/main" id="{A78F59B0-31A2-4CFC-AA39-9E7170165469}"/>
+                <a16:creationId xmlns:a16="http://schemas.microsoft.com/office/drawing/2014/main" id="{6424A4D5-FBF0-4131-846A-59ED32AD787D}"/>
               </a:ext>
             </a:extLst>
           </p:cNvPr>
@@ -3926,7 +5077,7 @@
           <p:cNvPr id="6" name="">
             <a:extLst xmlns:a="http://schemas.openxmlformats.org/drawingml/2006/main">
               <a:ext uri="{FF2B5EF4-FFF2-40B4-BE49-F238E27FC236}">
-                <a16:creationId xmlns:a16="http://schemas.microsoft.com/office/drawing/2014/main" id="{3AC3DC6E-7853-443B-A4F7-A376BD88A2E8}"/>
+                <a16:creationId xmlns:a16="http://schemas.microsoft.com/office/drawing/2014/main" id="{3CBB8A6B-DFBA-4B89-8793-41A3915E0F0C}"/>
               </a:ext>
             </a:extLst>
           </p:cNvPr>
@@ -3976,7 +5127,7 @@
           <p:cNvPr id="7" name="">
             <a:extLst xmlns:a="http://schemas.openxmlformats.org/drawingml/2006/main">
               <a:ext uri="{FF2B5EF4-FFF2-40B4-BE49-F238E27FC236}">
-                <a16:creationId xmlns:a16="http://schemas.microsoft.com/office/drawing/2014/main" id="{3ADABA3D-182E-43E4-9C9D-0C78AC26B666}"/>
+                <a16:creationId xmlns:a16="http://schemas.microsoft.com/office/drawing/2014/main" id="{6DC0B608-F916-4F95-98A1-BD7C22A72223}"/>
               </a:ext>
             </a:extLst>
           </p:cNvPr>
@@ -4007,7 +5158,7 @@
           <p:cNvPr id="8" name="">
             <a:extLst xmlns:a="http://schemas.openxmlformats.org/drawingml/2006/main">
               <a:ext uri="{FF2B5EF4-FFF2-40B4-BE49-F238E27FC236}">
-                <a16:creationId xmlns:a16="http://schemas.microsoft.com/office/drawing/2014/main" id="{90873525-D500-45E2-B335-23DD64952AA9}"/>
+                <a16:creationId xmlns:a16="http://schemas.microsoft.com/office/drawing/2014/main" id="{4F61E967-544A-4107-BE83-101B3316125A}"/>
               </a:ext>
             </a:extLst>
           </p:cNvPr>
@@ -4057,7 +5208,7 @@
           <p:cNvPr id="9" name="">
             <a:extLst xmlns:a="http://schemas.openxmlformats.org/drawingml/2006/main">
               <a:ext uri="{FF2B5EF4-FFF2-40B4-BE49-F238E27FC236}">
-                <a16:creationId xmlns:a16="http://schemas.microsoft.com/office/drawing/2014/main" id="{FE893C19-35FF-45E4-86AA-1FE3245E7165}"/>
+                <a16:creationId xmlns:a16="http://schemas.microsoft.com/office/drawing/2014/main" id="{B6B2685C-28DA-4C4A-AAED-0BF3AECBEF76}"/>
               </a:ext>
             </a:extLst>
           </p:cNvPr>
@@ -4107,7 +5258,7 @@
           <p:cNvPr id="10" name="">
             <a:extLst xmlns:a="http://schemas.openxmlformats.org/drawingml/2006/main">
               <a:ext uri="{FF2B5EF4-FFF2-40B4-BE49-F238E27FC236}">
-                <a16:creationId xmlns:a16="http://schemas.microsoft.com/office/drawing/2014/main" id="{26CA221D-22EF-40C0-8528-F26535DF711B}"/>
+                <a16:creationId xmlns:a16="http://schemas.microsoft.com/office/drawing/2014/main" id="{480B4AD4-8E7A-4063-AC12-D72D08BD5113}"/>
               </a:ext>
             </a:extLst>
           </p:cNvPr>
@@ -4138,7 +5289,7 @@
           <p:cNvPr id="11" name="">
             <a:extLst xmlns:a="http://schemas.openxmlformats.org/drawingml/2006/main">
               <a:ext uri="{FF2B5EF4-FFF2-40B4-BE49-F238E27FC236}">
-                <a16:creationId xmlns:a16="http://schemas.microsoft.com/office/drawing/2014/main" id="{2AB6D088-FAF2-464F-9B53-4AABBAA8CFBC}"/>
+                <a16:creationId xmlns:a16="http://schemas.microsoft.com/office/drawing/2014/main" id="{9BF660BA-5130-4DD8-BA50-1AFC38A143A2}"/>
               </a:ext>
             </a:extLst>
           </p:cNvPr>
@@ -4188,7 +5339,7 @@
           <p:cNvPr id="12" name="">
             <a:extLst xmlns:a="http://schemas.openxmlformats.org/drawingml/2006/main">
               <a:ext uri="{FF2B5EF4-FFF2-40B4-BE49-F238E27FC236}">
-                <a16:creationId xmlns:a16="http://schemas.microsoft.com/office/drawing/2014/main" id="{57502089-2B53-4049-92FC-2AA28F765B42}"/>
+                <a16:creationId xmlns:a16="http://schemas.microsoft.com/office/drawing/2014/main" id="{B0372723-48F9-4033-9276-D6BC600564D9}"/>
               </a:ext>
             </a:extLst>
           </p:cNvPr>
@@ -4238,7 +5389,7 @@
           <p:cNvPr id="13" name="">
             <a:extLst xmlns:a="http://schemas.openxmlformats.org/drawingml/2006/main">
               <a:ext uri="{FF2B5EF4-FFF2-40B4-BE49-F238E27FC236}">
-                <a16:creationId xmlns:a16="http://schemas.microsoft.com/office/drawing/2014/main" id="{500D4293-975B-4AA2-8B51-E57AF79166A3}"/>
+                <a16:creationId xmlns:a16="http://schemas.microsoft.com/office/drawing/2014/main" id="{EFE3BD57-1EB0-4283-B1D1-EA2AB1C5B597}"/>
               </a:ext>
             </a:extLst>
           </p:cNvPr>
@@ -4271,7 +5422,7 @@
           <p:cNvPr id="14" name="">
             <a:extLst xmlns:a="http://schemas.openxmlformats.org/drawingml/2006/main">
               <a:ext uri="{FF2B5EF4-FFF2-40B4-BE49-F238E27FC236}">
-                <a16:creationId xmlns:a16="http://schemas.microsoft.com/office/drawing/2014/main" id="{AAD0C934-4448-45A4-BFD4-3F0D5F292672}"/>
+                <a16:creationId xmlns:a16="http://schemas.microsoft.com/office/drawing/2014/main" id="{14A7374F-9E26-49F4-9759-BFD9E4A74BE6}"/>
               </a:ext>
             </a:extLst>
           </p:cNvPr>
@@ -4321,7 +5472,7 @@
           <p:cNvPr id="15" name="">
             <a:extLst xmlns:a="http://schemas.openxmlformats.org/drawingml/2006/main">
               <a:ext uri="{FF2B5EF4-FFF2-40B4-BE49-F238E27FC236}">
-                <a16:creationId xmlns:a16="http://schemas.microsoft.com/office/drawing/2014/main" id="{2EB1F151-A73A-4506-8E67-3C3F82E6605E}"/>
+                <a16:creationId xmlns:a16="http://schemas.microsoft.com/office/drawing/2014/main" id="{40C4D880-5B64-4B5F-A34C-241240D4A1F8}"/>
               </a:ext>
             </a:extLst>
           </p:cNvPr>
@@ -4369,7 +5520,7 @@
     </p:spTree>
     <p:extLst>
       <p:ext uri="{BB962C8B-B14F-4D97-AF65-F5344CB8AC3E}">
-        <p14:creationId xmlns:p14="http://schemas.microsoft.com/office/powerpoint/2010/main" val="1321850849"/>
+        <p14:creationId xmlns:p14="http://schemas.microsoft.com/office/powerpoint/2010/main" val="269918615"/>
       </p:ext>
     </p:extLst>
   </p:cSld>
@@ -4400,7 +5551,7 @@
           <p:cNvPr id="1" name="">
             <a:extLst xmlns:a="http://schemas.openxmlformats.org/drawingml/2006/main">
               <a:ext uri="{FF2B5EF4-FFF2-40B4-BE49-F238E27FC236}">
-                <a16:creationId xmlns:a16="http://schemas.microsoft.com/office/drawing/2014/main" id="{D762D62A-DBEF-493A-94A3-A330DCAD4EEB}"/>
+                <a16:creationId xmlns:a16="http://schemas.microsoft.com/office/drawing/2014/main" id="{51EB65AE-AF87-4BAB-9633-52C720EE43A4}"/>
               </a:ext>
             </a:extLst>
           </p:cNvPr>
@@ -4450,7 +5601,7 @@
           <p:cNvPr id="2" name="">
             <a:extLst xmlns:a="http://schemas.openxmlformats.org/drawingml/2006/main">
               <a:ext uri="{FF2B5EF4-FFF2-40B4-BE49-F238E27FC236}">
-                <a16:creationId xmlns:a16="http://schemas.microsoft.com/office/drawing/2014/main" id="{CC5EDC3A-2426-4B2B-9200-F39C88776B0D}"/>
+                <a16:creationId xmlns:a16="http://schemas.microsoft.com/office/drawing/2014/main" id="{DF481CB8-6037-4575-976B-B5068DC63276}"/>
               </a:ext>
             </a:extLst>
           </p:cNvPr>
@@ -4500,7 +5651,7 @@
           <p:cNvPr id="3" name="">
             <a:extLst xmlns:a="http://schemas.openxmlformats.org/drawingml/2006/main">
               <a:ext uri="{FF2B5EF4-FFF2-40B4-BE49-F238E27FC236}">
-                <a16:creationId xmlns:a16="http://schemas.microsoft.com/office/drawing/2014/main" id="{DA8EE7E0-D142-4A54-82DC-C9066748FD9D}"/>
+                <a16:creationId xmlns:a16="http://schemas.microsoft.com/office/drawing/2014/main" id="{10E193DF-651D-4C16-84EF-0EED6FFF898F}"/>
               </a:ext>
             </a:extLst>
           </p:cNvPr>
@@ -4550,7 +5701,7 @@
           <p:cNvPr id="4" name="">
             <a:extLst xmlns:a="http://schemas.openxmlformats.org/drawingml/2006/main">
               <a:ext uri="{FF2B5EF4-FFF2-40B4-BE49-F238E27FC236}">
-                <a16:creationId xmlns:a16="http://schemas.microsoft.com/office/drawing/2014/main" id="{9C616F95-5C6F-423F-B31F-E50739F006DD}"/>
+                <a16:creationId xmlns:a16="http://schemas.microsoft.com/office/drawing/2014/main" id="{9348C67B-3FF7-4214-845F-C646C16A0C60}"/>
               </a:ext>
             </a:extLst>
           </p:cNvPr>
@@ -4600,7 +5751,7 @@
           <p:cNvPr id="5" name="">
             <a:extLst xmlns:a="http://schemas.openxmlformats.org/drawingml/2006/main">
               <a:ext uri="{FF2B5EF4-FFF2-40B4-BE49-F238E27FC236}">
-                <a16:creationId xmlns:a16="http://schemas.microsoft.com/office/drawing/2014/main" id="{9442DEC8-E3A0-410C-A374-DF1561BD44AF}"/>
+                <a16:creationId xmlns:a16="http://schemas.microsoft.com/office/drawing/2014/main" id="{573D9C0C-8658-4689-A9D8-7B5E2BA17A58}"/>
               </a:ext>
             </a:extLst>
           </p:cNvPr>
@@ -4735,7 +5886,7 @@
           <p:cNvPr id="6" name="">
             <a:extLst xmlns:a="http://schemas.openxmlformats.org/drawingml/2006/main">
               <a:ext uri="{FF2B5EF4-FFF2-40B4-BE49-F238E27FC236}">
-                <a16:creationId xmlns:a16="http://schemas.microsoft.com/office/drawing/2014/main" id="{057B5D93-F789-4C05-A3E7-36AB9E39322E}"/>
+                <a16:creationId xmlns:a16="http://schemas.microsoft.com/office/drawing/2014/main" id="{FAC7B3BF-B522-46E6-BEC1-28C3507C461B}"/>
               </a:ext>
             </a:extLst>
           </p:cNvPr>
@@ -4785,7 +5936,7 @@
           <p:cNvPr id="7" name="">
             <a:extLst xmlns:a="http://schemas.openxmlformats.org/drawingml/2006/main">
               <a:ext uri="{FF2B5EF4-FFF2-40B4-BE49-F238E27FC236}">
-                <a16:creationId xmlns:a16="http://schemas.microsoft.com/office/drawing/2014/main" id="{FF8E2344-75FD-4366-A46B-A04AF250B14D}"/>
+                <a16:creationId xmlns:a16="http://schemas.microsoft.com/office/drawing/2014/main" id="{33905D27-08AE-4C7C-BA70-2D46B4A55582}"/>
               </a:ext>
             </a:extLst>
           </p:cNvPr>
@@ -4816,7 +5967,7 @@
           <p:cNvPr id="8" name="">
             <a:extLst xmlns:a="http://schemas.openxmlformats.org/drawingml/2006/main">
               <a:ext uri="{FF2B5EF4-FFF2-40B4-BE49-F238E27FC236}">
-                <a16:creationId xmlns:a16="http://schemas.microsoft.com/office/drawing/2014/main" id="{25333B13-B1BF-4733-8391-B9D2C32B7EFF}"/>
+                <a16:creationId xmlns:a16="http://schemas.microsoft.com/office/drawing/2014/main" id="{DCD9E953-A4F8-4657-9E84-4E2E7CF544F6}"/>
               </a:ext>
             </a:extLst>
           </p:cNvPr>
@@ -4866,7 +6017,7 @@
           <p:cNvPr id="9" name="">
             <a:extLst xmlns:a="http://schemas.openxmlformats.org/drawingml/2006/main">
               <a:ext uri="{FF2B5EF4-FFF2-40B4-BE49-F238E27FC236}">
-                <a16:creationId xmlns:a16="http://schemas.microsoft.com/office/drawing/2014/main" id="{B30FD037-CFB4-4293-85BC-C171E37FD64E}"/>
+                <a16:creationId xmlns:a16="http://schemas.microsoft.com/office/drawing/2014/main" id="{AB8D11D5-3BDD-4977-83DE-58CC23059F55}"/>
               </a:ext>
             </a:extLst>
           </p:cNvPr>
@@ -4897,7 +6048,7 @@
           <p:cNvPr id="10" name="">
             <a:extLst xmlns:a="http://schemas.openxmlformats.org/drawingml/2006/main">
               <a:ext uri="{FF2B5EF4-FFF2-40B4-BE49-F238E27FC236}">
-                <a16:creationId xmlns:a16="http://schemas.microsoft.com/office/drawing/2014/main" id="{52D846FC-0DAA-4972-A5E3-F4281DD467A2}"/>
+                <a16:creationId xmlns:a16="http://schemas.microsoft.com/office/drawing/2014/main" id="{2F9F84E8-8CC0-48D3-80B4-C1C657CAEB26}"/>
               </a:ext>
             </a:extLst>
           </p:cNvPr>
@@ -4947,7 +6098,7 @@
           <p:cNvPr id="11" name="">
             <a:extLst xmlns:a="http://schemas.openxmlformats.org/drawingml/2006/main">
               <a:ext uri="{FF2B5EF4-FFF2-40B4-BE49-F238E27FC236}">
-                <a16:creationId xmlns:a16="http://schemas.microsoft.com/office/drawing/2014/main" id="{035AE3C1-E16E-4EDB-8B6A-48B8B5D063EF}"/>
+                <a16:creationId xmlns:a16="http://schemas.microsoft.com/office/drawing/2014/main" id="{E5980BD8-749C-4EEB-BE3A-42E545255F7D}"/>
               </a:ext>
             </a:extLst>
           </p:cNvPr>
@@ -4997,7 +6148,7 @@
           <p:cNvPr id="12" name="">
             <a:extLst xmlns:a="http://schemas.openxmlformats.org/drawingml/2006/main">
               <a:ext uri="{FF2B5EF4-FFF2-40B4-BE49-F238E27FC236}">
-                <a16:creationId xmlns:a16="http://schemas.microsoft.com/office/drawing/2014/main" id="{79AAA5A5-ECB7-476E-8297-9185C455BE8F}"/>
+                <a16:creationId xmlns:a16="http://schemas.microsoft.com/office/drawing/2014/main" id="{D3612262-42F3-42C6-9F9A-954369F47698}"/>
               </a:ext>
             </a:extLst>
           </p:cNvPr>
@@ -5030,7 +6181,7 @@
           <p:cNvPr id="13" name="">
             <a:extLst xmlns:a="http://schemas.openxmlformats.org/drawingml/2006/main">
               <a:ext uri="{FF2B5EF4-FFF2-40B4-BE49-F238E27FC236}">
-                <a16:creationId xmlns:a16="http://schemas.microsoft.com/office/drawing/2014/main" id="{7D1AA4DA-5151-45D5-A123-DE2A3ACEB813}"/>
+                <a16:creationId xmlns:a16="http://schemas.microsoft.com/office/drawing/2014/main" id="{A0C474D0-E8BC-4CBF-B1D5-C1B2560C1662}"/>
               </a:ext>
             </a:extLst>
           </p:cNvPr>
@@ -5080,7 +6231,7 @@
           <p:cNvPr id="14" name="">
             <a:extLst xmlns:a="http://schemas.openxmlformats.org/drawingml/2006/main">
               <a:ext uri="{FF2B5EF4-FFF2-40B4-BE49-F238E27FC236}">
-                <a16:creationId xmlns:a16="http://schemas.microsoft.com/office/drawing/2014/main" id="{6CD1DB93-E37C-400A-9D51-3A3AF896ED21}"/>
+                <a16:creationId xmlns:a16="http://schemas.microsoft.com/office/drawing/2014/main" id="{3C3A7859-E86D-4912-8567-5B111F80A0E4}"/>
               </a:ext>
             </a:extLst>
           </p:cNvPr>
@@ -5128,7 +6279,7 @@
     </p:spTree>
     <p:extLst>
       <p:ext uri="{BB962C8B-B14F-4D97-AF65-F5344CB8AC3E}">
-        <p14:creationId xmlns:p14="http://schemas.microsoft.com/office/powerpoint/2010/main" val="845771341"/>
+        <p14:creationId xmlns:p14="http://schemas.microsoft.com/office/powerpoint/2010/main" val="1695776696"/>
       </p:ext>
     </p:extLst>
   </p:cSld>
@@ -5159,7 +6310,7 @@
           <p:cNvPr id="1" name="">
             <a:extLst xmlns:a="http://schemas.openxmlformats.org/drawingml/2006/main">
               <a:ext uri="{FF2B5EF4-FFF2-40B4-BE49-F238E27FC236}">
-                <a16:creationId xmlns:a16="http://schemas.microsoft.com/office/drawing/2014/main" id="{102BA0AA-17FA-4180-948B-799131C97A2A}"/>
+                <a16:creationId xmlns:a16="http://schemas.microsoft.com/office/drawing/2014/main" id="{B96222BF-D581-420B-B7EF-77785F4A96E0}"/>
               </a:ext>
             </a:extLst>
           </p:cNvPr>
@@ -5209,7 +6360,7 @@
           <p:cNvPr id="2" name="">
             <a:extLst xmlns:a="http://schemas.openxmlformats.org/drawingml/2006/main">
               <a:ext uri="{FF2B5EF4-FFF2-40B4-BE49-F238E27FC236}">
-                <a16:creationId xmlns:a16="http://schemas.microsoft.com/office/drawing/2014/main" id="{12D3ACF8-C055-404B-9617-32A8F5121BDD}"/>
+                <a16:creationId xmlns:a16="http://schemas.microsoft.com/office/drawing/2014/main" id="{244AC98C-70DE-4E3A-A1A7-D1E527954C1E}"/>
               </a:ext>
             </a:extLst>
           </p:cNvPr>
@@ -5259,7 +6410,7 @@
           <p:cNvPr id="3" name="">
             <a:extLst xmlns:a="http://schemas.openxmlformats.org/drawingml/2006/main">
               <a:ext uri="{FF2B5EF4-FFF2-40B4-BE49-F238E27FC236}">
-                <a16:creationId xmlns:a16="http://schemas.microsoft.com/office/drawing/2014/main" id="{B1F93CEF-F897-4BC5-9429-B3F95A2F488F}"/>
+                <a16:creationId xmlns:a16="http://schemas.microsoft.com/office/drawing/2014/main" id="{2BA0D338-3C57-4C84-A921-8ED6DB06C0D3}"/>
               </a:ext>
             </a:extLst>
           </p:cNvPr>
@@ -5309,7 +6460,7 @@
           <p:cNvPr id="4" name="">
             <a:extLst xmlns:a="http://schemas.openxmlformats.org/drawingml/2006/main">
               <a:ext uri="{FF2B5EF4-FFF2-40B4-BE49-F238E27FC236}">
-                <a16:creationId xmlns:a16="http://schemas.microsoft.com/office/drawing/2014/main" id="{627914DC-A7ED-4363-A285-494665F604FA}"/>
+                <a16:creationId xmlns:a16="http://schemas.microsoft.com/office/drawing/2014/main" id="{E749C205-7254-4C50-9CA4-4EFE87B9DB79}"/>
               </a:ext>
             </a:extLst>
           </p:cNvPr>
@@ -5427,7 +6578,7 @@
           <p:cNvPr id="5" name="">
             <a:extLst xmlns:a="http://schemas.openxmlformats.org/drawingml/2006/main">
               <a:ext uri="{FF2B5EF4-FFF2-40B4-BE49-F238E27FC236}">
-                <a16:creationId xmlns:a16="http://schemas.microsoft.com/office/drawing/2014/main" id="{78223C3F-6015-4A8F-9612-054C49CAF8DC}"/>
+                <a16:creationId xmlns:a16="http://schemas.microsoft.com/office/drawing/2014/main" id="{6AD87E77-1173-4A05-9519-7353CDB5B459}"/>
               </a:ext>
             </a:extLst>
           </p:cNvPr>
@@ -5477,7 +6628,7 @@
           <p:cNvPr id="6" name="">
             <a:extLst xmlns:a="http://schemas.openxmlformats.org/drawingml/2006/main">
               <a:ext uri="{FF2B5EF4-FFF2-40B4-BE49-F238E27FC236}">
-                <a16:creationId xmlns:a16="http://schemas.microsoft.com/office/drawing/2014/main" id="{CF91AB23-8191-498D-B867-1B3FD2DEC9FD}"/>
+                <a16:creationId xmlns:a16="http://schemas.microsoft.com/office/drawing/2014/main" id="{AD50A039-B3C0-4D49-A029-07369DDDFD38}"/>
               </a:ext>
             </a:extLst>
           </p:cNvPr>
@@ -5578,7 +6729,7 @@
           <p:cNvPr id="7" name="">
             <a:extLst xmlns:a="http://schemas.openxmlformats.org/drawingml/2006/main">
               <a:ext uri="{FF2B5EF4-FFF2-40B4-BE49-F238E27FC236}">
-                <a16:creationId xmlns:a16="http://schemas.microsoft.com/office/drawing/2014/main" id="{9A1825F4-4E46-4EB0-8433-FE11B1832A55}"/>
+                <a16:creationId xmlns:a16="http://schemas.microsoft.com/office/drawing/2014/main" id="{27FE2111-8C86-45DF-8769-A57E9967FAEB}"/>
               </a:ext>
             </a:extLst>
           </p:cNvPr>
@@ -5609,7 +6760,7 @@
           <p:cNvPr id="8" name="">
             <a:extLst xmlns:a="http://schemas.openxmlformats.org/drawingml/2006/main">
               <a:ext uri="{FF2B5EF4-FFF2-40B4-BE49-F238E27FC236}">
-                <a16:creationId xmlns:a16="http://schemas.microsoft.com/office/drawing/2014/main" id="{AF91B3D6-F0F6-4F11-B721-B966EAB4E00E}"/>
+                <a16:creationId xmlns:a16="http://schemas.microsoft.com/office/drawing/2014/main" id="{D18FC1AA-6CEB-42FC-8CA4-C00A9BE0114A}"/>
               </a:ext>
             </a:extLst>
           </p:cNvPr>
@@ -5659,7 +6810,7 @@
           <p:cNvPr id="9" name="">
             <a:extLst xmlns:a="http://schemas.openxmlformats.org/drawingml/2006/main">
               <a:ext uri="{FF2B5EF4-FFF2-40B4-BE49-F238E27FC236}">
-                <a16:creationId xmlns:a16="http://schemas.microsoft.com/office/drawing/2014/main" id="{EE971B65-C730-4A8A-871D-051C4D9A22DE}"/>
+                <a16:creationId xmlns:a16="http://schemas.microsoft.com/office/drawing/2014/main" id="{697BAAB7-F834-485F-A669-5D17748A11BB}"/>
               </a:ext>
             </a:extLst>
           </p:cNvPr>
@@ -5692,7 +6843,7 @@
           <p:cNvPr id="10" name="">
             <a:extLst xmlns:a="http://schemas.openxmlformats.org/drawingml/2006/main">
               <a:ext uri="{FF2B5EF4-FFF2-40B4-BE49-F238E27FC236}">
-                <a16:creationId xmlns:a16="http://schemas.microsoft.com/office/drawing/2014/main" id="{228FF417-6871-4C9F-8AFE-06AAAE4D7F9E}"/>
+                <a16:creationId xmlns:a16="http://schemas.microsoft.com/office/drawing/2014/main" id="{0931BC5A-EF7E-483B-AB61-92E1BC5B816D}"/>
               </a:ext>
             </a:extLst>
           </p:cNvPr>
@@ -5742,7 +6893,7 @@
           <p:cNvPr id="11" name="">
             <a:extLst xmlns:a="http://schemas.openxmlformats.org/drawingml/2006/main">
               <a:ext uri="{FF2B5EF4-FFF2-40B4-BE49-F238E27FC236}">
-                <a16:creationId xmlns:a16="http://schemas.microsoft.com/office/drawing/2014/main" id="{8266AD29-13F9-4890-B8D9-4205D7AE616D}"/>
+                <a16:creationId xmlns:a16="http://schemas.microsoft.com/office/drawing/2014/main" id="{E779A3C5-89E5-4112-AE8B-BEDFB2CFF62A}"/>
               </a:ext>
             </a:extLst>
           </p:cNvPr>
@@ -5790,7 +6941,7 @@
     </p:spTree>
     <p:extLst>
       <p:ext uri="{BB962C8B-B14F-4D97-AF65-F5344CB8AC3E}">
-        <p14:creationId xmlns:p14="http://schemas.microsoft.com/office/powerpoint/2010/main" val="466536398"/>
+        <p14:creationId xmlns:p14="http://schemas.microsoft.com/office/powerpoint/2010/main" val="1400951372"/>
       </p:ext>
     </p:extLst>
   </p:cSld>
@@ -5821,7 +6972,7 @@
           <p:cNvPr id="1" name="">
             <a:extLst xmlns:a="http://schemas.openxmlformats.org/drawingml/2006/main">
               <a:ext uri="{FF2B5EF4-FFF2-40B4-BE49-F238E27FC236}">
-                <a16:creationId xmlns:a16="http://schemas.microsoft.com/office/drawing/2014/main" id="{F0ABF19A-EA04-4346-959D-1026C3329AF7}"/>
+                <a16:creationId xmlns:a16="http://schemas.microsoft.com/office/drawing/2014/main" id="{17C03F0F-017F-4997-9969-111DC3BA3ABA}"/>
               </a:ext>
             </a:extLst>
           </p:cNvPr>
@@ -5871,7 +7022,7 @@
           <p:cNvPr id="2" name="">
             <a:extLst xmlns:a="http://schemas.openxmlformats.org/drawingml/2006/main">
               <a:ext uri="{FF2B5EF4-FFF2-40B4-BE49-F238E27FC236}">
-                <a16:creationId xmlns:a16="http://schemas.microsoft.com/office/drawing/2014/main" id="{7833A1BD-0DE8-4722-95B7-185BB1D2F38F}"/>
+                <a16:creationId xmlns:a16="http://schemas.microsoft.com/office/drawing/2014/main" id="{5DFAC302-D81B-46E3-8381-AE5B3E8863A3}"/>
               </a:ext>
             </a:extLst>
           </p:cNvPr>
@@ -5921,7 +7072,7 @@
           <p:cNvPr id="3" name="">
             <a:extLst xmlns:a="http://schemas.openxmlformats.org/drawingml/2006/main">
               <a:ext uri="{FF2B5EF4-FFF2-40B4-BE49-F238E27FC236}">
-                <a16:creationId xmlns:a16="http://schemas.microsoft.com/office/drawing/2014/main" id="{A2F3946F-AEE1-433C-A108-42EB8AF7E6FF}"/>
+                <a16:creationId xmlns:a16="http://schemas.microsoft.com/office/drawing/2014/main" id="{D4696A97-D674-4DA4-AA95-B2DD52BD62F4}"/>
               </a:ext>
             </a:extLst>
           </p:cNvPr>
@@ -5971,7 +7122,7 @@
           <p:cNvPr id="4" name="">
             <a:extLst xmlns:a="http://schemas.openxmlformats.org/drawingml/2006/main">
               <a:ext uri="{FF2B5EF4-FFF2-40B4-BE49-F238E27FC236}">
-                <a16:creationId xmlns:a16="http://schemas.microsoft.com/office/drawing/2014/main" id="{39AEF431-ABD4-4ACD-9856-9D30D6CB2217}"/>
+                <a16:creationId xmlns:a16="http://schemas.microsoft.com/office/drawing/2014/main" id="{CF136522-3DFF-411C-B89C-CC240965F59D}"/>
               </a:ext>
             </a:extLst>
           </p:cNvPr>
@@ -6002,7 +7153,7 @@
           <p:cNvPr id="5" name="">
             <a:extLst xmlns:a="http://schemas.openxmlformats.org/drawingml/2006/main">
               <a:ext uri="{FF2B5EF4-FFF2-40B4-BE49-F238E27FC236}">
-                <a16:creationId xmlns:a16="http://schemas.microsoft.com/office/drawing/2014/main" id="{3F738A00-FB5F-4E01-9CBE-DF3AB803F4EC}"/>
+                <a16:creationId xmlns:a16="http://schemas.microsoft.com/office/drawing/2014/main" id="{1AE87FC7-49D3-4AD1-B6BB-F23EC5AD0CCC}"/>
               </a:ext>
             </a:extLst>
           </p:cNvPr>
@@ -6052,7 +7203,7 @@
           <p:cNvPr id="6" name="">
             <a:extLst xmlns:a="http://schemas.openxmlformats.org/drawingml/2006/main">
               <a:ext uri="{FF2B5EF4-FFF2-40B4-BE49-F238E27FC236}">
-                <a16:creationId xmlns:a16="http://schemas.microsoft.com/office/drawing/2014/main" id="{D97DEE04-C0F7-4896-BEC8-6E88C1C16102}"/>
+                <a16:creationId xmlns:a16="http://schemas.microsoft.com/office/drawing/2014/main" id="{5FD408C0-8E20-458B-9F78-1B7DE920B54E}"/>
               </a:ext>
             </a:extLst>
           </p:cNvPr>
@@ -6102,7 +7253,7 @@
           <p:cNvPr id="7" name="">
             <a:extLst xmlns:a="http://schemas.openxmlformats.org/drawingml/2006/main">
               <a:ext uri="{FF2B5EF4-FFF2-40B4-BE49-F238E27FC236}">
-                <a16:creationId xmlns:a16="http://schemas.microsoft.com/office/drawing/2014/main" id="{2F2E83C6-7AF7-4EB3-A4C9-8643D1E4222F}"/>
+                <a16:creationId xmlns:a16="http://schemas.microsoft.com/office/drawing/2014/main" id="{4F8A9B70-F535-4F06-B0DE-B388697EE852}"/>
               </a:ext>
             </a:extLst>
           </p:cNvPr>
@@ -6133,7 +7284,7 @@
           <p:cNvPr id="8" name="">
             <a:extLst xmlns:a="http://schemas.openxmlformats.org/drawingml/2006/main">
               <a:ext uri="{FF2B5EF4-FFF2-40B4-BE49-F238E27FC236}">
-                <a16:creationId xmlns:a16="http://schemas.microsoft.com/office/drawing/2014/main" id="{75985248-7146-4E82-B3B8-8A35F89A08C8}"/>
+                <a16:creationId xmlns:a16="http://schemas.microsoft.com/office/drawing/2014/main" id="{C5629F78-6DFE-4641-8D90-6EE05BA2937A}"/>
               </a:ext>
             </a:extLst>
           </p:cNvPr>
@@ -6183,7 +7334,7 @@
           <p:cNvPr id="9" name="">
             <a:extLst xmlns:a="http://schemas.openxmlformats.org/drawingml/2006/main">
               <a:ext uri="{FF2B5EF4-FFF2-40B4-BE49-F238E27FC236}">
-                <a16:creationId xmlns:a16="http://schemas.microsoft.com/office/drawing/2014/main" id="{ABC28C80-3AE5-48A0-AF64-B6A57BEDBF16}"/>
+                <a16:creationId xmlns:a16="http://schemas.microsoft.com/office/drawing/2014/main" id="{61CE605E-1C65-49D9-BF88-F776676996A7}"/>
               </a:ext>
             </a:extLst>
           </p:cNvPr>
@@ -6233,7 +7384,7 @@
           <p:cNvPr id="10" name="">
             <a:extLst xmlns:a="http://schemas.openxmlformats.org/drawingml/2006/main">
               <a:ext uri="{FF2B5EF4-FFF2-40B4-BE49-F238E27FC236}">
-                <a16:creationId xmlns:a16="http://schemas.microsoft.com/office/drawing/2014/main" id="{C4BCBC0A-CAED-427B-8866-3543903FA7AA}"/>
+                <a16:creationId xmlns:a16="http://schemas.microsoft.com/office/drawing/2014/main" id="{1434BFE0-E5F9-4BBF-A82B-70DA01BCF68D}"/>
               </a:ext>
             </a:extLst>
           </p:cNvPr>
@@ -6264,7 +7415,7 @@
           <p:cNvPr id="11" name="">
             <a:extLst xmlns:a="http://schemas.openxmlformats.org/drawingml/2006/main">
               <a:ext uri="{FF2B5EF4-FFF2-40B4-BE49-F238E27FC236}">
-                <a16:creationId xmlns:a16="http://schemas.microsoft.com/office/drawing/2014/main" id="{E52B5F23-D03A-446F-9832-E8091A51E35D}"/>
+                <a16:creationId xmlns:a16="http://schemas.microsoft.com/office/drawing/2014/main" id="{55B90377-E934-4AFE-9E18-51D2338C777B}"/>
               </a:ext>
             </a:extLst>
           </p:cNvPr>
@@ -6314,7 +7465,7 @@
           <p:cNvPr id="12" name="">
             <a:extLst xmlns:a="http://schemas.openxmlformats.org/drawingml/2006/main">
               <a:ext uri="{FF2B5EF4-FFF2-40B4-BE49-F238E27FC236}">
-                <a16:creationId xmlns:a16="http://schemas.microsoft.com/office/drawing/2014/main" id="{A5BE7706-A6E5-4D3B-A140-5C3E284DCC72}"/>
+                <a16:creationId xmlns:a16="http://schemas.microsoft.com/office/drawing/2014/main" id="{9C204E6F-897F-468B-BEFE-B8884D5B250F}"/>
               </a:ext>
             </a:extLst>
           </p:cNvPr>
@@ -6364,7 +7515,7 @@
           <p:cNvPr id="13" name="">
             <a:extLst xmlns:a="http://schemas.openxmlformats.org/drawingml/2006/main">
               <a:ext uri="{FF2B5EF4-FFF2-40B4-BE49-F238E27FC236}">
-                <a16:creationId xmlns:a16="http://schemas.microsoft.com/office/drawing/2014/main" id="{E7CF3A14-8635-439C-B506-FB68EFD7506A}"/>
+                <a16:creationId xmlns:a16="http://schemas.microsoft.com/office/drawing/2014/main" id="{BBDC15A4-B417-4EED-BAE1-EDE21BC68305}"/>
               </a:ext>
             </a:extLst>
           </p:cNvPr>
@@ -6414,7 +7565,7 @@
           <p:cNvPr id="14" name="">
             <a:extLst xmlns:a="http://schemas.openxmlformats.org/drawingml/2006/main">
               <a:ext uri="{FF2B5EF4-FFF2-40B4-BE49-F238E27FC236}">
-                <a16:creationId xmlns:a16="http://schemas.microsoft.com/office/drawing/2014/main" id="{61B8EA2C-F4DF-4498-9B3D-41954DB1CCCA}"/>
+                <a16:creationId xmlns:a16="http://schemas.microsoft.com/office/drawing/2014/main" id="{A8A0A392-D8CC-4E91-8D5D-0A505F5DC494}"/>
               </a:ext>
             </a:extLst>
           </p:cNvPr>
@@ -6447,7 +7598,7 @@
           <p:cNvPr id="15" name="">
             <a:extLst xmlns:a="http://schemas.openxmlformats.org/drawingml/2006/main">
               <a:ext uri="{FF2B5EF4-FFF2-40B4-BE49-F238E27FC236}">
-                <a16:creationId xmlns:a16="http://schemas.microsoft.com/office/drawing/2014/main" id="{5623D250-351B-47DB-9585-550B5D01525C}"/>
+                <a16:creationId xmlns:a16="http://schemas.microsoft.com/office/drawing/2014/main" id="{A189DD7E-6564-477A-978C-20CF003CF731}"/>
               </a:ext>
             </a:extLst>
           </p:cNvPr>
@@ -6497,7 +7648,7 @@
           <p:cNvPr id="16" name="">
             <a:extLst xmlns:a="http://schemas.openxmlformats.org/drawingml/2006/main">
               <a:ext uri="{FF2B5EF4-FFF2-40B4-BE49-F238E27FC236}">
-                <a16:creationId xmlns:a16="http://schemas.microsoft.com/office/drawing/2014/main" id="{6975204C-74BB-4FBA-9BC9-D00B480CD8E1}"/>
+                <a16:creationId xmlns:a16="http://schemas.microsoft.com/office/drawing/2014/main" id="{79702BEE-9777-4F2E-8593-AF9E8371C3B4}"/>
               </a:ext>
             </a:extLst>
           </p:cNvPr>
@@ -6545,7 +7696,7 @@
     </p:spTree>
     <p:extLst>
       <p:ext uri="{BB962C8B-B14F-4D97-AF65-F5344CB8AC3E}">
-        <p14:creationId xmlns:p14="http://schemas.microsoft.com/office/powerpoint/2010/main" val="296939888"/>
+        <p14:creationId xmlns:p14="http://schemas.microsoft.com/office/powerpoint/2010/main" val="2123292303"/>
       </p:ext>
     </p:extLst>
   </p:cSld>
@@ -6576,7 +7727,7 @@
           <p:cNvPr id="1" name="">
             <a:extLst xmlns:a="http://schemas.openxmlformats.org/drawingml/2006/main">
               <a:ext uri="{FF2B5EF4-FFF2-40B4-BE49-F238E27FC236}">
-                <a16:creationId xmlns:a16="http://schemas.microsoft.com/office/drawing/2014/main" id="{EAFE3749-2F47-4D0A-9AA8-A893BE466A56}"/>
+                <a16:creationId xmlns:a16="http://schemas.microsoft.com/office/drawing/2014/main" id="{B7CDBA0F-F536-4404-81C8-0675A89EBBB8}"/>
               </a:ext>
             </a:extLst>
           </p:cNvPr>
@@ -6626,7 +7777,7 @@
           <p:cNvPr id="2" name="">
             <a:extLst xmlns:a="http://schemas.openxmlformats.org/drawingml/2006/main">
               <a:ext uri="{FF2B5EF4-FFF2-40B4-BE49-F238E27FC236}">
-                <a16:creationId xmlns:a16="http://schemas.microsoft.com/office/drawing/2014/main" id="{A4C862D9-F3A4-4F54-9D48-5EF3741794DD}"/>
+                <a16:creationId xmlns:a16="http://schemas.microsoft.com/office/drawing/2014/main" id="{491C57E9-BB52-4041-97A2-4526F2C11655}"/>
               </a:ext>
             </a:extLst>
           </p:cNvPr>
@@ -6676,7 +7827,7 @@
           <p:cNvPr id="3" name="">
             <a:extLst xmlns:a="http://schemas.openxmlformats.org/drawingml/2006/main">
               <a:ext uri="{FF2B5EF4-FFF2-40B4-BE49-F238E27FC236}">
-                <a16:creationId xmlns:a16="http://schemas.microsoft.com/office/drawing/2014/main" id="{0EDA81E7-9CFD-4BC5-A43A-28CB43F65324}"/>
+                <a16:creationId xmlns:a16="http://schemas.microsoft.com/office/drawing/2014/main" id="{6479FB56-E954-4E8A-81B5-3D9693A3CBF0}"/>
               </a:ext>
             </a:extLst>
           </p:cNvPr>
@@ -6707,7 +7858,7 @@
           <p:cNvPr id="4" name="">
             <a:extLst xmlns:a="http://schemas.openxmlformats.org/drawingml/2006/main">
               <a:ext uri="{FF2B5EF4-FFF2-40B4-BE49-F238E27FC236}">
-                <a16:creationId xmlns:a16="http://schemas.microsoft.com/office/drawing/2014/main" id="{5B0F40C9-2887-4D11-88CA-AFC87704210B}"/>
+                <a16:creationId xmlns:a16="http://schemas.microsoft.com/office/drawing/2014/main" id="{4309CEB1-8E8D-459C-B772-C10A9F70B320}"/>
               </a:ext>
             </a:extLst>
           </p:cNvPr>
@@ -6757,7 +7908,7 @@
           <p:cNvPr id="5" name="">
             <a:extLst xmlns:a="http://schemas.openxmlformats.org/drawingml/2006/main">
               <a:ext uri="{FF2B5EF4-FFF2-40B4-BE49-F238E27FC236}">
-                <a16:creationId xmlns:a16="http://schemas.microsoft.com/office/drawing/2014/main" id="{74C03A53-46CC-4973-AACF-FECB0CED55C0}"/>
+                <a16:creationId xmlns:a16="http://schemas.microsoft.com/office/drawing/2014/main" id="{90367CE9-E38E-4975-9FF3-E8024BA87943}"/>
               </a:ext>
             </a:extLst>
           </p:cNvPr>
@@ -6807,7 +7958,7 @@
           <p:cNvPr id="6" name="">
             <a:extLst xmlns:a="http://schemas.openxmlformats.org/drawingml/2006/main">
               <a:ext uri="{FF2B5EF4-FFF2-40B4-BE49-F238E27FC236}">
-                <a16:creationId xmlns:a16="http://schemas.microsoft.com/office/drawing/2014/main" id="{136D63E0-1ADB-49A4-A0D7-633309D746A9}"/>
+                <a16:creationId xmlns:a16="http://schemas.microsoft.com/office/drawing/2014/main" id="{173386F2-83FF-4FBC-B464-A7CD522442A1}"/>
               </a:ext>
             </a:extLst>
           </p:cNvPr>
@@ -6908,7 +8059,7 @@
           <p:cNvPr id="7" name="">
             <a:extLst xmlns:a="http://schemas.openxmlformats.org/drawingml/2006/main">
               <a:ext uri="{FF2B5EF4-FFF2-40B4-BE49-F238E27FC236}">
-                <a16:creationId xmlns:a16="http://schemas.microsoft.com/office/drawing/2014/main" id="{28AD40C1-B0DE-4EE3-8161-6E1EFEBB91C5}"/>
+                <a16:creationId xmlns:a16="http://schemas.microsoft.com/office/drawing/2014/main" id="{5AE9C245-5FE1-49D8-918A-55A2DE255CBE}"/>
               </a:ext>
             </a:extLst>
           </p:cNvPr>
@@ -6939,7 +8090,7 @@
           <p:cNvPr id="8" name="">
             <a:extLst xmlns:a="http://schemas.openxmlformats.org/drawingml/2006/main">
               <a:ext uri="{FF2B5EF4-FFF2-40B4-BE49-F238E27FC236}">
-                <a16:creationId xmlns:a16="http://schemas.microsoft.com/office/drawing/2014/main" id="{10AB2769-31D8-406C-9873-37A4559A1A51}"/>
+                <a16:creationId xmlns:a16="http://schemas.microsoft.com/office/drawing/2014/main" id="{0C1DC731-E4C1-4C11-AD41-BF8956A2BD17}"/>
               </a:ext>
             </a:extLst>
           </p:cNvPr>
@@ -6989,7 +8140,7 @@
           <p:cNvPr id="9" name="">
             <a:extLst xmlns:a="http://schemas.openxmlformats.org/drawingml/2006/main">
               <a:ext uri="{FF2B5EF4-FFF2-40B4-BE49-F238E27FC236}">
-                <a16:creationId xmlns:a16="http://schemas.microsoft.com/office/drawing/2014/main" id="{FF81E073-EB4A-47E4-AEE2-76EC9DE641FB}"/>
+                <a16:creationId xmlns:a16="http://schemas.microsoft.com/office/drawing/2014/main" id="{4E5A7B10-D67B-4439-AFA9-11BA6ECE5268}"/>
               </a:ext>
             </a:extLst>
           </p:cNvPr>
@@ -7039,7 +8190,7 @@
           <p:cNvPr id="10" name="">
             <a:extLst xmlns:a="http://schemas.openxmlformats.org/drawingml/2006/main">
               <a:ext uri="{FF2B5EF4-FFF2-40B4-BE49-F238E27FC236}">
-                <a16:creationId xmlns:a16="http://schemas.microsoft.com/office/drawing/2014/main" id="{3625DD9D-91B0-4028-8E78-325A06E38852}"/>
+                <a16:creationId xmlns:a16="http://schemas.microsoft.com/office/drawing/2014/main" id="{4696A15A-493E-4A79-A1E3-E496B7C5ED00}"/>
               </a:ext>
             </a:extLst>
           </p:cNvPr>
@@ -7140,7 +8291,7 @@
           <p:cNvPr id="11" name="">
             <a:extLst xmlns:a="http://schemas.openxmlformats.org/drawingml/2006/main">
               <a:ext uri="{FF2B5EF4-FFF2-40B4-BE49-F238E27FC236}">
-                <a16:creationId xmlns:a16="http://schemas.microsoft.com/office/drawing/2014/main" id="{FEBA71CF-6DA0-42E1-893E-D5E1D1B5CDE1}"/>
+                <a16:creationId xmlns:a16="http://schemas.microsoft.com/office/drawing/2014/main" id="{FE4418C6-05AA-40DC-B24D-9519E10F6702}"/>
               </a:ext>
             </a:extLst>
           </p:cNvPr>
@@ -7190,7 +8341,7 @@
           <p:cNvPr id="12" name="">
             <a:extLst xmlns:a="http://schemas.openxmlformats.org/drawingml/2006/main">
               <a:ext uri="{FF2B5EF4-FFF2-40B4-BE49-F238E27FC236}">
-                <a16:creationId xmlns:a16="http://schemas.microsoft.com/office/drawing/2014/main" id="{48B21B79-1C0B-445B-BCB9-9A604CEAA7FA}"/>
+                <a16:creationId xmlns:a16="http://schemas.microsoft.com/office/drawing/2014/main" id="{D84FB96D-64F7-4346-B5C4-F84310250B79}"/>
               </a:ext>
             </a:extLst>
           </p:cNvPr>
@@ -7223,7 +8374,7 @@
           <p:cNvPr id="13" name="">
             <a:extLst xmlns:a="http://schemas.openxmlformats.org/drawingml/2006/main">
               <a:ext uri="{FF2B5EF4-FFF2-40B4-BE49-F238E27FC236}">
-                <a16:creationId xmlns:a16="http://schemas.microsoft.com/office/drawing/2014/main" id="{55D70820-2B3E-4DD8-924A-41F6B1B5F432}"/>
+                <a16:creationId xmlns:a16="http://schemas.microsoft.com/office/drawing/2014/main" id="{507D3366-2096-4EFB-AE06-78B161E80002}"/>
               </a:ext>
             </a:extLst>
           </p:cNvPr>
@@ -7273,7 +8424,7 @@
           <p:cNvPr id="14" name="">
             <a:extLst xmlns:a="http://schemas.openxmlformats.org/drawingml/2006/main">
               <a:ext uri="{FF2B5EF4-FFF2-40B4-BE49-F238E27FC236}">
-                <a16:creationId xmlns:a16="http://schemas.microsoft.com/office/drawing/2014/main" id="{DC83B31A-B5AD-4DF4-A7E0-AC01A0E27488}"/>
+                <a16:creationId xmlns:a16="http://schemas.microsoft.com/office/drawing/2014/main" id="{B03C6676-4124-4F65-AFDB-5E69B5B95CD7}"/>
               </a:ext>
             </a:extLst>
           </p:cNvPr>
@@ -7321,7 +8472,7 @@
     </p:spTree>
     <p:extLst>
       <p:ext uri="{BB962C8B-B14F-4D97-AF65-F5344CB8AC3E}">
-        <p14:creationId xmlns:p14="http://schemas.microsoft.com/office/powerpoint/2010/main" val="1123074192"/>
+        <p14:creationId xmlns:p14="http://schemas.microsoft.com/office/powerpoint/2010/main" val="904244785"/>
       </p:ext>
     </p:extLst>
   </p:cSld>
@@ -7352,7 +8503,7 @@
           <p:cNvPr id="1" name="">
             <a:extLst xmlns:a="http://schemas.openxmlformats.org/drawingml/2006/main">
               <a:ext uri="{FF2B5EF4-FFF2-40B4-BE49-F238E27FC236}">
-                <a16:creationId xmlns:a16="http://schemas.microsoft.com/office/drawing/2014/main" id="{7200820A-1614-4766-8CC6-BA3BFE5E8D2D}"/>
+                <a16:creationId xmlns:a16="http://schemas.microsoft.com/office/drawing/2014/main" id="{F214BCCE-FD50-4FCD-B2AD-A521B286B915}"/>
               </a:ext>
             </a:extLst>
           </p:cNvPr>
@@ -7392,7 +8543,7 @@
                   <a:srgbClr val="555555"/>
                 </a:solidFill>
               </a:rPr>
-              <a:t>PRACTICAL LIMIT</a:t>
+              <a:t>A-LIVE RESULT</a:t>
             </a:r>
           </a:p>
         </p:txBody>
@@ -7402,7 +8553,7 @@
           <p:cNvPr id="2" name="">
             <a:extLst xmlns:a="http://schemas.openxmlformats.org/drawingml/2006/main">
               <a:ext uri="{FF2B5EF4-FFF2-40B4-BE49-F238E27FC236}">
-                <a16:creationId xmlns:a16="http://schemas.microsoft.com/office/drawing/2014/main" id="{107CD28D-E846-4335-9DE0-2ACFFC97E8A9}"/>
+                <a16:creationId xmlns:a16="http://schemas.microsoft.com/office/drawing/2014/main" id="{9845654B-B29F-4725-8D16-9CA6145D401F}"/>
               </a:ext>
             </a:extLst>
           </p:cNvPr>
@@ -7414,35 +8565,35 @@
         <p:spPr>
           <a:xfrm xmlns:a="http://schemas.openxmlformats.org/drawingml/2006/main">
             <a:off x="400050" y="838200"/>
-            <a:ext cx="10096500" cy="609600"/>
-          </a:xfrm>
-          <a:prstGeom xmlns:a="http://schemas.openxmlformats.org/drawingml/2006/main" prst="rect">
-            <a:avLst/>
-          </a:prstGeom>
-          <a:noFill xmlns:a="http://schemas.openxmlformats.org/drawingml/2006/main"/>
-          <a:ln xmlns:a="http://schemas.openxmlformats.org/drawingml/2006/main" w="0">
-            <a:noFill/>
-            <a:prstDash val="solid"/>
-          </a:ln>
-        </p:spPr>
-        <p:txBody>
-          <a:bodyPr xmlns:a="http://schemas.openxmlformats.org/drawingml/2006/main"/>
-          <a:lstStyle xmlns:a="http://schemas.openxmlformats.org/drawingml/2006/main"/>
-          <a:p xmlns:a="http://schemas.openxmlformats.org/drawingml/2006/main">
-            <a:pPr>
-              <a:defRPr sz="3000" b="1">
-                <a:solidFill>
-                  <a:srgbClr val="000000"/>
-                </a:solidFill>
-              </a:defRPr>
-            </a:pPr>
-            <a:r>
-              <a:rPr sz="3000" b="1">
-                <a:solidFill>
-                  <a:srgbClr val="000000"/>
-                </a:solidFill>
-              </a:rPr>
-              <a:t>The broader run needs resumable authority builds</a:t>
+            <a:ext cx="10096500" cy="914400"/>
+          </a:xfrm>
+          <a:prstGeom xmlns:a="http://schemas.openxmlformats.org/drawingml/2006/main" prst="rect">
+            <a:avLst/>
+          </a:prstGeom>
+          <a:noFill xmlns:a="http://schemas.openxmlformats.org/drawingml/2006/main"/>
+          <a:ln xmlns:a="http://schemas.openxmlformats.org/drawingml/2006/main" w="0">
+            <a:noFill/>
+            <a:prstDash val="solid"/>
+          </a:ln>
+        </p:spPr>
+        <p:txBody>
+          <a:bodyPr xmlns:a="http://schemas.openxmlformats.org/drawingml/2006/main"/>
+          <a:lstStyle xmlns:a="http://schemas.openxmlformats.org/drawingml/2006/main"/>
+          <a:p xmlns:a="http://schemas.openxmlformats.org/drawingml/2006/main">
+            <a:pPr>
+              <a:defRPr sz="2700" b="1">
+                <a:solidFill>
+                  <a:srgbClr val="000000"/>
+                </a:solidFill>
+              </a:defRPr>
+            </a:pPr>
+            <a:r>
+              <a:rPr sz="2700" b="1">
+                <a:solidFill>
+                  <a:srgbClr val="000000"/>
+                </a:solidFill>
+              </a:rPr>
+              <a:t>The live-basket lane favors direct selection, with one AMD-heavy exception</a:t>
             </a:r>
           </a:p>
         </p:txBody>
@@ -7452,19 +8603,19 @@
           <p:cNvPr id="3" name="">
             <a:extLst xmlns:a="http://schemas.openxmlformats.org/drawingml/2006/main">
               <a:ext uri="{FF2B5EF4-FFF2-40B4-BE49-F238E27FC236}">
-                <a16:creationId xmlns:a16="http://schemas.microsoft.com/office/drawing/2014/main" id="{88C129BC-8708-4A02-A8A0-3E7C74C42E21}"/>
-              </a:ext>
-            </a:extLst>
-          </p:cNvPr>
-          <p:cNvSpPr>
-            <a:spLocks xmlns:a="http://schemas.openxmlformats.org/drawingml/2006/main" noGrp="1"/>
-          </p:cNvSpPr>
-          <p:nvPr/>
-        </p:nvSpPr>
-        <p:spPr>
-          <a:xfrm xmlns:a="http://schemas.openxmlformats.org/drawingml/2006/main">
-            <a:off x="400050" y="1600200"/>
-            <a:ext cx="10096500" cy="990600"/>
+                <a16:creationId xmlns:a16="http://schemas.microsoft.com/office/drawing/2014/main" id="{CD85756C-042C-4810-99E6-390A170CC4B9}"/>
+              </a:ext>
+            </a:extLst>
+          </p:cNvPr>
+          <p:cNvSpPr>
+            <a:spLocks xmlns:a="http://schemas.openxmlformats.org/drawingml/2006/main" noGrp="1"/>
+          </p:cNvSpPr>
+          <p:nvPr/>
+        </p:nvSpPr>
+        <p:spPr>
+          <a:xfrm xmlns:a="http://schemas.openxmlformats.org/drawingml/2006/main">
+            <a:off x="400050" y="1943100"/>
+            <a:ext cx="10096500" cy="781050"/>
           </a:xfrm>
           <a:prstGeom xmlns:a="http://schemas.openxmlformats.org/drawingml/2006/main" prst="rect">
             <a:avLst/>
@@ -7492,7 +8643,7 @@
                   <a:srgbClr val="222222"/>
                 </a:solidFill>
               </a:rPr>
-              <a:t>A new five-symbol Gen4-like authority evaluates 172 candidate specs per asset before state routing. The first new A-live authority stayed compute-bound in an interactive run, so the wrapper now records the right job shape but the evidence packet is not complete yet.</a:t>
+              <a:t>The completed A-live packet spans 2025Q4 through 2026Q3 on AMD,NVDA,PLTR,TSLA,SOFI with the Gen4 RESEARCH_ASSETS context. It is still inspection evidence, not allocation acceptance.</a:t>
             </a:r>
           </a:p>
         </p:txBody>
@@ -7502,18 +8653,542 @@
           <p:cNvPr id="4" name="">
             <a:extLst xmlns:a="http://schemas.openxmlformats.org/drawingml/2006/main">
               <a:ext uri="{FF2B5EF4-FFF2-40B4-BE49-F238E27FC236}">
-                <a16:creationId xmlns:a16="http://schemas.microsoft.com/office/drawing/2014/main" id="{F735C104-0448-4CA6-A058-26E35FD767CB}"/>
-              </a:ext>
-            </a:extLst>
-          </p:cNvPr>
-          <p:cNvSpPr>
-            <a:spLocks xmlns:a="http://schemas.openxmlformats.org/drawingml/2006/main" noGrp="1"/>
-          </p:cNvSpPr>
-          <p:nvPr/>
-        </p:nvSpPr>
-        <p:spPr>
-          <a:xfrm xmlns:a="http://schemas.openxmlformats.org/drawingml/2006/main">
-            <a:off x="914400" y="3086100"/>
+                <a16:creationId xmlns:a16="http://schemas.microsoft.com/office/drawing/2014/main" id="{6A65D5DC-BC57-408C-9107-97C914B94DB9}"/>
+              </a:ext>
+            </a:extLst>
+          </p:cNvPr>
+          <p:cNvSpPr>
+            <a:spLocks xmlns:a="http://schemas.openxmlformats.org/drawingml/2006/main" noGrp="1"/>
+          </p:cNvSpPr>
+          <p:nvPr/>
+        </p:nvSpPr>
+        <p:spPr>
+          <a:xfrm xmlns:a="http://schemas.openxmlformats.org/drawingml/2006/main">
+            <a:off x="781050" y="3067050"/>
+            <a:ext cx="2381250" cy="1333500"/>
+          </a:xfrm>
+          <a:prstGeom xmlns:a="http://schemas.openxmlformats.org/drawingml/2006/main" prst="rect">
+            <a:avLst/>
+          </a:prstGeom>
+          <a:solidFill xmlns:a="http://schemas.openxmlformats.org/drawingml/2006/main">
+            <a:srgbClr val="F4F4F4"/>
+          </a:solidFill>
+          <a:ln xmlns:a="http://schemas.openxmlformats.org/drawingml/2006/main" w="0">
+            <a:noFill/>
+            <a:prstDash val="solid"/>
+          </a:ln>
+        </p:spPr>
+      </p:sp>
+      <p:sp>
+        <p:nvSpPr>
+          <p:cNvPr id="5" name="">
+            <a:extLst xmlns:a="http://schemas.openxmlformats.org/drawingml/2006/main">
+              <a:ext uri="{FF2B5EF4-FFF2-40B4-BE49-F238E27FC236}">
+                <a16:creationId xmlns:a16="http://schemas.microsoft.com/office/drawing/2014/main" id="{AA985C3C-CF42-4278-9EE7-13EDCB148905}"/>
+              </a:ext>
+            </a:extLst>
+          </p:cNvPr>
+          <p:cNvSpPr>
+            <a:spLocks xmlns:a="http://schemas.openxmlformats.org/drawingml/2006/main" noGrp="1"/>
+          </p:cNvSpPr>
+          <p:nvPr/>
+        </p:nvSpPr>
+        <p:spPr>
+          <a:xfrm xmlns:a="http://schemas.openxmlformats.org/drawingml/2006/main">
+            <a:off x="1047750" y="3257550"/>
+            <a:ext cx="1809750" cy="533400"/>
+          </a:xfrm>
+          <a:prstGeom xmlns:a="http://schemas.openxmlformats.org/drawingml/2006/main" prst="rect">
+            <a:avLst/>
+          </a:prstGeom>
+          <a:noFill xmlns:a="http://schemas.openxmlformats.org/drawingml/2006/main"/>
+          <a:ln xmlns:a="http://schemas.openxmlformats.org/drawingml/2006/main" w="0">
+            <a:noFill/>
+            <a:prstDash val="solid"/>
+          </a:ln>
+        </p:spPr>
+        <p:txBody>
+          <a:bodyPr xmlns:a="http://schemas.openxmlformats.org/drawingml/2006/main"/>
+          <a:lstStyle xmlns:a="http://schemas.openxmlformats.org/drawingml/2006/main"/>
+          <a:p xmlns:a="http://schemas.openxmlformats.org/drawingml/2006/main">
+            <a:pPr>
+              <a:defRPr sz="3225" b="1">
+                <a:solidFill>
+                  <a:srgbClr val="FF6B35"/>
+                </a:solidFill>
+              </a:defRPr>
+            </a:pPr>
+            <a:r>
+              <a:rPr sz="3225" b="1">
+                <a:solidFill>
+                  <a:srgbClr val="FF6B35"/>
+                </a:solidFill>
+              </a:rPr>
+              <a:t>85.92%</a:t>
+            </a:r>
+          </a:p>
+        </p:txBody>
+      </p:sp>
+      <p:sp>
+        <p:nvSpPr>
+          <p:cNvPr id="6" name="">
+            <a:extLst xmlns:a="http://schemas.openxmlformats.org/drawingml/2006/main">
+              <a:ext uri="{FF2B5EF4-FFF2-40B4-BE49-F238E27FC236}">
+                <a16:creationId xmlns:a16="http://schemas.microsoft.com/office/drawing/2014/main" id="{79FEBDD1-820E-4F53-B28F-DD1F04412736}"/>
+              </a:ext>
+            </a:extLst>
+          </p:cNvPr>
+          <p:cNvSpPr>
+            <a:spLocks xmlns:a="http://schemas.openxmlformats.org/drawingml/2006/main" noGrp="1"/>
+          </p:cNvSpPr>
+          <p:nvPr/>
+        </p:nvSpPr>
+        <p:spPr>
+          <a:xfrm xmlns:a="http://schemas.openxmlformats.org/drawingml/2006/main">
+            <a:off x="1047750" y="3905250"/>
+            <a:ext cx="1809750" cy="323850"/>
+          </a:xfrm>
+          <a:prstGeom xmlns:a="http://schemas.openxmlformats.org/drawingml/2006/main" prst="rect">
+            <a:avLst/>
+          </a:prstGeom>
+          <a:noFill xmlns:a="http://schemas.openxmlformats.org/drawingml/2006/main"/>
+          <a:ln xmlns:a="http://schemas.openxmlformats.org/drawingml/2006/main" w="0">
+            <a:noFill/>
+            <a:prstDash val="solid"/>
+          </a:ln>
+        </p:spPr>
+        <p:txBody>
+          <a:bodyPr xmlns:a="http://schemas.openxmlformats.org/drawingml/2006/main"/>
+          <a:lstStyle xmlns:a="http://schemas.openxmlformats.org/drawingml/2006/main"/>
+          <a:p xmlns:a="http://schemas.openxmlformats.org/drawingml/2006/main">
+            <a:pPr>
+              <a:defRPr sz="1425">
+                <a:solidFill>
+                  <a:srgbClr val="000000"/>
+                </a:solidFill>
+              </a:defRPr>
+            </a:pPr>
+            <a:r>
+              <a:rPr sz="1425">
+                <a:solidFill>
+                  <a:srgbClr val="000000"/>
+                </a:solidFill>
+              </a:rPr>
+              <a:t>asset-state map agreement</a:t>
+            </a:r>
+          </a:p>
+        </p:txBody>
+      </p:sp>
+      <p:sp>
+        <p:nvSpPr>
+          <p:cNvPr id="7" name="">
+            <a:extLst xmlns:a="http://schemas.openxmlformats.org/drawingml/2006/main">
+              <a:ext uri="{FF2B5EF4-FFF2-40B4-BE49-F238E27FC236}">
+                <a16:creationId xmlns:a16="http://schemas.microsoft.com/office/drawing/2014/main" id="{145C1511-CDB5-4538-8395-6D2E5D01368F}"/>
+              </a:ext>
+            </a:extLst>
+          </p:cNvPr>
+          <p:cNvSpPr>
+            <a:spLocks xmlns:a="http://schemas.openxmlformats.org/drawingml/2006/main" noGrp="1"/>
+          </p:cNvSpPr>
+          <p:nvPr/>
+        </p:nvSpPr>
+        <p:spPr>
+          <a:xfrm xmlns:a="http://schemas.openxmlformats.org/drawingml/2006/main">
+            <a:off x="3714750" y="3067050"/>
+            <a:ext cx="2381250" cy="1333500"/>
+          </a:xfrm>
+          <a:prstGeom xmlns:a="http://schemas.openxmlformats.org/drawingml/2006/main" prst="rect">
+            <a:avLst/>
+          </a:prstGeom>
+          <a:solidFill xmlns:a="http://schemas.openxmlformats.org/drawingml/2006/main">
+            <a:srgbClr val="F4F4F4"/>
+          </a:solidFill>
+          <a:ln xmlns:a="http://schemas.openxmlformats.org/drawingml/2006/main" w="0">
+            <a:noFill/>
+            <a:prstDash val="solid"/>
+          </a:ln>
+        </p:spPr>
+      </p:sp>
+      <p:sp>
+        <p:nvSpPr>
+          <p:cNvPr id="8" name="">
+            <a:extLst xmlns:a="http://schemas.openxmlformats.org/drawingml/2006/main">
+              <a:ext uri="{FF2B5EF4-FFF2-40B4-BE49-F238E27FC236}">
+                <a16:creationId xmlns:a16="http://schemas.microsoft.com/office/drawing/2014/main" id="{F2C9D021-4AA1-441E-AAC3-5FDE1AE89EBF}"/>
+              </a:ext>
+            </a:extLst>
+          </p:cNvPr>
+          <p:cNvSpPr>
+            <a:spLocks xmlns:a="http://schemas.openxmlformats.org/drawingml/2006/main" noGrp="1"/>
+          </p:cNvSpPr>
+          <p:nvPr/>
+        </p:nvSpPr>
+        <p:spPr>
+          <a:xfrm xmlns:a="http://schemas.openxmlformats.org/drawingml/2006/main">
+            <a:off x="3981450" y="3257550"/>
+            <a:ext cx="1809750" cy="533400"/>
+          </a:xfrm>
+          <a:prstGeom xmlns:a="http://schemas.openxmlformats.org/drawingml/2006/main" prst="rect">
+            <a:avLst/>
+          </a:prstGeom>
+          <a:noFill xmlns:a="http://schemas.openxmlformats.org/drawingml/2006/main"/>
+          <a:ln xmlns:a="http://schemas.openxmlformats.org/drawingml/2006/main" w="0">
+            <a:noFill/>
+            <a:prstDash val="solid"/>
+          </a:ln>
+        </p:spPr>
+        <p:txBody>
+          <a:bodyPr xmlns:a="http://schemas.openxmlformats.org/drawingml/2006/main"/>
+          <a:lstStyle xmlns:a="http://schemas.openxmlformats.org/drawingml/2006/main"/>
+          <a:p xmlns:a="http://schemas.openxmlformats.org/drawingml/2006/main">
+            <a:pPr>
+              <a:defRPr sz="3225" b="1">
+                <a:solidFill>
+                  <a:srgbClr val="1D4ED8"/>
+                </a:solidFill>
+              </a:defRPr>
+            </a:pPr>
+            <a:r>
+              <a:rPr sz="3225" b="1">
+                <a:solidFill>
+                  <a:srgbClr val="1D4ED8"/>
+                </a:solidFill>
+              </a:rPr>
+              <a:t>3 of 4</a:t>
+            </a:r>
+          </a:p>
+        </p:txBody>
+      </p:sp>
+      <p:sp>
+        <p:nvSpPr>
+          <p:cNvPr id="9" name="">
+            <a:extLst xmlns:a="http://schemas.openxmlformats.org/drawingml/2006/main">
+              <a:ext uri="{FF2B5EF4-FFF2-40B4-BE49-F238E27FC236}">
+                <a16:creationId xmlns:a16="http://schemas.microsoft.com/office/drawing/2014/main" id="{D9983BCD-5E9C-40EE-98BF-8AF2298A673B}"/>
+              </a:ext>
+            </a:extLst>
+          </p:cNvPr>
+          <p:cNvSpPr>
+            <a:spLocks xmlns:a="http://schemas.openxmlformats.org/drawingml/2006/main" noGrp="1"/>
+          </p:cNvSpPr>
+          <p:nvPr/>
+        </p:nvSpPr>
+        <p:spPr>
+          <a:xfrm xmlns:a="http://schemas.openxmlformats.org/drawingml/2006/main">
+            <a:off x="3981450" y="3905250"/>
+            <a:ext cx="1809750" cy="438150"/>
+          </a:xfrm>
+          <a:prstGeom xmlns:a="http://schemas.openxmlformats.org/drawingml/2006/main" prst="rect">
+            <a:avLst/>
+          </a:prstGeom>
+          <a:noFill xmlns:a="http://schemas.openxmlformats.org/drawingml/2006/main"/>
+          <a:ln xmlns:a="http://schemas.openxmlformats.org/drawingml/2006/main" w="0">
+            <a:noFill/>
+            <a:prstDash val="solid"/>
+          </a:ln>
+        </p:spPr>
+        <p:txBody>
+          <a:bodyPr xmlns:a="http://schemas.openxmlformats.org/drawingml/2006/main"/>
+          <a:lstStyle xmlns:a="http://schemas.openxmlformats.org/drawingml/2006/main"/>
+          <a:p xmlns:a="http://schemas.openxmlformats.org/drawingml/2006/main">
+            <a:pPr>
+              <a:defRPr sz="1350">
+                <a:solidFill>
+                  <a:srgbClr val="000000"/>
+                </a:solidFill>
+              </a:defRPr>
+            </a:pPr>
+            <a:r>
+              <a:rPr sz="1350">
+                <a:solidFill>
+                  <a:srgbClr val="000000"/>
+                </a:solidFill>
+              </a:rPr>
+              <a:t>windows favored direct on mean trace return</a:t>
+            </a:r>
+          </a:p>
+        </p:txBody>
+      </p:sp>
+      <p:sp>
+        <p:nvSpPr>
+          <p:cNvPr id="10" name="">
+            <a:extLst xmlns:a="http://schemas.openxmlformats.org/drawingml/2006/main">
+              <a:ext uri="{FF2B5EF4-FFF2-40B4-BE49-F238E27FC236}">
+                <a16:creationId xmlns:a16="http://schemas.microsoft.com/office/drawing/2014/main" id="{D608903D-7EE8-47D9-B8AA-AA4C782A612D}"/>
+              </a:ext>
+            </a:extLst>
+          </p:cNvPr>
+          <p:cNvSpPr>
+            <a:spLocks xmlns:a="http://schemas.openxmlformats.org/drawingml/2006/main" noGrp="1"/>
+          </p:cNvSpPr>
+          <p:nvPr/>
+        </p:nvSpPr>
+        <p:spPr>
+          <a:xfrm xmlns:a="http://schemas.openxmlformats.org/drawingml/2006/main">
+            <a:off x="6648450" y="3067050"/>
+            <a:ext cx="2381250" cy="1333500"/>
+          </a:xfrm>
+          <a:prstGeom xmlns:a="http://schemas.openxmlformats.org/drawingml/2006/main" prst="rect">
+            <a:avLst/>
+          </a:prstGeom>
+          <a:solidFill xmlns:a="http://schemas.openxmlformats.org/drawingml/2006/main">
+            <a:srgbClr val="F4F4F4"/>
+          </a:solidFill>
+          <a:ln xmlns:a="http://schemas.openxmlformats.org/drawingml/2006/main" w="0">
+            <a:noFill/>
+            <a:prstDash val="solid"/>
+          </a:ln>
+        </p:spPr>
+      </p:sp>
+      <p:sp>
+        <p:nvSpPr>
+          <p:cNvPr id="11" name="">
+            <a:extLst xmlns:a="http://schemas.openxmlformats.org/drawingml/2006/main">
+              <a:ext uri="{FF2B5EF4-FFF2-40B4-BE49-F238E27FC236}">
+                <a16:creationId xmlns:a16="http://schemas.microsoft.com/office/drawing/2014/main" id="{AB7A6CE4-9C13-410C-B82B-EB9A6F2B5AB8}"/>
+              </a:ext>
+            </a:extLst>
+          </p:cNvPr>
+          <p:cNvSpPr>
+            <a:spLocks xmlns:a="http://schemas.openxmlformats.org/drawingml/2006/main" noGrp="1"/>
+          </p:cNvSpPr>
+          <p:nvPr/>
+        </p:nvSpPr>
+        <p:spPr>
+          <a:xfrm xmlns:a="http://schemas.openxmlformats.org/drawingml/2006/main">
+            <a:off x="6915150" y="3257550"/>
+            <a:ext cx="1809750" cy="533400"/>
+          </a:xfrm>
+          <a:prstGeom xmlns:a="http://schemas.openxmlformats.org/drawingml/2006/main" prst="rect">
+            <a:avLst/>
+          </a:prstGeom>
+          <a:noFill xmlns:a="http://schemas.openxmlformats.org/drawingml/2006/main"/>
+          <a:ln xmlns:a="http://schemas.openxmlformats.org/drawingml/2006/main" w="0">
+            <a:noFill/>
+            <a:prstDash val="solid"/>
+          </a:ln>
+        </p:spPr>
+        <p:txBody>
+          <a:bodyPr xmlns:a="http://schemas.openxmlformats.org/drawingml/2006/main"/>
+          <a:lstStyle xmlns:a="http://schemas.openxmlformats.org/drawingml/2006/main"/>
+          <a:p xmlns:a="http://schemas.openxmlformats.org/drawingml/2006/main">
+            <a:pPr>
+              <a:defRPr sz="3225" b="1">
+                <a:solidFill>
+                  <a:srgbClr val="1D4ED8"/>
+                </a:solidFill>
+              </a:defRPr>
+            </a:pPr>
+            <a:r>
+              <a:rPr sz="3225" b="1">
+                <a:solidFill>
+                  <a:srgbClr val="1D4ED8"/>
+                </a:solidFill>
+              </a:rPr>
+              <a:t>4 of 4</a:t>
+            </a:r>
+          </a:p>
+        </p:txBody>
+      </p:sp>
+      <p:sp>
+        <p:nvSpPr>
+          <p:cNvPr id="12" name="">
+            <a:extLst xmlns:a="http://schemas.openxmlformats.org/drawingml/2006/main">
+              <a:ext uri="{FF2B5EF4-FFF2-40B4-BE49-F238E27FC236}">
+                <a16:creationId xmlns:a16="http://schemas.microsoft.com/office/drawing/2014/main" id="{FF9EE449-AF41-4C37-B7C1-9D272771BB4D}"/>
+              </a:ext>
+            </a:extLst>
+          </p:cNvPr>
+          <p:cNvSpPr>
+            <a:spLocks xmlns:a="http://schemas.openxmlformats.org/drawingml/2006/main" noGrp="1"/>
+          </p:cNvSpPr>
+          <p:nvPr/>
+        </p:nvSpPr>
+        <p:spPr>
+          <a:xfrm xmlns:a="http://schemas.openxmlformats.org/drawingml/2006/main">
+            <a:off x="6915150" y="3905250"/>
+            <a:ext cx="1809750" cy="438150"/>
+          </a:xfrm>
+          <a:prstGeom xmlns:a="http://schemas.openxmlformats.org/drawingml/2006/main" prst="rect">
+            <a:avLst/>
+          </a:prstGeom>
+          <a:noFill xmlns:a="http://schemas.openxmlformats.org/drawingml/2006/main"/>
+          <a:ln xmlns:a="http://schemas.openxmlformats.org/drawingml/2006/main" w="0">
+            <a:noFill/>
+            <a:prstDash val="solid"/>
+          </a:ln>
+        </p:spPr>
+        <p:txBody>
+          <a:bodyPr xmlns:a="http://schemas.openxmlformats.org/drawingml/2006/main"/>
+          <a:lstStyle xmlns:a="http://schemas.openxmlformats.org/drawingml/2006/main"/>
+          <a:p xmlns:a="http://schemas.openxmlformats.org/drawingml/2006/main">
+            <a:pPr>
+              <a:defRPr sz="1350">
+                <a:solidFill>
+                  <a:srgbClr val="000000"/>
+                </a:solidFill>
+              </a:defRPr>
+            </a:pPr>
+            <a:r>
+              <a:rPr sz="1350">
+                <a:solidFill>
+                  <a:srgbClr val="000000"/>
+                </a:solidFill>
+              </a:rPr>
+              <a:t>windows favored direct on win rate and Sharpe proxy</a:t>
+            </a:r>
+          </a:p>
+        </p:txBody>
+      </p:sp>
+      <p:sp>
+        <p:nvSpPr>
+          <p:cNvPr id="13" name="">
+            <a:extLst xmlns:a="http://schemas.openxmlformats.org/drawingml/2006/main">
+              <a:ext uri="{FF2B5EF4-FFF2-40B4-BE49-F238E27FC236}">
+                <a16:creationId xmlns:a16="http://schemas.microsoft.com/office/drawing/2014/main" id="{5FC4016C-87FD-4B4F-8EB2-A76598544914}"/>
+              </a:ext>
+            </a:extLst>
+          </p:cNvPr>
+          <p:cNvSpPr>
+            <a:spLocks xmlns:a="http://schemas.openxmlformats.org/drawingml/2006/main" noGrp="1"/>
+          </p:cNvSpPr>
+          <p:nvPr/>
+        </p:nvSpPr>
+        <p:spPr>
+          <a:xfrm xmlns:a="http://schemas.openxmlformats.org/drawingml/2006/main">
+            <a:off x="9582150" y="3067050"/>
+            <a:ext cx="1619250" cy="1333500"/>
+          </a:xfrm>
+          <a:prstGeom xmlns:a="http://schemas.openxmlformats.org/drawingml/2006/main" prst="rect">
+            <a:avLst/>
+          </a:prstGeom>
+          <a:solidFill xmlns:a="http://schemas.openxmlformats.org/drawingml/2006/main">
+            <a:srgbClr val="F4F4F4"/>
+          </a:solidFill>
+          <a:ln xmlns:a="http://schemas.openxmlformats.org/drawingml/2006/main" w="0">
+            <a:noFill/>
+            <a:prstDash val="solid"/>
+          </a:ln>
+        </p:spPr>
+      </p:sp>
+      <p:sp>
+        <p:nvSpPr>
+          <p:cNvPr id="14" name="">
+            <a:extLst xmlns:a="http://schemas.openxmlformats.org/drawingml/2006/main">
+              <a:ext uri="{FF2B5EF4-FFF2-40B4-BE49-F238E27FC236}">
+                <a16:creationId xmlns:a16="http://schemas.microsoft.com/office/drawing/2014/main" id="{7F0A137A-CA6E-48D5-A183-87B709501AC5}"/>
+              </a:ext>
+            </a:extLst>
+          </p:cNvPr>
+          <p:cNvSpPr>
+            <a:spLocks xmlns:a="http://schemas.openxmlformats.org/drawingml/2006/main" noGrp="1"/>
+          </p:cNvSpPr>
+          <p:nvPr/>
+        </p:nvSpPr>
+        <p:spPr>
+          <a:xfrm xmlns:a="http://schemas.openxmlformats.org/drawingml/2006/main">
+            <a:off x="9829800" y="3333750"/>
+            <a:ext cx="1143000" cy="457200"/>
+          </a:xfrm>
+          <a:prstGeom xmlns:a="http://schemas.openxmlformats.org/drawingml/2006/main" prst="rect">
+            <a:avLst/>
+          </a:prstGeom>
+          <a:noFill xmlns:a="http://schemas.openxmlformats.org/drawingml/2006/main"/>
+          <a:ln xmlns:a="http://schemas.openxmlformats.org/drawingml/2006/main" w="0">
+            <a:noFill/>
+            <a:prstDash val="solid"/>
+          </a:ln>
+        </p:spPr>
+        <p:txBody>
+          <a:bodyPr xmlns:a="http://schemas.openxmlformats.org/drawingml/2006/main"/>
+          <a:lstStyle xmlns:a="http://schemas.openxmlformats.org/drawingml/2006/main"/>
+          <a:p xmlns:a="http://schemas.openxmlformats.org/drawingml/2006/main">
+            <a:pPr>
+              <a:defRPr sz="2700" b="1">
+                <a:solidFill>
+                  <a:srgbClr val="1B7F5A"/>
+                </a:solidFill>
+              </a:defRPr>
+            </a:pPr>
+            <a:r>
+              <a:rPr sz="2700" b="1">
+                <a:solidFill>
+                  <a:srgbClr val="1B7F5A"/>
+                </a:solidFill>
+              </a:rPr>
+              <a:t>AMD</a:t>
+            </a:r>
+          </a:p>
+        </p:txBody>
+      </p:sp>
+      <p:sp>
+        <p:nvSpPr>
+          <p:cNvPr id="15" name="">
+            <a:extLst xmlns:a="http://schemas.openxmlformats.org/drawingml/2006/main">
+              <a:ext uri="{FF2B5EF4-FFF2-40B4-BE49-F238E27FC236}">
+                <a16:creationId xmlns:a16="http://schemas.microsoft.com/office/drawing/2014/main" id="{E16397FB-1A4A-4DFE-8FAB-B1CF81A15E24}"/>
+              </a:ext>
+            </a:extLst>
+          </p:cNvPr>
+          <p:cNvSpPr>
+            <a:spLocks xmlns:a="http://schemas.openxmlformats.org/drawingml/2006/main" noGrp="1"/>
+          </p:cNvSpPr>
+          <p:nvPr/>
+        </p:nvSpPr>
+        <p:spPr>
+          <a:xfrm xmlns:a="http://schemas.openxmlformats.org/drawingml/2006/main">
+            <a:off x="9829800" y="3905250"/>
+            <a:ext cx="1104900" cy="323850"/>
+          </a:xfrm>
+          <a:prstGeom xmlns:a="http://schemas.openxmlformats.org/drawingml/2006/main" prst="rect">
+            <a:avLst/>
+          </a:prstGeom>
+          <a:noFill xmlns:a="http://schemas.openxmlformats.org/drawingml/2006/main"/>
+          <a:ln xmlns:a="http://schemas.openxmlformats.org/drawingml/2006/main" w="0">
+            <a:noFill/>
+            <a:prstDash val="solid"/>
+          </a:ln>
+        </p:spPr>
+        <p:txBody>
+          <a:bodyPr xmlns:a="http://schemas.openxmlformats.org/drawingml/2006/main"/>
+          <a:lstStyle xmlns:a="http://schemas.openxmlformats.org/drawingml/2006/main"/>
+          <a:p xmlns:a="http://schemas.openxmlformats.org/drawingml/2006/main">
+            <a:pPr>
+              <a:defRPr sz="1350">
+                <a:solidFill>
+                  <a:srgbClr val="000000"/>
+                </a:solidFill>
+              </a:defRPr>
+            </a:pPr>
+            <a:r>
+              <a:rPr sz="1350">
+                <a:solidFill>
+                  <a:srgbClr val="000000"/>
+                </a:solidFill>
+              </a:rPr>
+              <a:t>drove pooled Q3</a:t>
+            </a:r>
+          </a:p>
+        </p:txBody>
+      </p:sp>
+      <p:sp>
+        <p:nvSpPr>
+          <p:cNvPr id="16" name="">
+            <a:extLst xmlns:a="http://schemas.openxmlformats.org/drawingml/2006/main">
+              <a:ext uri="{FF2B5EF4-FFF2-40B4-BE49-F238E27FC236}">
+                <a16:creationId xmlns:a16="http://schemas.microsoft.com/office/drawing/2014/main" id="{79EE9779-6147-4E73-8143-2784B78A5F84}"/>
+              </a:ext>
+            </a:extLst>
+          </p:cNvPr>
+          <p:cNvSpPr>
+            <a:spLocks xmlns:a="http://schemas.openxmlformats.org/drawingml/2006/main" noGrp="1"/>
+          </p:cNvSpPr>
+          <p:nvPr/>
+        </p:nvSpPr>
+        <p:spPr>
+          <a:xfrm xmlns:a="http://schemas.openxmlformats.org/drawingml/2006/main">
+            <a:off x="914400" y="4876800"/>
             <a:ext cx="2286000" cy="323850"/>
           </a:xfrm>
           <a:prstGeom xmlns:a="http://schemas.openxmlformats.org/drawingml/2006/main" prst="rect">
@@ -7542,316 +9217,67 @@
                   <a:srgbClr val="000000"/>
                 </a:solidFill>
               </a:rPr>
-              <a:t>Run order</a:t>
-            </a:r>
-          </a:p>
-        </p:txBody>
-      </p:sp>
-      <p:sp>
-        <p:nvSpPr>
-          <p:cNvPr id="5" name="">
-            <a:extLst xmlns:a="http://schemas.openxmlformats.org/drawingml/2006/main">
-              <a:ext uri="{FF2B5EF4-FFF2-40B4-BE49-F238E27FC236}">
-                <a16:creationId xmlns:a16="http://schemas.microsoft.com/office/drawing/2014/main" id="{7F9E15FB-B780-452A-9C2C-57C445E63747}"/>
-              </a:ext>
-            </a:extLst>
-          </p:cNvPr>
-          <p:cNvSpPr>
-            <a:spLocks xmlns:a="http://schemas.openxmlformats.org/drawingml/2006/main" noGrp="1"/>
-          </p:cNvSpPr>
-          <p:nvPr/>
-        </p:nvSpPr>
-        <p:spPr>
-          <a:xfrm xmlns:a="http://schemas.openxmlformats.org/drawingml/2006/main">
-            <a:off x="914400" y="3581400"/>
-            <a:ext cx="4953000" cy="1219200"/>
-          </a:xfrm>
-          <a:prstGeom xmlns:a="http://schemas.openxmlformats.org/drawingml/2006/main" prst="rect">
-            <a:avLst/>
-          </a:prstGeom>
-          <a:noFill xmlns:a="http://schemas.openxmlformats.org/drawingml/2006/main"/>
-          <a:ln xmlns:a="http://schemas.openxmlformats.org/drawingml/2006/main" w="0">
-            <a:noFill/>
-            <a:prstDash val="solid"/>
-          </a:ln>
-        </p:spPr>
-        <p:txBody>
-          <a:bodyPr xmlns:a="http://schemas.openxmlformats.org/drawingml/2006/main"/>
-          <a:lstStyle xmlns:a="http://schemas.openxmlformats.org/drawingml/2006/main"/>
-          <a:p xmlns:a="http://schemas.openxmlformats.org/drawingml/2006/main">
-            <a:pPr>
-              <a:defRPr sz="1650">
-                <a:solidFill>
-                  <a:srgbClr val="000000"/>
-                </a:solidFill>
-              </a:defRPr>
-            </a:pPr>
-            <a:r>
-              <a:rPr sz="1650">
-                <a:solidFill>
-                  <a:srgbClr val="000000"/>
-                </a:solidFill>
-              </a:rPr>
-              <a:t>• Run A_live as a standalone resumable job.</a:t>
-            </a:r>
-          </a:p>
-          <a:p xmlns:a="http://schemas.openxmlformats.org/drawingml/2006/main">
-            <a:pPr>
-              <a:defRPr sz="1650">
-                <a:solidFill>
-                  <a:srgbClr val="000000"/>
-                </a:solidFill>
-              </a:defRPr>
-            </a:pPr>
-            <a:r>
-              <a:rPr sz="1650">
-                <a:solidFill>
-                  <a:srgbClr val="000000"/>
-                </a:solidFill>
-              </a:rPr>
-              <a:t>• Inspect its report and visuals before starting B_hist.</a:t>
-            </a:r>
-          </a:p>
-          <a:p xmlns:a="http://schemas.openxmlformats.org/drawingml/2006/main">
-            <a:pPr>
-              <a:defRPr sz="1650">
-                <a:solidFill>
-                  <a:srgbClr val="000000"/>
-                </a:solidFill>
-              </a:defRPr>
-            </a:pPr>
-            <a:r>
-              <a:rPr sz="1650">
-                <a:solidFill>
-                  <a:srgbClr val="000000"/>
-                </a:solidFill>
-              </a:rPr>
-              <a:t>• Add per-symbol checkpoints if authority fitting remains too slow.</a:t>
-            </a:r>
-          </a:p>
-        </p:txBody>
-      </p:sp>
-      <p:sp>
-        <p:nvSpPr>
-          <p:cNvPr id="6" name="">
-            <a:extLst xmlns:a="http://schemas.openxmlformats.org/drawingml/2006/main">
-              <a:ext uri="{FF2B5EF4-FFF2-40B4-BE49-F238E27FC236}">
-                <a16:creationId xmlns:a16="http://schemas.microsoft.com/office/drawing/2014/main" id="{0FA7B00B-AC76-44F0-B86E-FF965B19A064}"/>
-              </a:ext>
-            </a:extLst>
-          </p:cNvPr>
-          <p:cNvSpPr>
-            <a:spLocks xmlns:a="http://schemas.openxmlformats.org/drawingml/2006/main" noGrp="1"/>
-          </p:cNvSpPr>
-          <p:nvPr/>
-        </p:nvSpPr>
-        <p:spPr>
-          <a:xfrm xmlns:a="http://schemas.openxmlformats.org/drawingml/2006/main">
-            <a:off x="6667500" y="3086100"/>
-            <a:ext cx="2857500" cy="323850"/>
-          </a:xfrm>
-          <a:prstGeom xmlns:a="http://schemas.openxmlformats.org/drawingml/2006/main" prst="rect">
-            <a:avLst/>
-          </a:prstGeom>
-          <a:noFill xmlns:a="http://schemas.openxmlformats.org/drawingml/2006/main"/>
-          <a:ln xmlns:a="http://schemas.openxmlformats.org/drawingml/2006/main" w="0">
-            <a:noFill/>
-            <a:prstDash val="solid"/>
-          </a:ln>
-        </p:spPr>
-        <p:txBody>
-          <a:bodyPr xmlns:a="http://schemas.openxmlformats.org/drawingml/2006/main"/>
-          <a:lstStyle xmlns:a="http://schemas.openxmlformats.org/drawingml/2006/main"/>
-          <a:p xmlns:a="http://schemas.openxmlformats.org/drawingml/2006/main">
-            <a:pPr>
-              <a:defRPr sz="1875" b="1">
-                <a:solidFill>
-                  <a:srgbClr val="000000"/>
-                </a:solidFill>
-              </a:defRPr>
-            </a:pPr>
-            <a:r>
-              <a:rPr sz="1875" b="1">
-                <a:solidFill>
-                  <a:srgbClr val="000000"/>
-                </a:solidFill>
-              </a:rPr>
-              <a:t>Decision boundary</a:t>
-            </a:r>
-          </a:p>
-        </p:txBody>
-      </p:sp>
-      <p:sp>
-        <p:nvSpPr>
-          <p:cNvPr id="7" name="">
-            <a:extLst xmlns:a="http://schemas.openxmlformats.org/drawingml/2006/main">
-              <a:ext uri="{FF2B5EF4-FFF2-40B4-BE49-F238E27FC236}">
-                <a16:creationId xmlns:a16="http://schemas.microsoft.com/office/drawing/2014/main" id="{3B9D9DB6-6AD5-44B4-B82B-62B0825F733A}"/>
-              </a:ext>
-            </a:extLst>
-          </p:cNvPr>
-          <p:cNvSpPr>
-            <a:spLocks xmlns:a="http://schemas.openxmlformats.org/drawingml/2006/main" noGrp="1"/>
-          </p:cNvSpPr>
-          <p:nvPr/>
-        </p:nvSpPr>
-        <p:spPr>
-          <a:xfrm xmlns:a="http://schemas.openxmlformats.org/drawingml/2006/main">
-            <a:off x="6667500" y="3581400"/>
-            <a:ext cx="4381500" cy="1219200"/>
-          </a:xfrm>
-          <a:prstGeom xmlns:a="http://schemas.openxmlformats.org/drawingml/2006/main" prst="rect">
-            <a:avLst/>
-          </a:prstGeom>
-          <a:noFill xmlns:a="http://schemas.openxmlformats.org/drawingml/2006/main"/>
-          <a:ln xmlns:a="http://schemas.openxmlformats.org/drawingml/2006/main" w="0">
-            <a:noFill/>
-            <a:prstDash val="solid"/>
-          </a:ln>
-        </p:spPr>
-        <p:txBody>
-          <a:bodyPr xmlns:a="http://schemas.openxmlformats.org/drawingml/2006/main"/>
-          <a:lstStyle xmlns:a="http://schemas.openxmlformats.org/drawingml/2006/main"/>
-          <a:p xmlns:a="http://schemas.openxmlformats.org/drawingml/2006/main">
-            <a:pPr>
-              <a:defRPr sz="1650">
-                <a:solidFill>
-                  <a:srgbClr val="000000"/>
-                </a:solidFill>
-              </a:defRPr>
-            </a:pPr>
-            <a:r>
-              <a:rPr sz="1650">
-                <a:solidFill>
-                  <a:srgbClr val="000000"/>
-                </a:solidFill>
-              </a:rPr>
-              <a:t>• No live bridge policy change yet.</a:t>
-            </a:r>
-          </a:p>
-          <a:p xmlns:a="http://schemas.openxmlformats.org/drawingml/2006/main">
-            <a:pPr>
-              <a:defRPr sz="1650">
-                <a:solidFill>
-                  <a:srgbClr val="000000"/>
-                </a:solidFill>
-              </a:defRPr>
-            </a:pPr>
-            <a:r>
-              <a:rPr sz="1650">
-                <a:solidFill>
-                  <a:srgbClr val="000000"/>
-                </a:solidFill>
-              </a:rPr>
-              <a:t>• No merged Screen A plus B winner table.</a:t>
-            </a:r>
-          </a:p>
-          <a:p xmlns:a="http://schemas.openxmlformats.org/drawingml/2006/main">
-            <a:pPr>
-              <a:defRPr sz="1650">
-                <a:solidFill>
-                  <a:srgbClr val="000000"/>
-                </a:solidFill>
-              </a:defRPr>
-            </a:pPr>
-            <a:r>
-              <a:rPr sz="1650">
-                <a:solidFill>
-                  <a:srgbClr val="000000"/>
-                </a:solidFill>
-              </a:rPr>
-              <a:t>• No performance acceptance from these inspection packets.</a:t>
-            </a:r>
-          </a:p>
-        </p:txBody>
-      </p:sp>
-      <p:sp>
-        <p:nvSpPr>
-          <p:cNvPr id="8" name="">
-            <a:extLst xmlns:a="http://schemas.openxmlformats.org/drawingml/2006/main">
-              <a:ext uri="{FF2B5EF4-FFF2-40B4-BE49-F238E27FC236}">
-                <a16:creationId xmlns:a16="http://schemas.microsoft.com/office/drawing/2014/main" id="{CC021D46-C856-4037-B840-F5DF8870F653}"/>
-              </a:ext>
-            </a:extLst>
-          </p:cNvPr>
-          <p:cNvSpPr>
-            <a:spLocks xmlns:a="http://schemas.openxmlformats.org/drawingml/2006/main" noGrp="1"/>
-          </p:cNvSpPr>
-          <p:nvPr/>
-        </p:nvSpPr>
-        <p:spPr>
-          <a:xfrm xmlns:a="http://schemas.openxmlformats.org/drawingml/2006/main">
-            <a:off x="876300" y="5257800"/>
-            <a:ext cx="10439400" cy="514350"/>
-          </a:xfrm>
-          <a:prstGeom xmlns:a="http://schemas.openxmlformats.org/drawingml/2006/main" prst="rect">
-            <a:avLst/>
-          </a:prstGeom>
-          <a:solidFill xmlns:a="http://schemas.openxmlformats.org/drawingml/2006/main">
-            <a:srgbClr val="FFE1D6"/>
-          </a:solidFill>
-          <a:ln xmlns:a="http://schemas.openxmlformats.org/drawingml/2006/main" w="0">
-            <a:noFill/>
-            <a:prstDash val="solid"/>
-          </a:ln>
-        </p:spPr>
-      </p:sp>
-      <p:sp>
-        <p:nvSpPr>
-          <p:cNvPr id="9" name="">
-            <a:extLst xmlns:a="http://schemas.openxmlformats.org/drawingml/2006/main">
-              <a:ext uri="{FF2B5EF4-FFF2-40B4-BE49-F238E27FC236}">
-                <a16:creationId xmlns:a16="http://schemas.microsoft.com/office/drawing/2014/main" id="{8467418A-7FF6-46A8-83FD-FE4383080CDC}"/>
-              </a:ext>
-            </a:extLst>
-          </p:cNvPr>
-          <p:cNvSpPr>
-            <a:spLocks xmlns:a="http://schemas.openxmlformats.org/drawingml/2006/main" noGrp="1"/>
-          </p:cNvSpPr>
-          <p:nvPr/>
-        </p:nvSpPr>
-        <p:spPr>
-          <a:xfrm xmlns:a="http://schemas.openxmlformats.org/drawingml/2006/main">
-            <a:off x="1143000" y="5410200"/>
-            <a:ext cx="9810750" cy="247650"/>
-          </a:xfrm>
-          <a:prstGeom xmlns:a="http://schemas.openxmlformats.org/drawingml/2006/main" prst="rect">
-            <a:avLst/>
-          </a:prstGeom>
-          <a:noFill xmlns:a="http://schemas.openxmlformats.org/drawingml/2006/main"/>
-          <a:ln xmlns:a="http://schemas.openxmlformats.org/drawingml/2006/main" w="0">
-            <a:noFill/>
-            <a:prstDash val="solid"/>
-          </a:ln>
-        </p:spPr>
-        <p:txBody>
-          <a:bodyPr xmlns:a="http://schemas.openxmlformats.org/drawingml/2006/main"/>
-          <a:lstStyle xmlns:a="http://schemas.openxmlformats.org/drawingml/2006/main"/>
-          <a:p xmlns:a="http://schemas.openxmlformats.org/drawingml/2006/main">
-            <a:pPr>
-              <a:defRPr sz="1500" b="1">
-                <a:solidFill>
-                  <a:srgbClr val="000000"/>
-                </a:solidFill>
-              </a:defRPr>
-            </a:pPr>
-            <a:r>
-              <a:rPr sz="1500" b="1">
-                <a:solidFill>
-                  <a:srgbClr val="000000"/>
-                </a:solidFill>
-              </a:rPr>
-              <a:t>The right next step is operational, not methodological: finish the authority packets without changing the experiment.</a:t>
-            </a:r>
-          </a:p>
-        </p:txBody>
-      </p:sp>
-      <p:sp>
-        <p:nvSpPr>
-          <p:cNvPr id="10" name="">
-            <a:extLst xmlns:a="http://schemas.openxmlformats.org/drawingml/2006/main">
-              <a:ext uri="{FF2B5EF4-FFF2-40B4-BE49-F238E27FC236}">
-                <a16:creationId xmlns:a16="http://schemas.microsoft.com/office/drawing/2014/main" id="{C723479D-0C05-44AA-A2E8-AE9DDD0777E4}"/>
+              <a:t>Meaning</a:t>
+            </a:r>
+          </a:p>
+        </p:txBody>
+      </p:sp>
+      <p:sp>
+        <p:nvSpPr>
+          <p:cNvPr id="17" name="">
+            <a:extLst xmlns:a="http://schemas.openxmlformats.org/drawingml/2006/main">
+              <a:ext uri="{FF2B5EF4-FFF2-40B4-BE49-F238E27FC236}">
+                <a16:creationId xmlns:a16="http://schemas.microsoft.com/office/drawing/2014/main" id="{533E48BE-B512-4235-B4CF-CD65021937D0}"/>
+              </a:ext>
+            </a:extLst>
+          </p:cNvPr>
+          <p:cNvSpPr>
+            <a:spLocks xmlns:a="http://schemas.openxmlformats.org/drawingml/2006/main" noGrp="1"/>
+          </p:cNvSpPr>
+          <p:nvPr/>
+        </p:nvSpPr>
+        <p:spPr>
+          <a:xfrm xmlns:a="http://schemas.openxmlformats.org/drawingml/2006/main">
+            <a:off x="914400" y="5276850"/>
+            <a:ext cx="9334500" cy="533400"/>
+          </a:xfrm>
+          <a:prstGeom xmlns:a="http://schemas.openxmlformats.org/drawingml/2006/main" prst="rect">
+            <a:avLst/>
+          </a:prstGeom>
+          <a:noFill xmlns:a="http://schemas.openxmlformats.org/drawingml/2006/main"/>
+          <a:ln xmlns:a="http://schemas.openxmlformats.org/drawingml/2006/main" w="0">
+            <a:noFill/>
+            <a:prstDash val="solid"/>
+          </a:ln>
+        </p:spPr>
+        <p:txBody>
+          <a:bodyPr xmlns:a="http://schemas.openxmlformats.org/drawingml/2006/main"/>
+          <a:lstStyle xmlns:a="http://schemas.openxmlformats.org/drawingml/2006/main"/>
+          <a:p xmlns:a="http://schemas.openxmlformats.org/drawingml/2006/main">
+            <a:pPr>
+              <a:defRPr sz="1575">
+                <a:solidFill>
+                  <a:srgbClr val="000000"/>
+                </a:solidFill>
+              </a:defRPr>
+            </a:pPr>
+            <a:r>
+              <a:rPr sz="1575">
+                <a:solidFill>
+                  <a:srgbClr val="000000"/>
+                </a:solidFill>
+              </a:rPr>
+              <a:t>The live-basket screen does not justify switching the bridge default to pooled-family. It does justify keeping pooled-family as a research contender because the AMD/Q3 behavior is too interesting to discard.</a:t>
+            </a:r>
+          </a:p>
+        </p:txBody>
+      </p:sp>
+      <p:sp>
+        <p:nvSpPr>
+          <p:cNvPr id="18" name="">
+            <a:extLst xmlns:a="http://schemas.openxmlformats.org/drawingml/2006/main">
+              <a:ext uri="{FF2B5EF4-FFF2-40B4-BE49-F238E27FC236}">
+                <a16:creationId xmlns:a16="http://schemas.microsoft.com/office/drawing/2014/main" id="{731C3786-02FE-4285-B3D7-A024E596A213}"/>
               </a:ext>
             </a:extLst>
           </p:cNvPr>
@@ -7881,10 +9307,10 @@
       </p:sp>
       <p:sp>
         <p:nvSpPr>
-          <p:cNvPr id="11" name="">
-            <a:extLst xmlns:a="http://schemas.openxmlformats.org/drawingml/2006/main">
-              <a:ext uri="{FF2B5EF4-FFF2-40B4-BE49-F238E27FC236}">
-                <a16:creationId xmlns:a16="http://schemas.microsoft.com/office/drawing/2014/main" id="{8CDF41CD-97DB-41A6-BBC9-093F91289C23}"/>
+          <p:cNvPr id="19" name="">
+            <a:extLst xmlns:a="http://schemas.openxmlformats.org/drawingml/2006/main">
+              <a:ext uri="{FF2B5EF4-FFF2-40B4-BE49-F238E27FC236}">
+                <a16:creationId xmlns:a16="http://schemas.microsoft.com/office/drawing/2014/main" id="{2E96DED0-E99E-41CA-B6A6-AF92ABDF896C}"/>
               </a:ext>
             </a:extLst>
           </p:cNvPr>
@@ -7931,10 +9357,10 @@
       </p:sp>
       <p:sp>
         <p:nvSpPr>
-          <p:cNvPr id="12" name="">
-            <a:extLst xmlns:a="http://schemas.openxmlformats.org/drawingml/2006/main">
-              <a:ext uri="{FF2B5EF4-FFF2-40B4-BE49-F238E27FC236}">
-                <a16:creationId xmlns:a16="http://schemas.microsoft.com/office/drawing/2014/main" id="{E7AD91E0-4D8A-4BE5-8949-A5877954C82E}"/>
+          <p:cNvPr id="20" name="">
+            <a:extLst xmlns:a="http://schemas.openxmlformats.org/drawingml/2006/main">
+              <a:ext uri="{FF2B5EF4-FFF2-40B4-BE49-F238E27FC236}">
+                <a16:creationId xmlns:a16="http://schemas.microsoft.com/office/drawing/2014/main" id="{FB20C178-83F6-4459-A472-DF2FF6D63374}"/>
               </a:ext>
             </a:extLst>
           </p:cNvPr>
@@ -7982,7 +9408,7 @@
     </p:spTree>
     <p:extLst>
       <p:ext uri="{BB962C8B-B14F-4D97-AF65-F5344CB8AC3E}">
-        <p14:creationId xmlns:p14="http://schemas.microsoft.com/office/powerpoint/2010/main" val="2051331921"/>
+        <p14:creationId xmlns:p14="http://schemas.microsoft.com/office/powerpoint/2010/main" val="629226205"/>
       </p:ext>
     </p:extLst>
   </p:cSld>

</xml_diff>

<commit_message>
Complete B-hist selection policy readout
</commit_message>
<xml_diff>
--- a/presentations/gen5_selection_policy_hypothesis.pptx
+++ b/presentations/gen5_selection_policy_hypothesis.pptx
@@ -2,23 +2,25 @@
 <file path=ppt/presentation.xml><?xml version="1.0" encoding="utf-8"?>
 <p:presentation xmlns:p="http://schemas.openxmlformats.org/presentationml/2006/main">
   <p:sldMasterIdLst>
-    <p:sldMasterId xmlns:r="http://schemas.openxmlformats.org/officeDocument/2006/relationships" id="2147483648" r:id="R0e87ac4984ee4dcf"/>
+    <p:sldMasterId xmlns:r="http://schemas.openxmlformats.org/officeDocument/2006/relationships" id="2147483648" r:id="R242945f4fc4d43da"/>
   </p:sldMasterIdLst>
   <p:notesMasterIdLst>
-    <p:notesMasterId xmlns:r="http://schemas.openxmlformats.org/officeDocument/2006/relationships" r:id="R31cd480f549844eb"/>
+    <p:notesMasterId xmlns:r="http://schemas.openxmlformats.org/officeDocument/2006/relationships" r:id="R54f1a9438538469d"/>
   </p:notesMasterIdLst>
   <p:sldIdLst>
-    <p:sldId xmlns:r="http://schemas.openxmlformats.org/officeDocument/2006/relationships" id="256" r:id="Rc6d9d3b4eb2348db"/>
-    <p:sldId xmlns:r="http://schemas.openxmlformats.org/officeDocument/2006/relationships" id="257" r:id="Rd550fd56e3ad4525"/>
-    <p:sldId xmlns:r="http://schemas.openxmlformats.org/officeDocument/2006/relationships" id="258" r:id="R9da405f31eef4ee3"/>
-    <p:sldId xmlns:r="http://schemas.openxmlformats.org/officeDocument/2006/relationships" id="259" r:id="R7f7604497b174844"/>
-    <p:sldId xmlns:r="http://schemas.openxmlformats.org/officeDocument/2006/relationships" id="260" r:id="R19bd0c9d9b3c4718"/>
-    <p:sldId xmlns:r="http://schemas.openxmlformats.org/officeDocument/2006/relationships" id="261" r:id="R13a5e1f0b4cb4470"/>
-    <p:sldId xmlns:r="http://schemas.openxmlformats.org/officeDocument/2006/relationships" id="262" r:id="R9695ee73cd0649bf"/>
-    <p:sldId xmlns:r="http://schemas.openxmlformats.org/officeDocument/2006/relationships" id="263" r:id="Raa83f651714944ba"/>
-    <p:sldId xmlns:r="http://schemas.openxmlformats.org/officeDocument/2006/relationships" id="264" r:id="Rf38b17f26aa04ce7"/>
-    <p:sldId xmlns:r="http://schemas.openxmlformats.org/officeDocument/2006/relationships" id="265" r:id="Redf0fc8edfe74c4e"/>
-    <p:sldId xmlns:r="http://schemas.openxmlformats.org/officeDocument/2006/relationships" id="266" r:id="R56fc06d00f0a4ae0"/>
+    <p:sldId xmlns:r="http://schemas.openxmlformats.org/officeDocument/2006/relationships" id="256" r:id="R79793780a951463f"/>
+    <p:sldId xmlns:r="http://schemas.openxmlformats.org/officeDocument/2006/relationships" id="257" r:id="R20165b04113946e8"/>
+    <p:sldId xmlns:r="http://schemas.openxmlformats.org/officeDocument/2006/relationships" id="258" r:id="R0b8fccafd0cc42f9"/>
+    <p:sldId xmlns:r="http://schemas.openxmlformats.org/officeDocument/2006/relationships" id="259" r:id="R8b91c137f3a54028"/>
+    <p:sldId xmlns:r="http://schemas.openxmlformats.org/officeDocument/2006/relationships" id="260" r:id="R06a852925ac74f70"/>
+    <p:sldId xmlns:r="http://schemas.openxmlformats.org/officeDocument/2006/relationships" id="261" r:id="Rce3db8144b9a4bf4"/>
+    <p:sldId xmlns:r="http://schemas.openxmlformats.org/officeDocument/2006/relationships" id="262" r:id="Re232de574a4e4a5a"/>
+    <p:sldId xmlns:r="http://schemas.openxmlformats.org/officeDocument/2006/relationships" id="263" r:id="R94992d0140bc44a3"/>
+    <p:sldId xmlns:r="http://schemas.openxmlformats.org/officeDocument/2006/relationships" id="264" r:id="R56f03ea35fa34cac"/>
+    <p:sldId xmlns:r="http://schemas.openxmlformats.org/officeDocument/2006/relationships" id="265" r:id="Rd2d0bab51c8e4dfa"/>
+    <p:sldId xmlns:r="http://schemas.openxmlformats.org/officeDocument/2006/relationships" id="266" r:id="Rc1157f6a11d04ea3"/>
+    <p:sldId xmlns:r="http://schemas.openxmlformats.org/officeDocument/2006/relationships" id="267" r:id="Rd07469e991164c4f"/>
+    <p:sldId xmlns:r="http://schemas.openxmlformats.org/officeDocument/2006/relationships" id="268" r:id="Rb349292a46e04131"/>
   </p:sldIdLst>
   <p:sldSz cx="12192000" cy="6858000"/>
   <p:notesSz cx="6858000" cy="9144000"/>
@@ -705,6 +707,138 @@
 </p:notes>
 </file>
 
+<file path=ppt/notesSlides/notesSlide12.xml><?xml version="1.0" encoding="utf-8"?>
+<p:notes xmlns:p="http://schemas.openxmlformats.org/presentationml/2006/main">
+  <p:cSld>
+    <p:spTree>
+      <p:nvGrpSpPr>
+        <p:cNvPr id="1" name=""/>
+        <p:cNvGrpSpPr/>
+        <p:nvPr/>
+      </p:nvGrpSpPr>
+      <p:grpSpPr>
+        <a:xfrm xmlns:a="http://schemas.openxmlformats.org/drawingml/2006/main"/>
+      </p:grpSpPr>
+      <p:sp>
+        <p:nvSpPr>
+          <p:cNvPr id="2" name="Slide Image Placeholder 1"/>
+          <p:cNvSpPr>
+            <a:spLocks xmlns:a="http://schemas.openxmlformats.org/drawingml/2006/main" noGrp="1"/>
+          </p:cNvSpPr>
+          <p:nvPr>
+            <p:ph type="sldImg" idx="0"/>
+          </p:nvPr>
+        </p:nvSpPr>
+        <p:spPr/>
+      </p:sp>
+      <p:sp>
+        <p:nvSpPr>
+          <p:cNvPr id="3" name="Notes Placeholder 2"/>
+          <p:cNvSpPr>
+            <a:spLocks xmlns:a="http://schemas.openxmlformats.org/drawingml/2006/main" noGrp="1"/>
+          </p:cNvSpPr>
+          <p:nvPr>
+            <p:ph type="body" idx="1"/>
+          </p:nvPr>
+        </p:nvSpPr>
+        <p:spPr/>
+        <p:txBody>
+          <a:bodyPr xmlns:a="http://schemas.openxmlformats.org/drawingml/2006/main"/>
+          <a:lstStyle xmlns:a="http://schemas.openxmlformats.org/drawingml/2006/main"/>
+          <a:p xmlns:a="http://schemas.openxmlformats.org/drawingml/2006/main"/>
+        </p:txBody>
+      </p:sp>
+      <p:sp>
+        <p:nvSpPr>
+          <p:cNvPr id="4" name="Slide Number Placeholder 3"/>
+          <p:cNvSpPr>
+            <a:spLocks xmlns:a="http://schemas.openxmlformats.org/drawingml/2006/main" noGrp="1"/>
+          </p:cNvSpPr>
+          <p:nvPr>
+            <p:ph type="sldNum" idx="5"/>
+          </p:nvPr>
+        </p:nvSpPr>
+        <p:spPr/>
+        <p:txBody>
+          <a:bodyPr xmlns:a="http://schemas.openxmlformats.org/drawingml/2006/main"/>
+          <a:lstStyle xmlns:a="http://schemas.openxmlformats.org/drawingml/2006/main"/>
+          <a:p xmlns:a="http://schemas.openxmlformats.org/drawingml/2006/main"/>
+        </p:txBody>
+      </p:sp>
+    </p:spTree>
+  </p:cSld>
+  <p:clrMapOvr>
+    <a:masterClrMapping xmlns:a="http://schemas.openxmlformats.org/drawingml/2006/main"/>
+  </p:clrMapOvr>
+</p:notes>
+</file>
+
+<file path=ppt/notesSlides/notesSlide13.xml><?xml version="1.0" encoding="utf-8"?>
+<p:notes xmlns:p="http://schemas.openxmlformats.org/presentationml/2006/main">
+  <p:cSld>
+    <p:spTree>
+      <p:nvGrpSpPr>
+        <p:cNvPr id="1" name=""/>
+        <p:cNvGrpSpPr/>
+        <p:nvPr/>
+      </p:nvGrpSpPr>
+      <p:grpSpPr>
+        <a:xfrm xmlns:a="http://schemas.openxmlformats.org/drawingml/2006/main"/>
+      </p:grpSpPr>
+      <p:sp>
+        <p:nvSpPr>
+          <p:cNvPr id="2" name="Slide Image Placeholder 1"/>
+          <p:cNvSpPr>
+            <a:spLocks xmlns:a="http://schemas.openxmlformats.org/drawingml/2006/main" noGrp="1"/>
+          </p:cNvSpPr>
+          <p:nvPr>
+            <p:ph type="sldImg" idx="0"/>
+          </p:nvPr>
+        </p:nvSpPr>
+        <p:spPr/>
+      </p:sp>
+      <p:sp>
+        <p:nvSpPr>
+          <p:cNvPr id="3" name="Notes Placeholder 2"/>
+          <p:cNvSpPr>
+            <a:spLocks xmlns:a="http://schemas.openxmlformats.org/drawingml/2006/main" noGrp="1"/>
+          </p:cNvSpPr>
+          <p:nvPr>
+            <p:ph type="body" idx="1"/>
+          </p:nvPr>
+        </p:nvSpPr>
+        <p:spPr/>
+        <p:txBody>
+          <a:bodyPr xmlns:a="http://schemas.openxmlformats.org/drawingml/2006/main"/>
+          <a:lstStyle xmlns:a="http://schemas.openxmlformats.org/drawingml/2006/main"/>
+          <a:p xmlns:a="http://schemas.openxmlformats.org/drawingml/2006/main"/>
+        </p:txBody>
+      </p:sp>
+      <p:sp>
+        <p:nvSpPr>
+          <p:cNvPr id="4" name="Slide Number Placeholder 3"/>
+          <p:cNvSpPr>
+            <a:spLocks xmlns:a="http://schemas.openxmlformats.org/drawingml/2006/main" noGrp="1"/>
+          </p:cNvSpPr>
+          <p:nvPr>
+            <p:ph type="sldNum" idx="5"/>
+          </p:nvPr>
+        </p:nvSpPr>
+        <p:spPr/>
+        <p:txBody>
+          <a:bodyPr xmlns:a="http://schemas.openxmlformats.org/drawingml/2006/main"/>
+          <a:lstStyle xmlns:a="http://schemas.openxmlformats.org/drawingml/2006/main"/>
+          <a:p xmlns:a="http://schemas.openxmlformats.org/drawingml/2006/main"/>
+        </p:txBody>
+      </p:sp>
+    </p:spTree>
+  </p:cSld>
+  <p:clrMapOvr>
+    <a:masterClrMapping xmlns:a="http://schemas.openxmlformats.org/drawingml/2006/main"/>
+  </p:clrMapOvr>
+</p:notes>
+</file>
+
 <file path=ppt/notesSlides/notesSlide2.xml><?xml version="1.0" encoding="utf-8"?>
 <p:notes xmlns:p="http://schemas.openxmlformats.org/presentationml/2006/main">
   <p:cSld>
@@ -1271,7 +1405,7 @@
   </p:cSld>
   <p:clrMap bg1="lt1" tx1="dk1" bg2="lt2" tx2="dk2" accent1="accent1" accent2="accent2" accent3="accent3" accent4="accent4" accent5="accent5" accent6="accent6" hlink="hlink" folHlink="folHlink"/>
   <p:sldLayoutIdLst>
-    <p:sldLayoutId xmlns:r="http://schemas.openxmlformats.org/officeDocument/2006/relationships" id="2147483649" r:id="Rf9e07c0ff6814830"/>
+    <p:sldLayoutId xmlns:r="http://schemas.openxmlformats.org/officeDocument/2006/relationships" id="2147483649" r:id="Ra2e0111ea61a424f"/>
   </p:sldLayoutIdLst>
   <p:txStyles>
     <p:titleStyle>
@@ -1822,7 +1956,7 @@
           <p:cNvPr id="1" name="">
             <a:extLst xmlns:a="http://schemas.openxmlformats.org/drawingml/2006/main">
               <a:ext uri="{FF2B5EF4-FFF2-40B4-BE49-F238E27FC236}">
-                <a16:creationId xmlns:a16="http://schemas.microsoft.com/office/drawing/2014/main" id="{2D9DAE99-6442-449C-8823-F7BD79A5B302}"/>
+                <a16:creationId xmlns:a16="http://schemas.microsoft.com/office/drawing/2014/main" id="{8F16E54E-CBDE-48F2-810C-4E4025DDB48A}"/>
               </a:ext>
             </a:extLst>
           </p:cNvPr>
@@ -1872,7 +2006,7 @@
           <p:cNvPr id="2" name="">
             <a:extLst xmlns:a="http://schemas.openxmlformats.org/drawingml/2006/main">
               <a:ext uri="{FF2B5EF4-FFF2-40B4-BE49-F238E27FC236}">
-                <a16:creationId xmlns:a16="http://schemas.microsoft.com/office/drawing/2014/main" id="{B745960D-BD86-414D-B8EE-F74CAACC06CE}"/>
+                <a16:creationId xmlns:a16="http://schemas.microsoft.com/office/drawing/2014/main" id="{9579863D-2952-453F-B525-81EA00757AC3}"/>
               </a:ext>
             </a:extLst>
           </p:cNvPr>
@@ -1922,7 +2056,7 @@
           <p:cNvPr id="3" name="">
             <a:extLst xmlns:a="http://schemas.openxmlformats.org/drawingml/2006/main">
               <a:ext uri="{FF2B5EF4-FFF2-40B4-BE49-F238E27FC236}">
-                <a16:creationId xmlns:a16="http://schemas.microsoft.com/office/drawing/2014/main" id="{8E6EA3B5-407B-4301-B7C9-D89F1DD456B3}"/>
+                <a16:creationId xmlns:a16="http://schemas.microsoft.com/office/drawing/2014/main" id="{C69D8249-E8E8-4A40-9463-46ECA478C0F8}"/>
               </a:ext>
             </a:extLst>
           </p:cNvPr>
@@ -1972,7 +2106,7 @@
           <p:cNvPr id="4" name="">
             <a:extLst xmlns:a="http://schemas.openxmlformats.org/drawingml/2006/main">
               <a:ext uri="{FF2B5EF4-FFF2-40B4-BE49-F238E27FC236}">
-                <a16:creationId xmlns:a16="http://schemas.microsoft.com/office/drawing/2014/main" id="{5C8D982B-81B8-4412-ABB9-13E969D7E5AA}"/>
+                <a16:creationId xmlns:a16="http://schemas.microsoft.com/office/drawing/2014/main" id="{4309A316-798B-41D6-B6BA-4D2555A03509}"/>
               </a:ext>
             </a:extLst>
           </p:cNvPr>
@@ -2003,7 +2137,7 @@
           <p:cNvPr id="5" name="">
             <a:extLst xmlns:a="http://schemas.openxmlformats.org/drawingml/2006/main">
               <a:ext uri="{FF2B5EF4-FFF2-40B4-BE49-F238E27FC236}">
-                <a16:creationId xmlns:a16="http://schemas.microsoft.com/office/drawing/2014/main" id="{9C9F85E9-5319-42D5-8615-04EA3D94A685}"/>
+                <a16:creationId xmlns:a16="http://schemas.microsoft.com/office/drawing/2014/main" id="{774E8CC4-5197-46EB-B837-82D08F3E4C7E}"/>
               </a:ext>
             </a:extLst>
           </p:cNvPr>
@@ -2104,7 +2238,7 @@
           <p:cNvPr id="6" name="">
             <a:extLst xmlns:a="http://schemas.openxmlformats.org/drawingml/2006/main">
               <a:ext uri="{FF2B5EF4-FFF2-40B4-BE49-F238E27FC236}">
-                <a16:creationId xmlns:a16="http://schemas.microsoft.com/office/drawing/2014/main" id="{567EACFE-FB0D-471B-A303-B39E5F240513}"/>
+                <a16:creationId xmlns:a16="http://schemas.microsoft.com/office/drawing/2014/main" id="{5D506C49-A03C-4E68-948F-E510BC02E5CE}"/>
               </a:ext>
             </a:extLst>
           </p:cNvPr>
@@ -2154,7 +2288,7 @@
           <p:cNvPr id="7" name="">
             <a:extLst xmlns:a="http://schemas.openxmlformats.org/drawingml/2006/main">
               <a:ext uri="{FF2B5EF4-FFF2-40B4-BE49-F238E27FC236}">
-                <a16:creationId xmlns:a16="http://schemas.microsoft.com/office/drawing/2014/main" id="{7DF03D61-EFA6-4AD7-BE48-8502B656598F}"/>
+                <a16:creationId xmlns:a16="http://schemas.microsoft.com/office/drawing/2014/main" id="{FCA06247-55C0-430C-B9AB-D0CCF7281CCD}"/>
               </a:ext>
             </a:extLst>
           </p:cNvPr>
@@ -2187,7 +2321,7 @@
           <p:cNvPr id="8" name="">
             <a:extLst xmlns:a="http://schemas.openxmlformats.org/drawingml/2006/main">
               <a:ext uri="{FF2B5EF4-FFF2-40B4-BE49-F238E27FC236}">
-                <a16:creationId xmlns:a16="http://schemas.microsoft.com/office/drawing/2014/main" id="{2FC6F915-90A1-4CC1-A9FA-14F67A92D8F7}"/>
+                <a16:creationId xmlns:a16="http://schemas.microsoft.com/office/drawing/2014/main" id="{29812FBD-5BF9-452C-9A22-5B998F9A5217}"/>
               </a:ext>
             </a:extLst>
           </p:cNvPr>
@@ -2237,7 +2371,7 @@
           <p:cNvPr id="9" name="">
             <a:extLst xmlns:a="http://schemas.openxmlformats.org/drawingml/2006/main">
               <a:ext uri="{FF2B5EF4-FFF2-40B4-BE49-F238E27FC236}">
-                <a16:creationId xmlns:a16="http://schemas.microsoft.com/office/drawing/2014/main" id="{87FD8498-8666-4E46-B702-F044FA9DF343}"/>
+                <a16:creationId xmlns:a16="http://schemas.microsoft.com/office/drawing/2014/main" id="{1288E612-3AC9-4A45-8E9B-49C07A57D4A0}"/>
               </a:ext>
             </a:extLst>
           </p:cNvPr>
@@ -2285,7 +2419,7 @@
     </p:spTree>
     <p:extLst>
       <p:ext uri="{BB962C8B-B14F-4D97-AF65-F5344CB8AC3E}">
-        <p14:creationId xmlns:p14="http://schemas.microsoft.com/office/powerpoint/2010/main" val="1213871233"/>
+        <p14:creationId xmlns:p14="http://schemas.microsoft.com/office/powerpoint/2010/main" val="556934988"/>
       </p:ext>
     </p:extLst>
   </p:cSld>
@@ -2316,7 +2450,7 @@
           <p:cNvPr id="1" name="">
             <a:extLst xmlns:a="http://schemas.openxmlformats.org/drawingml/2006/main">
               <a:ext uri="{FF2B5EF4-FFF2-40B4-BE49-F238E27FC236}">
-                <a16:creationId xmlns:a16="http://schemas.microsoft.com/office/drawing/2014/main" id="{41D68107-F777-4CCC-9B53-037372E3D57D}"/>
+                <a16:creationId xmlns:a16="http://schemas.microsoft.com/office/drawing/2014/main" id="{70B17791-ECF5-4F5B-8432-0C086322C9D2}"/>
               </a:ext>
             </a:extLst>
           </p:cNvPr>
@@ -2356,7 +2490,7 @@
                   <a:srgbClr val="555555"/>
                 </a:solidFill>
               </a:rPr>
-              <a:t>NEXT GATE</a:t>
+              <a:t>B-HIST RESULT</a:t>
             </a:r>
           </a:p>
         </p:txBody>
@@ -2366,7 +2500,7 @@
           <p:cNvPr id="2" name="">
             <a:extLst xmlns:a="http://schemas.openxmlformats.org/drawingml/2006/main">
               <a:ext uri="{FF2B5EF4-FFF2-40B4-BE49-F238E27FC236}">
-                <a16:creationId xmlns:a16="http://schemas.microsoft.com/office/drawing/2014/main" id="{C7921947-7E93-4BBA-8AA5-2C82EBA7B99C}"/>
+                <a16:creationId xmlns:a16="http://schemas.microsoft.com/office/drawing/2014/main" id="{F8E7B080-2538-40F8-BA5D-DCE0C2FBDE10}"/>
               </a:ext>
             </a:extLst>
           </p:cNvPr>
@@ -2406,7 +2540,7 @@
                   <a:srgbClr val="000000"/>
                 </a:solidFill>
               </a:rPr>
-              <a:t>The next decision is whether more history is worth changing the basket</a:t>
+              <a:t>Older substitute history turns the question into a tradeoff</a:t>
             </a:r>
           </a:p>
         </p:txBody>
@@ -2416,7 +2550,7 @@
           <p:cNvPr id="3" name="">
             <a:extLst xmlns:a="http://schemas.openxmlformats.org/drawingml/2006/main">
               <a:ext uri="{FF2B5EF4-FFF2-40B4-BE49-F238E27FC236}">
-                <a16:creationId xmlns:a16="http://schemas.microsoft.com/office/drawing/2014/main" id="{79CD4F24-EC76-4057-BC67-67F3D6654EDE}"/>
+                <a16:creationId xmlns:a16="http://schemas.microsoft.com/office/drawing/2014/main" id="{5AC94B8F-A2DF-4A82-ACF3-A455AA3C0604}"/>
               </a:ext>
             </a:extLst>
           </p:cNvPr>
@@ -2456,7 +2590,7 @@
                   <a:srgbClr val="222222"/>
                 </a:solidFill>
               </a:rPr>
-              <a:t>B_hist would swap SOFI and PLTR for AAPL and MSTR to reach older regimes. That is useful robustness evidence, but it is no longer a literal live-basket test.</a:t>
+              <a:t>B_hist swapped SOFI and PLTR for AAPL and MSTR to reach 2019, 2020, 2022, and 2025 windows. This is robustness evidence, not a literal live-basket replication.</a:t>
             </a:r>
           </a:p>
         </p:txBody>
@@ -2466,19 +2600,543 @@
           <p:cNvPr id="4" name="">
             <a:extLst xmlns:a="http://schemas.openxmlformats.org/drawingml/2006/main">
               <a:ext uri="{FF2B5EF4-FFF2-40B4-BE49-F238E27FC236}">
-                <a16:creationId xmlns:a16="http://schemas.microsoft.com/office/drawing/2014/main" id="{EA9ED100-C8D2-40ED-8D33-50015FCFA847}"/>
-              </a:ext>
-            </a:extLst>
-          </p:cNvPr>
-          <p:cNvSpPr>
-            <a:spLocks xmlns:a="http://schemas.openxmlformats.org/drawingml/2006/main" noGrp="1"/>
-          </p:cNvSpPr>
-          <p:nvPr/>
-        </p:nvSpPr>
-        <p:spPr>
-          <a:xfrm xmlns:a="http://schemas.openxmlformats.org/drawingml/2006/main">
-            <a:off x="914400" y="3028950"/>
-            <a:ext cx="3143250" cy="323850"/>
+                <a16:creationId xmlns:a16="http://schemas.microsoft.com/office/drawing/2014/main" id="{0E29AD8C-7B1F-4033-9212-C6B68F3D0235}"/>
+              </a:ext>
+            </a:extLst>
+          </p:cNvPr>
+          <p:cNvSpPr>
+            <a:spLocks xmlns:a="http://schemas.openxmlformats.org/drawingml/2006/main" noGrp="1"/>
+          </p:cNvSpPr>
+          <p:nvPr/>
+        </p:nvSpPr>
+        <p:spPr>
+          <a:xfrm xmlns:a="http://schemas.openxmlformats.org/drawingml/2006/main">
+            <a:off x="781050" y="2990850"/>
+            <a:ext cx="2381250" cy="1276350"/>
+          </a:xfrm>
+          <a:prstGeom xmlns:a="http://schemas.openxmlformats.org/drawingml/2006/main" prst="rect">
+            <a:avLst/>
+          </a:prstGeom>
+          <a:solidFill xmlns:a="http://schemas.openxmlformats.org/drawingml/2006/main">
+            <a:srgbClr val="F4F4F4"/>
+          </a:solidFill>
+          <a:ln xmlns:a="http://schemas.openxmlformats.org/drawingml/2006/main" w="0">
+            <a:noFill/>
+            <a:prstDash val="solid"/>
+          </a:ln>
+        </p:spPr>
+      </p:sp>
+      <p:sp>
+        <p:nvSpPr>
+          <p:cNvPr id="5" name="">
+            <a:extLst xmlns:a="http://schemas.openxmlformats.org/drawingml/2006/main">
+              <a:ext uri="{FF2B5EF4-FFF2-40B4-BE49-F238E27FC236}">
+                <a16:creationId xmlns:a16="http://schemas.microsoft.com/office/drawing/2014/main" id="{53AC7928-89F1-425E-A858-11E65332097C}"/>
+              </a:ext>
+            </a:extLst>
+          </p:cNvPr>
+          <p:cNvSpPr>
+            <a:spLocks xmlns:a="http://schemas.openxmlformats.org/drawingml/2006/main" noGrp="1"/>
+          </p:cNvSpPr>
+          <p:nvPr/>
+        </p:nvSpPr>
+        <p:spPr>
+          <a:xfrm xmlns:a="http://schemas.openxmlformats.org/drawingml/2006/main">
+            <a:off x="1047750" y="3162300"/>
+            <a:ext cx="1809750" cy="514350"/>
+          </a:xfrm>
+          <a:prstGeom xmlns:a="http://schemas.openxmlformats.org/drawingml/2006/main" prst="rect">
+            <a:avLst/>
+          </a:prstGeom>
+          <a:noFill xmlns:a="http://schemas.openxmlformats.org/drawingml/2006/main"/>
+          <a:ln xmlns:a="http://schemas.openxmlformats.org/drawingml/2006/main" w="0">
+            <a:noFill/>
+            <a:prstDash val="solid"/>
+          </a:ln>
+        </p:spPr>
+        <p:txBody>
+          <a:bodyPr xmlns:a="http://schemas.openxmlformats.org/drawingml/2006/main"/>
+          <a:lstStyle xmlns:a="http://schemas.openxmlformats.org/drawingml/2006/main"/>
+          <a:p xmlns:a="http://schemas.openxmlformats.org/drawingml/2006/main">
+            <a:pPr>
+              <a:defRPr sz="3150" b="1">
+                <a:solidFill>
+                  <a:srgbClr val="FF6B35"/>
+                </a:solidFill>
+              </a:defRPr>
+            </a:pPr>
+            <a:r>
+              <a:rPr sz="3150" b="1">
+                <a:solidFill>
+                  <a:srgbClr val="FF6B35"/>
+                </a:solidFill>
+              </a:rPr>
+              <a:t>81.84%</a:t>
+            </a:r>
+          </a:p>
+        </p:txBody>
+      </p:sp>
+      <p:sp>
+        <p:nvSpPr>
+          <p:cNvPr id="6" name="">
+            <a:extLst xmlns:a="http://schemas.openxmlformats.org/drawingml/2006/main">
+              <a:ext uri="{FF2B5EF4-FFF2-40B4-BE49-F238E27FC236}">
+                <a16:creationId xmlns:a16="http://schemas.microsoft.com/office/drawing/2014/main" id="{E0451D9E-3DF4-454C-AEBA-2667C95D7F40}"/>
+              </a:ext>
+            </a:extLst>
+          </p:cNvPr>
+          <p:cNvSpPr>
+            <a:spLocks xmlns:a="http://schemas.openxmlformats.org/drawingml/2006/main" noGrp="1"/>
+          </p:cNvSpPr>
+          <p:nvPr/>
+        </p:nvSpPr>
+        <p:spPr>
+          <a:xfrm xmlns:a="http://schemas.openxmlformats.org/drawingml/2006/main">
+            <a:off x="1047750" y="3790950"/>
+            <a:ext cx="1809750" cy="361950"/>
+          </a:xfrm>
+          <a:prstGeom xmlns:a="http://schemas.openxmlformats.org/drawingml/2006/main" prst="rect">
+            <a:avLst/>
+          </a:prstGeom>
+          <a:noFill xmlns:a="http://schemas.openxmlformats.org/drawingml/2006/main"/>
+          <a:ln xmlns:a="http://schemas.openxmlformats.org/drawingml/2006/main" w="0">
+            <a:noFill/>
+            <a:prstDash val="solid"/>
+          </a:ln>
+        </p:spPr>
+        <p:txBody>
+          <a:bodyPr xmlns:a="http://schemas.openxmlformats.org/drawingml/2006/main"/>
+          <a:lstStyle xmlns:a="http://schemas.openxmlformats.org/drawingml/2006/main"/>
+          <a:p xmlns:a="http://schemas.openxmlformats.org/drawingml/2006/main">
+            <a:pPr>
+              <a:defRPr sz="1350">
+                <a:solidFill>
+                  <a:srgbClr val="000000"/>
+                </a:solidFill>
+              </a:defRPr>
+            </a:pPr>
+            <a:r>
+              <a:rPr sz="1350">
+                <a:solidFill>
+                  <a:srgbClr val="000000"/>
+                </a:solidFill>
+              </a:rPr>
+              <a:t>exact map agreement across 10 authority quarters</a:t>
+            </a:r>
+          </a:p>
+        </p:txBody>
+      </p:sp>
+      <p:sp>
+        <p:nvSpPr>
+          <p:cNvPr id="7" name="">
+            <a:extLst xmlns:a="http://schemas.openxmlformats.org/drawingml/2006/main">
+              <a:ext uri="{FF2B5EF4-FFF2-40B4-BE49-F238E27FC236}">
+                <a16:creationId xmlns:a16="http://schemas.microsoft.com/office/drawing/2014/main" id="{FA238DF0-8056-4D2B-B2A0-D2715CFE52AB}"/>
+              </a:ext>
+            </a:extLst>
+          </p:cNvPr>
+          <p:cNvSpPr>
+            <a:spLocks xmlns:a="http://schemas.openxmlformats.org/drawingml/2006/main" noGrp="1"/>
+          </p:cNvSpPr>
+          <p:nvPr/>
+        </p:nvSpPr>
+        <p:spPr>
+          <a:xfrm xmlns:a="http://schemas.openxmlformats.org/drawingml/2006/main">
+            <a:off x="3714750" y="2990850"/>
+            <a:ext cx="2381250" cy="1276350"/>
+          </a:xfrm>
+          <a:prstGeom xmlns:a="http://schemas.openxmlformats.org/drawingml/2006/main" prst="rect">
+            <a:avLst/>
+          </a:prstGeom>
+          <a:solidFill xmlns:a="http://schemas.openxmlformats.org/drawingml/2006/main">
+            <a:srgbClr val="F4F4F4"/>
+          </a:solidFill>
+          <a:ln xmlns:a="http://schemas.openxmlformats.org/drawingml/2006/main" w="0">
+            <a:noFill/>
+            <a:prstDash val="solid"/>
+          </a:ln>
+        </p:spPr>
+      </p:sp>
+      <p:sp>
+        <p:nvSpPr>
+          <p:cNvPr id="8" name="">
+            <a:extLst xmlns:a="http://schemas.openxmlformats.org/drawingml/2006/main">
+              <a:ext uri="{FF2B5EF4-FFF2-40B4-BE49-F238E27FC236}">
+                <a16:creationId xmlns:a16="http://schemas.microsoft.com/office/drawing/2014/main" id="{28D518ED-FFEF-48A7-A932-FB614624E80F}"/>
+              </a:ext>
+            </a:extLst>
+          </p:cNvPr>
+          <p:cNvSpPr>
+            <a:spLocks xmlns:a="http://schemas.openxmlformats.org/drawingml/2006/main" noGrp="1"/>
+          </p:cNvSpPr>
+          <p:nvPr/>
+        </p:nvSpPr>
+        <p:spPr>
+          <a:xfrm xmlns:a="http://schemas.openxmlformats.org/drawingml/2006/main">
+            <a:off x="3981450" y="3162300"/>
+            <a:ext cx="1809750" cy="514350"/>
+          </a:xfrm>
+          <a:prstGeom xmlns:a="http://schemas.openxmlformats.org/drawingml/2006/main" prst="rect">
+            <a:avLst/>
+          </a:prstGeom>
+          <a:noFill xmlns:a="http://schemas.openxmlformats.org/drawingml/2006/main"/>
+          <a:ln xmlns:a="http://schemas.openxmlformats.org/drawingml/2006/main" w="0">
+            <a:noFill/>
+            <a:prstDash val="solid"/>
+          </a:ln>
+        </p:spPr>
+        <p:txBody>
+          <a:bodyPr xmlns:a="http://schemas.openxmlformats.org/drawingml/2006/main"/>
+          <a:lstStyle xmlns:a="http://schemas.openxmlformats.org/drawingml/2006/main"/>
+          <a:p xmlns:a="http://schemas.openxmlformats.org/drawingml/2006/main">
+            <a:pPr>
+              <a:defRPr sz="3150" b="1">
+                <a:solidFill>
+                  <a:srgbClr val="1D4ED8"/>
+                </a:solidFill>
+              </a:defRPr>
+            </a:pPr>
+            <a:r>
+              <a:rPr sz="3150" b="1">
+                <a:solidFill>
+                  <a:srgbClr val="1D4ED8"/>
+                </a:solidFill>
+              </a:rPr>
+              <a:t>3 of 5</a:t>
+            </a:r>
+          </a:p>
+        </p:txBody>
+      </p:sp>
+      <p:sp>
+        <p:nvSpPr>
+          <p:cNvPr id="9" name="">
+            <a:extLst xmlns:a="http://schemas.openxmlformats.org/drawingml/2006/main">
+              <a:ext uri="{FF2B5EF4-FFF2-40B4-BE49-F238E27FC236}">
+                <a16:creationId xmlns:a16="http://schemas.microsoft.com/office/drawing/2014/main" id="{62FBDD60-E777-42B3-9D52-5C19A1C3D4B0}"/>
+              </a:ext>
+            </a:extLst>
+          </p:cNvPr>
+          <p:cNvSpPr>
+            <a:spLocks xmlns:a="http://schemas.openxmlformats.org/drawingml/2006/main" noGrp="1"/>
+          </p:cNvSpPr>
+          <p:nvPr/>
+        </p:nvSpPr>
+        <p:spPr>
+          <a:xfrm xmlns:a="http://schemas.openxmlformats.org/drawingml/2006/main">
+            <a:off x="3981450" y="3790950"/>
+            <a:ext cx="1809750" cy="361950"/>
+          </a:xfrm>
+          <a:prstGeom xmlns:a="http://schemas.openxmlformats.org/drawingml/2006/main" prst="rect">
+            <a:avLst/>
+          </a:prstGeom>
+          <a:noFill xmlns:a="http://schemas.openxmlformats.org/drawingml/2006/main"/>
+          <a:ln xmlns:a="http://schemas.openxmlformats.org/drawingml/2006/main" w="0">
+            <a:noFill/>
+            <a:prstDash val="solid"/>
+          </a:ln>
+        </p:spPr>
+        <p:txBody>
+          <a:bodyPr xmlns:a="http://schemas.openxmlformats.org/drawingml/2006/main"/>
+          <a:lstStyle xmlns:a="http://schemas.openxmlformats.org/drawingml/2006/main"/>
+          <a:p xmlns:a="http://schemas.openxmlformats.org/drawingml/2006/main">
+            <a:pPr>
+              <a:defRPr sz="1350">
+                <a:solidFill>
+                  <a:srgbClr val="000000"/>
+                </a:solidFill>
+              </a:defRPr>
+            </a:pPr>
+            <a:r>
+              <a:rPr sz="1350">
+                <a:solidFill>
+                  <a:srgbClr val="000000"/>
+                </a:solidFill>
+              </a:rPr>
+              <a:t>windows favored direct on mean trace return</a:t>
+            </a:r>
+          </a:p>
+        </p:txBody>
+      </p:sp>
+      <p:sp>
+        <p:nvSpPr>
+          <p:cNvPr id="10" name="">
+            <a:extLst xmlns:a="http://schemas.openxmlformats.org/drawingml/2006/main">
+              <a:ext uri="{FF2B5EF4-FFF2-40B4-BE49-F238E27FC236}">
+                <a16:creationId xmlns:a16="http://schemas.microsoft.com/office/drawing/2014/main" id="{09E7609A-1488-4FCC-8F9F-4671F0B231BC}"/>
+              </a:ext>
+            </a:extLst>
+          </p:cNvPr>
+          <p:cNvSpPr>
+            <a:spLocks xmlns:a="http://schemas.openxmlformats.org/drawingml/2006/main" noGrp="1"/>
+          </p:cNvSpPr>
+          <p:nvPr/>
+        </p:nvSpPr>
+        <p:spPr>
+          <a:xfrm xmlns:a="http://schemas.openxmlformats.org/drawingml/2006/main">
+            <a:off x="6648450" y="2990850"/>
+            <a:ext cx="2381250" cy="1276350"/>
+          </a:xfrm>
+          <a:prstGeom xmlns:a="http://schemas.openxmlformats.org/drawingml/2006/main" prst="rect">
+            <a:avLst/>
+          </a:prstGeom>
+          <a:solidFill xmlns:a="http://schemas.openxmlformats.org/drawingml/2006/main">
+            <a:srgbClr val="F4F4F4"/>
+          </a:solidFill>
+          <a:ln xmlns:a="http://schemas.openxmlformats.org/drawingml/2006/main" w="0">
+            <a:noFill/>
+            <a:prstDash val="solid"/>
+          </a:ln>
+        </p:spPr>
+      </p:sp>
+      <p:sp>
+        <p:nvSpPr>
+          <p:cNvPr id="11" name="">
+            <a:extLst xmlns:a="http://schemas.openxmlformats.org/drawingml/2006/main">
+              <a:ext uri="{FF2B5EF4-FFF2-40B4-BE49-F238E27FC236}">
+                <a16:creationId xmlns:a16="http://schemas.microsoft.com/office/drawing/2014/main" id="{4B2A6440-2586-4BC5-A1F3-446874CE03E9}"/>
+              </a:ext>
+            </a:extLst>
+          </p:cNvPr>
+          <p:cNvSpPr>
+            <a:spLocks xmlns:a="http://schemas.openxmlformats.org/drawingml/2006/main" noGrp="1"/>
+          </p:cNvSpPr>
+          <p:nvPr/>
+        </p:nvSpPr>
+        <p:spPr>
+          <a:xfrm xmlns:a="http://schemas.openxmlformats.org/drawingml/2006/main">
+            <a:off x="6915150" y="3162300"/>
+            <a:ext cx="1809750" cy="514350"/>
+          </a:xfrm>
+          <a:prstGeom xmlns:a="http://schemas.openxmlformats.org/drawingml/2006/main" prst="rect">
+            <a:avLst/>
+          </a:prstGeom>
+          <a:noFill xmlns:a="http://schemas.openxmlformats.org/drawingml/2006/main"/>
+          <a:ln xmlns:a="http://schemas.openxmlformats.org/drawingml/2006/main" w="0">
+            <a:noFill/>
+            <a:prstDash val="solid"/>
+          </a:ln>
+        </p:spPr>
+        <p:txBody>
+          <a:bodyPr xmlns:a="http://schemas.openxmlformats.org/drawingml/2006/main"/>
+          <a:lstStyle xmlns:a="http://schemas.openxmlformats.org/drawingml/2006/main"/>
+          <a:p xmlns:a="http://schemas.openxmlformats.org/drawingml/2006/main">
+            <a:pPr>
+              <a:defRPr sz="3150" b="1">
+                <a:solidFill>
+                  <a:srgbClr val="1B7F5A"/>
+                </a:solidFill>
+              </a:defRPr>
+            </a:pPr>
+            <a:r>
+              <a:rPr sz="3150" b="1">
+                <a:solidFill>
+                  <a:srgbClr val="1B7F5A"/>
+                </a:solidFill>
+              </a:rPr>
+              <a:t>2 of 5</a:t>
+            </a:r>
+          </a:p>
+        </p:txBody>
+      </p:sp>
+      <p:sp>
+        <p:nvSpPr>
+          <p:cNvPr id="12" name="">
+            <a:extLst xmlns:a="http://schemas.openxmlformats.org/drawingml/2006/main">
+              <a:ext uri="{FF2B5EF4-FFF2-40B4-BE49-F238E27FC236}">
+                <a16:creationId xmlns:a16="http://schemas.microsoft.com/office/drawing/2014/main" id="{BAB75477-DD07-4DFE-B55B-0CBCC3084ECD}"/>
+              </a:ext>
+            </a:extLst>
+          </p:cNvPr>
+          <p:cNvSpPr>
+            <a:spLocks xmlns:a="http://schemas.openxmlformats.org/drawingml/2006/main" noGrp="1"/>
+          </p:cNvSpPr>
+          <p:nvPr/>
+        </p:nvSpPr>
+        <p:spPr>
+          <a:xfrm xmlns:a="http://schemas.openxmlformats.org/drawingml/2006/main">
+            <a:off x="6915150" y="3790950"/>
+            <a:ext cx="1809750" cy="361950"/>
+          </a:xfrm>
+          <a:prstGeom xmlns:a="http://schemas.openxmlformats.org/drawingml/2006/main" prst="rect">
+            <a:avLst/>
+          </a:prstGeom>
+          <a:noFill xmlns:a="http://schemas.openxmlformats.org/drawingml/2006/main"/>
+          <a:ln xmlns:a="http://schemas.openxmlformats.org/drawingml/2006/main" w="0">
+            <a:noFill/>
+            <a:prstDash val="solid"/>
+          </a:ln>
+        </p:spPr>
+        <p:txBody>
+          <a:bodyPr xmlns:a="http://schemas.openxmlformats.org/drawingml/2006/main"/>
+          <a:lstStyle xmlns:a="http://schemas.openxmlformats.org/drawingml/2006/main"/>
+          <a:p xmlns:a="http://schemas.openxmlformats.org/drawingml/2006/main">
+            <a:pPr>
+              <a:defRPr sz="1350">
+                <a:solidFill>
+                  <a:srgbClr val="000000"/>
+                </a:solidFill>
+              </a:defRPr>
+            </a:pPr>
+            <a:r>
+              <a:rPr sz="1350">
+                <a:solidFill>
+                  <a:srgbClr val="000000"/>
+                </a:solidFill>
+              </a:rPr>
+              <a:t>weak windows favored pooled defensiveness</a:t>
+            </a:r>
+          </a:p>
+        </p:txBody>
+      </p:sp>
+      <p:sp>
+        <p:nvSpPr>
+          <p:cNvPr id="13" name="">
+            <a:extLst xmlns:a="http://schemas.openxmlformats.org/drawingml/2006/main">
+              <a:ext uri="{FF2B5EF4-FFF2-40B4-BE49-F238E27FC236}">
+                <a16:creationId xmlns:a16="http://schemas.microsoft.com/office/drawing/2014/main" id="{5197D8FB-FE21-4885-8F69-821A12EDC93C}"/>
+              </a:ext>
+            </a:extLst>
+          </p:cNvPr>
+          <p:cNvSpPr>
+            <a:spLocks xmlns:a="http://schemas.openxmlformats.org/drawingml/2006/main" noGrp="1"/>
+          </p:cNvSpPr>
+          <p:nvPr/>
+        </p:nvSpPr>
+        <p:spPr>
+          <a:xfrm xmlns:a="http://schemas.openxmlformats.org/drawingml/2006/main">
+            <a:off x="9582150" y="2990850"/>
+            <a:ext cx="1619250" cy="1276350"/>
+          </a:xfrm>
+          <a:prstGeom xmlns:a="http://schemas.openxmlformats.org/drawingml/2006/main" prst="rect">
+            <a:avLst/>
+          </a:prstGeom>
+          <a:solidFill xmlns:a="http://schemas.openxmlformats.org/drawingml/2006/main">
+            <a:srgbClr val="F4F4F4"/>
+          </a:solidFill>
+          <a:ln xmlns:a="http://schemas.openxmlformats.org/drawingml/2006/main" w="0">
+            <a:noFill/>
+            <a:prstDash val="solid"/>
+          </a:ln>
+        </p:spPr>
+      </p:sp>
+      <p:sp>
+        <p:nvSpPr>
+          <p:cNvPr id="14" name="">
+            <a:extLst xmlns:a="http://schemas.openxmlformats.org/drawingml/2006/main">
+              <a:ext uri="{FF2B5EF4-FFF2-40B4-BE49-F238E27FC236}">
+                <a16:creationId xmlns:a16="http://schemas.microsoft.com/office/drawing/2014/main" id="{265E56EB-CC9D-4FA8-8401-D4529E959945}"/>
+              </a:ext>
+            </a:extLst>
+          </p:cNvPr>
+          <p:cNvSpPr>
+            <a:spLocks xmlns:a="http://schemas.openxmlformats.org/drawingml/2006/main" noGrp="1"/>
+          </p:cNvSpPr>
+          <p:nvPr/>
+        </p:nvSpPr>
+        <p:spPr>
+          <a:xfrm xmlns:a="http://schemas.openxmlformats.org/drawingml/2006/main">
+            <a:off x="9810750" y="3257550"/>
+            <a:ext cx="1143000" cy="419100"/>
+          </a:xfrm>
+          <a:prstGeom xmlns:a="http://schemas.openxmlformats.org/drawingml/2006/main" prst="rect">
+            <a:avLst/>
+          </a:prstGeom>
+          <a:noFill xmlns:a="http://schemas.openxmlformats.org/drawingml/2006/main"/>
+          <a:ln xmlns:a="http://schemas.openxmlformats.org/drawingml/2006/main" w="0">
+            <a:noFill/>
+            <a:prstDash val="solid"/>
+          </a:ln>
+        </p:spPr>
+        <p:txBody>
+          <a:bodyPr xmlns:a="http://schemas.openxmlformats.org/drawingml/2006/main"/>
+          <a:lstStyle xmlns:a="http://schemas.openxmlformats.org/drawingml/2006/main"/>
+          <a:p xmlns:a="http://schemas.openxmlformats.org/drawingml/2006/main">
+            <a:pPr>
+              <a:defRPr sz="2550" b="1">
+                <a:solidFill>
+                  <a:srgbClr val="1D4ED8"/>
+                </a:solidFill>
+              </a:defRPr>
+            </a:pPr>
+            <a:r>
+              <a:rPr sz="2550" b="1">
+                <a:solidFill>
+                  <a:srgbClr val="1D4ED8"/>
+                </a:solidFill>
+              </a:rPr>
+              <a:t>MSTR</a:t>
+            </a:r>
+          </a:p>
+        </p:txBody>
+      </p:sp>
+      <p:sp>
+        <p:nvSpPr>
+          <p:cNvPr id="15" name="">
+            <a:extLst xmlns:a="http://schemas.openxmlformats.org/drawingml/2006/main">
+              <a:ext uri="{FF2B5EF4-FFF2-40B4-BE49-F238E27FC236}">
+                <a16:creationId xmlns:a16="http://schemas.microsoft.com/office/drawing/2014/main" id="{3AB9FBB0-34F2-419C-B286-7530F261C788}"/>
+              </a:ext>
+            </a:extLst>
+          </p:cNvPr>
+          <p:cNvSpPr>
+            <a:spLocks xmlns:a="http://schemas.openxmlformats.org/drawingml/2006/main" noGrp="1"/>
+          </p:cNvSpPr>
+          <p:nvPr/>
+        </p:nvSpPr>
+        <p:spPr>
+          <a:xfrm xmlns:a="http://schemas.openxmlformats.org/drawingml/2006/main">
+            <a:off x="9810750" y="3790950"/>
+            <a:ext cx="1143000" cy="361950"/>
+          </a:xfrm>
+          <a:prstGeom xmlns:a="http://schemas.openxmlformats.org/drawingml/2006/main" prst="rect">
+            <a:avLst/>
+          </a:prstGeom>
+          <a:noFill xmlns:a="http://schemas.openxmlformats.org/drawingml/2006/main"/>
+          <a:ln xmlns:a="http://schemas.openxmlformats.org/drawingml/2006/main" w="0">
+            <a:noFill/>
+            <a:prstDash val="solid"/>
+          </a:ln>
+        </p:spPr>
+        <p:txBody>
+          <a:bodyPr xmlns:a="http://schemas.openxmlformats.org/drawingml/2006/main"/>
+          <a:lstStyle xmlns:a="http://schemas.openxmlformats.org/drawingml/2006/main"/>
+          <a:p xmlns:a="http://schemas.openxmlformats.org/drawingml/2006/main">
+            <a:pPr>
+              <a:defRPr sz="1275">
+                <a:solidFill>
+                  <a:srgbClr val="000000"/>
+                </a:solidFill>
+              </a:defRPr>
+            </a:pPr>
+            <a:r>
+              <a:rPr sz="1275">
+                <a:solidFill>
+                  <a:srgbClr val="000000"/>
+                </a:solidFill>
+              </a:rPr>
+              <a:t>drove direct 2025Q1 upside</a:t>
+            </a:r>
+          </a:p>
+        </p:txBody>
+      </p:sp>
+      <p:sp>
+        <p:nvSpPr>
+          <p:cNvPr id="16" name="">
+            <a:extLst xmlns:a="http://schemas.openxmlformats.org/drawingml/2006/main">
+              <a:ext uri="{FF2B5EF4-FFF2-40B4-BE49-F238E27FC236}">
+                <a16:creationId xmlns:a16="http://schemas.microsoft.com/office/drawing/2014/main" id="{576F942D-D15E-4E25-A6D4-5384686318A4}"/>
+              </a:ext>
+            </a:extLst>
+          </p:cNvPr>
+          <p:cNvSpPr>
+            <a:spLocks xmlns:a="http://schemas.openxmlformats.org/drawingml/2006/main" noGrp="1"/>
+          </p:cNvSpPr>
+          <p:nvPr/>
+        </p:nvSpPr>
+        <p:spPr>
+          <a:xfrm xmlns:a="http://schemas.openxmlformats.org/drawingml/2006/main">
+            <a:off x="914400" y="4762500"/>
+            <a:ext cx="2286000" cy="323850"/>
           </a:xfrm>
           <a:prstGeom xmlns:a="http://schemas.openxmlformats.org/drawingml/2006/main" prst="rect">
             <a:avLst/>
@@ -2506,29 +3164,29 @@
                   <a:srgbClr val="000000"/>
                 </a:solidFill>
               </a:rPr>
-              <a:t>Reason to run B_hist</a:t>
-            </a:r>
-          </a:p>
-        </p:txBody>
-      </p:sp>
-      <p:sp>
-        <p:nvSpPr>
-          <p:cNvPr id="5" name="">
-            <a:extLst xmlns:a="http://schemas.openxmlformats.org/drawingml/2006/main">
-              <a:ext uri="{FF2B5EF4-FFF2-40B4-BE49-F238E27FC236}">
-                <a16:creationId xmlns:a16="http://schemas.microsoft.com/office/drawing/2014/main" id="{B5B5C60C-F385-446E-BD76-31F2D3D94AA7}"/>
-              </a:ext>
-            </a:extLst>
-          </p:cNvPr>
-          <p:cNvSpPr>
-            <a:spLocks xmlns:a="http://schemas.openxmlformats.org/drawingml/2006/main" noGrp="1"/>
-          </p:cNvSpPr>
-          <p:nvPr/>
-        </p:nvSpPr>
-        <p:spPr>
-          <a:xfrm xmlns:a="http://schemas.openxmlformats.org/drawingml/2006/main">
-            <a:off x="914400" y="3524250"/>
-            <a:ext cx="4762500" cy="1257300"/>
+              <a:t>Meaning</a:t>
+            </a:r>
+          </a:p>
+        </p:txBody>
+      </p:sp>
+      <p:sp>
+        <p:nvSpPr>
+          <p:cNvPr id="17" name="">
+            <a:extLst xmlns:a="http://schemas.openxmlformats.org/drawingml/2006/main">
+              <a:ext uri="{FF2B5EF4-FFF2-40B4-BE49-F238E27FC236}">
+                <a16:creationId xmlns:a16="http://schemas.microsoft.com/office/drawing/2014/main" id="{3832B9EC-F0F3-4B37-94E8-E3F9CE8B2B97}"/>
+              </a:ext>
+            </a:extLst>
+          </p:cNvPr>
+          <p:cNvSpPr>
+            <a:spLocks xmlns:a="http://schemas.openxmlformats.org/drawingml/2006/main" noGrp="1"/>
+          </p:cNvSpPr>
+          <p:nvPr/>
+        </p:nvSpPr>
+        <p:spPr>
+          <a:xfrm xmlns:a="http://schemas.openxmlformats.org/drawingml/2006/main">
+            <a:off x="914400" y="5162550"/>
+            <a:ext cx="9334500" cy="590550"/>
           </a:xfrm>
           <a:prstGeom xmlns:a="http://schemas.openxmlformats.org/drawingml/2006/main" prst="rect">
             <a:avLst/>
@@ -2556,266 +3214,17 @@
                   <a:srgbClr val="000000"/>
                 </a:solidFill>
               </a:rPr>
-              <a:t>• Test whether pooled-family behaves better in older market regimes.</a:t>
-            </a:r>
-          </a:p>
-          <a:p xmlns:a="http://schemas.openxmlformats.org/drawingml/2006/main">
-            <a:pPr>
-              <a:defRPr sz="1575">
-                <a:solidFill>
-                  <a:srgbClr val="000000"/>
-                </a:solidFill>
-              </a:defRPr>
-            </a:pPr>
-            <a:r>
-              <a:rPr sz="1575">
-                <a:solidFill>
-                  <a:srgbClr val="000000"/>
-                </a:solidFill>
-              </a:rPr>
-              <a:t>• Decide whether selection policy belongs in future factorial screens.</a:t>
-            </a:r>
-          </a:p>
-          <a:p xmlns:a="http://schemas.openxmlformats.org/drawingml/2006/main">
-            <a:pPr>
-              <a:defRPr sz="1575">
-                <a:solidFill>
-                  <a:srgbClr val="000000"/>
-                </a:solidFill>
-              </a:defRPr>
-            </a:pPr>
-            <a:r>
-              <a:rPr sz="1575">
-                <a:solidFill>
-                  <a:srgbClr val="000000"/>
-                </a:solidFill>
-              </a:rPr>
-              <a:t>• Build collaborator-facing evidence beyond the recent live basket.</a:t>
-            </a:r>
-          </a:p>
-        </p:txBody>
-      </p:sp>
-      <p:sp>
-        <p:nvSpPr>
-          <p:cNvPr id="6" name="">
-            <a:extLst xmlns:a="http://schemas.openxmlformats.org/drawingml/2006/main">
-              <a:ext uri="{FF2B5EF4-FFF2-40B4-BE49-F238E27FC236}">
-                <a16:creationId xmlns:a16="http://schemas.microsoft.com/office/drawing/2014/main" id="{689C8111-9BD0-4F2D-8FF4-A7E3EF0309ED}"/>
-              </a:ext>
-            </a:extLst>
-          </p:cNvPr>
-          <p:cNvSpPr>
-            <a:spLocks xmlns:a="http://schemas.openxmlformats.org/drawingml/2006/main" noGrp="1"/>
-          </p:cNvSpPr>
-          <p:nvPr/>
-        </p:nvSpPr>
-        <p:spPr>
-          <a:xfrm xmlns:a="http://schemas.openxmlformats.org/drawingml/2006/main">
-            <a:off x="6667500" y="3028950"/>
-            <a:ext cx="3143250" cy="323850"/>
-          </a:xfrm>
-          <a:prstGeom xmlns:a="http://schemas.openxmlformats.org/drawingml/2006/main" prst="rect">
-            <a:avLst/>
-          </a:prstGeom>
-          <a:noFill xmlns:a="http://schemas.openxmlformats.org/drawingml/2006/main"/>
-          <a:ln xmlns:a="http://schemas.openxmlformats.org/drawingml/2006/main" w="0">
-            <a:noFill/>
-            <a:prstDash val="solid"/>
-          </a:ln>
-        </p:spPr>
-        <p:txBody>
-          <a:bodyPr xmlns:a="http://schemas.openxmlformats.org/drawingml/2006/main"/>
-          <a:lstStyle xmlns:a="http://schemas.openxmlformats.org/drawingml/2006/main"/>
-          <a:p xmlns:a="http://schemas.openxmlformats.org/drawingml/2006/main">
-            <a:pPr>
-              <a:defRPr sz="1875" b="1">
-                <a:solidFill>
-                  <a:srgbClr val="000000"/>
-                </a:solidFill>
-              </a:defRPr>
-            </a:pPr>
-            <a:r>
-              <a:rPr sz="1875" b="1">
-                <a:solidFill>
-                  <a:srgbClr val="000000"/>
-                </a:solidFill>
-              </a:rPr>
-              <a:t>Reason to pause</a:t>
-            </a:r>
-          </a:p>
-        </p:txBody>
-      </p:sp>
-      <p:sp>
-        <p:nvSpPr>
-          <p:cNvPr id="7" name="">
-            <a:extLst xmlns:a="http://schemas.openxmlformats.org/drawingml/2006/main">
-              <a:ext uri="{FF2B5EF4-FFF2-40B4-BE49-F238E27FC236}">
-                <a16:creationId xmlns:a16="http://schemas.microsoft.com/office/drawing/2014/main" id="{7D546A06-ED08-4835-8227-A7567348A0E9}"/>
-              </a:ext>
-            </a:extLst>
-          </p:cNvPr>
-          <p:cNvSpPr>
-            <a:spLocks xmlns:a="http://schemas.openxmlformats.org/drawingml/2006/main" noGrp="1"/>
-          </p:cNvSpPr>
-          <p:nvPr/>
-        </p:nvSpPr>
-        <p:spPr>
-          <a:xfrm xmlns:a="http://schemas.openxmlformats.org/drawingml/2006/main">
-            <a:off x="6667500" y="3524250"/>
-            <a:ext cx="4762500" cy="1257300"/>
-          </a:xfrm>
-          <a:prstGeom xmlns:a="http://schemas.openxmlformats.org/drawingml/2006/main" prst="rect">
-            <a:avLst/>
-          </a:prstGeom>
-          <a:noFill xmlns:a="http://schemas.openxmlformats.org/drawingml/2006/main"/>
-          <a:ln xmlns:a="http://schemas.openxmlformats.org/drawingml/2006/main" w="0">
-            <a:noFill/>
-            <a:prstDash val="solid"/>
-          </a:ln>
-        </p:spPr>
-        <p:txBody>
-          <a:bodyPr xmlns:a="http://schemas.openxmlformats.org/drawingml/2006/main"/>
-          <a:lstStyle xmlns:a="http://schemas.openxmlformats.org/drawingml/2006/main"/>
-          <a:p xmlns:a="http://schemas.openxmlformats.org/drawingml/2006/main">
-            <a:pPr>
-              <a:defRPr sz="1575">
-                <a:solidFill>
-                  <a:srgbClr val="000000"/>
-                </a:solidFill>
-              </a:defRPr>
-            </a:pPr>
-            <a:r>
-              <a:rPr sz="1575">
-                <a:solidFill>
-                  <a:srgbClr val="000000"/>
-                </a:solidFill>
-              </a:rPr>
-              <a:t>• A_live already favors keeping direct as the bridge default.</a:t>
-            </a:r>
-          </a:p>
-          <a:p xmlns:a="http://schemas.openxmlformats.org/drawingml/2006/main">
-            <a:pPr>
-              <a:defRPr sz="1575">
-                <a:solidFill>
-                  <a:srgbClr val="000000"/>
-                </a:solidFill>
-              </a:defRPr>
-            </a:pPr>
-            <a:r>
-              <a:rPr sz="1575">
-                <a:solidFill>
-                  <a:srgbClr val="000000"/>
-                </a:solidFill>
-              </a:rPr>
-              <a:t>• B_hist is compute-heavy and changes the traded basket.</a:t>
-            </a:r>
-          </a:p>
-          <a:p xmlns:a="http://schemas.openxmlformats.org/drawingml/2006/main">
-            <a:pPr>
-              <a:defRPr sz="1575">
-                <a:solidFill>
-                  <a:srgbClr val="000000"/>
-                </a:solidFill>
-              </a:defRPr>
-            </a:pPr>
-            <a:r>
-              <a:rPr sz="1575">
-                <a:solidFill>
-                  <a:srgbClr val="000000"/>
-                </a:solidFill>
-              </a:rPr>
-              <a:t>• It should not be merged into one winner table with A_live.</a:t>
-            </a:r>
-          </a:p>
-        </p:txBody>
-      </p:sp>
-      <p:sp>
-        <p:nvSpPr>
-          <p:cNvPr id="8" name="">
-            <a:extLst xmlns:a="http://schemas.openxmlformats.org/drawingml/2006/main">
-              <a:ext uri="{FF2B5EF4-FFF2-40B4-BE49-F238E27FC236}">
-                <a16:creationId xmlns:a16="http://schemas.microsoft.com/office/drawing/2014/main" id="{2DFE7CED-68D2-4157-939A-7D0870E5C271}"/>
-              </a:ext>
-            </a:extLst>
-          </p:cNvPr>
-          <p:cNvSpPr>
-            <a:spLocks xmlns:a="http://schemas.openxmlformats.org/drawingml/2006/main" noGrp="1"/>
-          </p:cNvSpPr>
-          <p:nvPr/>
-        </p:nvSpPr>
-        <p:spPr>
-          <a:xfrm xmlns:a="http://schemas.openxmlformats.org/drawingml/2006/main">
-            <a:off x="876300" y="5257800"/>
-            <a:ext cx="10439400" cy="514350"/>
-          </a:xfrm>
-          <a:prstGeom xmlns:a="http://schemas.openxmlformats.org/drawingml/2006/main" prst="rect">
-            <a:avLst/>
-          </a:prstGeom>
-          <a:solidFill xmlns:a="http://schemas.openxmlformats.org/drawingml/2006/main">
-            <a:srgbClr val="FFE1D6"/>
-          </a:solidFill>
-          <a:ln xmlns:a="http://schemas.openxmlformats.org/drawingml/2006/main" w="0">
-            <a:noFill/>
-            <a:prstDash val="solid"/>
-          </a:ln>
-        </p:spPr>
-      </p:sp>
-      <p:sp>
-        <p:nvSpPr>
-          <p:cNvPr id="9" name="">
-            <a:extLst xmlns:a="http://schemas.openxmlformats.org/drawingml/2006/main">
-              <a:ext uri="{FF2B5EF4-FFF2-40B4-BE49-F238E27FC236}">
-                <a16:creationId xmlns:a16="http://schemas.microsoft.com/office/drawing/2014/main" id="{C645926B-2632-4405-860C-957C2C787C99}"/>
-              </a:ext>
-            </a:extLst>
-          </p:cNvPr>
-          <p:cNvSpPr>
-            <a:spLocks xmlns:a="http://schemas.openxmlformats.org/drawingml/2006/main" noGrp="1"/>
-          </p:cNvSpPr>
-          <p:nvPr/>
-        </p:nvSpPr>
-        <p:spPr>
-          <a:xfrm xmlns:a="http://schemas.openxmlformats.org/drawingml/2006/main">
-            <a:off x="1143000" y="5410200"/>
-            <a:ext cx="9810750" cy="247650"/>
-          </a:xfrm>
-          <a:prstGeom xmlns:a="http://schemas.openxmlformats.org/drawingml/2006/main" prst="rect">
-            <a:avLst/>
-          </a:prstGeom>
-          <a:noFill xmlns:a="http://schemas.openxmlformats.org/drawingml/2006/main"/>
-          <a:ln xmlns:a="http://schemas.openxmlformats.org/drawingml/2006/main" w="0">
-            <a:noFill/>
-            <a:prstDash val="solid"/>
-          </a:ln>
-        </p:spPr>
-        <p:txBody>
-          <a:bodyPr xmlns:a="http://schemas.openxmlformats.org/drawingml/2006/main"/>
-          <a:lstStyle xmlns:a="http://schemas.openxmlformats.org/drawingml/2006/main"/>
-          <a:p xmlns:a="http://schemas.openxmlformats.org/drawingml/2006/main">
-            <a:pPr>
-              <a:defRPr sz="1500" b="1">
-                <a:solidFill>
-                  <a:srgbClr val="000000"/>
-                </a:solidFill>
-              </a:defRPr>
-            </a:pPr>
-            <a:r>
-              <a:rPr sz="1500" b="1">
-                <a:solidFill>
-                  <a:srgbClr val="000000"/>
-                </a:solidFill>
-              </a:rPr>
-              <a:t>Recommended posture: keep direct as default, preserve pooled-family as an optional research factor, and run B_hist only if older-regime robustness is the next decision.</a:t>
-            </a:r>
-          </a:p>
-        </p:txBody>
-      </p:sp>
-      <p:sp>
-        <p:nvSpPr>
-          <p:cNvPr id="10" name="">
-            <a:extLst xmlns:a="http://schemas.openxmlformats.org/drawingml/2006/main">
-              <a:ext uri="{FF2B5EF4-FFF2-40B4-BE49-F238E27FC236}">
-                <a16:creationId xmlns:a16="http://schemas.microsoft.com/office/drawing/2014/main" id="{74B84DAC-1421-46BD-8900-A779A6EAAC1B}"/>
+              <a:t>B_hist does not overturn A_live. It says pooled-family is not merely a Gen4 compatibility artifact: it may be a constrained, sometimes defensive research policy worth testing explicitly.</a:t>
+            </a:r>
+          </a:p>
+        </p:txBody>
+      </p:sp>
+      <p:sp>
+        <p:nvSpPr>
+          <p:cNvPr id="18" name="">
+            <a:extLst xmlns:a="http://schemas.openxmlformats.org/drawingml/2006/main">
+              <a:ext uri="{FF2B5EF4-FFF2-40B4-BE49-F238E27FC236}">
+                <a16:creationId xmlns:a16="http://schemas.microsoft.com/office/drawing/2014/main" id="{93539E5E-5D81-49D4-851F-A63B950DE764}"/>
               </a:ext>
             </a:extLst>
           </p:cNvPr>
@@ -2845,10 +3254,10 @@
       </p:sp>
       <p:sp>
         <p:nvSpPr>
-          <p:cNvPr id="11" name="">
-            <a:extLst xmlns:a="http://schemas.openxmlformats.org/drawingml/2006/main">
-              <a:ext uri="{FF2B5EF4-FFF2-40B4-BE49-F238E27FC236}">
-                <a16:creationId xmlns:a16="http://schemas.microsoft.com/office/drawing/2014/main" id="{BFD2C67C-831E-4187-9FC8-C966AE74198A}"/>
+          <p:cNvPr id="19" name="">
+            <a:extLst xmlns:a="http://schemas.openxmlformats.org/drawingml/2006/main">
+              <a:ext uri="{FF2B5EF4-FFF2-40B4-BE49-F238E27FC236}">
+                <a16:creationId xmlns:a16="http://schemas.microsoft.com/office/drawing/2014/main" id="{386B52AB-E7C0-4C7F-8E09-38B9EE375A17}"/>
               </a:ext>
             </a:extLst>
           </p:cNvPr>
@@ -2895,10 +3304,10 @@
       </p:sp>
       <p:sp>
         <p:nvSpPr>
-          <p:cNvPr id="12" name="">
-            <a:extLst xmlns:a="http://schemas.openxmlformats.org/drawingml/2006/main">
-              <a:ext uri="{FF2B5EF4-FFF2-40B4-BE49-F238E27FC236}">
-                <a16:creationId xmlns:a16="http://schemas.microsoft.com/office/drawing/2014/main" id="{FEF6EE1A-B27E-4E7E-8E4C-2E529DFE38C4}"/>
+          <p:cNvPr id="20" name="">
+            <a:extLst xmlns:a="http://schemas.openxmlformats.org/drawingml/2006/main">
+              <a:ext uri="{FF2B5EF4-FFF2-40B4-BE49-F238E27FC236}">
+                <a16:creationId xmlns:a16="http://schemas.microsoft.com/office/drawing/2014/main" id="{8C9FE54E-B6C0-4A90-9DF4-F5393DE49DC7}"/>
               </a:ext>
             </a:extLst>
           </p:cNvPr>
@@ -2946,7 +3355,7 @@
     </p:spTree>
     <p:extLst>
       <p:ext uri="{BB962C8B-B14F-4D97-AF65-F5344CB8AC3E}">
-        <p14:creationId xmlns:p14="http://schemas.microsoft.com/office/powerpoint/2010/main" val="1808578038"/>
+        <p14:creationId xmlns:p14="http://schemas.microsoft.com/office/powerpoint/2010/main" val="2128678238"/>
       </p:ext>
     </p:extLst>
   </p:cSld>
@@ -2977,7 +3386,7 @@
           <p:cNvPr id="1" name="">
             <a:extLst xmlns:a="http://schemas.openxmlformats.org/drawingml/2006/main">
               <a:ext uri="{FF2B5EF4-FFF2-40B4-BE49-F238E27FC236}">
-                <a16:creationId xmlns:a16="http://schemas.microsoft.com/office/drawing/2014/main" id="{8DE661A8-6E2B-454B-B75E-FAAD54397805}"/>
+                <a16:creationId xmlns:a16="http://schemas.microsoft.com/office/drawing/2014/main" id="{0516CE35-AD04-4304-AEE0-4A415FA94E59}"/>
               </a:ext>
             </a:extLst>
           </p:cNvPr>
@@ -3017,7 +3426,7 @@
                   <a:srgbClr val="555555"/>
                 </a:solidFill>
               </a:rPr>
-              <a:t>VISUAL EVIDENCE</a:t>
+              <a:t>DECISION POSTURE</a:t>
             </a:r>
           </a:p>
         </p:txBody>
@@ -3027,7 +3436,7 @@
           <p:cNvPr id="2" name="">
             <a:extLst xmlns:a="http://schemas.openxmlformats.org/drawingml/2006/main">
               <a:ext uri="{FF2B5EF4-FFF2-40B4-BE49-F238E27FC236}">
-                <a16:creationId xmlns:a16="http://schemas.microsoft.com/office/drawing/2014/main" id="{4EAAE26B-7FC2-416D-B22A-6AF10C4AC276}"/>
+                <a16:creationId xmlns:a16="http://schemas.microsoft.com/office/drawing/2014/main" id="{D9DFD6FF-8B4F-45E7-9348-30F659A7E811}"/>
               </a:ext>
             </a:extLst>
           </p:cNvPr>
@@ -3055,6 +3464,667 @@
           <a:lstStyle xmlns:a="http://schemas.openxmlformats.org/drawingml/2006/main"/>
           <a:p xmlns:a="http://schemas.openxmlformats.org/drawingml/2006/main">
             <a:pPr>
+              <a:defRPr sz="2700" b="1">
+                <a:solidFill>
+                  <a:srgbClr val="000000"/>
+                </a:solidFill>
+              </a:defRPr>
+            </a:pPr>
+            <a:r>
+              <a:rPr sz="2700" b="1">
+                <a:solidFill>
+                  <a:srgbClr val="000000"/>
+                </a:solidFill>
+              </a:rPr>
+              <a:t>Do not crown a winner; declare selection policy as a research factor</a:t>
+            </a:r>
+          </a:p>
+        </p:txBody>
+      </p:sp>
+      <p:sp>
+        <p:nvSpPr>
+          <p:cNvPr id="3" name="">
+            <a:extLst xmlns:a="http://schemas.openxmlformats.org/drawingml/2006/main">
+              <a:ext uri="{FF2B5EF4-FFF2-40B4-BE49-F238E27FC236}">
+                <a16:creationId xmlns:a16="http://schemas.microsoft.com/office/drawing/2014/main" id="{D1541955-CD17-4912-8CCA-45002576DAF3}"/>
+              </a:ext>
+            </a:extLst>
+          </p:cNvPr>
+          <p:cNvSpPr>
+            <a:spLocks xmlns:a="http://schemas.openxmlformats.org/drawingml/2006/main" noGrp="1"/>
+          </p:cNvSpPr>
+          <p:nvPr/>
+        </p:nvSpPr>
+        <p:spPr>
+          <a:xfrm xmlns:a="http://schemas.openxmlformats.org/drawingml/2006/main">
+            <a:off x="400050" y="1943100"/>
+            <a:ext cx="10096500" cy="685800"/>
+          </a:xfrm>
+          <a:prstGeom xmlns:a="http://schemas.openxmlformats.org/drawingml/2006/main" prst="rect">
+            <a:avLst/>
+          </a:prstGeom>
+          <a:noFill xmlns:a="http://schemas.openxmlformats.org/drawingml/2006/main"/>
+          <a:ln xmlns:a="http://schemas.openxmlformats.org/drawingml/2006/main" w="0">
+            <a:noFill/>
+            <a:prstDash val="solid"/>
+          </a:ln>
+        </p:spPr>
+        <p:txBody>
+          <a:bodyPr xmlns:a="http://schemas.openxmlformats.org/drawingml/2006/main"/>
+          <a:lstStyle xmlns:a="http://schemas.openxmlformats.org/drawingml/2006/main"/>
+          <a:p xmlns:a="http://schemas.openxmlformats.org/drawingml/2006/main">
+            <a:pPr>
+              <a:defRPr sz="1725">
+                <a:solidFill>
+                  <a:srgbClr val="222222"/>
+                </a:solidFill>
+              </a:defRPr>
+            </a:pPr>
+            <a:r>
+              <a:rPr sz="1725">
+                <a:solidFill>
+                  <a:srgbClr val="222222"/>
+                </a:solidFill>
+              </a:rPr>
+              <a:t>The two lanes answer different questions. A_live is the bridge-relevance lane; B_hist is the older-regime robustness lane. They should be read side by side, not collapsed into one leaderboard.</a:t>
+            </a:r>
+          </a:p>
+        </p:txBody>
+      </p:sp>
+      <p:sp>
+        <p:nvSpPr>
+          <p:cNvPr id="4" name="">
+            <a:extLst xmlns:a="http://schemas.openxmlformats.org/drawingml/2006/main">
+              <a:ext uri="{FF2B5EF4-FFF2-40B4-BE49-F238E27FC236}">
+                <a16:creationId xmlns:a16="http://schemas.microsoft.com/office/drawing/2014/main" id="{A288423A-8BA6-4B4E-B0D9-D6A9D0BF0E01}"/>
+              </a:ext>
+            </a:extLst>
+          </p:cNvPr>
+          <p:cNvSpPr>
+            <a:spLocks xmlns:a="http://schemas.openxmlformats.org/drawingml/2006/main" noGrp="1"/>
+          </p:cNvSpPr>
+          <p:nvPr/>
+        </p:nvSpPr>
+        <p:spPr>
+          <a:xfrm xmlns:a="http://schemas.openxmlformats.org/drawingml/2006/main">
+            <a:off x="914400" y="3028950"/>
+            <a:ext cx="3143250" cy="323850"/>
+          </a:xfrm>
+          <a:prstGeom xmlns:a="http://schemas.openxmlformats.org/drawingml/2006/main" prst="rect">
+            <a:avLst/>
+          </a:prstGeom>
+          <a:noFill xmlns:a="http://schemas.openxmlformats.org/drawingml/2006/main"/>
+          <a:ln xmlns:a="http://schemas.openxmlformats.org/drawingml/2006/main" w="0">
+            <a:noFill/>
+            <a:prstDash val="solid"/>
+          </a:ln>
+        </p:spPr>
+        <p:txBody>
+          <a:bodyPr xmlns:a="http://schemas.openxmlformats.org/drawingml/2006/main"/>
+          <a:lstStyle xmlns:a="http://schemas.openxmlformats.org/drawingml/2006/main"/>
+          <a:p xmlns:a="http://schemas.openxmlformats.org/drawingml/2006/main">
+            <a:pPr>
+              <a:defRPr sz="1875" b="1">
+                <a:solidFill>
+                  <a:srgbClr val="000000"/>
+                </a:solidFill>
+              </a:defRPr>
+            </a:pPr>
+            <a:r>
+              <a:rPr sz="1875" b="1">
+                <a:solidFill>
+                  <a:srgbClr val="000000"/>
+                </a:solidFill>
+              </a:rPr>
+              <a:t>Keep now</a:t>
+            </a:r>
+          </a:p>
+        </p:txBody>
+      </p:sp>
+      <p:sp>
+        <p:nvSpPr>
+          <p:cNvPr id="5" name="">
+            <a:extLst xmlns:a="http://schemas.openxmlformats.org/drawingml/2006/main">
+              <a:ext uri="{FF2B5EF4-FFF2-40B4-BE49-F238E27FC236}">
+                <a16:creationId xmlns:a16="http://schemas.microsoft.com/office/drawing/2014/main" id="{AE617461-25DF-4F8D-AFC9-D0870D42F8F4}"/>
+              </a:ext>
+            </a:extLst>
+          </p:cNvPr>
+          <p:cNvSpPr>
+            <a:spLocks xmlns:a="http://schemas.openxmlformats.org/drawingml/2006/main" noGrp="1"/>
+          </p:cNvSpPr>
+          <p:nvPr/>
+        </p:nvSpPr>
+        <p:spPr>
+          <a:xfrm xmlns:a="http://schemas.openxmlformats.org/drawingml/2006/main">
+            <a:off x="914400" y="3524250"/>
+            <a:ext cx="4762500" cy="1257300"/>
+          </a:xfrm>
+          <a:prstGeom xmlns:a="http://schemas.openxmlformats.org/drawingml/2006/main" prst="rect">
+            <a:avLst/>
+          </a:prstGeom>
+          <a:noFill xmlns:a="http://schemas.openxmlformats.org/drawingml/2006/main"/>
+          <a:ln xmlns:a="http://schemas.openxmlformats.org/drawingml/2006/main" w="0">
+            <a:noFill/>
+            <a:prstDash val="solid"/>
+          </a:ln>
+        </p:spPr>
+        <p:txBody>
+          <a:bodyPr xmlns:a="http://schemas.openxmlformats.org/drawingml/2006/main"/>
+          <a:lstStyle xmlns:a="http://schemas.openxmlformats.org/drawingml/2006/main"/>
+          <a:p xmlns:a="http://schemas.openxmlformats.org/drawingml/2006/main">
+            <a:pPr>
+              <a:defRPr sz="1575">
+                <a:solidFill>
+                  <a:srgbClr val="000000"/>
+                </a:solidFill>
+              </a:defRPr>
+            </a:pPr>
+            <a:r>
+              <a:rPr sz="1575">
+                <a:solidFill>
+                  <a:srgbClr val="000000"/>
+                </a:solidFill>
+              </a:rPr>
+              <a:t>• Direct full-spec selection as the temporary bridge default.</a:t>
+            </a:r>
+          </a:p>
+          <a:p xmlns:a="http://schemas.openxmlformats.org/drawingml/2006/main">
+            <a:pPr>
+              <a:defRPr sz="1575">
+                <a:solidFill>
+                  <a:srgbClr val="000000"/>
+                </a:solidFill>
+              </a:defRPr>
+            </a:pPr>
+            <a:r>
+              <a:rPr sz="1575">
+                <a:solidFill>
+                  <a:srgbClr val="000000"/>
+                </a:solidFill>
+              </a:rPr>
+              <a:t>• Pooled-family selection as a first-class research contender.</a:t>
+            </a:r>
+          </a:p>
+          <a:p xmlns:a="http://schemas.openxmlformats.org/drawingml/2006/main">
+            <a:pPr>
+              <a:defRPr sz="1575">
+                <a:solidFill>
+                  <a:srgbClr val="000000"/>
+                </a:solidFill>
+              </a:defRPr>
+            </a:pPr>
+            <a:r>
+              <a:rPr sz="1575">
+                <a:solidFill>
+                  <a:srgbClr val="000000"/>
+                </a:solidFill>
+              </a:rPr>
+              <a:t>• A/B lane labels whenever live and substitute evidence are mixed.</a:t>
+            </a:r>
+          </a:p>
+        </p:txBody>
+      </p:sp>
+      <p:sp>
+        <p:nvSpPr>
+          <p:cNvPr id="6" name="">
+            <a:extLst xmlns:a="http://schemas.openxmlformats.org/drawingml/2006/main">
+              <a:ext uri="{FF2B5EF4-FFF2-40B4-BE49-F238E27FC236}">
+                <a16:creationId xmlns:a16="http://schemas.microsoft.com/office/drawing/2014/main" id="{7B0E6EDC-A494-4219-9491-DF525D7E3124}"/>
+              </a:ext>
+            </a:extLst>
+          </p:cNvPr>
+          <p:cNvSpPr>
+            <a:spLocks xmlns:a="http://schemas.openxmlformats.org/drawingml/2006/main" noGrp="1"/>
+          </p:cNvSpPr>
+          <p:nvPr/>
+        </p:nvSpPr>
+        <p:spPr>
+          <a:xfrm xmlns:a="http://schemas.openxmlformats.org/drawingml/2006/main">
+            <a:off x="6667500" y="3028950"/>
+            <a:ext cx="3143250" cy="323850"/>
+          </a:xfrm>
+          <a:prstGeom xmlns:a="http://schemas.openxmlformats.org/drawingml/2006/main" prst="rect">
+            <a:avLst/>
+          </a:prstGeom>
+          <a:noFill xmlns:a="http://schemas.openxmlformats.org/drawingml/2006/main"/>
+          <a:ln xmlns:a="http://schemas.openxmlformats.org/drawingml/2006/main" w="0">
+            <a:noFill/>
+            <a:prstDash val="solid"/>
+          </a:ln>
+        </p:spPr>
+        <p:txBody>
+          <a:bodyPr xmlns:a="http://schemas.openxmlformats.org/drawingml/2006/main"/>
+          <a:lstStyle xmlns:a="http://schemas.openxmlformats.org/drawingml/2006/main"/>
+          <a:p xmlns:a="http://schemas.openxmlformats.org/drawingml/2006/main">
+            <a:pPr>
+              <a:defRPr sz="1875" b="1">
+                <a:solidFill>
+                  <a:srgbClr val="000000"/>
+                </a:solidFill>
+              </a:defRPr>
+            </a:pPr>
+            <a:r>
+              <a:rPr sz="1875" b="1">
+                <a:solidFill>
+                  <a:srgbClr val="000000"/>
+                </a:solidFill>
+              </a:rPr>
+              <a:t>Stop before</a:t>
+            </a:r>
+          </a:p>
+        </p:txBody>
+      </p:sp>
+      <p:sp>
+        <p:nvSpPr>
+          <p:cNvPr id="7" name="">
+            <a:extLst xmlns:a="http://schemas.openxmlformats.org/drawingml/2006/main">
+              <a:ext uri="{FF2B5EF4-FFF2-40B4-BE49-F238E27FC236}">
+                <a16:creationId xmlns:a16="http://schemas.microsoft.com/office/drawing/2014/main" id="{0AEB73D5-E319-48AB-9FB1-414BEB238F87}"/>
+              </a:ext>
+            </a:extLst>
+          </p:cNvPr>
+          <p:cNvSpPr>
+            <a:spLocks xmlns:a="http://schemas.openxmlformats.org/drawingml/2006/main" noGrp="1"/>
+          </p:cNvSpPr>
+          <p:nvPr/>
+        </p:nvSpPr>
+        <p:spPr>
+          <a:xfrm xmlns:a="http://schemas.openxmlformats.org/drawingml/2006/main">
+            <a:off x="6667500" y="3524250"/>
+            <a:ext cx="4762500" cy="1257300"/>
+          </a:xfrm>
+          <a:prstGeom xmlns:a="http://schemas.openxmlformats.org/drawingml/2006/main" prst="rect">
+            <a:avLst/>
+          </a:prstGeom>
+          <a:noFill xmlns:a="http://schemas.openxmlformats.org/drawingml/2006/main"/>
+          <a:ln xmlns:a="http://schemas.openxmlformats.org/drawingml/2006/main" w="0">
+            <a:noFill/>
+            <a:prstDash val="solid"/>
+          </a:ln>
+        </p:spPr>
+        <p:txBody>
+          <a:bodyPr xmlns:a="http://schemas.openxmlformats.org/drawingml/2006/main"/>
+          <a:lstStyle xmlns:a="http://schemas.openxmlformats.org/drawingml/2006/main"/>
+          <a:p xmlns:a="http://schemas.openxmlformats.org/drawingml/2006/main">
+            <a:pPr>
+              <a:defRPr sz="1575">
+                <a:solidFill>
+                  <a:srgbClr val="000000"/>
+                </a:solidFill>
+              </a:defRPr>
+            </a:pPr>
+            <a:r>
+              <a:rPr sz="1575">
+                <a:solidFill>
+                  <a:srgbClr val="000000"/>
+                </a:solidFill>
+              </a:rPr>
+              <a:t>• Changing live bridge behavior for Gen4 fidelity alone.</a:t>
+            </a:r>
+          </a:p>
+          <a:p xmlns:a="http://schemas.openxmlformats.org/drawingml/2006/main">
+            <a:pPr>
+              <a:defRPr sz="1575">
+                <a:solidFill>
+                  <a:srgbClr val="000000"/>
+                </a:solidFill>
+              </a:defRPr>
+            </a:pPr>
+            <a:r>
+              <a:rPr sz="1575">
+                <a:solidFill>
+                  <a:srgbClr val="000000"/>
+                </a:solidFill>
+              </a:rPr>
+              <a:t>• Rerunning major context/state screens under a hidden policy swap.</a:t>
+            </a:r>
+          </a:p>
+          <a:p xmlns:a="http://schemas.openxmlformats.org/drawingml/2006/main">
+            <a:pPr>
+              <a:defRPr sz="1575">
+                <a:solidFill>
+                  <a:srgbClr val="000000"/>
+                </a:solidFill>
+              </a:defRPr>
+            </a:pPr>
+            <a:r>
+              <a:rPr sz="1575">
+                <a:solidFill>
+                  <a:srgbClr val="000000"/>
+                </a:solidFill>
+              </a:rPr>
+              <a:t>• Treating these compact proxies as allocation evidence.</a:t>
+            </a:r>
+          </a:p>
+        </p:txBody>
+      </p:sp>
+      <p:sp>
+        <p:nvSpPr>
+          <p:cNvPr id="8" name="">
+            <a:extLst xmlns:a="http://schemas.openxmlformats.org/drawingml/2006/main">
+              <a:ext uri="{FF2B5EF4-FFF2-40B4-BE49-F238E27FC236}">
+                <a16:creationId xmlns:a16="http://schemas.microsoft.com/office/drawing/2014/main" id="{452126AE-F519-4FDE-AAEE-F6D162388BB3}"/>
+              </a:ext>
+            </a:extLst>
+          </p:cNvPr>
+          <p:cNvSpPr>
+            <a:spLocks xmlns:a="http://schemas.openxmlformats.org/drawingml/2006/main" noGrp="1"/>
+          </p:cNvSpPr>
+          <p:nvPr/>
+        </p:nvSpPr>
+        <p:spPr>
+          <a:xfrm xmlns:a="http://schemas.openxmlformats.org/drawingml/2006/main">
+            <a:off x="876300" y="5105400"/>
+            <a:ext cx="10439400" cy="723900"/>
+          </a:xfrm>
+          <a:prstGeom xmlns:a="http://schemas.openxmlformats.org/drawingml/2006/main" prst="rect">
+            <a:avLst/>
+          </a:prstGeom>
+          <a:solidFill xmlns:a="http://schemas.openxmlformats.org/drawingml/2006/main">
+            <a:srgbClr val="FFE1D6"/>
+          </a:solidFill>
+          <a:ln xmlns:a="http://schemas.openxmlformats.org/drawingml/2006/main" w="0">
+            <a:noFill/>
+            <a:prstDash val="solid"/>
+          </a:ln>
+        </p:spPr>
+      </p:sp>
+      <p:sp>
+        <p:nvSpPr>
+          <p:cNvPr id="9" name="">
+            <a:extLst xmlns:a="http://schemas.openxmlformats.org/drawingml/2006/main">
+              <a:ext uri="{FF2B5EF4-FFF2-40B4-BE49-F238E27FC236}">
+                <a16:creationId xmlns:a16="http://schemas.microsoft.com/office/drawing/2014/main" id="{A41F7095-7ADC-4177-9D0B-38BBB1A21476}"/>
+              </a:ext>
+            </a:extLst>
+          </p:cNvPr>
+          <p:cNvSpPr>
+            <a:spLocks xmlns:a="http://schemas.openxmlformats.org/drawingml/2006/main" noGrp="1"/>
+          </p:cNvSpPr>
+          <p:nvPr/>
+        </p:nvSpPr>
+        <p:spPr>
+          <a:xfrm xmlns:a="http://schemas.openxmlformats.org/drawingml/2006/main">
+            <a:off x="1143000" y="5295900"/>
+            <a:ext cx="9810750" cy="419100"/>
+          </a:xfrm>
+          <a:prstGeom xmlns:a="http://schemas.openxmlformats.org/drawingml/2006/main" prst="rect">
+            <a:avLst/>
+          </a:prstGeom>
+          <a:noFill xmlns:a="http://schemas.openxmlformats.org/drawingml/2006/main"/>
+          <a:ln xmlns:a="http://schemas.openxmlformats.org/drawingml/2006/main" w="0">
+            <a:noFill/>
+            <a:prstDash val="solid"/>
+          </a:ln>
+        </p:spPr>
+        <p:txBody>
+          <a:bodyPr xmlns:a="http://schemas.openxmlformats.org/drawingml/2006/main"/>
+          <a:lstStyle xmlns:a="http://schemas.openxmlformats.org/drawingml/2006/main"/>
+          <a:p xmlns:a="http://schemas.openxmlformats.org/drawingml/2006/main">
+            <a:pPr>
+              <a:defRPr sz="1500" b="1">
+                <a:solidFill>
+                  <a:srgbClr val="000000"/>
+                </a:solidFill>
+              </a:defRPr>
+            </a:pPr>
+            <a:r>
+              <a:rPr sz="1500" b="1">
+                <a:solidFill>
+                  <a:srgbClr val="000000"/>
+                </a:solidFill>
+              </a:rPr>
+              <a:t>Recommended next slice: compare selection policy only inside a small, declared research grid using the strongest current context/state-map settings.</a:t>
+            </a:r>
+          </a:p>
+        </p:txBody>
+      </p:sp>
+      <p:sp>
+        <p:nvSpPr>
+          <p:cNvPr id="10" name="">
+            <a:extLst xmlns:a="http://schemas.openxmlformats.org/drawingml/2006/main">
+              <a:ext uri="{FF2B5EF4-FFF2-40B4-BE49-F238E27FC236}">
+                <a16:creationId xmlns:a16="http://schemas.microsoft.com/office/drawing/2014/main" id="{AE98D244-DE76-446E-90E7-BD4368551D96}"/>
+              </a:ext>
+            </a:extLst>
+          </p:cNvPr>
+          <p:cNvSpPr>
+            <a:spLocks xmlns:a="http://schemas.openxmlformats.org/drawingml/2006/main" noGrp="1"/>
+          </p:cNvSpPr>
+          <p:nvPr/>
+        </p:nvSpPr>
+        <p:spPr>
+          <a:xfrm xmlns:a="http://schemas.openxmlformats.org/drawingml/2006/main">
+            <a:off x="400050" y="6343650"/>
+            <a:ext cx="11391900" cy="13335"/>
+          </a:xfrm>
+          <a:prstGeom xmlns:a="http://schemas.openxmlformats.org/drawingml/2006/main" prst="rect">
+            <a:avLst/>
+          </a:prstGeom>
+          <a:solidFill xmlns:a="http://schemas.openxmlformats.org/drawingml/2006/main">
+            <a:srgbClr val="B8BCC4"/>
+          </a:solidFill>
+          <a:ln xmlns:a="http://schemas.openxmlformats.org/drawingml/2006/main" w="0">
+            <a:solidFill>
+              <a:srgbClr val="B8BCC4"/>
+            </a:solidFill>
+            <a:prstDash val="solid"/>
+          </a:ln>
+        </p:spPr>
+      </p:sp>
+      <p:sp>
+        <p:nvSpPr>
+          <p:cNvPr id="11" name="">
+            <a:extLst xmlns:a="http://schemas.openxmlformats.org/drawingml/2006/main">
+              <a:ext uri="{FF2B5EF4-FFF2-40B4-BE49-F238E27FC236}">
+                <a16:creationId xmlns:a16="http://schemas.microsoft.com/office/drawing/2014/main" id="{724DCC95-4442-4038-AF56-C845C5AB3BD1}"/>
+              </a:ext>
+            </a:extLst>
+          </p:cNvPr>
+          <p:cNvSpPr>
+            <a:spLocks xmlns:a="http://schemas.openxmlformats.org/drawingml/2006/main" noGrp="1"/>
+          </p:cNvSpPr>
+          <p:nvPr/>
+        </p:nvSpPr>
+        <p:spPr>
+          <a:xfrm xmlns:a="http://schemas.openxmlformats.org/drawingml/2006/main">
+            <a:off x="400050" y="6477000"/>
+            <a:ext cx="4381500" cy="228600"/>
+          </a:xfrm>
+          <a:prstGeom xmlns:a="http://schemas.openxmlformats.org/drawingml/2006/main" prst="rect">
+            <a:avLst/>
+          </a:prstGeom>
+          <a:noFill xmlns:a="http://schemas.openxmlformats.org/drawingml/2006/main"/>
+          <a:ln xmlns:a="http://schemas.openxmlformats.org/drawingml/2006/main" w="0">
+            <a:noFill/>
+            <a:prstDash val="solid"/>
+          </a:ln>
+        </p:spPr>
+        <p:txBody>
+          <a:bodyPr xmlns:a="http://schemas.openxmlformats.org/drawingml/2006/main"/>
+          <a:lstStyle xmlns:a="http://schemas.openxmlformats.org/drawingml/2006/main"/>
+          <a:p xmlns:a="http://schemas.openxmlformats.org/drawingml/2006/main">
+            <a:pPr>
+              <a:defRPr sz="1050">
+                <a:solidFill>
+                  <a:srgbClr val="555555"/>
+                </a:solidFill>
+              </a:defRPr>
+            </a:pPr>
+            <a:r>
+              <a:rPr sz="1050">
+                <a:solidFill>
+                  <a:srgbClr val="555555"/>
+                </a:solidFill>
+              </a:rPr>
+              <a:t>Gen5.1 selection-policy hypothesis</a:t>
+            </a:r>
+          </a:p>
+        </p:txBody>
+      </p:sp>
+      <p:sp>
+        <p:nvSpPr>
+          <p:cNvPr id="12" name="">
+            <a:extLst xmlns:a="http://schemas.openxmlformats.org/drawingml/2006/main">
+              <a:ext uri="{FF2B5EF4-FFF2-40B4-BE49-F238E27FC236}">
+                <a16:creationId xmlns:a16="http://schemas.microsoft.com/office/drawing/2014/main" id="{6F793285-561B-48DE-8369-1F2D4C5AC705}"/>
+              </a:ext>
+            </a:extLst>
+          </p:cNvPr>
+          <p:cNvSpPr>
+            <a:spLocks xmlns:a="http://schemas.openxmlformats.org/drawingml/2006/main" noGrp="1"/>
+          </p:cNvSpPr>
+          <p:nvPr/>
+        </p:nvSpPr>
+        <p:spPr>
+          <a:xfrm xmlns:a="http://schemas.openxmlformats.org/drawingml/2006/main">
+            <a:off x="11277600" y="6457950"/>
+            <a:ext cx="514350" cy="266700"/>
+          </a:xfrm>
+          <a:prstGeom xmlns:a="http://schemas.openxmlformats.org/drawingml/2006/main" prst="rect">
+            <a:avLst/>
+          </a:prstGeom>
+          <a:noFill xmlns:a="http://schemas.openxmlformats.org/drawingml/2006/main"/>
+          <a:ln xmlns:a="http://schemas.openxmlformats.org/drawingml/2006/main" w="0">
+            <a:noFill/>
+            <a:prstDash val="solid"/>
+          </a:ln>
+        </p:spPr>
+        <p:txBody>
+          <a:bodyPr xmlns:a="http://schemas.openxmlformats.org/drawingml/2006/main"/>
+          <a:lstStyle xmlns:a="http://schemas.openxmlformats.org/drawingml/2006/main"/>
+          <a:p xmlns:a="http://schemas.openxmlformats.org/drawingml/2006/main">
+            <a:pPr algn="r">
+              <a:defRPr sz="1200" b="1">
+                <a:solidFill>
+                  <a:srgbClr val="555555"/>
+                </a:solidFill>
+              </a:defRPr>
+            </a:pPr>
+            <a:r>
+              <a:rPr sz="1200" b="1">
+                <a:solidFill>
+                  <a:srgbClr val="555555"/>
+                </a:solidFill>
+              </a:rPr>
+              <a:t>11</a:t>
+            </a:r>
+          </a:p>
+        </p:txBody>
+      </p:sp>
+    </p:spTree>
+    <p:extLst>
+      <p:ext uri="{BB962C8B-B14F-4D97-AF65-F5344CB8AC3E}">
+        <p14:creationId xmlns:p14="http://schemas.microsoft.com/office/powerpoint/2010/main" val="396323860"/>
+      </p:ext>
+    </p:extLst>
+  </p:cSld>
+</p:sld>
+</file>
+
+<file path=ppt/slides/slide12.xml><?xml version="1.0" encoding="utf-8"?>
+<p:sld xmlns:p="http://schemas.openxmlformats.org/presentationml/2006/main">
+  <p:cSld>
+    <p:bg>
+      <p:bgPr>
+        <a:solidFill xmlns:a="http://schemas.openxmlformats.org/drawingml/2006/main">
+          <a:srgbClr val="FFFFFF"/>
+        </a:solidFill>
+      </p:bgPr>
+    </p:bg>
+    <p:spTree>
+      <p:nvGrpSpPr>
+        <p:cNvPr id="1" name=""/>
+        <p:cNvGrpSpPr/>
+        <p:nvPr/>
+      </p:nvGrpSpPr>
+      <p:grpSpPr>
+        <a:xfrm xmlns:a="http://schemas.openxmlformats.org/drawingml/2006/main"/>
+      </p:grpSpPr>
+      <p:sp>
+        <p:nvSpPr>
+          <p:cNvPr id="1" name="">
+            <a:extLst xmlns:a="http://schemas.openxmlformats.org/drawingml/2006/main">
+              <a:ext uri="{FF2B5EF4-FFF2-40B4-BE49-F238E27FC236}">
+                <a16:creationId xmlns:a16="http://schemas.microsoft.com/office/drawing/2014/main" id="{CA3DFF9E-B377-411B-8B2C-0DB0C695723B}"/>
+              </a:ext>
+            </a:extLst>
+          </p:cNvPr>
+          <p:cNvSpPr>
+            <a:spLocks xmlns:a="http://schemas.openxmlformats.org/drawingml/2006/main" noGrp="1"/>
+          </p:cNvSpPr>
+          <p:nvPr/>
+        </p:nvSpPr>
+        <p:spPr>
+          <a:xfrm xmlns:a="http://schemas.openxmlformats.org/drawingml/2006/main">
+            <a:off x="400050" y="400050"/>
+            <a:ext cx="2476500" cy="266700"/>
+          </a:xfrm>
+          <a:prstGeom xmlns:a="http://schemas.openxmlformats.org/drawingml/2006/main" prst="rect">
+            <a:avLst/>
+          </a:prstGeom>
+          <a:noFill xmlns:a="http://schemas.openxmlformats.org/drawingml/2006/main"/>
+          <a:ln xmlns:a="http://schemas.openxmlformats.org/drawingml/2006/main" w="0">
+            <a:noFill/>
+            <a:prstDash val="solid"/>
+          </a:ln>
+        </p:spPr>
+        <p:txBody>
+          <a:bodyPr xmlns:a="http://schemas.openxmlformats.org/drawingml/2006/main"/>
+          <a:lstStyle xmlns:a="http://schemas.openxmlformats.org/drawingml/2006/main"/>
+          <a:p xmlns:a="http://schemas.openxmlformats.org/drawingml/2006/main">
+            <a:pPr>
+              <a:defRPr sz="1200" b="1">
+                <a:solidFill>
+                  <a:srgbClr val="555555"/>
+                </a:solidFill>
+              </a:defRPr>
+            </a:pPr>
+            <a:r>
+              <a:rPr sz="1200" b="1">
+                <a:solidFill>
+                  <a:srgbClr val="555555"/>
+                </a:solidFill>
+              </a:rPr>
+              <a:t>VISUAL EVIDENCE</a:t>
+            </a:r>
+          </a:p>
+        </p:txBody>
+      </p:sp>
+      <p:sp>
+        <p:nvSpPr>
+          <p:cNvPr id="2" name="">
+            <a:extLst xmlns:a="http://schemas.openxmlformats.org/drawingml/2006/main">
+              <a:ext uri="{FF2B5EF4-FFF2-40B4-BE49-F238E27FC236}">
+                <a16:creationId xmlns:a16="http://schemas.microsoft.com/office/drawing/2014/main" id="{4C3F6A18-E7D9-43B3-A0AD-18751B0DECD4}"/>
+              </a:ext>
+            </a:extLst>
+          </p:cNvPr>
+          <p:cNvSpPr>
+            <a:spLocks xmlns:a="http://schemas.openxmlformats.org/drawingml/2006/main" noGrp="1"/>
+          </p:cNvSpPr>
+          <p:nvPr/>
+        </p:nvSpPr>
+        <p:spPr>
+          <a:xfrm xmlns:a="http://schemas.openxmlformats.org/drawingml/2006/main">
+            <a:off x="400050" y="838200"/>
+            <a:ext cx="10096500" cy="914400"/>
+          </a:xfrm>
+          <a:prstGeom xmlns:a="http://schemas.openxmlformats.org/drawingml/2006/main" prst="rect">
+            <a:avLst/>
+          </a:prstGeom>
+          <a:noFill xmlns:a="http://schemas.openxmlformats.org/drawingml/2006/main"/>
+          <a:ln xmlns:a="http://schemas.openxmlformats.org/drawingml/2006/main" w="0">
+            <a:noFill/>
+            <a:prstDash val="solid"/>
+          </a:ln>
+        </p:spPr>
+        <p:txBody>
+          <a:bodyPr xmlns:a="http://schemas.openxmlformats.org/drawingml/2006/main"/>
+          <a:lstStyle xmlns:a="http://schemas.openxmlformats.org/drawingml/2006/main"/>
+          <a:p xmlns:a="http://schemas.openxmlformats.org/drawingml/2006/main">
+            <a:pPr>
               <a:defRPr sz="2550" b="1">
                 <a:solidFill>
                   <a:srgbClr val="000000"/>
@@ -3077,7 +4147,7 @@
           <p:cNvPr id="3" name="">
             <a:extLst xmlns:a="http://schemas.openxmlformats.org/drawingml/2006/main">
               <a:ext uri="{FF2B5EF4-FFF2-40B4-BE49-F238E27FC236}">
-                <a16:creationId xmlns:a16="http://schemas.microsoft.com/office/drawing/2014/main" id="{8E716224-95A6-4426-8518-C326A053A111}"/>
+                <a16:creationId xmlns:a16="http://schemas.microsoft.com/office/drawing/2014/main" id="{4B3CB362-C30D-4A27-8390-334611AD8BF8}"/>
               </a:ext>
             </a:extLst>
           </p:cNvPr>
@@ -3131,7 +4201,7 @@
           <p:nvPr/>
         </p:nvPicPr>
         <p:blipFill>
-          <a:blip xmlns:r="http://schemas.openxmlformats.org/officeDocument/2006/relationships" xmlns:a="http://schemas.openxmlformats.org/drawingml/2006/main" r:embed="Rcb3d46d7ef0b40ea"/>
+          <a:blip xmlns:r="http://schemas.openxmlformats.org/officeDocument/2006/relationships" xmlns:a="http://schemas.openxmlformats.org/drawingml/2006/main" r:embed="R34faaf38c86747b9"/>
           <a:stretch xmlns:a="http://schemas.openxmlformats.org/drawingml/2006/main"/>
         </p:blipFill>
         <p:spPr>
@@ -3153,7 +4223,7 @@
           <p:nvPr/>
         </p:nvPicPr>
         <p:blipFill>
-          <a:blip xmlns:r="http://schemas.openxmlformats.org/officeDocument/2006/relationships" xmlns:a="http://schemas.openxmlformats.org/drawingml/2006/main" r:embed="R9a60dc8ecfa14704"/>
+          <a:blip xmlns:r="http://schemas.openxmlformats.org/officeDocument/2006/relationships" xmlns:a="http://schemas.openxmlformats.org/drawingml/2006/main" r:embed="R1fdfad84966045ce"/>
           <a:stretch xmlns:a="http://schemas.openxmlformats.org/drawingml/2006/main"/>
         </p:blipFill>
         <p:spPr>
@@ -3171,7 +4241,7 @@
           <p:cNvPr id="6" name="">
             <a:extLst xmlns:a="http://schemas.openxmlformats.org/drawingml/2006/main">
               <a:ext uri="{FF2B5EF4-FFF2-40B4-BE49-F238E27FC236}">
-                <a16:creationId xmlns:a16="http://schemas.microsoft.com/office/drawing/2014/main" id="{0D56D31D-A435-465F-B75B-889A6EAA42FC}"/>
+                <a16:creationId xmlns:a16="http://schemas.microsoft.com/office/drawing/2014/main" id="{9C78930D-1866-4AAE-9F0E-291D49782BAE}"/>
               </a:ext>
             </a:extLst>
           </p:cNvPr>
@@ -3204,7 +4274,7 @@
           <p:cNvPr id="7" name="">
             <a:extLst xmlns:a="http://schemas.openxmlformats.org/drawingml/2006/main">
               <a:ext uri="{FF2B5EF4-FFF2-40B4-BE49-F238E27FC236}">
-                <a16:creationId xmlns:a16="http://schemas.microsoft.com/office/drawing/2014/main" id="{9112D585-57E3-485D-A779-B59C228DD857}"/>
+                <a16:creationId xmlns:a16="http://schemas.microsoft.com/office/drawing/2014/main" id="{D4D68E29-2BD8-4C0F-B35A-D1F840159C83}"/>
               </a:ext>
             </a:extLst>
           </p:cNvPr>
@@ -3254,7 +4324,7 @@
           <p:cNvPr id="8" name="">
             <a:extLst xmlns:a="http://schemas.openxmlformats.org/drawingml/2006/main">
               <a:ext uri="{FF2B5EF4-FFF2-40B4-BE49-F238E27FC236}">
-                <a16:creationId xmlns:a16="http://schemas.microsoft.com/office/drawing/2014/main" id="{72EF93EE-B01D-4357-AD64-ACEC785CD22E}"/>
+                <a16:creationId xmlns:a16="http://schemas.microsoft.com/office/drawing/2014/main" id="{FECADB71-0292-4146-A8EB-7E9F40822CCB}"/>
               </a:ext>
             </a:extLst>
           </p:cNvPr>
@@ -3294,7 +4364,7 @@
                   <a:srgbClr val="555555"/>
                 </a:solidFill>
               </a:rPr>
-              <a:t>11</a:t>
+              <a:t>12</a:t>
             </a:r>
           </a:p>
         </p:txBody>
@@ -3302,7 +4372,385 @@
     </p:spTree>
     <p:extLst>
       <p:ext uri="{BB962C8B-B14F-4D97-AF65-F5344CB8AC3E}">
-        <p14:creationId xmlns:p14="http://schemas.microsoft.com/office/powerpoint/2010/main" val="1012383203"/>
+        <p14:creationId xmlns:p14="http://schemas.microsoft.com/office/powerpoint/2010/main" val="1842125832"/>
+      </p:ext>
+    </p:extLst>
+  </p:cSld>
+</p:sld>
+</file>
+
+<file path=ppt/slides/slide13.xml><?xml version="1.0" encoding="utf-8"?>
+<p:sld xmlns:p="http://schemas.openxmlformats.org/presentationml/2006/main">
+  <p:cSld>
+    <p:bg>
+      <p:bgPr>
+        <a:solidFill xmlns:a="http://schemas.openxmlformats.org/drawingml/2006/main">
+          <a:srgbClr val="FFFFFF"/>
+        </a:solidFill>
+      </p:bgPr>
+    </p:bg>
+    <p:spTree>
+      <p:nvGrpSpPr>
+        <p:cNvPr id="1" name=""/>
+        <p:cNvGrpSpPr/>
+        <p:nvPr/>
+      </p:nvGrpSpPr>
+      <p:grpSpPr>
+        <a:xfrm xmlns:a="http://schemas.openxmlformats.org/drawingml/2006/main"/>
+      </p:grpSpPr>
+      <p:sp>
+        <p:nvSpPr>
+          <p:cNvPr id="1" name="">
+            <a:extLst xmlns:a="http://schemas.openxmlformats.org/drawingml/2006/main">
+              <a:ext uri="{FF2B5EF4-FFF2-40B4-BE49-F238E27FC236}">
+                <a16:creationId xmlns:a16="http://schemas.microsoft.com/office/drawing/2014/main" id="{F66E9FE8-EC67-46E5-851A-09CAE21583C9}"/>
+              </a:ext>
+            </a:extLst>
+          </p:cNvPr>
+          <p:cNvSpPr>
+            <a:spLocks xmlns:a="http://schemas.openxmlformats.org/drawingml/2006/main" noGrp="1"/>
+          </p:cNvSpPr>
+          <p:nvPr/>
+        </p:nvSpPr>
+        <p:spPr>
+          <a:xfrm xmlns:a="http://schemas.openxmlformats.org/drawingml/2006/main">
+            <a:off x="400050" y="400050"/>
+            <a:ext cx="2476500" cy="266700"/>
+          </a:xfrm>
+          <a:prstGeom xmlns:a="http://schemas.openxmlformats.org/drawingml/2006/main" prst="rect">
+            <a:avLst/>
+          </a:prstGeom>
+          <a:noFill xmlns:a="http://schemas.openxmlformats.org/drawingml/2006/main"/>
+          <a:ln xmlns:a="http://schemas.openxmlformats.org/drawingml/2006/main" w="0">
+            <a:noFill/>
+            <a:prstDash val="solid"/>
+          </a:ln>
+        </p:spPr>
+        <p:txBody>
+          <a:bodyPr xmlns:a="http://schemas.openxmlformats.org/drawingml/2006/main"/>
+          <a:lstStyle xmlns:a="http://schemas.openxmlformats.org/drawingml/2006/main"/>
+          <a:p xmlns:a="http://schemas.openxmlformats.org/drawingml/2006/main">
+            <a:pPr>
+              <a:defRPr sz="1200" b="1">
+                <a:solidFill>
+                  <a:srgbClr val="555555"/>
+                </a:solidFill>
+              </a:defRPr>
+            </a:pPr>
+            <a:r>
+              <a:rPr sz="1200" b="1">
+                <a:solidFill>
+                  <a:srgbClr val="555555"/>
+                </a:solidFill>
+              </a:rPr>
+              <a:t>VISUAL EVIDENCE</a:t>
+            </a:r>
+          </a:p>
+        </p:txBody>
+      </p:sp>
+      <p:sp>
+        <p:nvSpPr>
+          <p:cNvPr id="2" name="">
+            <a:extLst xmlns:a="http://schemas.openxmlformats.org/drawingml/2006/main">
+              <a:ext uri="{FF2B5EF4-FFF2-40B4-BE49-F238E27FC236}">
+                <a16:creationId xmlns:a16="http://schemas.microsoft.com/office/drawing/2014/main" id="{8AC80222-24E4-4375-A12E-EA70F7E5C832}"/>
+              </a:ext>
+            </a:extLst>
+          </p:cNvPr>
+          <p:cNvSpPr>
+            <a:spLocks xmlns:a="http://schemas.openxmlformats.org/drawingml/2006/main" noGrp="1"/>
+          </p:cNvSpPr>
+          <p:nvPr/>
+        </p:nvSpPr>
+        <p:spPr>
+          <a:xfrm xmlns:a="http://schemas.openxmlformats.org/drawingml/2006/main">
+            <a:off x="400050" y="838200"/>
+            <a:ext cx="10096500" cy="914400"/>
+          </a:xfrm>
+          <a:prstGeom xmlns:a="http://schemas.openxmlformats.org/drawingml/2006/main" prst="rect">
+            <a:avLst/>
+          </a:prstGeom>
+          <a:noFill xmlns:a="http://schemas.openxmlformats.org/drawingml/2006/main"/>
+          <a:ln xmlns:a="http://schemas.openxmlformats.org/drawingml/2006/main" w="0">
+            <a:noFill/>
+            <a:prstDash val="solid"/>
+          </a:ln>
+        </p:spPr>
+        <p:txBody>
+          <a:bodyPr xmlns:a="http://schemas.openxmlformats.org/drawingml/2006/main"/>
+          <a:lstStyle xmlns:a="http://schemas.openxmlformats.org/drawingml/2006/main"/>
+          <a:p xmlns:a="http://schemas.openxmlformats.org/drawingml/2006/main">
+            <a:pPr>
+              <a:defRPr sz="2550" b="1">
+                <a:solidFill>
+                  <a:srgbClr val="000000"/>
+                </a:solidFill>
+              </a:defRPr>
+            </a:pPr>
+            <a:r>
+              <a:rPr sz="2550" b="1">
+                <a:solidFill>
+                  <a:srgbClr val="000000"/>
+                </a:solidFill>
+              </a:rPr>
+              <a:t>The B-hist charts show defensive pooled windows and direct upside windows</a:t>
+            </a:r>
+          </a:p>
+        </p:txBody>
+      </p:sp>
+      <p:sp>
+        <p:nvSpPr>
+          <p:cNvPr id="3" name="">
+            <a:extLst xmlns:a="http://schemas.openxmlformats.org/drawingml/2006/main">
+              <a:ext uri="{FF2B5EF4-FFF2-40B4-BE49-F238E27FC236}">
+                <a16:creationId xmlns:a16="http://schemas.microsoft.com/office/drawing/2014/main" id="{A6947DC1-221F-460B-8E73-F0CB180321CC}"/>
+              </a:ext>
+            </a:extLst>
+          </p:cNvPr>
+          <p:cNvSpPr>
+            <a:spLocks xmlns:a="http://schemas.openxmlformats.org/drawingml/2006/main" noGrp="1"/>
+          </p:cNvSpPr>
+          <p:nvPr/>
+        </p:nvSpPr>
+        <p:spPr>
+          <a:xfrm xmlns:a="http://schemas.openxmlformats.org/drawingml/2006/main">
+            <a:off x="400050" y="1943100"/>
+            <a:ext cx="10096500" cy="438150"/>
+          </a:xfrm>
+          <a:prstGeom xmlns:a="http://schemas.openxmlformats.org/drawingml/2006/main" prst="rect">
+            <a:avLst/>
+          </a:prstGeom>
+          <a:noFill xmlns:a="http://schemas.openxmlformats.org/drawingml/2006/main"/>
+          <a:ln xmlns:a="http://schemas.openxmlformats.org/drawingml/2006/main" w="0">
+            <a:noFill/>
+            <a:prstDash val="solid"/>
+          </a:ln>
+        </p:spPr>
+        <p:txBody>
+          <a:bodyPr xmlns:a="http://schemas.openxmlformats.org/drawingml/2006/main"/>
+          <a:lstStyle xmlns:a="http://schemas.openxmlformats.org/drawingml/2006/main"/>
+          <a:p xmlns:a="http://schemas.openxmlformats.org/drawingml/2006/main">
+            <a:pPr>
+              <a:defRPr sz="1575">
+                <a:solidFill>
+                  <a:srgbClr val="222222"/>
+                </a:solidFill>
+              </a:defRPr>
+            </a:pPr>
+            <a:r>
+              <a:rPr sz="1575">
+                <a:solidFill>
+                  <a:srgbClr val="222222"/>
+                </a:solidFill>
+              </a:rPr>
+              <a:t>Green cells favor pooled-family; red cells favor direct. The equity overlay makes the path behavior visible across weak and strong historical windows.</a:t>
+            </a:r>
+          </a:p>
+        </p:txBody>
+      </p:sp>
+      <p:pic>
+        <p:nvPicPr>
+          <p:cNvPr id="13" name=""/>
+          <p:cNvPicPr>
+            <a:picLocks xmlns:a="http://schemas.openxmlformats.org/drawingml/2006/main" noChangeAspect="1"/>
+          </p:cNvPicPr>
+          <p:nvPr/>
+        </p:nvPicPr>
+        <p:blipFill>
+          <a:blip xmlns:r="http://schemas.openxmlformats.org/officeDocument/2006/relationships" xmlns:a="http://schemas.openxmlformats.org/drawingml/2006/main" r:embed="R111a113f7be24f87"/>
+          <a:stretch xmlns:a="http://schemas.openxmlformats.org/drawingml/2006/main"/>
+        </p:blipFill>
+        <p:spPr>
+          <a:xfrm xmlns:a="http://schemas.openxmlformats.org/drawingml/2006/main">
+            <a:off x="783648" y="2571750"/>
+            <a:ext cx="4909705" cy="3000375"/>
+          </a:xfrm>
+          <a:prstGeom xmlns:a="http://schemas.openxmlformats.org/drawingml/2006/main" prst="rect">
+            <a:avLst/>
+          </a:prstGeom>
+        </p:spPr>
+      </p:pic>
+      <p:pic>
+        <p:nvPicPr>
+          <p:cNvPr id="14" name=""/>
+          <p:cNvPicPr>
+            <a:picLocks xmlns:a="http://schemas.openxmlformats.org/drawingml/2006/main" noChangeAspect="1"/>
+          </p:cNvPicPr>
+          <p:nvPr/>
+        </p:nvPicPr>
+        <p:blipFill>
+          <a:blip xmlns:r="http://schemas.openxmlformats.org/officeDocument/2006/relationships" xmlns:a="http://schemas.openxmlformats.org/drawingml/2006/main" r:embed="R148a92ae1d8f43aa"/>
+          <a:stretch xmlns:a="http://schemas.openxmlformats.org/drawingml/2006/main"/>
+        </p:blipFill>
+        <p:spPr>
+          <a:xfrm xmlns:a="http://schemas.openxmlformats.org/drawingml/2006/main">
+            <a:off x="7658100" y="2571750"/>
+            <a:ext cx="2209800" cy="1381125"/>
+          </a:xfrm>
+          <a:prstGeom xmlns:a="http://schemas.openxmlformats.org/drawingml/2006/main" prst="rect">
+            <a:avLst/>
+          </a:prstGeom>
+        </p:spPr>
+      </p:pic>
+      <p:pic>
+        <p:nvPicPr>
+          <p:cNvPr id="15" name=""/>
+          <p:cNvPicPr>
+            <a:picLocks xmlns:a="http://schemas.openxmlformats.org/drawingml/2006/main" noChangeAspect="1"/>
+          </p:cNvPicPr>
+          <p:nvPr/>
+        </p:nvPicPr>
+        <p:blipFill>
+          <a:blip xmlns:r="http://schemas.openxmlformats.org/officeDocument/2006/relationships" xmlns:a="http://schemas.openxmlformats.org/drawingml/2006/main" r:embed="Rf88cbe5cf9c84943"/>
+          <a:stretch xmlns:a="http://schemas.openxmlformats.org/drawingml/2006/main"/>
+        </p:blipFill>
+        <p:spPr>
+          <a:xfrm xmlns:a="http://schemas.openxmlformats.org/drawingml/2006/main">
+            <a:off x="7578237" y="4171950"/>
+            <a:ext cx="2369527" cy="1400175"/>
+          </a:xfrm>
+          <a:prstGeom xmlns:a="http://schemas.openxmlformats.org/drawingml/2006/main" prst="rect">
+            <a:avLst/>
+          </a:prstGeom>
+        </p:spPr>
+      </p:pic>
+      <p:sp>
+        <p:nvSpPr>
+          <p:cNvPr id="7" name="">
+            <a:extLst xmlns:a="http://schemas.openxmlformats.org/drawingml/2006/main">
+              <a:ext uri="{FF2B5EF4-FFF2-40B4-BE49-F238E27FC236}">
+                <a16:creationId xmlns:a16="http://schemas.microsoft.com/office/drawing/2014/main" id="{D7A6A334-05FE-4A39-9A63-FCB9A5C5913D}"/>
+              </a:ext>
+            </a:extLst>
+          </p:cNvPr>
+          <p:cNvSpPr>
+            <a:spLocks xmlns:a="http://schemas.openxmlformats.org/drawingml/2006/main" noGrp="1"/>
+          </p:cNvSpPr>
+          <p:nvPr/>
+        </p:nvSpPr>
+        <p:spPr>
+          <a:xfrm xmlns:a="http://schemas.openxmlformats.org/drawingml/2006/main">
+            <a:off x="400050" y="6343650"/>
+            <a:ext cx="11391900" cy="13335"/>
+          </a:xfrm>
+          <a:prstGeom xmlns:a="http://schemas.openxmlformats.org/drawingml/2006/main" prst="rect">
+            <a:avLst/>
+          </a:prstGeom>
+          <a:solidFill xmlns:a="http://schemas.openxmlformats.org/drawingml/2006/main">
+            <a:srgbClr val="B8BCC4"/>
+          </a:solidFill>
+          <a:ln xmlns:a="http://schemas.openxmlformats.org/drawingml/2006/main" w="0">
+            <a:solidFill>
+              <a:srgbClr val="B8BCC4"/>
+            </a:solidFill>
+            <a:prstDash val="solid"/>
+          </a:ln>
+        </p:spPr>
+      </p:sp>
+      <p:sp>
+        <p:nvSpPr>
+          <p:cNvPr id="8" name="">
+            <a:extLst xmlns:a="http://schemas.openxmlformats.org/drawingml/2006/main">
+              <a:ext uri="{FF2B5EF4-FFF2-40B4-BE49-F238E27FC236}">
+                <a16:creationId xmlns:a16="http://schemas.microsoft.com/office/drawing/2014/main" id="{06981473-A9BA-4334-802B-E75E32E17450}"/>
+              </a:ext>
+            </a:extLst>
+          </p:cNvPr>
+          <p:cNvSpPr>
+            <a:spLocks xmlns:a="http://schemas.openxmlformats.org/drawingml/2006/main" noGrp="1"/>
+          </p:cNvSpPr>
+          <p:nvPr/>
+        </p:nvSpPr>
+        <p:spPr>
+          <a:xfrm xmlns:a="http://schemas.openxmlformats.org/drawingml/2006/main">
+            <a:off x="400050" y="6477000"/>
+            <a:ext cx="4381500" cy="228600"/>
+          </a:xfrm>
+          <a:prstGeom xmlns:a="http://schemas.openxmlformats.org/drawingml/2006/main" prst="rect">
+            <a:avLst/>
+          </a:prstGeom>
+          <a:noFill xmlns:a="http://schemas.openxmlformats.org/drawingml/2006/main"/>
+          <a:ln xmlns:a="http://schemas.openxmlformats.org/drawingml/2006/main" w="0">
+            <a:noFill/>
+            <a:prstDash val="solid"/>
+          </a:ln>
+        </p:spPr>
+        <p:txBody>
+          <a:bodyPr xmlns:a="http://schemas.openxmlformats.org/drawingml/2006/main"/>
+          <a:lstStyle xmlns:a="http://schemas.openxmlformats.org/drawingml/2006/main"/>
+          <a:p xmlns:a="http://schemas.openxmlformats.org/drawingml/2006/main">
+            <a:pPr>
+              <a:defRPr sz="1050">
+                <a:solidFill>
+                  <a:srgbClr val="555555"/>
+                </a:solidFill>
+              </a:defRPr>
+            </a:pPr>
+            <a:r>
+              <a:rPr sz="1050">
+                <a:solidFill>
+                  <a:srgbClr val="555555"/>
+                </a:solidFill>
+              </a:rPr>
+              <a:t>Gen5.1 selection-policy hypothesis</a:t>
+            </a:r>
+          </a:p>
+        </p:txBody>
+      </p:sp>
+      <p:sp>
+        <p:nvSpPr>
+          <p:cNvPr id="9" name="">
+            <a:extLst xmlns:a="http://schemas.openxmlformats.org/drawingml/2006/main">
+              <a:ext uri="{FF2B5EF4-FFF2-40B4-BE49-F238E27FC236}">
+                <a16:creationId xmlns:a16="http://schemas.microsoft.com/office/drawing/2014/main" id="{CD695E7A-2E75-4C8C-B9BB-CC3401D1BB66}"/>
+              </a:ext>
+            </a:extLst>
+          </p:cNvPr>
+          <p:cNvSpPr>
+            <a:spLocks xmlns:a="http://schemas.openxmlformats.org/drawingml/2006/main" noGrp="1"/>
+          </p:cNvSpPr>
+          <p:nvPr/>
+        </p:nvSpPr>
+        <p:spPr>
+          <a:xfrm xmlns:a="http://schemas.openxmlformats.org/drawingml/2006/main">
+            <a:off x="11277600" y="6457950"/>
+            <a:ext cx="514350" cy="266700"/>
+          </a:xfrm>
+          <a:prstGeom xmlns:a="http://schemas.openxmlformats.org/drawingml/2006/main" prst="rect">
+            <a:avLst/>
+          </a:prstGeom>
+          <a:noFill xmlns:a="http://schemas.openxmlformats.org/drawingml/2006/main"/>
+          <a:ln xmlns:a="http://schemas.openxmlformats.org/drawingml/2006/main" w="0">
+            <a:noFill/>
+            <a:prstDash val="solid"/>
+          </a:ln>
+        </p:spPr>
+        <p:txBody>
+          <a:bodyPr xmlns:a="http://schemas.openxmlformats.org/drawingml/2006/main"/>
+          <a:lstStyle xmlns:a="http://schemas.openxmlformats.org/drawingml/2006/main"/>
+          <a:p xmlns:a="http://schemas.openxmlformats.org/drawingml/2006/main">
+            <a:pPr algn="r">
+              <a:defRPr sz="1200" b="1">
+                <a:solidFill>
+                  <a:srgbClr val="555555"/>
+                </a:solidFill>
+              </a:defRPr>
+            </a:pPr>
+            <a:r>
+              <a:rPr sz="1200" b="1">
+                <a:solidFill>
+                  <a:srgbClr val="555555"/>
+                </a:solidFill>
+              </a:rPr>
+              <a:t>13</a:t>
+            </a:r>
+          </a:p>
+        </p:txBody>
+      </p:sp>
+    </p:spTree>
+    <p:extLst>
+      <p:ext uri="{BB962C8B-B14F-4D97-AF65-F5344CB8AC3E}">
+        <p14:creationId xmlns:p14="http://schemas.microsoft.com/office/powerpoint/2010/main" val="1258641250"/>
       </p:ext>
     </p:extLst>
   </p:cSld>
@@ -3333,7 +4781,7 @@
           <p:cNvPr id="1" name="">
             <a:extLst xmlns:a="http://schemas.openxmlformats.org/drawingml/2006/main">
               <a:ext uri="{FF2B5EF4-FFF2-40B4-BE49-F238E27FC236}">
-                <a16:creationId xmlns:a16="http://schemas.microsoft.com/office/drawing/2014/main" id="{9FF72302-E148-4FFE-B64E-2740223AB21F}"/>
+                <a16:creationId xmlns:a16="http://schemas.microsoft.com/office/drawing/2014/main" id="{EA317AE8-E9B9-415C-9C4A-6A73B76E6E86}"/>
               </a:ext>
             </a:extLst>
           </p:cNvPr>
@@ -3383,7 +4831,7 @@
           <p:cNvPr id="2" name="">
             <a:extLst xmlns:a="http://schemas.openxmlformats.org/drawingml/2006/main">
               <a:ext uri="{FF2B5EF4-FFF2-40B4-BE49-F238E27FC236}">
-                <a16:creationId xmlns:a16="http://schemas.microsoft.com/office/drawing/2014/main" id="{8A1991E9-9C96-4DE7-BE6A-1335D12F5EBE}"/>
+                <a16:creationId xmlns:a16="http://schemas.microsoft.com/office/drawing/2014/main" id="{988A30CA-3E2B-49AE-AC8E-7BBD1DFAB7C9}"/>
               </a:ext>
             </a:extLst>
           </p:cNvPr>
@@ -3433,7 +4881,7 @@
           <p:cNvPr id="3" name="">
             <a:extLst xmlns:a="http://schemas.openxmlformats.org/drawingml/2006/main">
               <a:ext uri="{FF2B5EF4-FFF2-40B4-BE49-F238E27FC236}">
-                <a16:creationId xmlns:a16="http://schemas.microsoft.com/office/drawing/2014/main" id="{2A35D6ED-DF47-44F5-8664-B214243C2E17}"/>
+                <a16:creationId xmlns:a16="http://schemas.microsoft.com/office/drawing/2014/main" id="{52C57E1A-DC4B-4EF2-900A-E9CC63DBE02F}"/>
               </a:ext>
             </a:extLst>
           </p:cNvPr>
@@ -3483,7 +4931,7 @@
           <p:cNvPr id="4" name="">
             <a:extLst xmlns:a="http://schemas.openxmlformats.org/drawingml/2006/main">
               <a:ext uri="{FF2B5EF4-FFF2-40B4-BE49-F238E27FC236}">
-                <a16:creationId xmlns:a16="http://schemas.microsoft.com/office/drawing/2014/main" id="{6AC38604-CC7D-4EAE-929A-1AE9AC5D4D63}"/>
+                <a16:creationId xmlns:a16="http://schemas.microsoft.com/office/drawing/2014/main" id="{E847BA13-6227-4BC4-BAB8-31282D427023}"/>
               </a:ext>
             </a:extLst>
           </p:cNvPr>
@@ -3514,7 +4962,7 @@
           <p:cNvPr id="5" name="">
             <a:extLst xmlns:a="http://schemas.openxmlformats.org/drawingml/2006/main">
               <a:ext uri="{FF2B5EF4-FFF2-40B4-BE49-F238E27FC236}">
-                <a16:creationId xmlns:a16="http://schemas.microsoft.com/office/drawing/2014/main" id="{9D053A91-BB31-443F-829C-8EAAC34A86D4}"/>
+                <a16:creationId xmlns:a16="http://schemas.microsoft.com/office/drawing/2014/main" id="{9D1B2D61-2BFF-42D7-9063-45ECA1AA1283}"/>
               </a:ext>
             </a:extLst>
           </p:cNvPr>
@@ -3564,7 +5012,7 @@
           <p:cNvPr id="6" name="">
             <a:extLst xmlns:a="http://schemas.openxmlformats.org/drawingml/2006/main">
               <a:ext uri="{FF2B5EF4-FFF2-40B4-BE49-F238E27FC236}">
-                <a16:creationId xmlns:a16="http://schemas.microsoft.com/office/drawing/2014/main" id="{12330348-EDDC-42F6-860F-D991B11FDD18}"/>
+                <a16:creationId xmlns:a16="http://schemas.microsoft.com/office/drawing/2014/main" id="{5F6B3CC6-46B2-4A10-874B-0F2006B07349}"/>
               </a:ext>
             </a:extLst>
           </p:cNvPr>
@@ -3614,7 +5062,7 @@
           <p:cNvPr id="7" name="">
             <a:extLst xmlns:a="http://schemas.openxmlformats.org/drawingml/2006/main">
               <a:ext uri="{FF2B5EF4-FFF2-40B4-BE49-F238E27FC236}">
-                <a16:creationId xmlns:a16="http://schemas.microsoft.com/office/drawing/2014/main" id="{B58D9695-7D94-439E-8932-4E3888197A71}"/>
+                <a16:creationId xmlns:a16="http://schemas.microsoft.com/office/drawing/2014/main" id="{02DF3B78-6089-426A-8D25-D2A87E5F8CAF}"/>
               </a:ext>
             </a:extLst>
           </p:cNvPr>
@@ -3645,7 +5093,7 @@
           <p:cNvPr id="8" name="">
             <a:extLst xmlns:a="http://schemas.openxmlformats.org/drawingml/2006/main">
               <a:ext uri="{FF2B5EF4-FFF2-40B4-BE49-F238E27FC236}">
-                <a16:creationId xmlns:a16="http://schemas.microsoft.com/office/drawing/2014/main" id="{6C9F00F6-518F-4412-87EE-FFCC40A8772B}"/>
+                <a16:creationId xmlns:a16="http://schemas.microsoft.com/office/drawing/2014/main" id="{3E1EEE5B-744C-49EA-996C-CDCAE190DDCB}"/>
               </a:ext>
             </a:extLst>
           </p:cNvPr>
@@ -3695,7 +5143,7 @@
           <p:cNvPr id="9" name="">
             <a:extLst xmlns:a="http://schemas.openxmlformats.org/drawingml/2006/main">
               <a:ext uri="{FF2B5EF4-FFF2-40B4-BE49-F238E27FC236}">
-                <a16:creationId xmlns:a16="http://schemas.microsoft.com/office/drawing/2014/main" id="{0038523F-B5F1-4FF8-B24A-C948C58309D5}"/>
+                <a16:creationId xmlns:a16="http://schemas.microsoft.com/office/drawing/2014/main" id="{09A547DE-9518-4BA7-AFF1-14C6718F14CC}"/>
               </a:ext>
             </a:extLst>
           </p:cNvPr>
@@ -3745,7 +5193,7 @@
           <p:cNvPr id="10" name="">
             <a:extLst xmlns:a="http://schemas.openxmlformats.org/drawingml/2006/main">
               <a:ext uri="{FF2B5EF4-FFF2-40B4-BE49-F238E27FC236}">
-                <a16:creationId xmlns:a16="http://schemas.microsoft.com/office/drawing/2014/main" id="{99A89105-ABC8-4488-A5F4-13EE69DB3DE6}"/>
+                <a16:creationId xmlns:a16="http://schemas.microsoft.com/office/drawing/2014/main" id="{58677604-0A18-42A0-8C30-F82162859704}"/>
               </a:ext>
             </a:extLst>
           </p:cNvPr>
@@ -3776,7 +5224,7 @@
           <p:cNvPr id="11" name="">
             <a:extLst xmlns:a="http://schemas.openxmlformats.org/drawingml/2006/main">
               <a:ext uri="{FF2B5EF4-FFF2-40B4-BE49-F238E27FC236}">
-                <a16:creationId xmlns:a16="http://schemas.microsoft.com/office/drawing/2014/main" id="{E967EBD0-D5D2-4C25-B9C4-B86C133B7452}"/>
+                <a16:creationId xmlns:a16="http://schemas.microsoft.com/office/drawing/2014/main" id="{92D8E5EB-799C-4817-BFD8-A51692C94CDE}"/>
               </a:ext>
             </a:extLst>
           </p:cNvPr>
@@ -3826,7 +5274,7 @@
           <p:cNvPr id="12" name="">
             <a:extLst xmlns:a="http://schemas.openxmlformats.org/drawingml/2006/main">
               <a:ext uri="{FF2B5EF4-FFF2-40B4-BE49-F238E27FC236}">
-                <a16:creationId xmlns:a16="http://schemas.microsoft.com/office/drawing/2014/main" id="{70E57310-CB82-4D6B-955F-E41AA16663AE}"/>
+                <a16:creationId xmlns:a16="http://schemas.microsoft.com/office/drawing/2014/main" id="{71459AFD-701F-4E1F-BEC1-60D65E00E6D2}"/>
               </a:ext>
             </a:extLst>
           </p:cNvPr>
@@ -3876,7 +5324,7 @@
           <p:cNvPr id="13" name="">
             <a:extLst xmlns:a="http://schemas.openxmlformats.org/drawingml/2006/main">
               <a:ext uri="{FF2B5EF4-FFF2-40B4-BE49-F238E27FC236}">
-                <a16:creationId xmlns:a16="http://schemas.microsoft.com/office/drawing/2014/main" id="{B8C8A495-2435-490D-B4BD-D0C4BA704EAB}"/>
+                <a16:creationId xmlns:a16="http://schemas.microsoft.com/office/drawing/2014/main" id="{55FAF6AD-FA37-4058-8045-97F1F8133FF3}"/>
               </a:ext>
             </a:extLst>
           </p:cNvPr>
@@ -3926,7 +5374,7 @@
           <p:cNvPr id="14" name="">
             <a:extLst xmlns:a="http://schemas.openxmlformats.org/drawingml/2006/main">
               <a:ext uri="{FF2B5EF4-FFF2-40B4-BE49-F238E27FC236}">
-                <a16:creationId xmlns:a16="http://schemas.microsoft.com/office/drawing/2014/main" id="{BF428658-F2DD-474C-BDCA-AB98E5AAC9FE}"/>
+                <a16:creationId xmlns:a16="http://schemas.microsoft.com/office/drawing/2014/main" id="{C1954A4A-334B-48B2-ABB4-FF78B55E3A04}"/>
               </a:ext>
             </a:extLst>
           </p:cNvPr>
@@ -3959,7 +5407,7 @@
           <p:cNvPr id="15" name="">
             <a:extLst xmlns:a="http://schemas.openxmlformats.org/drawingml/2006/main">
               <a:ext uri="{FF2B5EF4-FFF2-40B4-BE49-F238E27FC236}">
-                <a16:creationId xmlns:a16="http://schemas.microsoft.com/office/drawing/2014/main" id="{1D427AB1-16F3-47EA-8FFC-635184E7765C}"/>
+                <a16:creationId xmlns:a16="http://schemas.microsoft.com/office/drawing/2014/main" id="{8C2A8918-A379-4658-BAB0-D954DD1B9FF5}"/>
               </a:ext>
             </a:extLst>
           </p:cNvPr>
@@ -4009,7 +5457,7 @@
           <p:cNvPr id="16" name="">
             <a:extLst xmlns:a="http://schemas.openxmlformats.org/drawingml/2006/main">
               <a:ext uri="{FF2B5EF4-FFF2-40B4-BE49-F238E27FC236}">
-                <a16:creationId xmlns:a16="http://schemas.microsoft.com/office/drawing/2014/main" id="{FDC2674E-B110-47FB-A455-B254500B73EC}"/>
+                <a16:creationId xmlns:a16="http://schemas.microsoft.com/office/drawing/2014/main" id="{6DEC3CE9-99C0-48F8-A3E9-4FDC56DC0BE1}"/>
               </a:ext>
             </a:extLst>
           </p:cNvPr>
@@ -4057,7 +5505,7 @@
     </p:spTree>
     <p:extLst>
       <p:ext uri="{BB962C8B-B14F-4D97-AF65-F5344CB8AC3E}">
-        <p14:creationId xmlns:p14="http://schemas.microsoft.com/office/powerpoint/2010/main" val="1915247318"/>
+        <p14:creationId xmlns:p14="http://schemas.microsoft.com/office/powerpoint/2010/main" val="272166807"/>
       </p:ext>
     </p:extLst>
   </p:cSld>
@@ -4088,7 +5536,7 @@
           <p:cNvPr id="1" name="">
             <a:extLst xmlns:a="http://schemas.openxmlformats.org/drawingml/2006/main">
               <a:ext uri="{FF2B5EF4-FFF2-40B4-BE49-F238E27FC236}">
-                <a16:creationId xmlns:a16="http://schemas.microsoft.com/office/drawing/2014/main" id="{17BDAB3D-6565-4D23-A17A-DB8E49E5BA66}"/>
+                <a16:creationId xmlns:a16="http://schemas.microsoft.com/office/drawing/2014/main" id="{58478811-19F9-470C-9063-90CEB7214A61}"/>
               </a:ext>
             </a:extLst>
           </p:cNvPr>
@@ -4138,7 +5586,7 @@
           <p:cNvPr id="2" name="">
             <a:extLst xmlns:a="http://schemas.openxmlformats.org/drawingml/2006/main">
               <a:ext uri="{FF2B5EF4-FFF2-40B4-BE49-F238E27FC236}">
-                <a16:creationId xmlns:a16="http://schemas.microsoft.com/office/drawing/2014/main" id="{4C7065CF-9445-465F-94A8-DA91F9C0BF48}"/>
+                <a16:creationId xmlns:a16="http://schemas.microsoft.com/office/drawing/2014/main" id="{3264C571-04C2-46A1-9319-187604D3AB23}"/>
               </a:ext>
             </a:extLst>
           </p:cNvPr>
@@ -4188,7 +5636,7 @@
           <p:cNvPr id="3" name="">
             <a:extLst xmlns:a="http://schemas.openxmlformats.org/drawingml/2006/main">
               <a:ext uri="{FF2B5EF4-FFF2-40B4-BE49-F238E27FC236}">
-                <a16:creationId xmlns:a16="http://schemas.microsoft.com/office/drawing/2014/main" id="{167BFA29-F12F-4948-B7E2-AD884E6F6EFB}"/>
+                <a16:creationId xmlns:a16="http://schemas.microsoft.com/office/drawing/2014/main" id="{DE5F27C6-EA01-4F4D-ACE5-A6FFE0444866}"/>
               </a:ext>
             </a:extLst>
           </p:cNvPr>
@@ -4219,7 +5667,7 @@
           <p:cNvPr id="4" name="">
             <a:extLst xmlns:a="http://schemas.openxmlformats.org/drawingml/2006/main">
               <a:ext uri="{FF2B5EF4-FFF2-40B4-BE49-F238E27FC236}">
-                <a16:creationId xmlns:a16="http://schemas.microsoft.com/office/drawing/2014/main" id="{5CBDED1C-2019-498B-B0C1-638912061157}"/>
+                <a16:creationId xmlns:a16="http://schemas.microsoft.com/office/drawing/2014/main" id="{C5C8F028-53A3-43CB-9BE3-E840DC916665}"/>
               </a:ext>
             </a:extLst>
           </p:cNvPr>
@@ -4269,7 +5717,7 @@
           <p:cNvPr id="5" name="">
             <a:extLst xmlns:a="http://schemas.openxmlformats.org/drawingml/2006/main">
               <a:ext uri="{FF2B5EF4-FFF2-40B4-BE49-F238E27FC236}">
-                <a16:creationId xmlns:a16="http://schemas.microsoft.com/office/drawing/2014/main" id="{33A914FE-A271-4E9E-8D90-0E506979D77B}"/>
+                <a16:creationId xmlns:a16="http://schemas.microsoft.com/office/drawing/2014/main" id="{D6AFCD50-4C00-4C55-AFF7-FBF41F64CBF2}"/>
               </a:ext>
             </a:extLst>
           </p:cNvPr>
@@ -4319,7 +5767,7 @@
           <p:cNvPr id="6" name="">
             <a:extLst xmlns:a="http://schemas.openxmlformats.org/drawingml/2006/main">
               <a:ext uri="{FF2B5EF4-FFF2-40B4-BE49-F238E27FC236}">
-                <a16:creationId xmlns:a16="http://schemas.microsoft.com/office/drawing/2014/main" id="{98500A35-03C5-428E-9968-B57C9E2C2C87}"/>
+                <a16:creationId xmlns:a16="http://schemas.microsoft.com/office/drawing/2014/main" id="{C02E028E-6BF6-42D6-9C04-583183B44B30}"/>
               </a:ext>
             </a:extLst>
           </p:cNvPr>
@@ -4352,7 +5800,7 @@
           <p:cNvPr id="7" name="">
             <a:extLst xmlns:a="http://schemas.openxmlformats.org/drawingml/2006/main">
               <a:ext uri="{FF2B5EF4-FFF2-40B4-BE49-F238E27FC236}">
-                <a16:creationId xmlns:a16="http://schemas.microsoft.com/office/drawing/2014/main" id="{908B3CAB-5F6E-46DB-B954-B6F7308D9DCD}"/>
+                <a16:creationId xmlns:a16="http://schemas.microsoft.com/office/drawing/2014/main" id="{E75FE30A-A100-4A4A-81AA-66BC61DBB72C}"/>
               </a:ext>
             </a:extLst>
           </p:cNvPr>
@@ -4436,7 +5884,7 @@
           <p:cNvPr id="8" name="">
             <a:extLst xmlns:a="http://schemas.openxmlformats.org/drawingml/2006/main">
               <a:ext uri="{FF2B5EF4-FFF2-40B4-BE49-F238E27FC236}">
-                <a16:creationId xmlns:a16="http://schemas.microsoft.com/office/drawing/2014/main" id="{74B7D7B8-B468-4C8D-A7A7-63788F9D9D8D}"/>
+                <a16:creationId xmlns:a16="http://schemas.microsoft.com/office/drawing/2014/main" id="{B714F170-B33D-4254-8F21-2EF9C7C40DCE}"/>
               </a:ext>
             </a:extLst>
           </p:cNvPr>
@@ -4467,7 +5915,7 @@
           <p:cNvPr id="9" name="">
             <a:extLst xmlns:a="http://schemas.openxmlformats.org/drawingml/2006/main">
               <a:ext uri="{FF2B5EF4-FFF2-40B4-BE49-F238E27FC236}">
-                <a16:creationId xmlns:a16="http://schemas.microsoft.com/office/drawing/2014/main" id="{03F4308E-081C-497E-B9CA-175DE3DD4BE6}"/>
+                <a16:creationId xmlns:a16="http://schemas.microsoft.com/office/drawing/2014/main" id="{103B5FF8-04F6-46ED-B923-CF3151B8D61D}"/>
               </a:ext>
             </a:extLst>
           </p:cNvPr>
@@ -4517,7 +5965,7 @@
           <p:cNvPr id="10" name="">
             <a:extLst xmlns:a="http://schemas.openxmlformats.org/drawingml/2006/main">
               <a:ext uri="{FF2B5EF4-FFF2-40B4-BE49-F238E27FC236}">
-                <a16:creationId xmlns:a16="http://schemas.microsoft.com/office/drawing/2014/main" id="{11C443BE-053F-4B5B-BB27-BC6D1171C14A}"/>
+                <a16:creationId xmlns:a16="http://schemas.microsoft.com/office/drawing/2014/main" id="{49AF8FBA-A49A-477E-B21D-329A0A9BE1C3}"/>
               </a:ext>
             </a:extLst>
           </p:cNvPr>
@@ -4567,7 +6015,7 @@
           <p:cNvPr id="11" name="">
             <a:extLst xmlns:a="http://schemas.openxmlformats.org/drawingml/2006/main">
               <a:ext uri="{FF2B5EF4-FFF2-40B4-BE49-F238E27FC236}">
-                <a16:creationId xmlns:a16="http://schemas.microsoft.com/office/drawing/2014/main" id="{D039E851-B986-49FF-92FA-9D683030262F}"/>
+                <a16:creationId xmlns:a16="http://schemas.microsoft.com/office/drawing/2014/main" id="{787D47FC-DD10-4E01-980A-C4F5701A87FF}"/>
               </a:ext>
             </a:extLst>
           </p:cNvPr>
@@ -4600,7 +6048,7 @@
           <p:cNvPr id="12" name="">
             <a:extLst xmlns:a="http://schemas.openxmlformats.org/drawingml/2006/main">
               <a:ext uri="{FF2B5EF4-FFF2-40B4-BE49-F238E27FC236}">
-                <a16:creationId xmlns:a16="http://schemas.microsoft.com/office/drawing/2014/main" id="{14E13225-8A18-462B-81BB-CA277B035576}"/>
+                <a16:creationId xmlns:a16="http://schemas.microsoft.com/office/drawing/2014/main" id="{2D9AE98A-6AEA-4030-8A0A-03DC0B44E335}"/>
               </a:ext>
             </a:extLst>
           </p:cNvPr>
@@ -4684,7 +6132,7 @@
           <p:cNvPr id="13" name="">
             <a:extLst xmlns:a="http://schemas.openxmlformats.org/drawingml/2006/main">
               <a:ext uri="{FF2B5EF4-FFF2-40B4-BE49-F238E27FC236}">
-                <a16:creationId xmlns:a16="http://schemas.microsoft.com/office/drawing/2014/main" id="{FD1E8350-0E5A-4546-9029-97B6DFAB2934}"/>
+                <a16:creationId xmlns:a16="http://schemas.microsoft.com/office/drawing/2014/main" id="{EFE788E7-83C1-476C-B8B5-7F4D130C74CF}"/>
               </a:ext>
             </a:extLst>
           </p:cNvPr>
@@ -4717,7 +6165,7 @@
           <p:cNvPr id="14" name="">
             <a:extLst xmlns:a="http://schemas.openxmlformats.org/drawingml/2006/main">
               <a:ext uri="{FF2B5EF4-FFF2-40B4-BE49-F238E27FC236}">
-                <a16:creationId xmlns:a16="http://schemas.microsoft.com/office/drawing/2014/main" id="{FCB443EB-4E42-455E-A652-8EA06E0DD1B7}"/>
+                <a16:creationId xmlns:a16="http://schemas.microsoft.com/office/drawing/2014/main" id="{273A5DBC-081E-48EE-9D7B-3CFF19E76F4F}"/>
               </a:ext>
             </a:extLst>
           </p:cNvPr>
@@ -4767,7 +6215,7 @@
           <p:cNvPr id="15" name="">
             <a:extLst xmlns:a="http://schemas.openxmlformats.org/drawingml/2006/main">
               <a:ext uri="{FF2B5EF4-FFF2-40B4-BE49-F238E27FC236}">
-                <a16:creationId xmlns:a16="http://schemas.microsoft.com/office/drawing/2014/main" id="{E4F69070-6AFF-41CF-9FED-DABEC3B3F885}"/>
+                <a16:creationId xmlns:a16="http://schemas.microsoft.com/office/drawing/2014/main" id="{F879E31A-009A-4547-B78F-D84C6F5F5E54}"/>
               </a:ext>
             </a:extLst>
           </p:cNvPr>
@@ -4815,7 +6263,7 @@
     </p:spTree>
     <p:extLst>
       <p:ext uri="{BB962C8B-B14F-4D97-AF65-F5344CB8AC3E}">
-        <p14:creationId xmlns:p14="http://schemas.microsoft.com/office/powerpoint/2010/main" val="696732711"/>
+        <p14:creationId xmlns:p14="http://schemas.microsoft.com/office/powerpoint/2010/main" val="1128289508"/>
       </p:ext>
     </p:extLst>
   </p:cSld>
@@ -4846,7 +6294,7 @@
           <p:cNvPr id="1" name="">
             <a:extLst xmlns:a="http://schemas.openxmlformats.org/drawingml/2006/main">
               <a:ext uri="{FF2B5EF4-FFF2-40B4-BE49-F238E27FC236}">
-                <a16:creationId xmlns:a16="http://schemas.microsoft.com/office/drawing/2014/main" id="{65ADB377-17B5-45CE-BCB0-BC38C6CE8BA3}"/>
+                <a16:creationId xmlns:a16="http://schemas.microsoft.com/office/drawing/2014/main" id="{7CD1F644-1A95-4F0F-9ED4-02D7A0079989}"/>
               </a:ext>
             </a:extLst>
           </p:cNvPr>
@@ -4896,7 +6344,7 @@
           <p:cNvPr id="2" name="">
             <a:extLst xmlns:a="http://schemas.openxmlformats.org/drawingml/2006/main">
               <a:ext uri="{FF2B5EF4-FFF2-40B4-BE49-F238E27FC236}">
-                <a16:creationId xmlns:a16="http://schemas.microsoft.com/office/drawing/2014/main" id="{3C15BF38-EC4C-4492-A5FA-4186E28A8025}"/>
+                <a16:creationId xmlns:a16="http://schemas.microsoft.com/office/drawing/2014/main" id="{677EA99C-3256-4B75-9D80-F454AB29777B}"/>
               </a:ext>
             </a:extLst>
           </p:cNvPr>
@@ -4946,7 +6394,7 @@
           <p:cNvPr id="3" name="">
             <a:extLst xmlns:a="http://schemas.openxmlformats.org/drawingml/2006/main">
               <a:ext uri="{FF2B5EF4-FFF2-40B4-BE49-F238E27FC236}">
-                <a16:creationId xmlns:a16="http://schemas.microsoft.com/office/drawing/2014/main" id="{9E282AF2-A2BC-4157-BEA5-F06A7878ADB4}"/>
+                <a16:creationId xmlns:a16="http://schemas.microsoft.com/office/drawing/2014/main" id="{9585B6D0-23E0-41D7-9CB3-0DE2556DEAE4}"/>
               </a:ext>
             </a:extLst>
           </p:cNvPr>
@@ -4996,7 +6444,7 @@
           <p:cNvPr id="4" name="">
             <a:extLst xmlns:a="http://schemas.openxmlformats.org/drawingml/2006/main">
               <a:ext uri="{FF2B5EF4-FFF2-40B4-BE49-F238E27FC236}">
-                <a16:creationId xmlns:a16="http://schemas.microsoft.com/office/drawing/2014/main" id="{A5BAF0C5-3FCA-4EA8-BA74-6C3CE6E871CB}"/>
+                <a16:creationId xmlns:a16="http://schemas.microsoft.com/office/drawing/2014/main" id="{CA7E8625-6004-4156-B67C-4A68D2D95343}"/>
               </a:ext>
             </a:extLst>
           </p:cNvPr>
@@ -5027,7 +6475,7 @@
           <p:cNvPr id="5" name="">
             <a:extLst xmlns:a="http://schemas.openxmlformats.org/drawingml/2006/main">
               <a:ext uri="{FF2B5EF4-FFF2-40B4-BE49-F238E27FC236}">
-                <a16:creationId xmlns:a16="http://schemas.microsoft.com/office/drawing/2014/main" id="{6424A4D5-FBF0-4131-846A-59ED32AD787D}"/>
+                <a16:creationId xmlns:a16="http://schemas.microsoft.com/office/drawing/2014/main" id="{882E2308-782F-42F8-A2BC-BA183B73C2E9}"/>
               </a:ext>
             </a:extLst>
           </p:cNvPr>
@@ -5077,7 +6525,7 @@
           <p:cNvPr id="6" name="">
             <a:extLst xmlns:a="http://schemas.openxmlformats.org/drawingml/2006/main">
               <a:ext uri="{FF2B5EF4-FFF2-40B4-BE49-F238E27FC236}">
-                <a16:creationId xmlns:a16="http://schemas.microsoft.com/office/drawing/2014/main" id="{3CBB8A6B-DFBA-4B89-8793-41A3915E0F0C}"/>
+                <a16:creationId xmlns:a16="http://schemas.microsoft.com/office/drawing/2014/main" id="{CC386421-3E8F-42B9-988F-E4B45546665C}"/>
               </a:ext>
             </a:extLst>
           </p:cNvPr>
@@ -5127,7 +6575,7 @@
           <p:cNvPr id="7" name="">
             <a:extLst xmlns:a="http://schemas.openxmlformats.org/drawingml/2006/main">
               <a:ext uri="{FF2B5EF4-FFF2-40B4-BE49-F238E27FC236}">
-                <a16:creationId xmlns:a16="http://schemas.microsoft.com/office/drawing/2014/main" id="{6DC0B608-F916-4F95-98A1-BD7C22A72223}"/>
+                <a16:creationId xmlns:a16="http://schemas.microsoft.com/office/drawing/2014/main" id="{EB4EB06F-F56D-4774-87BB-9646CAE819EC}"/>
               </a:ext>
             </a:extLst>
           </p:cNvPr>
@@ -5158,7 +6606,7 @@
           <p:cNvPr id="8" name="">
             <a:extLst xmlns:a="http://schemas.openxmlformats.org/drawingml/2006/main">
               <a:ext uri="{FF2B5EF4-FFF2-40B4-BE49-F238E27FC236}">
-                <a16:creationId xmlns:a16="http://schemas.microsoft.com/office/drawing/2014/main" id="{4F61E967-544A-4107-BE83-101B3316125A}"/>
+                <a16:creationId xmlns:a16="http://schemas.microsoft.com/office/drawing/2014/main" id="{BA50A6C3-2D40-446D-AE37-724621F186C6}"/>
               </a:ext>
             </a:extLst>
           </p:cNvPr>
@@ -5208,7 +6656,7 @@
           <p:cNvPr id="9" name="">
             <a:extLst xmlns:a="http://schemas.openxmlformats.org/drawingml/2006/main">
               <a:ext uri="{FF2B5EF4-FFF2-40B4-BE49-F238E27FC236}">
-                <a16:creationId xmlns:a16="http://schemas.microsoft.com/office/drawing/2014/main" id="{B6B2685C-28DA-4C4A-AAED-0BF3AECBEF76}"/>
+                <a16:creationId xmlns:a16="http://schemas.microsoft.com/office/drawing/2014/main" id="{760760CE-2E73-4201-AF94-6506C3CAD4F5}"/>
               </a:ext>
             </a:extLst>
           </p:cNvPr>
@@ -5258,7 +6706,7 @@
           <p:cNvPr id="10" name="">
             <a:extLst xmlns:a="http://schemas.openxmlformats.org/drawingml/2006/main">
               <a:ext uri="{FF2B5EF4-FFF2-40B4-BE49-F238E27FC236}">
-                <a16:creationId xmlns:a16="http://schemas.microsoft.com/office/drawing/2014/main" id="{480B4AD4-8E7A-4063-AC12-D72D08BD5113}"/>
+                <a16:creationId xmlns:a16="http://schemas.microsoft.com/office/drawing/2014/main" id="{974D9E04-D409-4A51-90E0-20393F0AA4CF}"/>
               </a:ext>
             </a:extLst>
           </p:cNvPr>
@@ -5289,7 +6737,7 @@
           <p:cNvPr id="11" name="">
             <a:extLst xmlns:a="http://schemas.openxmlformats.org/drawingml/2006/main">
               <a:ext uri="{FF2B5EF4-FFF2-40B4-BE49-F238E27FC236}">
-                <a16:creationId xmlns:a16="http://schemas.microsoft.com/office/drawing/2014/main" id="{9BF660BA-5130-4DD8-BA50-1AFC38A143A2}"/>
+                <a16:creationId xmlns:a16="http://schemas.microsoft.com/office/drawing/2014/main" id="{1B89A485-0021-420F-96C2-814ABAD5AEB8}"/>
               </a:ext>
             </a:extLst>
           </p:cNvPr>
@@ -5339,7 +6787,7 @@
           <p:cNvPr id="12" name="">
             <a:extLst xmlns:a="http://schemas.openxmlformats.org/drawingml/2006/main">
               <a:ext uri="{FF2B5EF4-FFF2-40B4-BE49-F238E27FC236}">
-                <a16:creationId xmlns:a16="http://schemas.microsoft.com/office/drawing/2014/main" id="{B0372723-48F9-4033-9276-D6BC600564D9}"/>
+                <a16:creationId xmlns:a16="http://schemas.microsoft.com/office/drawing/2014/main" id="{ABA4B93C-887B-4CA9-822F-4E5FC26682AB}"/>
               </a:ext>
             </a:extLst>
           </p:cNvPr>
@@ -5389,7 +6837,7 @@
           <p:cNvPr id="13" name="">
             <a:extLst xmlns:a="http://schemas.openxmlformats.org/drawingml/2006/main">
               <a:ext uri="{FF2B5EF4-FFF2-40B4-BE49-F238E27FC236}">
-                <a16:creationId xmlns:a16="http://schemas.microsoft.com/office/drawing/2014/main" id="{EFE3BD57-1EB0-4283-B1D1-EA2AB1C5B597}"/>
+                <a16:creationId xmlns:a16="http://schemas.microsoft.com/office/drawing/2014/main" id="{EA1CEDAE-C8EB-4E1D-B4C4-58734FDBDD33}"/>
               </a:ext>
             </a:extLst>
           </p:cNvPr>
@@ -5422,7 +6870,7 @@
           <p:cNvPr id="14" name="">
             <a:extLst xmlns:a="http://schemas.openxmlformats.org/drawingml/2006/main">
               <a:ext uri="{FF2B5EF4-FFF2-40B4-BE49-F238E27FC236}">
-                <a16:creationId xmlns:a16="http://schemas.microsoft.com/office/drawing/2014/main" id="{14A7374F-9E26-49F4-9759-BFD9E4A74BE6}"/>
+                <a16:creationId xmlns:a16="http://schemas.microsoft.com/office/drawing/2014/main" id="{6F6EFFEF-D34B-44A6-90D8-C800EC09FB70}"/>
               </a:ext>
             </a:extLst>
           </p:cNvPr>
@@ -5472,7 +6920,7 @@
           <p:cNvPr id="15" name="">
             <a:extLst xmlns:a="http://schemas.openxmlformats.org/drawingml/2006/main">
               <a:ext uri="{FF2B5EF4-FFF2-40B4-BE49-F238E27FC236}">
-                <a16:creationId xmlns:a16="http://schemas.microsoft.com/office/drawing/2014/main" id="{40C4D880-5B64-4B5F-A34C-241240D4A1F8}"/>
+                <a16:creationId xmlns:a16="http://schemas.microsoft.com/office/drawing/2014/main" id="{1B4581C7-663B-4807-BF10-375A7850498F}"/>
               </a:ext>
             </a:extLst>
           </p:cNvPr>
@@ -5520,7 +6968,7 @@
     </p:spTree>
     <p:extLst>
       <p:ext uri="{BB962C8B-B14F-4D97-AF65-F5344CB8AC3E}">
-        <p14:creationId xmlns:p14="http://schemas.microsoft.com/office/powerpoint/2010/main" val="269918615"/>
+        <p14:creationId xmlns:p14="http://schemas.microsoft.com/office/powerpoint/2010/main" val="1132917537"/>
       </p:ext>
     </p:extLst>
   </p:cSld>
@@ -5551,7 +6999,7 @@
           <p:cNvPr id="1" name="">
             <a:extLst xmlns:a="http://schemas.openxmlformats.org/drawingml/2006/main">
               <a:ext uri="{FF2B5EF4-FFF2-40B4-BE49-F238E27FC236}">
-                <a16:creationId xmlns:a16="http://schemas.microsoft.com/office/drawing/2014/main" id="{51EB65AE-AF87-4BAB-9633-52C720EE43A4}"/>
+                <a16:creationId xmlns:a16="http://schemas.microsoft.com/office/drawing/2014/main" id="{7C88CE35-C315-46C4-BB91-939BE0D17156}"/>
               </a:ext>
             </a:extLst>
           </p:cNvPr>
@@ -5601,7 +7049,7 @@
           <p:cNvPr id="2" name="">
             <a:extLst xmlns:a="http://schemas.openxmlformats.org/drawingml/2006/main">
               <a:ext uri="{FF2B5EF4-FFF2-40B4-BE49-F238E27FC236}">
-                <a16:creationId xmlns:a16="http://schemas.microsoft.com/office/drawing/2014/main" id="{DF481CB8-6037-4575-976B-B5068DC63276}"/>
+                <a16:creationId xmlns:a16="http://schemas.microsoft.com/office/drawing/2014/main" id="{14DA63F5-E68F-41F5-A7F3-A8E7550254E2}"/>
               </a:ext>
             </a:extLst>
           </p:cNvPr>
@@ -5651,7 +7099,7 @@
           <p:cNvPr id="3" name="">
             <a:extLst xmlns:a="http://schemas.openxmlformats.org/drawingml/2006/main">
               <a:ext uri="{FF2B5EF4-FFF2-40B4-BE49-F238E27FC236}">
-                <a16:creationId xmlns:a16="http://schemas.microsoft.com/office/drawing/2014/main" id="{10E193DF-651D-4C16-84EF-0EED6FFF898F}"/>
+                <a16:creationId xmlns:a16="http://schemas.microsoft.com/office/drawing/2014/main" id="{4E571858-0273-4DBB-89C9-132CE1259DE8}"/>
               </a:ext>
             </a:extLst>
           </p:cNvPr>
@@ -5701,7 +7149,7 @@
           <p:cNvPr id="4" name="">
             <a:extLst xmlns:a="http://schemas.openxmlformats.org/drawingml/2006/main">
               <a:ext uri="{FF2B5EF4-FFF2-40B4-BE49-F238E27FC236}">
-                <a16:creationId xmlns:a16="http://schemas.microsoft.com/office/drawing/2014/main" id="{9348C67B-3FF7-4214-845F-C646C16A0C60}"/>
+                <a16:creationId xmlns:a16="http://schemas.microsoft.com/office/drawing/2014/main" id="{07D71633-04EE-4568-87AA-7E8914134669}"/>
               </a:ext>
             </a:extLst>
           </p:cNvPr>
@@ -5751,7 +7199,7 @@
           <p:cNvPr id="5" name="">
             <a:extLst xmlns:a="http://schemas.openxmlformats.org/drawingml/2006/main">
               <a:ext uri="{FF2B5EF4-FFF2-40B4-BE49-F238E27FC236}">
-                <a16:creationId xmlns:a16="http://schemas.microsoft.com/office/drawing/2014/main" id="{573D9C0C-8658-4689-A9D8-7B5E2BA17A58}"/>
+                <a16:creationId xmlns:a16="http://schemas.microsoft.com/office/drawing/2014/main" id="{DB8E03AA-E8C4-4597-A012-B422D7F3CE0F}"/>
               </a:ext>
             </a:extLst>
           </p:cNvPr>
@@ -5886,7 +7334,7 @@
           <p:cNvPr id="6" name="">
             <a:extLst xmlns:a="http://schemas.openxmlformats.org/drawingml/2006/main">
               <a:ext uri="{FF2B5EF4-FFF2-40B4-BE49-F238E27FC236}">
-                <a16:creationId xmlns:a16="http://schemas.microsoft.com/office/drawing/2014/main" id="{FAC7B3BF-B522-46E6-BEC1-28C3507C461B}"/>
+                <a16:creationId xmlns:a16="http://schemas.microsoft.com/office/drawing/2014/main" id="{D3E01247-0A36-4DAD-9491-FF6C2F56827C}"/>
               </a:ext>
             </a:extLst>
           </p:cNvPr>
@@ -5936,7 +7384,7 @@
           <p:cNvPr id="7" name="">
             <a:extLst xmlns:a="http://schemas.openxmlformats.org/drawingml/2006/main">
               <a:ext uri="{FF2B5EF4-FFF2-40B4-BE49-F238E27FC236}">
-                <a16:creationId xmlns:a16="http://schemas.microsoft.com/office/drawing/2014/main" id="{33905D27-08AE-4C7C-BA70-2D46B4A55582}"/>
+                <a16:creationId xmlns:a16="http://schemas.microsoft.com/office/drawing/2014/main" id="{46A09022-7666-4384-9D75-92AEB01669BE}"/>
               </a:ext>
             </a:extLst>
           </p:cNvPr>
@@ -5967,7 +7415,7 @@
           <p:cNvPr id="8" name="">
             <a:extLst xmlns:a="http://schemas.openxmlformats.org/drawingml/2006/main">
               <a:ext uri="{FF2B5EF4-FFF2-40B4-BE49-F238E27FC236}">
-                <a16:creationId xmlns:a16="http://schemas.microsoft.com/office/drawing/2014/main" id="{DCD9E953-A4F8-4657-9E84-4E2E7CF544F6}"/>
+                <a16:creationId xmlns:a16="http://schemas.microsoft.com/office/drawing/2014/main" id="{5372524E-D975-4916-9E23-9283115D423A}"/>
               </a:ext>
             </a:extLst>
           </p:cNvPr>
@@ -6017,7 +7465,7 @@
           <p:cNvPr id="9" name="">
             <a:extLst xmlns:a="http://schemas.openxmlformats.org/drawingml/2006/main">
               <a:ext uri="{FF2B5EF4-FFF2-40B4-BE49-F238E27FC236}">
-                <a16:creationId xmlns:a16="http://schemas.microsoft.com/office/drawing/2014/main" id="{AB8D11D5-3BDD-4977-83DE-58CC23059F55}"/>
+                <a16:creationId xmlns:a16="http://schemas.microsoft.com/office/drawing/2014/main" id="{C32953D5-8C6A-4759-98E9-3A9B40881F9C}"/>
               </a:ext>
             </a:extLst>
           </p:cNvPr>
@@ -6048,7 +7496,7 @@
           <p:cNvPr id="10" name="">
             <a:extLst xmlns:a="http://schemas.openxmlformats.org/drawingml/2006/main">
               <a:ext uri="{FF2B5EF4-FFF2-40B4-BE49-F238E27FC236}">
-                <a16:creationId xmlns:a16="http://schemas.microsoft.com/office/drawing/2014/main" id="{2F9F84E8-8CC0-48D3-80B4-C1C657CAEB26}"/>
+                <a16:creationId xmlns:a16="http://schemas.microsoft.com/office/drawing/2014/main" id="{097B1D9F-1643-4447-8329-B53FEC169629}"/>
               </a:ext>
             </a:extLst>
           </p:cNvPr>
@@ -6098,7 +7546,7 @@
           <p:cNvPr id="11" name="">
             <a:extLst xmlns:a="http://schemas.openxmlformats.org/drawingml/2006/main">
               <a:ext uri="{FF2B5EF4-FFF2-40B4-BE49-F238E27FC236}">
-                <a16:creationId xmlns:a16="http://schemas.microsoft.com/office/drawing/2014/main" id="{E5980BD8-749C-4EEB-BE3A-42E545255F7D}"/>
+                <a16:creationId xmlns:a16="http://schemas.microsoft.com/office/drawing/2014/main" id="{572C801D-5F70-483C-82EC-6AB5B879BCCC}"/>
               </a:ext>
             </a:extLst>
           </p:cNvPr>
@@ -6148,7 +7596,7 @@
           <p:cNvPr id="12" name="">
             <a:extLst xmlns:a="http://schemas.openxmlformats.org/drawingml/2006/main">
               <a:ext uri="{FF2B5EF4-FFF2-40B4-BE49-F238E27FC236}">
-                <a16:creationId xmlns:a16="http://schemas.microsoft.com/office/drawing/2014/main" id="{D3612262-42F3-42C6-9F9A-954369F47698}"/>
+                <a16:creationId xmlns:a16="http://schemas.microsoft.com/office/drawing/2014/main" id="{6CC0112C-A59F-4E24-9D84-C936CFCF688D}"/>
               </a:ext>
             </a:extLst>
           </p:cNvPr>
@@ -6181,7 +7629,7 @@
           <p:cNvPr id="13" name="">
             <a:extLst xmlns:a="http://schemas.openxmlformats.org/drawingml/2006/main">
               <a:ext uri="{FF2B5EF4-FFF2-40B4-BE49-F238E27FC236}">
-                <a16:creationId xmlns:a16="http://schemas.microsoft.com/office/drawing/2014/main" id="{A0C474D0-E8BC-4CBF-B1D5-C1B2560C1662}"/>
+                <a16:creationId xmlns:a16="http://schemas.microsoft.com/office/drawing/2014/main" id="{193BB7BA-5FEA-473F-843D-35D07A031BD0}"/>
               </a:ext>
             </a:extLst>
           </p:cNvPr>
@@ -6231,7 +7679,7 @@
           <p:cNvPr id="14" name="">
             <a:extLst xmlns:a="http://schemas.openxmlformats.org/drawingml/2006/main">
               <a:ext uri="{FF2B5EF4-FFF2-40B4-BE49-F238E27FC236}">
-                <a16:creationId xmlns:a16="http://schemas.microsoft.com/office/drawing/2014/main" id="{3C3A7859-E86D-4912-8567-5B111F80A0E4}"/>
+                <a16:creationId xmlns:a16="http://schemas.microsoft.com/office/drawing/2014/main" id="{C3523082-4F21-4D9B-8F4B-1C36AE31EFBE}"/>
               </a:ext>
             </a:extLst>
           </p:cNvPr>
@@ -6279,7 +7727,7 @@
     </p:spTree>
     <p:extLst>
       <p:ext uri="{BB962C8B-B14F-4D97-AF65-F5344CB8AC3E}">
-        <p14:creationId xmlns:p14="http://schemas.microsoft.com/office/powerpoint/2010/main" val="1695776696"/>
+        <p14:creationId xmlns:p14="http://schemas.microsoft.com/office/powerpoint/2010/main" val="306303268"/>
       </p:ext>
     </p:extLst>
   </p:cSld>
@@ -6310,7 +7758,7 @@
           <p:cNvPr id="1" name="">
             <a:extLst xmlns:a="http://schemas.openxmlformats.org/drawingml/2006/main">
               <a:ext uri="{FF2B5EF4-FFF2-40B4-BE49-F238E27FC236}">
-                <a16:creationId xmlns:a16="http://schemas.microsoft.com/office/drawing/2014/main" id="{B96222BF-D581-420B-B7EF-77785F4A96E0}"/>
+                <a16:creationId xmlns:a16="http://schemas.microsoft.com/office/drawing/2014/main" id="{0561A77D-C60F-4AD3-90FF-95D196DDE728}"/>
               </a:ext>
             </a:extLst>
           </p:cNvPr>
@@ -6360,7 +7808,7 @@
           <p:cNvPr id="2" name="">
             <a:extLst xmlns:a="http://schemas.openxmlformats.org/drawingml/2006/main">
               <a:ext uri="{FF2B5EF4-FFF2-40B4-BE49-F238E27FC236}">
-                <a16:creationId xmlns:a16="http://schemas.microsoft.com/office/drawing/2014/main" id="{244AC98C-70DE-4E3A-A1A7-D1E527954C1E}"/>
+                <a16:creationId xmlns:a16="http://schemas.microsoft.com/office/drawing/2014/main" id="{643D82CF-7CE4-429A-B026-F9389F4C7DF3}"/>
               </a:ext>
             </a:extLst>
           </p:cNvPr>
@@ -6410,7 +7858,7 @@
           <p:cNvPr id="3" name="">
             <a:extLst xmlns:a="http://schemas.openxmlformats.org/drawingml/2006/main">
               <a:ext uri="{FF2B5EF4-FFF2-40B4-BE49-F238E27FC236}">
-                <a16:creationId xmlns:a16="http://schemas.microsoft.com/office/drawing/2014/main" id="{2BA0D338-3C57-4C84-A921-8ED6DB06C0D3}"/>
+                <a16:creationId xmlns:a16="http://schemas.microsoft.com/office/drawing/2014/main" id="{7E04A3E6-F951-4AB0-9A29-8164CB21D00A}"/>
               </a:ext>
             </a:extLst>
           </p:cNvPr>
@@ -6460,7 +7908,7 @@
           <p:cNvPr id="4" name="">
             <a:extLst xmlns:a="http://schemas.openxmlformats.org/drawingml/2006/main">
               <a:ext uri="{FF2B5EF4-FFF2-40B4-BE49-F238E27FC236}">
-                <a16:creationId xmlns:a16="http://schemas.microsoft.com/office/drawing/2014/main" id="{E749C205-7254-4C50-9CA4-4EFE87B9DB79}"/>
+                <a16:creationId xmlns:a16="http://schemas.microsoft.com/office/drawing/2014/main" id="{CDF10A79-FDD0-4253-887C-37AB83105068}"/>
               </a:ext>
             </a:extLst>
           </p:cNvPr>
@@ -6578,7 +8026,7 @@
           <p:cNvPr id="5" name="">
             <a:extLst xmlns:a="http://schemas.openxmlformats.org/drawingml/2006/main">
               <a:ext uri="{FF2B5EF4-FFF2-40B4-BE49-F238E27FC236}">
-                <a16:creationId xmlns:a16="http://schemas.microsoft.com/office/drawing/2014/main" id="{6AD87E77-1173-4A05-9519-7353CDB5B459}"/>
+                <a16:creationId xmlns:a16="http://schemas.microsoft.com/office/drawing/2014/main" id="{B7F3AB89-F4C0-40DE-BB80-E7A1E2F83244}"/>
               </a:ext>
             </a:extLst>
           </p:cNvPr>
@@ -6628,7 +8076,7 @@
           <p:cNvPr id="6" name="">
             <a:extLst xmlns:a="http://schemas.openxmlformats.org/drawingml/2006/main">
               <a:ext uri="{FF2B5EF4-FFF2-40B4-BE49-F238E27FC236}">
-                <a16:creationId xmlns:a16="http://schemas.microsoft.com/office/drawing/2014/main" id="{AD50A039-B3C0-4D49-A029-07369DDDFD38}"/>
+                <a16:creationId xmlns:a16="http://schemas.microsoft.com/office/drawing/2014/main" id="{96BEBF57-62C4-490A-BBA4-441C11104388}"/>
               </a:ext>
             </a:extLst>
           </p:cNvPr>
@@ -6729,7 +8177,7 @@
           <p:cNvPr id="7" name="">
             <a:extLst xmlns:a="http://schemas.openxmlformats.org/drawingml/2006/main">
               <a:ext uri="{FF2B5EF4-FFF2-40B4-BE49-F238E27FC236}">
-                <a16:creationId xmlns:a16="http://schemas.microsoft.com/office/drawing/2014/main" id="{27FE2111-8C86-45DF-8769-A57E9967FAEB}"/>
+                <a16:creationId xmlns:a16="http://schemas.microsoft.com/office/drawing/2014/main" id="{EBE1D08D-3B5F-4B40-94B8-61310536C99C}"/>
               </a:ext>
             </a:extLst>
           </p:cNvPr>
@@ -6760,7 +8208,7 @@
           <p:cNvPr id="8" name="">
             <a:extLst xmlns:a="http://schemas.openxmlformats.org/drawingml/2006/main">
               <a:ext uri="{FF2B5EF4-FFF2-40B4-BE49-F238E27FC236}">
-                <a16:creationId xmlns:a16="http://schemas.microsoft.com/office/drawing/2014/main" id="{D18FC1AA-6CEB-42FC-8CA4-C00A9BE0114A}"/>
+                <a16:creationId xmlns:a16="http://schemas.microsoft.com/office/drawing/2014/main" id="{DC262963-F092-4BAB-BD22-59836E8E849C}"/>
               </a:ext>
             </a:extLst>
           </p:cNvPr>
@@ -6810,7 +8258,7 @@
           <p:cNvPr id="9" name="">
             <a:extLst xmlns:a="http://schemas.openxmlformats.org/drawingml/2006/main">
               <a:ext uri="{FF2B5EF4-FFF2-40B4-BE49-F238E27FC236}">
-                <a16:creationId xmlns:a16="http://schemas.microsoft.com/office/drawing/2014/main" id="{697BAAB7-F834-485F-A669-5D17748A11BB}"/>
+                <a16:creationId xmlns:a16="http://schemas.microsoft.com/office/drawing/2014/main" id="{D188F64D-48BC-4C96-B3AA-66D6F8FD681C}"/>
               </a:ext>
             </a:extLst>
           </p:cNvPr>
@@ -6843,7 +8291,7 @@
           <p:cNvPr id="10" name="">
             <a:extLst xmlns:a="http://schemas.openxmlformats.org/drawingml/2006/main">
               <a:ext uri="{FF2B5EF4-FFF2-40B4-BE49-F238E27FC236}">
-                <a16:creationId xmlns:a16="http://schemas.microsoft.com/office/drawing/2014/main" id="{0931BC5A-EF7E-483B-AB61-92E1BC5B816D}"/>
+                <a16:creationId xmlns:a16="http://schemas.microsoft.com/office/drawing/2014/main" id="{D01FA299-80BE-4A03-82B5-A1900DFC30FC}"/>
               </a:ext>
             </a:extLst>
           </p:cNvPr>
@@ -6893,7 +8341,7 @@
           <p:cNvPr id="11" name="">
             <a:extLst xmlns:a="http://schemas.openxmlformats.org/drawingml/2006/main">
               <a:ext uri="{FF2B5EF4-FFF2-40B4-BE49-F238E27FC236}">
-                <a16:creationId xmlns:a16="http://schemas.microsoft.com/office/drawing/2014/main" id="{E779A3C5-89E5-4112-AE8B-BEDFB2CFF62A}"/>
+                <a16:creationId xmlns:a16="http://schemas.microsoft.com/office/drawing/2014/main" id="{F5375C9F-08C8-4BDA-9156-ECC6FE519A10}"/>
               </a:ext>
             </a:extLst>
           </p:cNvPr>
@@ -6941,7 +8389,7 @@
     </p:spTree>
     <p:extLst>
       <p:ext uri="{BB962C8B-B14F-4D97-AF65-F5344CB8AC3E}">
-        <p14:creationId xmlns:p14="http://schemas.microsoft.com/office/powerpoint/2010/main" val="1400951372"/>
+        <p14:creationId xmlns:p14="http://schemas.microsoft.com/office/powerpoint/2010/main" val="2017320787"/>
       </p:ext>
     </p:extLst>
   </p:cSld>
@@ -6972,7 +8420,7 @@
           <p:cNvPr id="1" name="">
             <a:extLst xmlns:a="http://schemas.openxmlformats.org/drawingml/2006/main">
               <a:ext uri="{FF2B5EF4-FFF2-40B4-BE49-F238E27FC236}">
-                <a16:creationId xmlns:a16="http://schemas.microsoft.com/office/drawing/2014/main" id="{17C03F0F-017F-4997-9969-111DC3BA3ABA}"/>
+                <a16:creationId xmlns:a16="http://schemas.microsoft.com/office/drawing/2014/main" id="{AB42DE12-0C0F-4E93-A048-B7AE82EA1859}"/>
               </a:ext>
             </a:extLst>
           </p:cNvPr>
@@ -7022,7 +8470,7 @@
           <p:cNvPr id="2" name="">
             <a:extLst xmlns:a="http://schemas.openxmlformats.org/drawingml/2006/main">
               <a:ext uri="{FF2B5EF4-FFF2-40B4-BE49-F238E27FC236}">
-                <a16:creationId xmlns:a16="http://schemas.microsoft.com/office/drawing/2014/main" id="{5DFAC302-D81B-46E3-8381-AE5B3E8863A3}"/>
+                <a16:creationId xmlns:a16="http://schemas.microsoft.com/office/drawing/2014/main" id="{D56F2DB5-8A10-4FF1-B96C-7F071F0C5CD0}"/>
               </a:ext>
             </a:extLst>
           </p:cNvPr>
@@ -7072,7 +8520,7 @@
           <p:cNvPr id="3" name="">
             <a:extLst xmlns:a="http://schemas.openxmlformats.org/drawingml/2006/main">
               <a:ext uri="{FF2B5EF4-FFF2-40B4-BE49-F238E27FC236}">
-                <a16:creationId xmlns:a16="http://schemas.microsoft.com/office/drawing/2014/main" id="{D4696A97-D674-4DA4-AA95-B2DD52BD62F4}"/>
+                <a16:creationId xmlns:a16="http://schemas.microsoft.com/office/drawing/2014/main" id="{4DB8AB1B-51A9-42E2-9FEA-02E811BA5EF5}"/>
               </a:ext>
             </a:extLst>
           </p:cNvPr>
@@ -7122,7 +8570,7 @@
           <p:cNvPr id="4" name="">
             <a:extLst xmlns:a="http://schemas.openxmlformats.org/drawingml/2006/main">
               <a:ext uri="{FF2B5EF4-FFF2-40B4-BE49-F238E27FC236}">
-                <a16:creationId xmlns:a16="http://schemas.microsoft.com/office/drawing/2014/main" id="{CF136522-3DFF-411C-B89C-CC240965F59D}"/>
+                <a16:creationId xmlns:a16="http://schemas.microsoft.com/office/drawing/2014/main" id="{04DB264A-3746-4104-8F8B-618A479851A8}"/>
               </a:ext>
             </a:extLst>
           </p:cNvPr>
@@ -7153,7 +8601,7 @@
           <p:cNvPr id="5" name="">
             <a:extLst xmlns:a="http://schemas.openxmlformats.org/drawingml/2006/main">
               <a:ext uri="{FF2B5EF4-FFF2-40B4-BE49-F238E27FC236}">
-                <a16:creationId xmlns:a16="http://schemas.microsoft.com/office/drawing/2014/main" id="{1AE87FC7-49D3-4AD1-B6BB-F23EC5AD0CCC}"/>
+                <a16:creationId xmlns:a16="http://schemas.microsoft.com/office/drawing/2014/main" id="{816B5830-B41A-4A1B-A442-6F0FF4E65D3B}"/>
               </a:ext>
             </a:extLst>
           </p:cNvPr>
@@ -7203,7 +8651,7 @@
           <p:cNvPr id="6" name="">
             <a:extLst xmlns:a="http://schemas.openxmlformats.org/drawingml/2006/main">
               <a:ext uri="{FF2B5EF4-FFF2-40B4-BE49-F238E27FC236}">
-                <a16:creationId xmlns:a16="http://schemas.microsoft.com/office/drawing/2014/main" id="{5FD408C0-8E20-458B-9F78-1B7DE920B54E}"/>
+                <a16:creationId xmlns:a16="http://schemas.microsoft.com/office/drawing/2014/main" id="{CC912A06-AD27-41E7-A79F-26139A8758BB}"/>
               </a:ext>
             </a:extLst>
           </p:cNvPr>
@@ -7253,7 +8701,7 @@
           <p:cNvPr id="7" name="">
             <a:extLst xmlns:a="http://schemas.openxmlformats.org/drawingml/2006/main">
               <a:ext uri="{FF2B5EF4-FFF2-40B4-BE49-F238E27FC236}">
-                <a16:creationId xmlns:a16="http://schemas.microsoft.com/office/drawing/2014/main" id="{4F8A9B70-F535-4F06-B0DE-B388697EE852}"/>
+                <a16:creationId xmlns:a16="http://schemas.microsoft.com/office/drawing/2014/main" id="{8F15A191-1696-4C48-8E78-D091757B5B21}"/>
               </a:ext>
             </a:extLst>
           </p:cNvPr>
@@ -7284,7 +8732,7 @@
           <p:cNvPr id="8" name="">
             <a:extLst xmlns:a="http://schemas.openxmlformats.org/drawingml/2006/main">
               <a:ext uri="{FF2B5EF4-FFF2-40B4-BE49-F238E27FC236}">
-                <a16:creationId xmlns:a16="http://schemas.microsoft.com/office/drawing/2014/main" id="{C5629F78-6DFE-4641-8D90-6EE05BA2937A}"/>
+                <a16:creationId xmlns:a16="http://schemas.microsoft.com/office/drawing/2014/main" id="{BE787AAD-EE6E-40F4-BADA-6184DF88D5A9}"/>
               </a:ext>
             </a:extLst>
           </p:cNvPr>
@@ -7334,7 +8782,7 @@
           <p:cNvPr id="9" name="">
             <a:extLst xmlns:a="http://schemas.openxmlformats.org/drawingml/2006/main">
               <a:ext uri="{FF2B5EF4-FFF2-40B4-BE49-F238E27FC236}">
-                <a16:creationId xmlns:a16="http://schemas.microsoft.com/office/drawing/2014/main" id="{61CE605E-1C65-49D9-BF88-F776676996A7}"/>
+                <a16:creationId xmlns:a16="http://schemas.microsoft.com/office/drawing/2014/main" id="{D7E3C1B3-784D-4783-A87F-A82F38812837}"/>
               </a:ext>
             </a:extLst>
           </p:cNvPr>
@@ -7384,7 +8832,7 @@
           <p:cNvPr id="10" name="">
             <a:extLst xmlns:a="http://schemas.openxmlformats.org/drawingml/2006/main">
               <a:ext uri="{FF2B5EF4-FFF2-40B4-BE49-F238E27FC236}">
-                <a16:creationId xmlns:a16="http://schemas.microsoft.com/office/drawing/2014/main" id="{1434BFE0-E5F9-4BBF-A82B-70DA01BCF68D}"/>
+                <a16:creationId xmlns:a16="http://schemas.microsoft.com/office/drawing/2014/main" id="{52BA21A0-5123-45AB-942B-025234EF3C71}"/>
               </a:ext>
             </a:extLst>
           </p:cNvPr>
@@ -7415,7 +8863,7 @@
           <p:cNvPr id="11" name="">
             <a:extLst xmlns:a="http://schemas.openxmlformats.org/drawingml/2006/main">
               <a:ext uri="{FF2B5EF4-FFF2-40B4-BE49-F238E27FC236}">
-                <a16:creationId xmlns:a16="http://schemas.microsoft.com/office/drawing/2014/main" id="{55B90377-E934-4AFE-9E18-51D2338C777B}"/>
+                <a16:creationId xmlns:a16="http://schemas.microsoft.com/office/drawing/2014/main" id="{4A3F8004-BA79-4D27-8DFF-DE3C7A55AEB4}"/>
               </a:ext>
             </a:extLst>
           </p:cNvPr>
@@ -7465,7 +8913,7 @@
           <p:cNvPr id="12" name="">
             <a:extLst xmlns:a="http://schemas.openxmlformats.org/drawingml/2006/main">
               <a:ext uri="{FF2B5EF4-FFF2-40B4-BE49-F238E27FC236}">
-                <a16:creationId xmlns:a16="http://schemas.microsoft.com/office/drawing/2014/main" id="{9C204E6F-897F-468B-BEFE-B8884D5B250F}"/>
+                <a16:creationId xmlns:a16="http://schemas.microsoft.com/office/drawing/2014/main" id="{FDCCC970-2FBA-4C7D-8C4C-B289859C8548}"/>
               </a:ext>
             </a:extLst>
           </p:cNvPr>
@@ -7515,7 +8963,7 @@
           <p:cNvPr id="13" name="">
             <a:extLst xmlns:a="http://schemas.openxmlformats.org/drawingml/2006/main">
               <a:ext uri="{FF2B5EF4-FFF2-40B4-BE49-F238E27FC236}">
-                <a16:creationId xmlns:a16="http://schemas.microsoft.com/office/drawing/2014/main" id="{BBDC15A4-B417-4EED-BAE1-EDE21BC68305}"/>
+                <a16:creationId xmlns:a16="http://schemas.microsoft.com/office/drawing/2014/main" id="{88663F98-9B06-4C81-90C7-4F10877F499E}"/>
               </a:ext>
             </a:extLst>
           </p:cNvPr>
@@ -7565,7 +9013,7 @@
           <p:cNvPr id="14" name="">
             <a:extLst xmlns:a="http://schemas.openxmlformats.org/drawingml/2006/main">
               <a:ext uri="{FF2B5EF4-FFF2-40B4-BE49-F238E27FC236}">
-                <a16:creationId xmlns:a16="http://schemas.microsoft.com/office/drawing/2014/main" id="{A8A0A392-D8CC-4E91-8D5D-0A505F5DC494}"/>
+                <a16:creationId xmlns:a16="http://schemas.microsoft.com/office/drawing/2014/main" id="{ACA398C6-1E1C-4693-942B-005783CF2799}"/>
               </a:ext>
             </a:extLst>
           </p:cNvPr>
@@ -7598,7 +9046,7 @@
           <p:cNvPr id="15" name="">
             <a:extLst xmlns:a="http://schemas.openxmlformats.org/drawingml/2006/main">
               <a:ext uri="{FF2B5EF4-FFF2-40B4-BE49-F238E27FC236}">
-                <a16:creationId xmlns:a16="http://schemas.microsoft.com/office/drawing/2014/main" id="{A189DD7E-6564-477A-978C-20CF003CF731}"/>
+                <a16:creationId xmlns:a16="http://schemas.microsoft.com/office/drawing/2014/main" id="{BAFAC117-D4B5-4B5B-B193-531D2B83A217}"/>
               </a:ext>
             </a:extLst>
           </p:cNvPr>
@@ -7648,7 +9096,7 @@
           <p:cNvPr id="16" name="">
             <a:extLst xmlns:a="http://schemas.openxmlformats.org/drawingml/2006/main">
               <a:ext uri="{FF2B5EF4-FFF2-40B4-BE49-F238E27FC236}">
-                <a16:creationId xmlns:a16="http://schemas.microsoft.com/office/drawing/2014/main" id="{79702BEE-9777-4F2E-8593-AF9E8371C3B4}"/>
+                <a16:creationId xmlns:a16="http://schemas.microsoft.com/office/drawing/2014/main" id="{8A897DD0-B51E-4E46-8201-DAB46DDF3DF9}"/>
               </a:ext>
             </a:extLst>
           </p:cNvPr>
@@ -7696,7 +9144,7 @@
     </p:spTree>
     <p:extLst>
       <p:ext uri="{BB962C8B-B14F-4D97-AF65-F5344CB8AC3E}">
-        <p14:creationId xmlns:p14="http://schemas.microsoft.com/office/powerpoint/2010/main" val="2123292303"/>
+        <p14:creationId xmlns:p14="http://schemas.microsoft.com/office/powerpoint/2010/main" val="2028410404"/>
       </p:ext>
     </p:extLst>
   </p:cSld>
@@ -7727,7 +9175,7 @@
           <p:cNvPr id="1" name="">
             <a:extLst xmlns:a="http://schemas.openxmlformats.org/drawingml/2006/main">
               <a:ext uri="{FF2B5EF4-FFF2-40B4-BE49-F238E27FC236}">
-                <a16:creationId xmlns:a16="http://schemas.microsoft.com/office/drawing/2014/main" id="{B7CDBA0F-F536-4404-81C8-0675A89EBBB8}"/>
+                <a16:creationId xmlns:a16="http://schemas.microsoft.com/office/drawing/2014/main" id="{A00FC08C-847D-434D-9243-FDA98FC0AAC2}"/>
               </a:ext>
             </a:extLst>
           </p:cNvPr>
@@ -7777,7 +9225,7 @@
           <p:cNvPr id="2" name="">
             <a:extLst xmlns:a="http://schemas.openxmlformats.org/drawingml/2006/main">
               <a:ext uri="{FF2B5EF4-FFF2-40B4-BE49-F238E27FC236}">
-                <a16:creationId xmlns:a16="http://schemas.microsoft.com/office/drawing/2014/main" id="{491C57E9-BB52-4041-97A2-4526F2C11655}"/>
+                <a16:creationId xmlns:a16="http://schemas.microsoft.com/office/drawing/2014/main" id="{1C7903B0-40AF-4BFA-9043-9FDAE9CE17FD}"/>
               </a:ext>
             </a:extLst>
           </p:cNvPr>
@@ -7827,7 +9275,7 @@
           <p:cNvPr id="3" name="">
             <a:extLst xmlns:a="http://schemas.openxmlformats.org/drawingml/2006/main">
               <a:ext uri="{FF2B5EF4-FFF2-40B4-BE49-F238E27FC236}">
-                <a16:creationId xmlns:a16="http://schemas.microsoft.com/office/drawing/2014/main" id="{6479FB56-E954-4E8A-81B5-3D9693A3CBF0}"/>
+                <a16:creationId xmlns:a16="http://schemas.microsoft.com/office/drawing/2014/main" id="{311BD28E-0EB5-4804-AAA7-800512444529}"/>
               </a:ext>
             </a:extLst>
           </p:cNvPr>
@@ -7858,7 +9306,7 @@
           <p:cNvPr id="4" name="">
             <a:extLst xmlns:a="http://schemas.openxmlformats.org/drawingml/2006/main">
               <a:ext uri="{FF2B5EF4-FFF2-40B4-BE49-F238E27FC236}">
-                <a16:creationId xmlns:a16="http://schemas.microsoft.com/office/drawing/2014/main" id="{4309CEB1-8E8D-459C-B772-C10A9F70B320}"/>
+                <a16:creationId xmlns:a16="http://schemas.microsoft.com/office/drawing/2014/main" id="{6B9435FF-2F95-448A-9540-24E6E7D1A6C0}"/>
               </a:ext>
             </a:extLst>
           </p:cNvPr>
@@ -7908,7 +9356,7 @@
           <p:cNvPr id="5" name="">
             <a:extLst xmlns:a="http://schemas.openxmlformats.org/drawingml/2006/main">
               <a:ext uri="{FF2B5EF4-FFF2-40B4-BE49-F238E27FC236}">
-                <a16:creationId xmlns:a16="http://schemas.microsoft.com/office/drawing/2014/main" id="{90367CE9-E38E-4975-9FF3-E8024BA87943}"/>
+                <a16:creationId xmlns:a16="http://schemas.microsoft.com/office/drawing/2014/main" id="{38457AB1-6396-4310-AA3C-CE69F410BC85}"/>
               </a:ext>
             </a:extLst>
           </p:cNvPr>
@@ -7958,7 +9406,7 @@
           <p:cNvPr id="6" name="">
             <a:extLst xmlns:a="http://schemas.openxmlformats.org/drawingml/2006/main">
               <a:ext uri="{FF2B5EF4-FFF2-40B4-BE49-F238E27FC236}">
-                <a16:creationId xmlns:a16="http://schemas.microsoft.com/office/drawing/2014/main" id="{173386F2-83FF-4FBC-B464-A7CD522442A1}"/>
+                <a16:creationId xmlns:a16="http://schemas.microsoft.com/office/drawing/2014/main" id="{7E36092C-A58E-4080-894A-FC6463911B80}"/>
               </a:ext>
             </a:extLst>
           </p:cNvPr>
@@ -8059,7 +9507,7 @@
           <p:cNvPr id="7" name="">
             <a:extLst xmlns:a="http://schemas.openxmlformats.org/drawingml/2006/main">
               <a:ext uri="{FF2B5EF4-FFF2-40B4-BE49-F238E27FC236}">
-                <a16:creationId xmlns:a16="http://schemas.microsoft.com/office/drawing/2014/main" id="{5AE9C245-5FE1-49D8-918A-55A2DE255CBE}"/>
+                <a16:creationId xmlns:a16="http://schemas.microsoft.com/office/drawing/2014/main" id="{8D73CD13-72B6-4B52-B228-2DD7CAD4C362}"/>
               </a:ext>
             </a:extLst>
           </p:cNvPr>
@@ -8090,7 +9538,7 @@
           <p:cNvPr id="8" name="">
             <a:extLst xmlns:a="http://schemas.openxmlformats.org/drawingml/2006/main">
               <a:ext uri="{FF2B5EF4-FFF2-40B4-BE49-F238E27FC236}">
-                <a16:creationId xmlns:a16="http://schemas.microsoft.com/office/drawing/2014/main" id="{0C1DC731-E4C1-4C11-AD41-BF8956A2BD17}"/>
+                <a16:creationId xmlns:a16="http://schemas.microsoft.com/office/drawing/2014/main" id="{07336704-BBF4-4C55-ADEC-B4798AFB8901}"/>
               </a:ext>
             </a:extLst>
           </p:cNvPr>
@@ -8140,7 +9588,7 @@
           <p:cNvPr id="9" name="">
             <a:extLst xmlns:a="http://schemas.openxmlformats.org/drawingml/2006/main">
               <a:ext uri="{FF2B5EF4-FFF2-40B4-BE49-F238E27FC236}">
-                <a16:creationId xmlns:a16="http://schemas.microsoft.com/office/drawing/2014/main" id="{4E5A7B10-D67B-4439-AFA9-11BA6ECE5268}"/>
+                <a16:creationId xmlns:a16="http://schemas.microsoft.com/office/drawing/2014/main" id="{FDA763C4-5233-44F7-9D5E-CE1B59DA3B96}"/>
               </a:ext>
             </a:extLst>
           </p:cNvPr>
@@ -8190,7 +9638,7 @@
           <p:cNvPr id="10" name="">
             <a:extLst xmlns:a="http://schemas.openxmlformats.org/drawingml/2006/main">
               <a:ext uri="{FF2B5EF4-FFF2-40B4-BE49-F238E27FC236}">
-                <a16:creationId xmlns:a16="http://schemas.microsoft.com/office/drawing/2014/main" id="{4696A15A-493E-4A79-A1E3-E496B7C5ED00}"/>
+                <a16:creationId xmlns:a16="http://schemas.microsoft.com/office/drawing/2014/main" id="{9A7D1AA6-5282-4148-8F09-3010E05D0AF1}"/>
               </a:ext>
             </a:extLst>
           </p:cNvPr>
@@ -8291,7 +9739,7 @@
           <p:cNvPr id="11" name="">
             <a:extLst xmlns:a="http://schemas.openxmlformats.org/drawingml/2006/main">
               <a:ext uri="{FF2B5EF4-FFF2-40B4-BE49-F238E27FC236}">
-                <a16:creationId xmlns:a16="http://schemas.microsoft.com/office/drawing/2014/main" id="{FE4418C6-05AA-40DC-B24D-9519E10F6702}"/>
+                <a16:creationId xmlns:a16="http://schemas.microsoft.com/office/drawing/2014/main" id="{9B3A7BDF-6B62-4A7E-A3AB-11B64A51BBA4}"/>
               </a:ext>
             </a:extLst>
           </p:cNvPr>
@@ -8341,7 +9789,7 @@
           <p:cNvPr id="12" name="">
             <a:extLst xmlns:a="http://schemas.openxmlformats.org/drawingml/2006/main">
               <a:ext uri="{FF2B5EF4-FFF2-40B4-BE49-F238E27FC236}">
-                <a16:creationId xmlns:a16="http://schemas.microsoft.com/office/drawing/2014/main" id="{D84FB96D-64F7-4346-B5C4-F84310250B79}"/>
+                <a16:creationId xmlns:a16="http://schemas.microsoft.com/office/drawing/2014/main" id="{E6FF5AB1-4F66-419D-BB23-D475873342D7}"/>
               </a:ext>
             </a:extLst>
           </p:cNvPr>
@@ -8374,7 +9822,7 @@
           <p:cNvPr id="13" name="">
             <a:extLst xmlns:a="http://schemas.openxmlformats.org/drawingml/2006/main">
               <a:ext uri="{FF2B5EF4-FFF2-40B4-BE49-F238E27FC236}">
-                <a16:creationId xmlns:a16="http://schemas.microsoft.com/office/drawing/2014/main" id="{507D3366-2096-4EFB-AE06-78B161E80002}"/>
+                <a16:creationId xmlns:a16="http://schemas.microsoft.com/office/drawing/2014/main" id="{F93529C2-C347-4A57-9B0E-557CE504502A}"/>
               </a:ext>
             </a:extLst>
           </p:cNvPr>
@@ -8424,7 +9872,7 @@
           <p:cNvPr id="14" name="">
             <a:extLst xmlns:a="http://schemas.openxmlformats.org/drawingml/2006/main">
               <a:ext uri="{FF2B5EF4-FFF2-40B4-BE49-F238E27FC236}">
-                <a16:creationId xmlns:a16="http://schemas.microsoft.com/office/drawing/2014/main" id="{B03C6676-4124-4F65-AFDB-5E69B5B95CD7}"/>
+                <a16:creationId xmlns:a16="http://schemas.microsoft.com/office/drawing/2014/main" id="{41E4F260-8248-4176-B968-E07C99EB9BDC}"/>
               </a:ext>
             </a:extLst>
           </p:cNvPr>
@@ -8472,7 +9920,7 @@
     </p:spTree>
     <p:extLst>
       <p:ext uri="{BB962C8B-B14F-4D97-AF65-F5344CB8AC3E}">
-        <p14:creationId xmlns:p14="http://schemas.microsoft.com/office/powerpoint/2010/main" val="904244785"/>
+        <p14:creationId xmlns:p14="http://schemas.microsoft.com/office/powerpoint/2010/main" val="846631524"/>
       </p:ext>
     </p:extLst>
   </p:cSld>
@@ -8503,7 +9951,7 @@
           <p:cNvPr id="1" name="">
             <a:extLst xmlns:a="http://schemas.openxmlformats.org/drawingml/2006/main">
               <a:ext uri="{FF2B5EF4-FFF2-40B4-BE49-F238E27FC236}">
-                <a16:creationId xmlns:a16="http://schemas.microsoft.com/office/drawing/2014/main" id="{F214BCCE-FD50-4FCD-B2AD-A521B286B915}"/>
+                <a16:creationId xmlns:a16="http://schemas.microsoft.com/office/drawing/2014/main" id="{7717D42D-BCBB-49ED-AAE0-07EDDCE9D02E}"/>
               </a:ext>
             </a:extLst>
           </p:cNvPr>
@@ -8553,7 +10001,7 @@
           <p:cNvPr id="2" name="">
             <a:extLst xmlns:a="http://schemas.openxmlformats.org/drawingml/2006/main">
               <a:ext uri="{FF2B5EF4-FFF2-40B4-BE49-F238E27FC236}">
-                <a16:creationId xmlns:a16="http://schemas.microsoft.com/office/drawing/2014/main" id="{9845654B-B29F-4725-8D16-9CA6145D401F}"/>
+                <a16:creationId xmlns:a16="http://schemas.microsoft.com/office/drawing/2014/main" id="{2BB024BE-E277-4056-B17E-B4B9EA028457}"/>
               </a:ext>
             </a:extLst>
           </p:cNvPr>
@@ -8603,7 +10051,7 @@
           <p:cNvPr id="3" name="">
             <a:extLst xmlns:a="http://schemas.openxmlformats.org/drawingml/2006/main">
               <a:ext uri="{FF2B5EF4-FFF2-40B4-BE49-F238E27FC236}">
-                <a16:creationId xmlns:a16="http://schemas.microsoft.com/office/drawing/2014/main" id="{CD85756C-042C-4810-99E6-390A170CC4B9}"/>
+                <a16:creationId xmlns:a16="http://schemas.microsoft.com/office/drawing/2014/main" id="{97EEF48E-537C-40CD-83E3-BF22D4283E07}"/>
               </a:ext>
             </a:extLst>
           </p:cNvPr>
@@ -8653,7 +10101,7 @@
           <p:cNvPr id="4" name="">
             <a:extLst xmlns:a="http://schemas.openxmlformats.org/drawingml/2006/main">
               <a:ext uri="{FF2B5EF4-FFF2-40B4-BE49-F238E27FC236}">
-                <a16:creationId xmlns:a16="http://schemas.microsoft.com/office/drawing/2014/main" id="{6A65D5DC-BC57-408C-9107-97C914B94DB9}"/>
+                <a16:creationId xmlns:a16="http://schemas.microsoft.com/office/drawing/2014/main" id="{EAB0178F-9AD2-4198-85E1-39D4FD1DCECA}"/>
               </a:ext>
             </a:extLst>
           </p:cNvPr>
@@ -8684,7 +10132,7 @@
           <p:cNvPr id="5" name="">
             <a:extLst xmlns:a="http://schemas.openxmlformats.org/drawingml/2006/main">
               <a:ext uri="{FF2B5EF4-FFF2-40B4-BE49-F238E27FC236}">
-                <a16:creationId xmlns:a16="http://schemas.microsoft.com/office/drawing/2014/main" id="{AA985C3C-CF42-4278-9EE7-13EDCB148905}"/>
+                <a16:creationId xmlns:a16="http://schemas.microsoft.com/office/drawing/2014/main" id="{24841DF7-B050-474A-BC9F-2AA30AE4472A}"/>
               </a:ext>
             </a:extLst>
           </p:cNvPr>
@@ -8734,7 +10182,7 @@
           <p:cNvPr id="6" name="">
             <a:extLst xmlns:a="http://schemas.openxmlformats.org/drawingml/2006/main">
               <a:ext uri="{FF2B5EF4-FFF2-40B4-BE49-F238E27FC236}">
-                <a16:creationId xmlns:a16="http://schemas.microsoft.com/office/drawing/2014/main" id="{79FEBDD1-820E-4F53-B28F-DD1F04412736}"/>
+                <a16:creationId xmlns:a16="http://schemas.microsoft.com/office/drawing/2014/main" id="{841DC3AC-94D6-4C91-945C-FE1C9D524E00}"/>
               </a:ext>
             </a:extLst>
           </p:cNvPr>
@@ -8784,7 +10232,7 @@
           <p:cNvPr id="7" name="">
             <a:extLst xmlns:a="http://schemas.openxmlformats.org/drawingml/2006/main">
               <a:ext uri="{FF2B5EF4-FFF2-40B4-BE49-F238E27FC236}">
-                <a16:creationId xmlns:a16="http://schemas.microsoft.com/office/drawing/2014/main" id="{145C1511-CDB5-4538-8395-6D2E5D01368F}"/>
+                <a16:creationId xmlns:a16="http://schemas.microsoft.com/office/drawing/2014/main" id="{37225CE6-F217-4537-A770-9F26D6128EE2}"/>
               </a:ext>
             </a:extLst>
           </p:cNvPr>
@@ -8815,7 +10263,7 @@
           <p:cNvPr id="8" name="">
             <a:extLst xmlns:a="http://schemas.openxmlformats.org/drawingml/2006/main">
               <a:ext uri="{FF2B5EF4-FFF2-40B4-BE49-F238E27FC236}">
-                <a16:creationId xmlns:a16="http://schemas.microsoft.com/office/drawing/2014/main" id="{F2C9D021-4AA1-441E-AAC3-5FDE1AE89EBF}"/>
+                <a16:creationId xmlns:a16="http://schemas.microsoft.com/office/drawing/2014/main" id="{D81CFF70-5799-40E5-AADA-61D8D7146615}"/>
               </a:ext>
             </a:extLst>
           </p:cNvPr>
@@ -8865,7 +10313,7 @@
           <p:cNvPr id="9" name="">
             <a:extLst xmlns:a="http://schemas.openxmlformats.org/drawingml/2006/main">
               <a:ext uri="{FF2B5EF4-FFF2-40B4-BE49-F238E27FC236}">
-                <a16:creationId xmlns:a16="http://schemas.microsoft.com/office/drawing/2014/main" id="{D9983BCD-5E9C-40EE-98BF-8AF2298A673B}"/>
+                <a16:creationId xmlns:a16="http://schemas.microsoft.com/office/drawing/2014/main" id="{C17E8DEB-6B19-41A2-9222-A0507AC70C3C}"/>
               </a:ext>
             </a:extLst>
           </p:cNvPr>
@@ -8915,7 +10363,7 @@
           <p:cNvPr id="10" name="">
             <a:extLst xmlns:a="http://schemas.openxmlformats.org/drawingml/2006/main">
               <a:ext uri="{FF2B5EF4-FFF2-40B4-BE49-F238E27FC236}">
-                <a16:creationId xmlns:a16="http://schemas.microsoft.com/office/drawing/2014/main" id="{D608903D-7EE8-47D9-B8AA-AA4C782A612D}"/>
+                <a16:creationId xmlns:a16="http://schemas.microsoft.com/office/drawing/2014/main" id="{C7270510-97D8-4DE8-A4B0-631C761E2C4A}"/>
               </a:ext>
             </a:extLst>
           </p:cNvPr>
@@ -8946,7 +10394,7 @@
           <p:cNvPr id="11" name="">
             <a:extLst xmlns:a="http://schemas.openxmlformats.org/drawingml/2006/main">
               <a:ext uri="{FF2B5EF4-FFF2-40B4-BE49-F238E27FC236}">
-                <a16:creationId xmlns:a16="http://schemas.microsoft.com/office/drawing/2014/main" id="{AB7A6CE4-9C13-410C-B82B-EB9A6F2B5AB8}"/>
+                <a16:creationId xmlns:a16="http://schemas.microsoft.com/office/drawing/2014/main" id="{780C8FA1-5A64-48C1-B47B-2CD159966E88}"/>
               </a:ext>
             </a:extLst>
           </p:cNvPr>
@@ -8996,7 +10444,7 @@
           <p:cNvPr id="12" name="">
             <a:extLst xmlns:a="http://schemas.openxmlformats.org/drawingml/2006/main">
               <a:ext uri="{FF2B5EF4-FFF2-40B4-BE49-F238E27FC236}">
-                <a16:creationId xmlns:a16="http://schemas.microsoft.com/office/drawing/2014/main" id="{FF9EE449-AF41-4C37-B7C1-9D272771BB4D}"/>
+                <a16:creationId xmlns:a16="http://schemas.microsoft.com/office/drawing/2014/main" id="{977B47C1-ABB5-4410-92AF-C0FD4D09DC0B}"/>
               </a:ext>
             </a:extLst>
           </p:cNvPr>
@@ -9046,7 +10494,7 @@
           <p:cNvPr id="13" name="">
             <a:extLst xmlns:a="http://schemas.openxmlformats.org/drawingml/2006/main">
               <a:ext uri="{FF2B5EF4-FFF2-40B4-BE49-F238E27FC236}">
-                <a16:creationId xmlns:a16="http://schemas.microsoft.com/office/drawing/2014/main" id="{5FC4016C-87FD-4B4F-8EB2-A76598544914}"/>
+                <a16:creationId xmlns:a16="http://schemas.microsoft.com/office/drawing/2014/main" id="{2B5F0DB9-2589-4A8E-81F1-3432F2094986}"/>
               </a:ext>
             </a:extLst>
           </p:cNvPr>
@@ -9077,7 +10525,7 @@
           <p:cNvPr id="14" name="">
             <a:extLst xmlns:a="http://schemas.openxmlformats.org/drawingml/2006/main">
               <a:ext uri="{FF2B5EF4-FFF2-40B4-BE49-F238E27FC236}">
-                <a16:creationId xmlns:a16="http://schemas.microsoft.com/office/drawing/2014/main" id="{7F0A137A-CA6E-48D5-A183-87B709501AC5}"/>
+                <a16:creationId xmlns:a16="http://schemas.microsoft.com/office/drawing/2014/main" id="{37CD0487-7E41-43C4-B44E-577FBFC94A46}"/>
               </a:ext>
             </a:extLst>
           </p:cNvPr>
@@ -9127,7 +10575,7 @@
           <p:cNvPr id="15" name="">
             <a:extLst xmlns:a="http://schemas.openxmlformats.org/drawingml/2006/main">
               <a:ext uri="{FF2B5EF4-FFF2-40B4-BE49-F238E27FC236}">
-                <a16:creationId xmlns:a16="http://schemas.microsoft.com/office/drawing/2014/main" id="{E16397FB-1A4A-4DFE-8FAB-B1CF81A15E24}"/>
+                <a16:creationId xmlns:a16="http://schemas.microsoft.com/office/drawing/2014/main" id="{AD1A8B48-BA50-4CF1-BFC5-B76ADCBE0686}"/>
               </a:ext>
             </a:extLst>
           </p:cNvPr>
@@ -9177,7 +10625,7 @@
           <p:cNvPr id="16" name="">
             <a:extLst xmlns:a="http://schemas.openxmlformats.org/drawingml/2006/main">
               <a:ext uri="{FF2B5EF4-FFF2-40B4-BE49-F238E27FC236}">
-                <a16:creationId xmlns:a16="http://schemas.microsoft.com/office/drawing/2014/main" id="{79EE9779-6147-4E73-8143-2784B78A5F84}"/>
+                <a16:creationId xmlns:a16="http://schemas.microsoft.com/office/drawing/2014/main" id="{7C54272A-5337-4344-B6F1-C26A616F06B4}"/>
               </a:ext>
             </a:extLst>
           </p:cNvPr>
@@ -9227,7 +10675,7 @@
           <p:cNvPr id="17" name="">
             <a:extLst xmlns:a="http://schemas.openxmlformats.org/drawingml/2006/main">
               <a:ext uri="{FF2B5EF4-FFF2-40B4-BE49-F238E27FC236}">
-                <a16:creationId xmlns:a16="http://schemas.microsoft.com/office/drawing/2014/main" id="{533E48BE-B512-4235-B4CF-CD65021937D0}"/>
+                <a16:creationId xmlns:a16="http://schemas.microsoft.com/office/drawing/2014/main" id="{D5DCFB4B-547E-4FB8-9408-0544DE8AC09D}"/>
               </a:ext>
             </a:extLst>
           </p:cNvPr>
@@ -9277,7 +10725,7 @@
           <p:cNvPr id="18" name="">
             <a:extLst xmlns:a="http://schemas.openxmlformats.org/drawingml/2006/main">
               <a:ext uri="{FF2B5EF4-FFF2-40B4-BE49-F238E27FC236}">
-                <a16:creationId xmlns:a16="http://schemas.microsoft.com/office/drawing/2014/main" id="{731C3786-02FE-4285-B3D7-A024E596A213}"/>
+                <a16:creationId xmlns:a16="http://schemas.microsoft.com/office/drawing/2014/main" id="{34889FEE-7B0F-412A-8333-53B011F234C0}"/>
               </a:ext>
             </a:extLst>
           </p:cNvPr>
@@ -9310,7 +10758,7 @@
           <p:cNvPr id="19" name="">
             <a:extLst xmlns:a="http://schemas.openxmlformats.org/drawingml/2006/main">
               <a:ext uri="{FF2B5EF4-FFF2-40B4-BE49-F238E27FC236}">
-                <a16:creationId xmlns:a16="http://schemas.microsoft.com/office/drawing/2014/main" id="{2E96DED0-E99E-41CA-B6A6-AF92ABDF896C}"/>
+                <a16:creationId xmlns:a16="http://schemas.microsoft.com/office/drawing/2014/main" id="{EE2C187E-2FE3-4B5B-AFFA-03487BA45080}"/>
               </a:ext>
             </a:extLst>
           </p:cNvPr>
@@ -9360,7 +10808,7 @@
           <p:cNvPr id="20" name="">
             <a:extLst xmlns:a="http://schemas.openxmlformats.org/drawingml/2006/main">
               <a:ext uri="{FF2B5EF4-FFF2-40B4-BE49-F238E27FC236}">
-                <a16:creationId xmlns:a16="http://schemas.microsoft.com/office/drawing/2014/main" id="{FB20C178-83F6-4459-A472-DF2FF6D63374}"/>
+                <a16:creationId xmlns:a16="http://schemas.microsoft.com/office/drawing/2014/main" id="{E06720DA-7409-4D15-8B85-95D548681440}"/>
               </a:ext>
             </a:extLst>
           </p:cNvPr>
@@ -9408,7 +10856,7 @@
     </p:spTree>
     <p:extLst>
       <p:ext uri="{BB962C8B-B14F-4D97-AF65-F5344CB8AC3E}">
-        <p14:creationId xmlns:p14="http://schemas.microsoft.com/office/powerpoint/2010/main" val="629226205"/>
+        <p14:creationId xmlns:p14="http://schemas.microsoft.com/office/powerpoint/2010/main" val="1663067218"/>
       </p:ext>
     </p:extLst>
   </p:cSld>

</xml_diff>